<commit_message>
deck 3-2: §2 the database design space (slides 4-8)
Stage 2 of 6: the five-dimension abstract database model (the lecture's
central visual), four data-model families, relational-vs-NoSQL as a
requirements question (with the folk rule crossed out in red-on-cream),
semantics-over-labels questions, and the reservations-vs-telemetry
choosing exercise. 19 of 75 min banked.

Co-Authored-By: Claude Opus 5 <noreply@anthropic.com>
</commit_message>
<xml_diff>
--- a/course/lectures/act-3-software-in-the-world/02-compute-environments-and-data-management/3-2-Data-Management.pptx
+++ b/course/lectures/act-3-software-in-the-world/02-compute-environments-and-data-management/3-2-Data-Management.pptx
@@ -11,6 +11,11 @@
     <p:sldId id="256" r:id="rId7"/>
     <p:sldId id="257" r:id="rId8"/>
     <p:sldId id="258" r:id="rId9"/>
+    <p:sldId id="259" r:id="rId10"/>
+    <p:sldId id="260" r:id="rId11"/>
+    <p:sldId id="261" r:id="rId12"/>
+    <p:sldId id="262" r:id="rId13"/>
+    <p:sldId id="263" r:id="rId14"/>
   </p:sldIdLst>
   <p:sldSz cx="9144000" cy="6858000" type="screen4x3"/>
   <p:notesSz cx="6858000" cy="9144000"/>
@@ -1685,6 +1690,434 @@
           <a:p>
             <a:r>
               <a:t>Next slide makes "the contract" precise: five dimensions that organize the rest of the lecture.</a:t>
+            </a:r>
+          </a:p>
+        </p:txBody>
+      </p:sp>
+      <p:sp>
+        <p:nvSpPr>
+          <p:cNvPr id="4" name="Slide Number Placeholder 3"/>
+          <p:cNvSpPr>
+            <a:spLocks noGrp="1"/>
+          </p:cNvSpPr>
+          <p:nvPr>
+            <p:ph type="sldNum" idx="12"/>
+          </p:nvPr>
+        </p:nvSpPr>
+        <p:spPr/>
+      </p:sp>
+    </p:spTree>
+  </p:cSld>
+  <p:clrMapOvr>
+    <a:masterClrMapping/>
+  </p:clrMapOvr>
+</p:notes>
+</file>
+
+<file path=ppt/notesSlides/notesSlide4.xml><?xml version="1.0" encoding="utf-8"?>
+<p:notes xmlns:a="http://schemas.openxmlformats.org/drawingml/2006/main" xmlns:p="http://schemas.openxmlformats.org/presentationml/2006/main" xmlns:r="http://schemas.openxmlformats.org/officeDocument/2006/relationships">
+  <p:cSld>
+    <p:spTree>
+      <p:nvGrpSpPr>
+        <p:cNvPr id="1" name=""/>
+        <p:cNvGrpSpPr/>
+        <p:nvPr/>
+      </p:nvGrpSpPr>
+      <p:grpSpPr>
+        <a:xfrm>
+          <a:off x="0" y="0"/>
+          <a:ext cx="0" cy="0"/>
+          <a:chOff x="0" y="0"/>
+          <a:chExt cx="0" cy="0"/>
+        </a:xfrm>
+      </p:grpSpPr>
+      <p:sp>
+        <p:nvSpPr>
+          <p:cNvPr id="2" name="Slide Image Placeholder 1"/>
+          <p:cNvSpPr>
+            <a:spLocks noGrp="1"/>
+          </p:cNvSpPr>
+          <p:nvPr>
+            <p:ph type="sldImg" idx="3"/>
+          </p:nvPr>
+        </p:nvSpPr>
+        <p:spPr/>
+      </p:sp>
+      <p:sp>
+        <p:nvSpPr>
+          <p:cNvPr id="3" name="Notes Placeholder 2"/>
+          <p:cNvSpPr>
+            <a:spLocks noGrp="1"/>
+          </p:cNvSpPr>
+          <p:nvPr>
+            <p:ph type="body" idx="1"/>
+          </p:nvPr>
+        </p:nvSpPr>
+        <p:spPr/>
+        <p:txBody>
+          <a:bodyPr/>
+          <a:lstStyle/>
+          <a:p>
+            <a:r>
+              <a:t>TIMING: 4 minutes.</a:t>
+            </a:r>
+          </a:p>
+          <a:p/>
+          <a:p>
+            <a:r>
+              <a:t>This is the lecture's central visual; everything that follows lives somewhere on it. Walk each row as an engineering QUESTION, not a feature list. When relational vs NoSQL, ORMs, query plans, or transactions come up later, return here and point at the row they occupy.</a:t>
+            </a:r>
+          </a:p>
+          <a:p/>
+          <a:p>
+            <a:r>
+              <a:t>The footer line is the model's point: requirements belong to the APPLICATION; guarantees belong to the DATABASE. Keeping those separate is what lets "NoSQL" be a set of points in this space rather than a rival camp — and what makes "does the database enforce my invariant?" a question with a precise answer rather than a vibe.</a:t>
+            </a:r>
+          </a:p>
+          <a:p/>
+          <a:p>
+            <a:r>
+              <a:t>Operations (backup, recovery, migration, administration) is a real sixth dimension; we defer it to the Operations &amp; SRE unit rather than pretending it fits today.</a:t>
+            </a:r>
+          </a:p>
+        </p:txBody>
+      </p:sp>
+      <p:sp>
+        <p:nvSpPr>
+          <p:cNvPr id="4" name="Slide Number Placeholder 3"/>
+          <p:cNvSpPr>
+            <a:spLocks noGrp="1"/>
+          </p:cNvSpPr>
+          <p:nvPr>
+            <p:ph type="sldNum" idx="12"/>
+          </p:nvPr>
+        </p:nvSpPr>
+        <p:spPr/>
+      </p:sp>
+    </p:spTree>
+  </p:cSld>
+  <p:clrMapOvr>
+    <a:masterClrMapping/>
+  </p:clrMapOvr>
+</p:notes>
+</file>
+
+<file path=ppt/notesSlides/notesSlide5.xml><?xml version="1.0" encoding="utf-8"?>
+<p:notes xmlns:a="http://schemas.openxmlformats.org/drawingml/2006/main" xmlns:p="http://schemas.openxmlformats.org/presentationml/2006/main" xmlns:r="http://schemas.openxmlformats.org/officeDocument/2006/relationships">
+  <p:cSld>
+    <p:spTree>
+      <p:nvGrpSpPr>
+        <p:cNvPr id="1" name=""/>
+        <p:cNvGrpSpPr/>
+        <p:nvPr/>
+      </p:nvGrpSpPr>
+      <p:grpSpPr>
+        <a:xfrm>
+          <a:off x="0" y="0"/>
+          <a:ext cx="0" cy="0"/>
+          <a:chOff x="0" y="0"/>
+          <a:chExt cx="0" cy="0"/>
+        </a:xfrm>
+      </p:grpSpPr>
+      <p:sp>
+        <p:nvSpPr>
+          <p:cNvPr id="2" name="Slide Image Placeholder 1"/>
+          <p:cNvSpPr>
+            <a:spLocks noGrp="1"/>
+          </p:cNvSpPr>
+          <p:nvPr>
+            <p:ph type="sldImg" idx="3"/>
+          </p:nvPr>
+        </p:nvSpPr>
+        <p:spPr/>
+      </p:sp>
+      <p:sp>
+        <p:nvSpPr>
+          <p:cNvPr id="3" name="Notes Placeholder 2"/>
+          <p:cNvSpPr>
+            <a:spLocks noGrp="1"/>
+          </p:cNvSpPr>
+          <p:nvPr>
+            <p:ph type="body" idx="1"/>
+          </p:nvPr>
+        </p:nvSpPr>
+        <p:spPr/>
+        <p:txBody>
+          <a:bodyPr/>
+          <a:lstStyle/>
+          <a:p>
+            <a:r>
+              <a:t>TIMING: 2 minutes.</a:t>
+            </a:r>
+          </a:p>
+          <a:p/>
+          <a:p>
+            <a:r>
+              <a:t>One pass, one sentence per family, always the same facts: rooms, users, reservations.</a:t>
+            </a:r>
+          </a:p>
+          <a:p/>
+          <a:p>
+            <a:r>
+              <a:t>DO NOT claim capability walls. A document database CAN represent relationships (references across documents); a relational database CAN store JSON (jsonb columns). The real differences are NATIVE representation and common usage — what the system makes easy, indexed, and idiomatic. Teaching these as absolute capabilities is the second named non-claim of this lecture.</a:t>
+            </a:r>
+          </a:p>
+          <a:p/>
+          <a:p>
+            <a:r>
+              <a:t>Foreshadow: "easy vs harder" is about to matter — our invariant is a cross-row rule.</a:t>
+            </a:r>
+          </a:p>
+        </p:txBody>
+      </p:sp>
+      <p:sp>
+        <p:nvSpPr>
+          <p:cNvPr id="4" name="Slide Number Placeholder 3"/>
+          <p:cNvSpPr>
+            <a:spLocks noGrp="1"/>
+          </p:cNvSpPr>
+          <p:nvPr>
+            <p:ph type="sldNum" idx="12"/>
+          </p:nvPr>
+        </p:nvSpPr>
+        <p:spPr/>
+      </p:sp>
+    </p:spTree>
+  </p:cSld>
+  <p:clrMapOvr>
+    <a:masterClrMapping/>
+  </p:clrMapOvr>
+</p:notes>
+</file>
+
+<file path=ppt/notesSlides/notesSlide6.xml><?xml version="1.0" encoding="utf-8"?>
+<p:notes xmlns:a="http://schemas.openxmlformats.org/drawingml/2006/main" xmlns:p="http://schemas.openxmlformats.org/presentationml/2006/main" xmlns:r="http://schemas.openxmlformats.org/officeDocument/2006/relationships">
+  <p:cSld>
+    <p:spTree>
+      <p:nvGrpSpPr>
+        <p:cNvPr id="1" name=""/>
+        <p:cNvGrpSpPr/>
+        <p:nvPr/>
+      </p:nvGrpSpPr>
+      <p:grpSpPr>
+        <a:xfrm>
+          <a:off x="0" y="0"/>
+          <a:ext cx="0" cy="0"/>
+          <a:chOff x="0" y="0"/>
+          <a:chExt cx="0" cy="0"/>
+        </a:xfrm>
+      </p:grpSpPr>
+      <p:sp>
+        <p:nvSpPr>
+          <p:cNvPr id="2" name="Slide Image Placeholder 1"/>
+          <p:cNvSpPr>
+            <a:spLocks noGrp="1"/>
+          </p:cNvSpPr>
+          <p:nvPr>
+            <p:ph type="sldImg" idx="3"/>
+          </p:nvPr>
+        </p:nvSpPr>
+        <p:spPr/>
+      </p:sp>
+      <p:sp>
+        <p:nvSpPr>
+          <p:cNvPr id="3" name="Notes Placeholder 2"/>
+          <p:cNvSpPr>
+            <a:spLocks noGrp="1"/>
+          </p:cNvSpPr>
+          <p:nvPr>
+            <p:ph type="body" idx="1"/>
+          </p:nvPr>
+        </p:nvSpPr>
+        <p:spPr/>
+        <p:txBody>
+          <a:bodyPr/>
+          <a:lstStyle/>
+          <a:p>
+            <a:r>
+              <a:t>TIMING: 2 minutes.</a:t>
+            </a:r>
+          </a:p>
+          <a:p/>
+          <a:p>
+            <a:r>
+              <a:t>The crossed-out line is folk wisdom students arrive with; name it and reject it explicitly — it is not a defensible engineering rule. "NoSQL" is not a single consistency model: Spanner-class relational systems are distributed and horizontally scalable; several document and key-value systems offer strong consistency and multi-document transactions. The engineering move is the previous slide's footer: compare GUARANTEES against REQUIREMENTS, per system, per dimension.</a:t>
+            </a:r>
+          </a:p>
+          <a:p/>
+          <a:p>
+            <a:r>
+              <a:t>We now commit to a relational first implementation — not because relational is "the default answer," but because our requirements (left card) select it. Later slides compare NoSQL alternatives against those same requirements.</a:t>
+            </a:r>
+          </a:p>
+        </p:txBody>
+      </p:sp>
+      <p:sp>
+        <p:nvSpPr>
+          <p:cNvPr id="4" name="Slide Number Placeholder 3"/>
+          <p:cNvSpPr>
+            <a:spLocks noGrp="1"/>
+          </p:cNvSpPr>
+          <p:nvPr>
+            <p:ph type="sldNum" idx="12"/>
+          </p:nvPr>
+        </p:nvSpPr>
+        <p:spPr/>
+      </p:sp>
+    </p:spTree>
+  </p:cSld>
+  <p:clrMapOvr>
+    <a:masterClrMapping/>
+  </p:clrMapOvr>
+</p:notes>
+</file>
+
+<file path=ppt/notesSlides/notesSlide7.xml><?xml version="1.0" encoding="utf-8"?>
+<p:notes xmlns:a="http://schemas.openxmlformats.org/drawingml/2006/main" xmlns:p="http://schemas.openxmlformats.org/presentationml/2006/main" xmlns:r="http://schemas.openxmlformats.org/officeDocument/2006/relationships">
+  <p:cSld>
+    <p:spTree>
+      <p:nvGrpSpPr>
+        <p:cNvPr id="1" name=""/>
+        <p:cNvGrpSpPr/>
+        <p:nvPr/>
+      </p:nvGrpSpPr>
+      <p:grpSpPr>
+        <a:xfrm>
+          <a:off x="0" y="0"/>
+          <a:ext cx="0" cy="0"/>
+          <a:chOff x="0" y="0"/>
+          <a:chExt cx="0" cy="0"/>
+        </a:xfrm>
+      </p:grpSpPr>
+      <p:sp>
+        <p:nvSpPr>
+          <p:cNvPr id="2" name="Slide Image Placeholder 1"/>
+          <p:cNvSpPr>
+            <a:spLocks noGrp="1"/>
+          </p:cNvSpPr>
+          <p:nvPr>
+            <p:ph type="sldImg" idx="3"/>
+          </p:nvPr>
+        </p:nvSpPr>
+        <p:spPr/>
+      </p:sp>
+      <p:sp>
+        <p:nvSpPr>
+          <p:cNvPr id="3" name="Notes Placeholder 2"/>
+          <p:cNvSpPr>
+            <a:spLocks noGrp="1"/>
+          </p:cNvSpPr>
+          <p:nvPr>
+            <p:ph type="body" idx="1"/>
+          </p:nvPr>
+        </p:nvSpPr>
+        <p:spPr/>
+        <p:txBody>
+          <a:bodyPr/>
+          <a:lstStyle/>
+          <a:p>
+            <a:r>
+              <a:t>TIMING: 2 minutes.</a:t>
+            </a:r>
+          </a:p>
+          <a:p/>
+          <a:p>
+            <a:r>
+              <a:t>These four questions make the Semantics and Concurrency rows of the abstract model operational. The answers differ WITHIN camps, not just between them: two relational engines at their default isolation levels answer question 3 differently, and so do two NoSQL systems. That is why the label ("SQL," "NoSQL") tells you less than the documentation's guarantees section.</a:t>
+            </a:r>
+          </a:p>
+          <a:p/>
+          <a:p>
+            <a:r>
+              <a:t>Question 3 is the lecture's destination — hold it up now, promise it gets 20 minutes later. Question 4 foreshadows the three-fixes slide: in some systems the invariant can live IN the database; in others it must live in application discipline.</a:t>
+            </a:r>
+          </a:p>
+        </p:txBody>
+      </p:sp>
+      <p:sp>
+        <p:nvSpPr>
+          <p:cNvPr id="4" name="Slide Number Placeholder 3"/>
+          <p:cNvSpPr>
+            <a:spLocks noGrp="1"/>
+          </p:cNvSpPr>
+          <p:nvPr>
+            <p:ph type="sldNum" idx="12"/>
+          </p:nvPr>
+        </p:nvSpPr>
+        <p:spPr/>
+      </p:sp>
+    </p:spTree>
+  </p:cSld>
+  <p:clrMapOvr>
+    <a:masterClrMapping/>
+  </p:clrMapOvr>
+</p:notes>
+</file>
+
+<file path=ppt/notesSlides/notesSlide8.xml><?xml version="1.0" encoding="utf-8"?>
+<p:notes xmlns:a="http://schemas.openxmlformats.org/drawingml/2006/main" xmlns:p="http://schemas.openxmlformats.org/presentationml/2006/main" xmlns:r="http://schemas.openxmlformats.org/officeDocument/2006/relationships">
+  <p:cSld>
+    <p:spTree>
+      <p:nvGrpSpPr>
+        <p:cNvPr id="1" name=""/>
+        <p:cNvGrpSpPr/>
+        <p:nvPr/>
+      </p:nvGrpSpPr>
+      <p:grpSpPr>
+        <a:xfrm>
+          <a:off x="0" y="0"/>
+          <a:ext cx="0" cy="0"/>
+          <a:chOff x="0" y="0"/>
+          <a:chExt cx="0" cy="0"/>
+        </a:xfrm>
+      </p:grpSpPr>
+      <p:sp>
+        <p:nvSpPr>
+          <p:cNvPr id="2" name="Slide Image Placeholder 1"/>
+          <p:cNvSpPr>
+            <a:spLocks noGrp="1"/>
+          </p:cNvSpPr>
+          <p:nvPr>
+            <p:ph type="sldImg" idx="3"/>
+          </p:nvPr>
+        </p:nvSpPr>
+        <p:spPr/>
+      </p:sp>
+      <p:sp>
+        <p:nvSpPr>
+          <p:cNvPr id="3" name="Notes Placeholder 2"/>
+          <p:cNvSpPr>
+            <a:spLocks noGrp="1"/>
+          </p:cNvSpPr>
+          <p:nvPr>
+            <p:ph type="body" idx="1"/>
+          </p:nvPr>
+        </p:nvSpPr>
+        <p:spPr/>
+        <p:txBody>
+          <a:bodyPr/>
+          <a:lstStyle/>
+          <a:p>
+            <a:r>
+              <a:t>TIMING: 2 minutes.</a:t>
+            </a:r>
+          </a:p>
+          <a:p/>
+          <a:p>
+            <a:r>
+              <a:t>Quick poll, not a worksheet: for each system, pick a data model, a consistency posture, and a scaling posture — one minute of neighbor discussion, then take answers.</a:t>
+            </a:r>
+          </a:p>
+          <a:p/>
+          <a:p>
+            <a:r>
+              <a:t>Expected: A → relational, strong isolation available, single primary, indexes for ad-hoc queries. B → partitioned key-value / wide-column, relaxed consistency, write-optimized, partition by device id; no cross-row invariant exists, so nothing is lost by relaxing it.</a:t>
+            </a:r>
+          </a:p>
+          <a:p/>
+          <a:p>
+            <a:r>
+              <a:t>The teaching point: B is not "worse engineering" than A — its requirements genuinely do not need what A must pay for. Resist any student framing of A as legacy and B as modern.</a:t>
             </a:r>
           </a:p>
         </p:txBody>
@@ -10273,6 +10706,3017 @@
 </p:sld>
 </file>
 
+<file path=ppt/slides/slide4.xml><?xml version="1.0" encoding="utf-8"?>
+<p:sld xmlns:a="http://schemas.openxmlformats.org/drawingml/2006/main" xmlns:p="http://schemas.openxmlformats.org/presentationml/2006/main" xmlns:r="http://schemas.openxmlformats.org/officeDocument/2006/relationships">
+  <p:cSld>
+    <p:spTree>
+      <p:nvGrpSpPr>
+        <p:cNvPr id="1" name=""/>
+        <p:cNvGrpSpPr/>
+        <p:nvPr/>
+      </p:nvGrpSpPr>
+      <p:grpSpPr/>
+      <p:sp>
+        <p:nvSpPr>
+          <p:cNvPr id="2" name="Title"/>
+          <p:cNvSpPr txBox="1"/>
+          <p:nvPr/>
+        </p:nvSpPr>
+        <p:spPr>
+          <a:xfrm>
+            <a:off x="274320" y="128016"/>
+            <a:ext cx="8595360" cy="594360"/>
+          </a:xfrm>
+          <a:prstGeom prst="rect">
+            <a:avLst/>
+          </a:prstGeom>
+          <a:noFill/>
+        </p:spPr>
+        <p:txBody>
+          <a:bodyPr wrap="square">
+            <a:spAutoFit/>
+          </a:bodyPr>
+          <a:lstStyle/>
+          <a:p>
+            <a:pPr algn="l">
+              <a:spcAft>
+                <a:spcPts val="400"/>
+              </a:spcAft>
+            </a:pPr>
+            <a:r>
+              <a:rPr sz="2400" b="0">
+                <a:solidFill>
+                  <a:srgbClr val="2D2D2D"/>
+                </a:solidFill>
+                <a:latin typeface="Calibri"/>
+              </a:rPr>
+              <a:t>An abstract model of a database: five dimensions</a:t>
+            </a:r>
+          </a:p>
+        </p:txBody>
+      </p:sp>
+      <p:sp>
+        <p:nvSpPr>
+          <p:cNvPr id="3" name="Card"/>
+          <p:cNvSpPr/>
+          <p:nvPr/>
+        </p:nvSpPr>
+        <p:spPr>
+          <a:xfrm>
+            <a:off x="411480" y="914400"/>
+            <a:ext cx="8321040" cy="841248"/>
+          </a:xfrm>
+          <a:prstGeom prst="rect">
+            <a:avLst/>
+          </a:prstGeom>
+          <a:solidFill>
+            <a:srgbClr val="F5F1E8"/>
+          </a:solidFill>
+          <a:ln>
+            <a:noFill/>
+          </a:ln>
+          <a:effectLst/>
+        </p:spPr>
+        <p:style>
+          <a:lnRef idx="1">
+            <a:schemeClr val="accent1"/>
+          </a:lnRef>
+          <a:fillRef idx="3">
+            <a:schemeClr val="accent1"/>
+          </a:fillRef>
+          <a:effectRef idx="2">
+            <a:schemeClr val="accent1"/>
+          </a:effectRef>
+          <a:fontRef idx="minor">
+            <a:schemeClr val="lt1"/>
+          </a:fontRef>
+        </p:style>
+        <p:txBody>
+          <a:bodyPr rtlCol="0" anchor="ctr" wrap="square"/>
+          <a:lstStyle/>
+          <a:p>
+            <a:pPr algn="ctr"/>
+          </a:p>
+        </p:txBody>
+      </p:sp>
+      <p:sp>
+        <p:nvSpPr>
+          <p:cNvPr id="4" name="RowLabel"/>
+          <p:cNvSpPr txBox="1"/>
+          <p:nvPr/>
+        </p:nvSpPr>
+        <p:spPr>
+          <a:xfrm>
+            <a:off x="557784" y="950976"/>
+            <a:ext cx="2103120" cy="768096"/>
+          </a:xfrm>
+          <a:prstGeom prst="rect">
+            <a:avLst/>
+          </a:prstGeom>
+          <a:noFill/>
+        </p:spPr>
+        <p:txBody>
+          <a:bodyPr wrap="square" anchor="ctr">
+            <a:spAutoFit/>
+          </a:bodyPr>
+          <a:lstStyle/>
+          <a:p>
+            <a:pPr algn="l">
+              <a:spcAft>
+                <a:spcPts val="400"/>
+              </a:spcAft>
+            </a:pPr>
+            <a:r>
+              <a:rPr sz="2000" b="1">
+                <a:solidFill>
+                  <a:srgbClr val="8E6F3E"/>
+                </a:solidFill>
+                <a:latin typeface="Calibri"/>
+              </a:rPr>
+              <a:t>Data model</a:t>
+            </a:r>
+          </a:p>
+        </p:txBody>
+      </p:sp>
+      <p:sp>
+        <p:nvSpPr>
+          <p:cNvPr id="5" name="RowBody"/>
+          <p:cNvSpPr txBox="1"/>
+          <p:nvPr/>
+        </p:nvSpPr>
+        <p:spPr>
+          <a:xfrm>
+            <a:off x="2752344" y="950976"/>
+            <a:ext cx="5833872" cy="768096"/>
+          </a:xfrm>
+          <a:prstGeom prst="rect">
+            <a:avLst/>
+          </a:prstGeom>
+          <a:noFill/>
+        </p:spPr>
+        <p:txBody>
+          <a:bodyPr wrap="square">
+            <a:spAutoFit/>
+          </a:bodyPr>
+          <a:lstStyle/>
+          <a:p>
+            <a:pPr algn="l">
+              <a:spcAft>
+                <a:spcPts val="100"/>
+              </a:spcAft>
+            </a:pPr>
+            <a:r>
+              <a:rPr sz="2000" b="1">
+                <a:solidFill>
+                  <a:srgbClr val="5C4826"/>
+                </a:solidFill>
+                <a:latin typeface="Calibri"/>
+              </a:rPr>
+              <a:t>How is information represented?</a:t>
+            </a:r>
+          </a:p>
+          <a:p>
+            <a:pPr algn="l">
+              <a:spcAft>
+                <a:spcPts val="400"/>
+              </a:spcAft>
+            </a:pPr>
+            <a:r>
+              <a:rPr sz="2000" b="0">
+                <a:solidFill>
+                  <a:srgbClr val="555960"/>
+                </a:solidFill>
+                <a:latin typeface="Calibri"/>
+              </a:rPr>
+              <a:t>relations · documents · key-value pairs · graphs</a:t>
+            </a:r>
+          </a:p>
+        </p:txBody>
+      </p:sp>
+      <p:sp>
+        <p:nvSpPr>
+          <p:cNvPr id="6" name="Card"/>
+          <p:cNvSpPr/>
+          <p:nvPr/>
+        </p:nvSpPr>
+        <p:spPr>
+          <a:xfrm>
+            <a:off x="411480" y="1828800"/>
+            <a:ext cx="8321040" cy="841248"/>
+          </a:xfrm>
+          <a:prstGeom prst="rect">
+            <a:avLst/>
+          </a:prstGeom>
+          <a:solidFill>
+            <a:srgbClr val="FCFAF6"/>
+          </a:solidFill>
+          <a:ln>
+            <a:noFill/>
+          </a:ln>
+          <a:effectLst/>
+        </p:spPr>
+        <p:style>
+          <a:lnRef idx="1">
+            <a:schemeClr val="accent1"/>
+          </a:lnRef>
+          <a:fillRef idx="3">
+            <a:schemeClr val="accent1"/>
+          </a:fillRef>
+          <a:effectRef idx="2">
+            <a:schemeClr val="accent1"/>
+          </a:effectRef>
+          <a:fontRef idx="minor">
+            <a:schemeClr val="lt1"/>
+          </a:fontRef>
+        </p:style>
+        <p:txBody>
+          <a:bodyPr rtlCol="0" anchor="ctr" wrap="square"/>
+          <a:lstStyle/>
+          <a:p>
+            <a:pPr algn="ctr"/>
+          </a:p>
+        </p:txBody>
+      </p:sp>
+      <p:sp>
+        <p:nvSpPr>
+          <p:cNvPr id="7" name="RowLabel"/>
+          <p:cNvSpPr txBox="1"/>
+          <p:nvPr/>
+        </p:nvSpPr>
+        <p:spPr>
+          <a:xfrm>
+            <a:off x="557784" y="1865376"/>
+            <a:ext cx="2103120" cy="768096"/>
+          </a:xfrm>
+          <a:prstGeom prst="rect">
+            <a:avLst/>
+          </a:prstGeom>
+          <a:noFill/>
+        </p:spPr>
+        <p:txBody>
+          <a:bodyPr wrap="square" anchor="ctr">
+            <a:spAutoFit/>
+          </a:bodyPr>
+          <a:lstStyle/>
+          <a:p>
+            <a:pPr algn="l">
+              <a:spcAft>
+                <a:spcPts val="400"/>
+              </a:spcAft>
+            </a:pPr>
+            <a:r>
+              <a:rPr sz="2000" b="1">
+                <a:solidFill>
+                  <a:srgbClr val="8E6F3E"/>
+                </a:solidFill>
+                <a:latin typeface="Calibri"/>
+              </a:rPr>
+              <a:t>Semantics</a:t>
+            </a:r>
+          </a:p>
+        </p:txBody>
+      </p:sp>
+      <p:sp>
+        <p:nvSpPr>
+          <p:cNvPr id="8" name="RowBody"/>
+          <p:cNvSpPr txBox="1"/>
+          <p:nvPr/>
+        </p:nvSpPr>
+        <p:spPr>
+          <a:xfrm>
+            <a:off x="2752344" y="1865376"/>
+            <a:ext cx="5833872" cy="768096"/>
+          </a:xfrm>
+          <a:prstGeom prst="rect">
+            <a:avLst/>
+          </a:prstGeom>
+          <a:noFill/>
+        </p:spPr>
+        <p:txBody>
+          <a:bodyPr wrap="square">
+            <a:spAutoFit/>
+          </a:bodyPr>
+          <a:lstStyle/>
+          <a:p>
+            <a:pPr algn="l">
+              <a:spcAft>
+                <a:spcPts val="100"/>
+              </a:spcAft>
+            </a:pPr>
+            <a:r>
+              <a:rPr sz="2000" b="1">
+                <a:solidFill>
+                  <a:srgbClr val="5C4826"/>
+                </a:solidFill>
+                <a:latin typeface="Calibri"/>
+              </a:rPr>
+              <a:t>What does it promise about the data?</a:t>
+            </a:r>
+          </a:p>
+          <a:p>
+            <a:pPr algn="l">
+              <a:spcAft>
+                <a:spcPts val="400"/>
+              </a:spcAft>
+            </a:pPr>
+            <a:r>
+              <a:rPr sz="2000" b="0">
+                <a:solidFill>
+                  <a:srgbClr val="555960"/>
+                </a:solidFill>
+                <a:latin typeface="Calibri"/>
+              </a:rPr>
+              <a:t>schema constraints · durability · consistency</a:t>
+            </a:r>
+          </a:p>
+        </p:txBody>
+      </p:sp>
+      <p:sp>
+        <p:nvSpPr>
+          <p:cNvPr id="9" name="Card"/>
+          <p:cNvSpPr/>
+          <p:nvPr/>
+        </p:nvSpPr>
+        <p:spPr>
+          <a:xfrm>
+            <a:off x="411480" y="2743200"/>
+            <a:ext cx="8321040" cy="841248"/>
+          </a:xfrm>
+          <a:prstGeom prst="rect">
+            <a:avLst/>
+          </a:prstGeom>
+          <a:solidFill>
+            <a:srgbClr val="F5F1E8"/>
+          </a:solidFill>
+          <a:ln>
+            <a:noFill/>
+          </a:ln>
+          <a:effectLst/>
+        </p:spPr>
+        <p:style>
+          <a:lnRef idx="1">
+            <a:schemeClr val="accent1"/>
+          </a:lnRef>
+          <a:fillRef idx="3">
+            <a:schemeClr val="accent1"/>
+          </a:fillRef>
+          <a:effectRef idx="2">
+            <a:schemeClr val="accent1"/>
+          </a:effectRef>
+          <a:fontRef idx="minor">
+            <a:schemeClr val="lt1"/>
+          </a:fontRef>
+        </p:style>
+        <p:txBody>
+          <a:bodyPr rtlCol="0" anchor="ctr" wrap="square"/>
+          <a:lstStyle/>
+          <a:p>
+            <a:pPr algn="ctr"/>
+          </a:p>
+        </p:txBody>
+      </p:sp>
+      <p:sp>
+        <p:nvSpPr>
+          <p:cNvPr id="10" name="RowLabel"/>
+          <p:cNvSpPr txBox="1"/>
+          <p:nvPr/>
+        </p:nvSpPr>
+        <p:spPr>
+          <a:xfrm>
+            <a:off x="557784" y="2779776"/>
+            <a:ext cx="2103120" cy="768096"/>
+          </a:xfrm>
+          <a:prstGeom prst="rect">
+            <a:avLst/>
+          </a:prstGeom>
+          <a:noFill/>
+        </p:spPr>
+        <p:txBody>
+          <a:bodyPr wrap="square" anchor="ctr">
+            <a:spAutoFit/>
+          </a:bodyPr>
+          <a:lstStyle/>
+          <a:p>
+            <a:pPr algn="l">
+              <a:spcAft>
+                <a:spcPts val="400"/>
+              </a:spcAft>
+            </a:pPr>
+            <a:r>
+              <a:rPr sz="2000" b="1">
+                <a:solidFill>
+                  <a:srgbClr val="8E6F3E"/>
+                </a:solidFill>
+                <a:latin typeface="Calibri"/>
+              </a:rPr>
+              <a:t>Query interface</a:t>
+            </a:r>
+          </a:p>
+        </p:txBody>
+      </p:sp>
+      <p:sp>
+        <p:nvSpPr>
+          <p:cNvPr id="11" name="RowBody"/>
+          <p:cNvSpPr txBox="1"/>
+          <p:nvPr/>
+        </p:nvSpPr>
+        <p:spPr>
+          <a:xfrm>
+            <a:off x="2752344" y="2779776"/>
+            <a:ext cx="5833872" cy="768096"/>
+          </a:xfrm>
+          <a:prstGeom prst="rect">
+            <a:avLst/>
+          </a:prstGeom>
+          <a:noFill/>
+        </p:spPr>
+        <p:txBody>
+          <a:bodyPr wrap="square">
+            <a:spAutoFit/>
+          </a:bodyPr>
+          <a:lstStyle/>
+          <a:p>
+            <a:pPr algn="l">
+              <a:spcAft>
+                <a:spcPts val="100"/>
+              </a:spcAft>
+            </a:pPr>
+            <a:r>
+              <a:rPr sz="2000" b="1">
+                <a:solidFill>
+                  <a:srgbClr val="5C4826"/>
+                </a:solidFill>
+                <a:latin typeface="Calibri"/>
+              </a:rPr>
+              <a:t>How does the app express its needs?</a:t>
+            </a:r>
+          </a:p>
+          <a:p>
+            <a:pPr algn="l">
+              <a:spcAft>
+                <a:spcPts val="400"/>
+              </a:spcAft>
+            </a:pPr>
+            <a:r>
+              <a:rPr sz="2000" b="0">
+                <a:solidFill>
+                  <a:srgbClr val="555960"/>
+                </a:solidFill>
+                <a:latin typeface="Calibri"/>
+              </a:rPr>
+              <a:t>SQL · document queries · ORM</a:t>
+            </a:r>
+          </a:p>
+        </p:txBody>
+      </p:sp>
+      <p:sp>
+        <p:nvSpPr>
+          <p:cNvPr id="12" name="Card"/>
+          <p:cNvSpPr/>
+          <p:nvPr/>
+        </p:nvSpPr>
+        <p:spPr>
+          <a:xfrm>
+            <a:off x="411480" y="3657600"/>
+            <a:ext cx="8321040" cy="841248"/>
+          </a:xfrm>
+          <a:prstGeom prst="rect">
+            <a:avLst/>
+          </a:prstGeom>
+          <a:solidFill>
+            <a:srgbClr val="FCFAF6"/>
+          </a:solidFill>
+          <a:ln>
+            <a:noFill/>
+          </a:ln>
+          <a:effectLst/>
+        </p:spPr>
+        <p:style>
+          <a:lnRef idx="1">
+            <a:schemeClr val="accent1"/>
+          </a:lnRef>
+          <a:fillRef idx="3">
+            <a:schemeClr val="accent1"/>
+          </a:fillRef>
+          <a:effectRef idx="2">
+            <a:schemeClr val="accent1"/>
+          </a:effectRef>
+          <a:fontRef idx="minor">
+            <a:schemeClr val="lt1"/>
+          </a:fontRef>
+        </p:style>
+        <p:txBody>
+          <a:bodyPr rtlCol="0" anchor="ctr" wrap="square"/>
+          <a:lstStyle/>
+          <a:p>
+            <a:pPr algn="ctr"/>
+          </a:p>
+        </p:txBody>
+      </p:sp>
+      <p:sp>
+        <p:nvSpPr>
+          <p:cNvPr id="13" name="RowLabel"/>
+          <p:cNvSpPr txBox="1"/>
+          <p:nvPr/>
+        </p:nvSpPr>
+        <p:spPr>
+          <a:xfrm>
+            <a:off x="557784" y="3694176"/>
+            <a:ext cx="2103120" cy="768096"/>
+          </a:xfrm>
+          <a:prstGeom prst="rect">
+            <a:avLst/>
+          </a:prstGeom>
+          <a:noFill/>
+        </p:spPr>
+        <p:txBody>
+          <a:bodyPr wrap="square" anchor="ctr">
+            <a:spAutoFit/>
+          </a:bodyPr>
+          <a:lstStyle/>
+          <a:p>
+            <a:pPr algn="l">
+              <a:spcAft>
+                <a:spcPts val="400"/>
+              </a:spcAft>
+            </a:pPr>
+            <a:r>
+              <a:rPr sz="2000" b="1">
+                <a:solidFill>
+                  <a:srgbClr val="8E6F3E"/>
+                </a:solidFill>
+                <a:latin typeface="Calibri"/>
+              </a:rPr>
+              <a:t>Concurrency</a:t>
+            </a:r>
+          </a:p>
+        </p:txBody>
+      </p:sp>
+      <p:sp>
+        <p:nvSpPr>
+          <p:cNvPr id="14" name="RowBody"/>
+          <p:cNvSpPr txBox="1"/>
+          <p:nvPr/>
+        </p:nvSpPr>
+        <p:spPr>
+          <a:xfrm>
+            <a:off x="2752344" y="3694176"/>
+            <a:ext cx="5833872" cy="768096"/>
+          </a:xfrm>
+          <a:prstGeom prst="rect">
+            <a:avLst/>
+          </a:prstGeom>
+          <a:noFill/>
+        </p:spPr>
+        <p:txBody>
+          <a:bodyPr wrap="square">
+            <a:spAutoFit/>
+          </a:bodyPr>
+          <a:lstStyle/>
+          <a:p>
+            <a:pPr algn="l">
+              <a:spcAft>
+                <a:spcPts val="100"/>
+              </a:spcAft>
+            </a:pPr>
+            <a:r>
+              <a:rPr sz="2000" b="1">
+                <a:solidFill>
+                  <a:srgbClr val="5C4826"/>
+                </a:solidFill>
+                <a:latin typeface="Calibri"/>
+              </a:rPr>
+              <a:t>What happens when operations overlap?</a:t>
+            </a:r>
+          </a:p>
+          <a:p>
+            <a:pPr algn="l">
+              <a:spcAft>
+                <a:spcPts val="400"/>
+              </a:spcAft>
+            </a:pPr>
+            <a:r>
+              <a:rPr sz="2000" b="0">
+                <a:solidFill>
+                  <a:srgbClr val="555960"/>
+                </a:solidFill>
+                <a:latin typeface="Calibri"/>
+              </a:rPr>
+              <a:t>transactions · isolation · optimistic control</a:t>
+            </a:r>
+          </a:p>
+        </p:txBody>
+      </p:sp>
+      <p:sp>
+        <p:nvSpPr>
+          <p:cNvPr id="15" name="Card"/>
+          <p:cNvSpPr/>
+          <p:nvPr/>
+        </p:nvSpPr>
+        <p:spPr>
+          <a:xfrm>
+            <a:off x="411480" y="4572000"/>
+            <a:ext cx="8321040" cy="841248"/>
+          </a:xfrm>
+          <a:prstGeom prst="rect">
+            <a:avLst/>
+          </a:prstGeom>
+          <a:solidFill>
+            <a:srgbClr val="F5F1E8"/>
+          </a:solidFill>
+          <a:ln>
+            <a:noFill/>
+          </a:ln>
+          <a:effectLst/>
+        </p:spPr>
+        <p:style>
+          <a:lnRef idx="1">
+            <a:schemeClr val="accent1"/>
+          </a:lnRef>
+          <a:fillRef idx="3">
+            <a:schemeClr val="accent1"/>
+          </a:fillRef>
+          <a:effectRef idx="2">
+            <a:schemeClr val="accent1"/>
+          </a:effectRef>
+          <a:fontRef idx="minor">
+            <a:schemeClr val="lt1"/>
+          </a:fontRef>
+        </p:style>
+        <p:txBody>
+          <a:bodyPr rtlCol="0" anchor="ctr" wrap="square"/>
+          <a:lstStyle/>
+          <a:p>
+            <a:pPr algn="ctr"/>
+          </a:p>
+        </p:txBody>
+      </p:sp>
+      <p:sp>
+        <p:nvSpPr>
+          <p:cNvPr id="16" name="RowLabel"/>
+          <p:cNvSpPr txBox="1"/>
+          <p:nvPr/>
+        </p:nvSpPr>
+        <p:spPr>
+          <a:xfrm>
+            <a:off x="557784" y="4608576"/>
+            <a:ext cx="2103120" cy="768096"/>
+          </a:xfrm>
+          <a:prstGeom prst="rect">
+            <a:avLst/>
+          </a:prstGeom>
+          <a:noFill/>
+        </p:spPr>
+        <p:txBody>
+          <a:bodyPr wrap="square" anchor="ctr">
+            <a:spAutoFit/>
+          </a:bodyPr>
+          <a:lstStyle/>
+          <a:p>
+            <a:pPr algn="l">
+              <a:spcAft>
+                <a:spcPts val="400"/>
+              </a:spcAft>
+            </a:pPr>
+            <a:r>
+              <a:rPr sz="2000" b="1">
+                <a:solidFill>
+                  <a:srgbClr val="8E6F3E"/>
+                </a:solidFill>
+                <a:latin typeface="Calibri"/>
+              </a:rPr>
+              <a:t>Scalability</a:t>
+            </a:r>
+          </a:p>
+        </p:txBody>
+      </p:sp>
+      <p:sp>
+        <p:nvSpPr>
+          <p:cNvPr id="17" name="RowBody"/>
+          <p:cNvSpPr txBox="1"/>
+          <p:nvPr/>
+        </p:nvSpPr>
+        <p:spPr>
+          <a:xfrm>
+            <a:off x="2752344" y="4608576"/>
+            <a:ext cx="5833872" cy="768096"/>
+          </a:xfrm>
+          <a:prstGeom prst="rect">
+            <a:avLst/>
+          </a:prstGeom>
+          <a:noFill/>
+        </p:spPr>
+        <p:txBody>
+          <a:bodyPr wrap="square">
+            <a:spAutoFit/>
+          </a:bodyPr>
+          <a:lstStyle/>
+          <a:p>
+            <a:pPr algn="l">
+              <a:spcAft>
+                <a:spcPts val="100"/>
+              </a:spcAft>
+            </a:pPr>
+            <a:r>
+              <a:rPr sz="2000" b="1">
+                <a:solidFill>
+                  <a:srgbClr val="5C4826"/>
+                </a:solidFill>
+                <a:latin typeface="Calibri"/>
+              </a:rPr>
+              <a:t>How does it behave as demand grows?</a:t>
+            </a:r>
+          </a:p>
+          <a:p>
+            <a:pPr algn="l">
+              <a:spcAft>
+                <a:spcPts val="400"/>
+              </a:spcAft>
+            </a:pPr>
+            <a:r>
+              <a:rPr sz="2000" b="0">
+                <a:solidFill>
+                  <a:srgbClr val="555960"/>
+                </a:solidFill>
+                <a:latin typeface="Calibri"/>
+              </a:rPr>
+              <a:t>indexing · replication · partitioning</a:t>
+            </a:r>
+          </a:p>
+        </p:txBody>
+      </p:sp>
+      <p:sp>
+        <p:nvSpPr>
+          <p:cNvPr id="18" name="OperationsNote"/>
+          <p:cNvSpPr txBox="1"/>
+          <p:nvPr/>
+        </p:nvSpPr>
+        <p:spPr>
+          <a:xfrm>
+            <a:off x="411480" y="5504688"/>
+            <a:ext cx="8321040" cy="347472"/>
+          </a:xfrm>
+          <a:prstGeom prst="rect">
+            <a:avLst/>
+          </a:prstGeom>
+          <a:noFill/>
+        </p:spPr>
+        <p:txBody>
+          <a:bodyPr wrap="square">
+            <a:spAutoFit/>
+          </a:bodyPr>
+          <a:lstStyle/>
+          <a:p>
+            <a:pPr algn="l">
+              <a:spcAft>
+                <a:spcPts val="400"/>
+              </a:spcAft>
+            </a:pPr>
+            <a:r>
+              <a:rPr sz="2000" b="0">
+                <a:solidFill>
+                  <a:srgbClr val="555960"/>
+                </a:solidFill>
+                <a:latin typeface="Calibri"/>
+              </a:rPr>
+              <a:t>Sixth, Operations — backup, recovery, migration — deferred to Unit 6</a:t>
+            </a:r>
+          </a:p>
+        </p:txBody>
+      </p:sp>
+      <p:sp>
+        <p:nvSpPr>
+          <p:cNvPr id="19" name="FooterBand"/>
+          <p:cNvSpPr/>
+          <p:nvPr/>
+        </p:nvSpPr>
+        <p:spPr>
+          <a:xfrm>
+            <a:off x="274320" y="5879592"/>
+            <a:ext cx="8595360" cy="502920"/>
+          </a:xfrm>
+          <a:prstGeom prst="rect">
+            <a:avLst/>
+          </a:prstGeom>
+          <a:solidFill>
+            <a:srgbClr val="8E6F3E"/>
+          </a:solidFill>
+          <a:ln>
+            <a:noFill/>
+          </a:ln>
+          <a:effectLst/>
+        </p:spPr>
+        <p:style>
+          <a:lnRef idx="1">
+            <a:schemeClr val="accent1"/>
+          </a:lnRef>
+          <a:fillRef idx="3">
+            <a:schemeClr val="accent1"/>
+          </a:fillRef>
+          <a:effectRef idx="2">
+            <a:schemeClr val="accent1"/>
+          </a:effectRef>
+          <a:fontRef idx="minor">
+            <a:schemeClr val="lt1"/>
+          </a:fontRef>
+        </p:style>
+        <p:txBody>
+          <a:bodyPr rtlCol="0" anchor="ctr" wrap="square"/>
+          <a:lstStyle/>
+          <a:p>
+            <a:pPr algn="ctr"/>
+          </a:p>
+        </p:txBody>
+      </p:sp>
+      <p:sp>
+        <p:nvSpPr>
+          <p:cNvPr id="20" name="FooterBandText"/>
+          <p:cNvSpPr txBox="1"/>
+          <p:nvPr/>
+        </p:nvSpPr>
+        <p:spPr>
+          <a:xfrm>
+            <a:off x="384048" y="5897880"/>
+            <a:ext cx="8375904" cy="457200"/>
+          </a:xfrm>
+          <a:prstGeom prst="rect">
+            <a:avLst/>
+          </a:prstGeom>
+          <a:noFill/>
+        </p:spPr>
+        <p:txBody>
+          <a:bodyPr wrap="square">
+            <a:spAutoFit/>
+          </a:bodyPr>
+          <a:lstStyle/>
+          <a:p>
+            <a:pPr algn="ctr">
+              <a:spcAft>
+                <a:spcPts val="400"/>
+              </a:spcAft>
+            </a:pPr>
+            <a:r>
+              <a:rPr sz="2000" b="1">
+                <a:solidFill>
+                  <a:srgbClr val="FFFFFF"/>
+                </a:solidFill>
+                <a:latin typeface="Calibri"/>
+              </a:rPr>
+              <a:t>Separate what the app REQUIRES from what the database GUARANTEES</a:t>
+            </a:r>
+          </a:p>
+        </p:txBody>
+      </p:sp>
+    </p:spTree>
+  </p:cSld>
+  <p:clrMapOvr>
+    <a:masterClrMapping/>
+  </p:clrMapOvr>
+</p:sld>
+</file>
+
+<file path=ppt/slides/slide5.xml><?xml version="1.0" encoding="utf-8"?>
+<p:sld xmlns:a="http://schemas.openxmlformats.org/drawingml/2006/main" xmlns:p="http://schemas.openxmlformats.org/presentationml/2006/main" xmlns:r="http://schemas.openxmlformats.org/officeDocument/2006/relationships">
+  <p:cSld>
+    <p:spTree>
+      <p:nvGrpSpPr>
+        <p:cNvPr id="1" name=""/>
+        <p:cNvGrpSpPr/>
+        <p:nvPr/>
+      </p:nvGrpSpPr>
+      <p:grpSpPr/>
+      <p:sp>
+        <p:nvSpPr>
+          <p:cNvPr id="2" name="Title"/>
+          <p:cNvSpPr txBox="1"/>
+          <p:nvPr/>
+        </p:nvSpPr>
+        <p:spPr>
+          <a:xfrm>
+            <a:off x="274320" y="128016"/>
+            <a:ext cx="8595360" cy="594360"/>
+          </a:xfrm>
+          <a:prstGeom prst="rect">
+            <a:avLst/>
+          </a:prstGeom>
+          <a:noFill/>
+        </p:spPr>
+        <p:txBody>
+          <a:bodyPr wrap="square">
+            <a:spAutoFit/>
+          </a:bodyPr>
+          <a:lstStyle/>
+          <a:p>
+            <a:pPr algn="l">
+              <a:spcAft>
+                <a:spcPts val="400"/>
+              </a:spcAft>
+            </a:pPr>
+            <a:r>
+              <a:rPr sz="2400" b="0">
+                <a:solidFill>
+                  <a:srgbClr val="2D2D2D"/>
+                </a:solidFill>
+                <a:latin typeface="Calibri"/>
+              </a:rPr>
+              <a:t>Four ways to represent a reservation</a:t>
+            </a:r>
+          </a:p>
+        </p:txBody>
+      </p:sp>
+      <p:sp>
+        <p:nvSpPr>
+          <p:cNvPr id="3" name="Card"/>
+          <p:cNvSpPr/>
+          <p:nvPr/>
+        </p:nvSpPr>
+        <p:spPr>
+          <a:xfrm>
+            <a:off x="411480" y="960120"/>
+            <a:ext cx="4069080" cy="2103120"/>
+          </a:xfrm>
+          <a:prstGeom prst="rect">
+            <a:avLst/>
+          </a:prstGeom>
+          <a:solidFill>
+            <a:srgbClr val="F5F1E8"/>
+          </a:solidFill>
+          <a:ln>
+            <a:noFill/>
+          </a:ln>
+          <a:effectLst/>
+        </p:spPr>
+        <p:style>
+          <a:lnRef idx="1">
+            <a:schemeClr val="accent1"/>
+          </a:lnRef>
+          <a:fillRef idx="3">
+            <a:schemeClr val="accent1"/>
+          </a:fillRef>
+          <a:effectRef idx="2">
+            <a:schemeClr val="accent1"/>
+          </a:effectRef>
+          <a:fontRef idx="minor">
+            <a:schemeClr val="lt1"/>
+          </a:fontRef>
+        </p:style>
+        <p:txBody>
+          <a:bodyPr rtlCol="0" anchor="ctr" wrap="square"/>
+          <a:lstStyle/>
+          <a:p>
+            <a:pPr algn="ctr"/>
+          </a:p>
+        </p:txBody>
+      </p:sp>
+      <p:sp>
+        <p:nvSpPr>
+          <p:cNvPr id="4" name="CardBody"/>
+          <p:cNvSpPr txBox="1"/>
+          <p:nvPr/>
+        </p:nvSpPr>
+        <p:spPr>
+          <a:xfrm>
+            <a:off x="557784" y="1051560"/>
+            <a:ext cx="3776472" cy="1920240"/>
+          </a:xfrm>
+          <a:prstGeom prst="rect">
+            <a:avLst/>
+          </a:prstGeom>
+          <a:noFill/>
+        </p:spPr>
+        <p:txBody>
+          <a:bodyPr wrap="square">
+            <a:spAutoFit/>
+          </a:bodyPr>
+          <a:lstStyle/>
+          <a:p>
+            <a:pPr algn="l">
+              <a:spcAft>
+                <a:spcPts val="400"/>
+              </a:spcAft>
+            </a:pPr>
+            <a:r>
+              <a:rPr sz="2000" b="1">
+                <a:solidFill>
+                  <a:srgbClr val="8E6F3E"/>
+                </a:solidFill>
+                <a:latin typeface="Calibri"/>
+              </a:rPr>
+              <a:t>RELATIONAL</a:t>
+            </a:r>
+          </a:p>
+          <a:p>
+            <a:pPr algn="l">
+              <a:spcAft>
+                <a:spcPts val="400"/>
+              </a:spcAft>
+            </a:pPr>
+            <a:r>
+              <a:rPr sz="2000" b="0">
+                <a:solidFill>
+                  <a:srgbClr val="5C4826"/>
+                </a:solidFill>
+                <a:latin typeface="Calibri"/>
+              </a:rPr>
+              <a:t>Tables of rows; relationships via keys</a:t>
+            </a:r>
+          </a:p>
+          <a:p>
+            <a:pPr algn="l">
+              <a:spcAft>
+                <a:spcPts val="400"/>
+              </a:spcAft>
+            </a:pPr>
+            <a:r>
+              <a:rPr sz="2000" b="0">
+                <a:solidFill>
+                  <a:srgbClr val="555960"/>
+                </a:solidFill>
+                <a:latin typeface="Calibri"/>
+              </a:rPr>
+              <a:t>Easy: joins, cross-row rules · Harder: deep nesting</a:t>
+            </a:r>
+          </a:p>
+        </p:txBody>
+      </p:sp>
+      <p:sp>
+        <p:nvSpPr>
+          <p:cNvPr id="5" name="Card"/>
+          <p:cNvSpPr/>
+          <p:nvPr/>
+        </p:nvSpPr>
+        <p:spPr>
+          <a:xfrm>
+            <a:off x="4663440" y="960120"/>
+            <a:ext cx="4069080" cy="2103120"/>
+          </a:xfrm>
+          <a:prstGeom prst="rect">
+            <a:avLst/>
+          </a:prstGeom>
+          <a:solidFill>
+            <a:srgbClr val="FCFAF6"/>
+          </a:solidFill>
+          <a:ln>
+            <a:noFill/>
+          </a:ln>
+          <a:effectLst/>
+        </p:spPr>
+        <p:style>
+          <a:lnRef idx="1">
+            <a:schemeClr val="accent1"/>
+          </a:lnRef>
+          <a:fillRef idx="3">
+            <a:schemeClr val="accent1"/>
+          </a:fillRef>
+          <a:effectRef idx="2">
+            <a:schemeClr val="accent1"/>
+          </a:effectRef>
+          <a:fontRef idx="minor">
+            <a:schemeClr val="lt1"/>
+          </a:fontRef>
+        </p:style>
+        <p:txBody>
+          <a:bodyPr rtlCol="0" anchor="ctr" wrap="square"/>
+          <a:lstStyle/>
+          <a:p>
+            <a:pPr algn="ctr"/>
+          </a:p>
+        </p:txBody>
+      </p:sp>
+      <p:sp>
+        <p:nvSpPr>
+          <p:cNvPr id="6" name="CardBody"/>
+          <p:cNvSpPr txBox="1"/>
+          <p:nvPr/>
+        </p:nvSpPr>
+        <p:spPr>
+          <a:xfrm>
+            <a:off x="4809744" y="1051560"/>
+            <a:ext cx="3776472" cy="1920240"/>
+          </a:xfrm>
+          <a:prstGeom prst="rect">
+            <a:avLst/>
+          </a:prstGeom>
+          <a:noFill/>
+        </p:spPr>
+        <p:txBody>
+          <a:bodyPr wrap="square">
+            <a:spAutoFit/>
+          </a:bodyPr>
+          <a:lstStyle/>
+          <a:p>
+            <a:pPr algn="l">
+              <a:spcAft>
+                <a:spcPts val="400"/>
+              </a:spcAft>
+            </a:pPr>
+            <a:r>
+              <a:rPr sz="2000" b="1">
+                <a:solidFill>
+                  <a:srgbClr val="8E6F3E"/>
+                </a:solidFill>
+                <a:latin typeface="Calibri"/>
+              </a:rPr>
+              <a:t>DOCUMENT</a:t>
+            </a:r>
+          </a:p>
+          <a:p>
+            <a:pPr algn="l">
+              <a:spcAft>
+                <a:spcPts val="400"/>
+              </a:spcAft>
+            </a:pPr>
+            <a:r>
+              <a:rPr sz="2000" b="0">
+                <a:solidFill>
+                  <a:srgbClr val="5C4826"/>
+                </a:solidFill>
+                <a:latin typeface="Calibri"/>
+              </a:rPr>
+              <a:t>A room document embeds its reservations (JSON)</a:t>
+            </a:r>
+          </a:p>
+          <a:p>
+            <a:pPr algn="l">
+              <a:spcAft>
+                <a:spcPts val="400"/>
+              </a:spcAft>
+            </a:pPr>
+            <a:r>
+              <a:rPr sz="2000" b="0">
+                <a:solidFill>
+                  <a:srgbClr val="555960"/>
+                </a:solidFill>
+                <a:latin typeface="Calibri"/>
+              </a:rPr>
+              <a:t>Easy: read one unit whole · Harder: cross-document rules</a:t>
+            </a:r>
+          </a:p>
+        </p:txBody>
+      </p:sp>
+      <p:sp>
+        <p:nvSpPr>
+          <p:cNvPr id="7" name="Card"/>
+          <p:cNvSpPr/>
+          <p:nvPr/>
+        </p:nvSpPr>
+        <p:spPr>
+          <a:xfrm>
+            <a:off x="411480" y="3246120"/>
+            <a:ext cx="4069080" cy="2103120"/>
+          </a:xfrm>
+          <a:prstGeom prst="rect">
+            <a:avLst/>
+          </a:prstGeom>
+          <a:solidFill>
+            <a:srgbClr val="FCFAF6"/>
+          </a:solidFill>
+          <a:ln>
+            <a:noFill/>
+          </a:ln>
+          <a:effectLst/>
+        </p:spPr>
+        <p:style>
+          <a:lnRef idx="1">
+            <a:schemeClr val="accent1"/>
+          </a:lnRef>
+          <a:fillRef idx="3">
+            <a:schemeClr val="accent1"/>
+          </a:fillRef>
+          <a:effectRef idx="2">
+            <a:schemeClr val="accent1"/>
+          </a:effectRef>
+          <a:fontRef idx="minor">
+            <a:schemeClr val="lt1"/>
+          </a:fontRef>
+        </p:style>
+        <p:txBody>
+          <a:bodyPr rtlCol="0" anchor="ctr" wrap="square"/>
+          <a:lstStyle/>
+          <a:p>
+            <a:pPr algn="ctr"/>
+          </a:p>
+        </p:txBody>
+      </p:sp>
+      <p:sp>
+        <p:nvSpPr>
+          <p:cNvPr id="8" name="CardBody"/>
+          <p:cNvSpPr txBox="1"/>
+          <p:nvPr/>
+        </p:nvSpPr>
+        <p:spPr>
+          <a:xfrm>
+            <a:off x="557784" y="3337560"/>
+            <a:ext cx="3776472" cy="1920240"/>
+          </a:xfrm>
+          <a:prstGeom prst="rect">
+            <a:avLst/>
+          </a:prstGeom>
+          <a:noFill/>
+        </p:spPr>
+        <p:txBody>
+          <a:bodyPr wrap="square">
+            <a:spAutoFit/>
+          </a:bodyPr>
+          <a:lstStyle/>
+          <a:p>
+            <a:pPr algn="l">
+              <a:spcAft>
+                <a:spcPts val="400"/>
+              </a:spcAft>
+            </a:pPr>
+            <a:r>
+              <a:rPr sz="2000" b="1">
+                <a:solidFill>
+                  <a:srgbClr val="8E6F3E"/>
+                </a:solidFill>
+                <a:latin typeface="Calibri"/>
+              </a:rPr>
+              <a:t>KEY-VALUE</a:t>
+            </a:r>
+          </a:p>
+          <a:p>
+            <a:pPr algn="l">
+              <a:spcAft>
+                <a:spcPts val="400"/>
+              </a:spcAft>
+            </a:pPr>
+            <a:r>
+              <a:rPr sz="2000" b="0">
+                <a:solidFill>
+                  <a:srgbClr val="5C4826"/>
+                </a:solidFill>
+                <a:latin typeface="Calibri"/>
+              </a:rPr>
+              <a:t>room:117 → an opaque value, fetched by key</a:t>
+            </a:r>
+          </a:p>
+          <a:p>
+            <a:pPr algn="l">
+              <a:spcAft>
+                <a:spcPts val="400"/>
+              </a:spcAft>
+            </a:pPr>
+            <a:r>
+              <a:rPr sz="2000" b="0">
+                <a:solidFill>
+                  <a:srgbClr val="555960"/>
+                </a:solidFill>
+                <a:latin typeface="Calibri"/>
+              </a:rPr>
+              <a:t>Easy: speed and scale · Harder: any other question</a:t>
+            </a:r>
+          </a:p>
+        </p:txBody>
+      </p:sp>
+      <p:sp>
+        <p:nvSpPr>
+          <p:cNvPr id="9" name="Card"/>
+          <p:cNvSpPr/>
+          <p:nvPr/>
+        </p:nvSpPr>
+        <p:spPr>
+          <a:xfrm>
+            <a:off x="4663440" y="3246120"/>
+            <a:ext cx="4069080" cy="2103120"/>
+          </a:xfrm>
+          <a:prstGeom prst="rect">
+            <a:avLst/>
+          </a:prstGeom>
+          <a:solidFill>
+            <a:srgbClr val="F5F1E8"/>
+          </a:solidFill>
+          <a:ln>
+            <a:noFill/>
+          </a:ln>
+          <a:effectLst/>
+        </p:spPr>
+        <p:style>
+          <a:lnRef idx="1">
+            <a:schemeClr val="accent1"/>
+          </a:lnRef>
+          <a:fillRef idx="3">
+            <a:schemeClr val="accent1"/>
+          </a:fillRef>
+          <a:effectRef idx="2">
+            <a:schemeClr val="accent1"/>
+          </a:effectRef>
+          <a:fontRef idx="minor">
+            <a:schemeClr val="lt1"/>
+          </a:fontRef>
+        </p:style>
+        <p:txBody>
+          <a:bodyPr rtlCol="0" anchor="ctr" wrap="square"/>
+          <a:lstStyle/>
+          <a:p>
+            <a:pPr algn="ctr"/>
+          </a:p>
+        </p:txBody>
+      </p:sp>
+      <p:sp>
+        <p:nvSpPr>
+          <p:cNvPr id="10" name="CardBody"/>
+          <p:cNvSpPr txBox="1"/>
+          <p:nvPr/>
+        </p:nvSpPr>
+        <p:spPr>
+          <a:xfrm>
+            <a:off x="4809744" y="3337560"/>
+            <a:ext cx="3776472" cy="1920240"/>
+          </a:xfrm>
+          <a:prstGeom prst="rect">
+            <a:avLst/>
+          </a:prstGeom>
+          <a:noFill/>
+        </p:spPr>
+        <p:txBody>
+          <a:bodyPr wrap="square">
+            <a:spAutoFit/>
+          </a:bodyPr>
+          <a:lstStyle/>
+          <a:p>
+            <a:pPr algn="l">
+              <a:spcAft>
+                <a:spcPts val="400"/>
+              </a:spcAft>
+            </a:pPr>
+            <a:r>
+              <a:rPr sz="2000" b="1">
+                <a:solidFill>
+                  <a:srgbClr val="8E6F3E"/>
+                </a:solidFill>
+                <a:latin typeface="Calibri"/>
+              </a:rPr>
+              <a:t>GRAPH</a:t>
+            </a:r>
+          </a:p>
+          <a:p>
+            <a:pPr algn="l">
+              <a:spcAft>
+                <a:spcPts val="400"/>
+              </a:spcAft>
+            </a:pPr>
+            <a:r>
+              <a:rPr sz="2000" b="0">
+                <a:solidFill>
+                  <a:srgbClr val="5C4826"/>
+                </a:solidFill>
+                <a:latin typeface="Calibri"/>
+              </a:rPr>
+              <a:t>Nodes (user, room) and edges (RESERVED)</a:t>
+            </a:r>
+          </a:p>
+          <a:p>
+            <a:pPr algn="l">
+              <a:spcAft>
+                <a:spcPts val="400"/>
+              </a:spcAft>
+            </a:pPr>
+            <a:r>
+              <a:rPr sz="2000" b="0">
+                <a:solidFill>
+                  <a:srgbClr val="555960"/>
+                </a:solidFill>
+                <a:latin typeface="Calibri"/>
+              </a:rPr>
+              <a:t>Easy: traversals · Harder: bulk aggregates</a:t>
+            </a:r>
+          </a:p>
+        </p:txBody>
+      </p:sp>
+      <p:sp>
+        <p:nvSpPr>
+          <p:cNvPr id="11" name="FooterBand"/>
+          <p:cNvSpPr/>
+          <p:nvPr/>
+        </p:nvSpPr>
+        <p:spPr>
+          <a:xfrm>
+            <a:off x="274320" y="5879592"/>
+            <a:ext cx="8595360" cy="502920"/>
+          </a:xfrm>
+          <a:prstGeom prst="rect">
+            <a:avLst/>
+          </a:prstGeom>
+          <a:solidFill>
+            <a:srgbClr val="8E6F3E"/>
+          </a:solidFill>
+          <a:ln>
+            <a:noFill/>
+          </a:ln>
+          <a:effectLst/>
+        </p:spPr>
+        <p:style>
+          <a:lnRef idx="1">
+            <a:schemeClr val="accent1"/>
+          </a:lnRef>
+          <a:fillRef idx="3">
+            <a:schemeClr val="accent1"/>
+          </a:fillRef>
+          <a:effectRef idx="2">
+            <a:schemeClr val="accent1"/>
+          </a:effectRef>
+          <a:fontRef idx="minor">
+            <a:schemeClr val="lt1"/>
+          </a:fontRef>
+        </p:style>
+        <p:txBody>
+          <a:bodyPr rtlCol="0" anchor="ctr" wrap="square"/>
+          <a:lstStyle/>
+          <a:p>
+            <a:pPr algn="ctr"/>
+          </a:p>
+        </p:txBody>
+      </p:sp>
+      <p:sp>
+        <p:nvSpPr>
+          <p:cNvPr id="12" name="FooterBandText"/>
+          <p:cNvSpPr txBox="1"/>
+          <p:nvPr/>
+        </p:nvSpPr>
+        <p:spPr>
+          <a:xfrm>
+            <a:off x="384048" y="5897880"/>
+            <a:ext cx="8375904" cy="457200"/>
+          </a:xfrm>
+          <a:prstGeom prst="rect">
+            <a:avLst/>
+          </a:prstGeom>
+          <a:noFill/>
+        </p:spPr>
+        <p:txBody>
+          <a:bodyPr wrap="square">
+            <a:spAutoFit/>
+          </a:bodyPr>
+          <a:lstStyle/>
+          <a:p>
+            <a:pPr algn="ctr">
+              <a:spcAft>
+                <a:spcPts val="400"/>
+              </a:spcAft>
+            </a:pPr>
+            <a:r>
+              <a:rPr sz="2000" b="1">
+                <a:solidFill>
+                  <a:srgbClr val="FFFFFF"/>
+                </a:solidFill>
+                <a:latin typeface="Calibri"/>
+              </a:rPr>
+              <a:t>Same facts, four native shapes — the choice changes what is easy</a:t>
+            </a:r>
+          </a:p>
+        </p:txBody>
+      </p:sp>
+    </p:spTree>
+  </p:cSld>
+  <p:clrMapOvr>
+    <a:masterClrMapping/>
+  </p:clrMapOvr>
+</p:sld>
+</file>
+
+<file path=ppt/slides/slide6.xml><?xml version="1.0" encoding="utf-8"?>
+<p:sld xmlns:a="http://schemas.openxmlformats.org/drawingml/2006/main" xmlns:p="http://schemas.openxmlformats.org/presentationml/2006/main" xmlns:r="http://schemas.openxmlformats.org/officeDocument/2006/relationships">
+  <p:cSld>
+    <p:spTree>
+      <p:nvGrpSpPr>
+        <p:cNvPr id="1" name=""/>
+        <p:cNvGrpSpPr/>
+        <p:nvPr/>
+      </p:nvGrpSpPr>
+      <p:grpSpPr/>
+      <p:sp>
+        <p:nvSpPr>
+          <p:cNvPr id="2" name="Title"/>
+          <p:cNvSpPr txBox="1"/>
+          <p:nvPr/>
+        </p:nvSpPr>
+        <p:spPr>
+          <a:xfrm>
+            <a:off x="274320" y="128016"/>
+            <a:ext cx="8595360" cy="594360"/>
+          </a:xfrm>
+          <a:prstGeom prst="rect">
+            <a:avLst/>
+          </a:prstGeom>
+          <a:noFill/>
+        </p:spPr>
+        <p:txBody>
+          <a:bodyPr wrap="square">
+            <a:spAutoFit/>
+          </a:bodyPr>
+          <a:lstStyle/>
+          <a:p>
+            <a:pPr algn="l">
+              <a:spcAft>
+                <a:spcPts val="400"/>
+              </a:spcAft>
+            </a:pPr>
+            <a:r>
+              <a:rPr sz="2400" b="0">
+                <a:solidFill>
+                  <a:srgbClr val="2D2D2D"/>
+                </a:solidFill>
+                <a:latin typeface="Calibri"/>
+              </a:rPr>
+              <a:t>Relational vs NoSQL is a requirements question</a:t>
+            </a:r>
+          </a:p>
+        </p:txBody>
+      </p:sp>
+      <p:sp>
+        <p:nvSpPr>
+          <p:cNvPr id="3" name="Card"/>
+          <p:cNvSpPr/>
+          <p:nvPr/>
+        </p:nvSpPr>
+        <p:spPr>
+          <a:xfrm>
+            <a:off x="411480" y="960120"/>
+            <a:ext cx="4069080" cy="2057400"/>
+          </a:xfrm>
+          <a:prstGeom prst="rect">
+            <a:avLst/>
+          </a:prstGeom>
+          <a:solidFill>
+            <a:srgbClr val="FCFAF6"/>
+          </a:solidFill>
+          <a:ln>
+            <a:noFill/>
+          </a:ln>
+          <a:effectLst/>
+        </p:spPr>
+        <p:style>
+          <a:lnRef idx="1">
+            <a:schemeClr val="accent1"/>
+          </a:lnRef>
+          <a:fillRef idx="3">
+            <a:schemeClr val="accent1"/>
+          </a:fillRef>
+          <a:effectRef idx="2">
+            <a:schemeClr val="accent1"/>
+          </a:effectRef>
+          <a:fontRef idx="minor">
+            <a:schemeClr val="lt1"/>
+          </a:fontRef>
+        </p:style>
+        <p:txBody>
+          <a:bodyPr rtlCol="0" anchor="ctr" wrap="square"/>
+          <a:lstStyle/>
+          <a:p>
+            <a:pPr algn="ctr"/>
+          </a:p>
+        </p:txBody>
+      </p:sp>
+      <p:sp>
+        <p:nvSpPr>
+          <p:cNvPr id="4" name="CardBody"/>
+          <p:cNvSpPr txBox="1"/>
+          <p:nvPr/>
+        </p:nvSpPr>
+        <p:spPr>
+          <a:xfrm>
+            <a:off x="557784" y="1051560"/>
+            <a:ext cx="3776472" cy="1874519"/>
+          </a:xfrm>
+          <a:prstGeom prst="rect">
+            <a:avLst/>
+          </a:prstGeom>
+          <a:noFill/>
+        </p:spPr>
+        <p:txBody>
+          <a:bodyPr wrap="square">
+            <a:spAutoFit/>
+          </a:bodyPr>
+          <a:lstStyle/>
+          <a:p>
+            <a:pPr algn="l">
+              <a:spcAft>
+                <a:spcPts val="400"/>
+              </a:spcAft>
+            </a:pPr>
+            <a:r>
+              <a:rPr sz="2000" b="1">
+                <a:solidFill>
+                  <a:srgbClr val="8E6F3E"/>
+                </a:solidFill>
+                <a:latin typeface="Calibri"/>
+              </a:rPr>
+              <a:t>OUR SERVICE LEANS RELATIONAL</a:t>
+            </a:r>
+          </a:p>
+          <a:p>
+            <a:pPr algn="l">
+              <a:spcAft>
+                <a:spcPts val="400"/>
+              </a:spcAft>
+            </a:pPr>
+            <a:r>
+              <a:rPr sz="2000" b="0">
+                <a:solidFill>
+                  <a:srgbClr val="5C4826"/>
+                </a:solidFill>
+                <a:latin typeface="Calibri"/>
+              </a:rPr>
+              <a:t>Invariant relates rows to rows</a:t>
+            </a:r>
+          </a:p>
+          <a:p>
+            <a:pPr algn="l">
+              <a:spcAft>
+                <a:spcPts val="400"/>
+              </a:spcAft>
+            </a:pPr>
+            <a:r>
+              <a:rPr sz="2000" b="0">
+                <a:solidFill>
+                  <a:srgbClr val="5C4826"/>
+                </a:solidFill>
+                <a:latin typeface="Calibri"/>
+              </a:rPr>
+              <a:t>Ad-hoc queries across entities</a:t>
+            </a:r>
+          </a:p>
+          <a:p>
+            <a:pPr algn="l">
+              <a:spcAft>
+                <a:spcPts val="400"/>
+              </a:spcAft>
+            </a:pPr>
+            <a:r>
+              <a:rPr sz="2000" b="0">
+                <a:solidFill>
+                  <a:srgbClr val="5C4826"/>
+                </a:solidFill>
+                <a:latin typeface="Calibri"/>
+              </a:rPr>
+              <a:t>One authoritative copy; modest volume</a:t>
+            </a:r>
+          </a:p>
+        </p:txBody>
+      </p:sp>
+      <p:sp>
+        <p:nvSpPr>
+          <p:cNvPr id="5" name="Card"/>
+          <p:cNvSpPr/>
+          <p:nvPr/>
+        </p:nvSpPr>
+        <p:spPr>
+          <a:xfrm>
+            <a:off x="4663440" y="960120"/>
+            <a:ext cx="4069080" cy="2057400"/>
+          </a:xfrm>
+          <a:prstGeom prst="rect">
+            <a:avLst/>
+          </a:prstGeom>
+          <a:solidFill>
+            <a:srgbClr val="FCFAF6"/>
+          </a:solidFill>
+          <a:ln>
+            <a:noFill/>
+          </a:ln>
+          <a:effectLst/>
+        </p:spPr>
+        <p:style>
+          <a:lnRef idx="1">
+            <a:schemeClr val="accent1"/>
+          </a:lnRef>
+          <a:fillRef idx="3">
+            <a:schemeClr val="accent1"/>
+          </a:fillRef>
+          <a:effectRef idx="2">
+            <a:schemeClr val="accent1"/>
+          </a:effectRef>
+          <a:fontRef idx="minor">
+            <a:schemeClr val="lt1"/>
+          </a:fontRef>
+        </p:style>
+        <p:txBody>
+          <a:bodyPr rtlCol="0" anchor="ctr" wrap="square"/>
+          <a:lstStyle/>
+          <a:p>
+            <a:pPr algn="ctr"/>
+          </a:p>
+        </p:txBody>
+      </p:sp>
+      <p:sp>
+        <p:nvSpPr>
+          <p:cNvPr id="6" name="CardBody"/>
+          <p:cNvSpPr txBox="1"/>
+          <p:nvPr/>
+        </p:nvSpPr>
+        <p:spPr>
+          <a:xfrm>
+            <a:off x="4809744" y="1051560"/>
+            <a:ext cx="3776472" cy="1874519"/>
+          </a:xfrm>
+          <a:prstGeom prst="rect">
+            <a:avLst/>
+          </a:prstGeom>
+          <a:noFill/>
+        </p:spPr>
+        <p:txBody>
+          <a:bodyPr wrap="square">
+            <a:spAutoFit/>
+          </a:bodyPr>
+          <a:lstStyle/>
+          <a:p>
+            <a:pPr algn="l">
+              <a:spcAft>
+                <a:spcPts val="400"/>
+              </a:spcAft>
+            </a:pPr>
+            <a:r>
+              <a:rPr sz="2000" b="1">
+                <a:solidFill>
+                  <a:srgbClr val="8E6F3E"/>
+                </a:solidFill>
+                <a:latin typeface="Calibri"/>
+              </a:rPr>
+              <a:t>WHEN OTHER POINTS WIN</a:t>
+            </a:r>
+          </a:p>
+          <a:p>
+            <a:pPr algn="l">
+              <a:spcAft>
+                <a:spcPts val="400"/>
+              </a:spcAft>
+            </a:pPr>
+            <a:r>
+              <a:rPr sz="2000" b="0">
+                <a:solidFill>
+                  <a:srgbClr val="5C4826"/>
+                </a:solidFill>
+                <a:latin typeface="Calibri"/>
+              </a:rPr>
+              <a:t>Shape varies per record → document</a:t>
+            </a:r>
+          </a:p>
+          <a:p>
+            <a:pPr algn="l">
+              <a:spcAft>
+                <a:spcPts val="400"/>
+              </a:spcAft>
+            </a:pPr>
+            <a:r>
+              <a:rPr sz="2000" b="0">
+                <a:solidFill>
+                  <a:srgbClr val="5C4826"/>
+                </a:solidFill>
+                <a:latin typeface="Calibri"/>
+              </a:rPr>
+              <a:t>Key lookups at huge scale → key-value</a:t>
+            </a:r>
+          </a:p>
+          <a:p>
+            <a:pPr algn="l">
+              <a:spcAft>
+                <a:spcPts val="400"/>
+              </a:spcAft>
+            </a:pPr>
+            <a:r>
+              <a:rPr sz="2000" b="0">
+                <a:solidFill>
+                  <a:srgbClr val="5C4826"/>
+                </a:solidFill>
+                <a:latin typeface="Calibri"/>
+              </a:rPr>
+              <a:t>Traversal-heavy questions → graph</a:t>
+            </a:r>
+          </a:p>
+        </p:txBody>
+      </p:sp>
+      <p:sp>
+        <p:nvSpPr>
+          <p:cNvPr id="7" name="Card"/>
+          <p:cNvSpPr/>
+          <p:nvPr/>
+        </p:nvSpPr>
+        <p:spPr>
+          <a:xfrm>
+            <a:off x="411480" y="3246120"/>
+            <a:ext cx="8321040" cy="1417320"/>
+          </a:xfrm>
+          <a:prstGeom prst="rect">
+            <a:avLst/>
+          </a:prstGeom>
+          <a:solidFill>
+            <a:srgbClr val="F5F1E8"/>
+          </a:solidFill>
+          <a:ln>
+            <a:noFill/>
+          </a:ln>
+          <a:effectLst/>
+        </p:spPr>
+        <p:style>
+          <a:lnRef idx="1">
+            <a:schemeClr val="accent1"/>
+          </a:lnRef>
+          <a:fillRef idx="3">
+            <a:schemeClr val="accent1"/>
+          </a:fillRef>
+          <a:effectRef idx="2">
+            <a:schemeClr val="accent1"/>
+          </a:effectRef>
+          <a:fontRef idx="minor">
+            <a:schemeClr val="lt1"/>
+          </a:fontRef>
+        </p:style>
+        <p:txBody>
+          <a:bodyPr rtlCol="0" anchor="ctr" wrap="square"/>
+          <a:lstStyle/>
+          <a:p>
+            <a:pPr algn="ctr"/>
+          </a:p>
+        </p:txBody>
+      </p:sp>
+      <p:sp>
+        <p:nvSpPr>
+          <p:cNvPr id="8" name="NonClaim"/>
+          <p:cNvSpPr txBox="1"/>
+          <p:nvPr/>
+        </p:nvSpPr>
+        <p:spPr>
+          <a:xfrm>
+            <a:off x="557784" y="3319272"/>
+            <a:ext cx="8046720" cy="1280160"/>
+          </a:xfrm>
+          <a:prstGeom prst="rect">
+            <a:avLst/>
+          </a:prstGeom>
+          <a:noFill/>
+        </p:spPr>
+        <p:txBody>
+          <a:bodyPr wrap="square">
+            <a:spAutoFit/>
+          </a:bodyPr>
+          <a:lstStyle/>
+          <a:p>
+            <a:pPr algn="l">
+              <a:spcAft>
+                <a:spcPts val="400"/>
+              </a:spcAft>
+            </a:pPr>
+            <a:r>
+              <a:rPr sz="2000" b="1">
+                <a:solidFill>
+                  <a:srgbClr val="C01B1B"/>
+                </a:solidFill>
+                <a:latin typeface="Calibri"/>
+              </a:rPr>
+              <a:t>✗  “SQL = consistent but slow; NoSQL = scalable but inconsistent”</a:t>
+            </a:r>
+          </a:p>
+          <a:p>
+            <a:pPr algn="l">
+              <a:spcAft>
+                <a:spcPts val="400"/>
+              </a:spcAft>
+            </a:pPr>
+            <a:r>
+              <a:rPr sz="2000" b="0">
+                <a:solidFill>
+                  <a:srgbClr val="555960"/>
+                </a:solidFill>
+                <a:latin typeface="Calibri"/>
+              </a:rPr>
+              <a:t>Some NoSQL systems offer strong consistency and transactions; some relational systems are distributed and horizontally scalable.</a:t>
+            </a:r>
+          </a:p>
+        </p:txBody>
+      </p:sp>
+      <p:sp>
+        <p:nvSpPr>
+          <p:cNvPr id="9" name="FooterBand"/>
+          <p:cNvSpPr/>
+          <p:nvPr/>
+        </p:nvSpPr>
+        <p:spPr>
+          <a:xfrm>
+            <a:off x="274320" y="5879592"/>
+            <a:ext cx="8595360" cy="502920"/>
+          </a:xfrm>
+          <a:prstGeom prst="rect">
+            <a:avLst/>
+          </a:prstGeom>
+          <a:solidFill>
+            <a:srgbClr val="8E6F3E"/>
+          </a:solidFill>
+          <a:ln>
+            <a:noFill/>
+          </a:ln>
+          <a:effectLst/>
+        </p:spPr>
+        <p:style>
+          <a:lnRef idx="1">
+            <a:schemeClr val="accent1"/>
+          </a:lnRef>
+          <a:fillRef idx="3">
+            <a:schemeClr val="accent1"/>
+          </a:fillRef>
+          <a:effectRef idx="2">
+            <a:schemeClr val="accent1"/>
+          </a:effectRef>
+          <a:fontRef idx="minor">
+            <a:schemeClr val="lt1"/>
+          </a:fontRef>
+        </p:style>
+        <p:txBody>
+          <a:bodyPr rtlCol="0" anchor="ctr" wrap="square"/>
+          <a:lstStyle/>
+          <a:p>
+            <a:pPr algn="ctr"/>
+          </a:p>
+        </p:txBody>
+      </p:sp>
+      <p:sp>
+        <p:nvSpPr>
+          <p:cNvPr id="10" name="FooterBandText"/>
+          <p:cNvSpPr txBox="1"/>
+          <p:nvPr/>
+        </p:nvSpPr>
+        <p:spPr>
+          <a:xfrm>
+            <a:off x="384048" y="5897880"/>
+            <a:ext cx="8375904" cy="457200"/>
+          </a:xfrm>
+          <a:prstGeom prst="rect">
+            <a:avLst/>
+          </a:prstGeom>
+          <a:noFill/>
+        </p:spPr>
+        <p:txBody>
+          <a:bodyPr wrap="square">
+            <a:spAutoFit/>
+          </a:bodyPr>
+          <a:lstStyle/>
+          <a:p>
+            <a:pPr algn="ctr">
+              <a:spcAft>
+                <a:spcPts val="400"/>
+              </a:spcAft>
+            </a:pPr>
+            <a:r>
+              <a:rPr sz="2000" b="1">
+                <a:solidFill>
+                  <a:srgbClr val="FFFFFF"/>
+                </a:solidFill>
+                <a:latin typeface="Calibri"/>
+              </a:rPr>
+              <a:t>Points in one design space — not rival camps</a:t>
+            </a:r>
+          </a:p>
+        </p:txBody>
+      </p:sp>
+    </p:spTree>
+  </p:cSld>
+  <p:clrMapOvr>
+    <a:masterClrMapping/>
+  </p:clrMapOvr>
+</p:sld>
+</file>
+
+<file path=ppt/slides/slide7.xml><?xml version="1.0" encoding="utf-8"?>
+<p:sld xmlns:a="http://schemas.openxmlformats.org/drawingml/2006/main" xmlns:p="http://schemas.openxmlformats.org/presentationml/2006/main" xmlns:r="http://schemas.openxmlformats.org/officeDocument/2006/relationships">
+  <p:cSld>
+    <p:spTree>
+      <p:nvGrpSpPr>
+        <p:cNvPr id="1" name=""/>
+        <p:cNvGrpSpPr/>
+        <p:nvPr/>
+      </p:nvGrpSpPr>
+      <p:grpSpPr/>
+      <p:sp>
+        <p:nvSpPr>
+          <p:cNvPr id="2" name="Title"/>
+          <p:cNvSpPr txBox="1"/>
+          <p:nvPr/>
+        </p:nvSpPr>
+        <p:spPr>
+          <a:xfrm>
+            <a:off x="274320" y="128016"/>
+            <a:ext cx="8595360" cy="594360"/>
+          </a:xfrm>
+          <a:prstGeom prst="rect">
+            <a:avLst/>
+          </a:prstGeom>
+          <a:noFill/>
+        </p:spPr>
+        <p:txBody>
+          <a:bodyPr wrap="square">
+            <a:spAutoFit/>
+          </a:bodyPr>
+          <a:lstStyle/>
+          <a:p>
+            <a:pPr algn="l">
+              <a:spcAft>
+                <a:spcPts val="400"/>
+              </a:spcAft>
+            </a:pPr>
+            <a:r>
+              <a:rPr sz="2400" b="0">
+                <a:solidFill>
+                  <a:srgbClr val="2D2D2D"/>
+                </a:solidFill>
+                <a:latin typeface="Calibri"/>
+              </a:rPr>
+              <a:t>Semantics matter more than labels</a:t>
+            </a:r>
+          </a:p>
+        </p:txBody>
+      </p:sp>
+      <p:sp>
+        <p:nvSpPr>
+          <p:cNvPr id="3" name="Label"/>
+          <p:cNvSpPr txBox="1"/>
+          <p:nvPr/>
+        </p:nvSpPr>
+        <p:spPr>
+          <a:xfrm>
+            <a:off x="411480" y="868680"/>
+            <a:ext cx="8321040" cy="411480"/>
+          </a:xfrm>
+          <a:prstGeom prst="rect">
+            <a:avLst/>
+          </a:prstGeom>
+          <a:noFill/>
+        </p:spPr>
+        <p:txBody>
+          <a:bodyPr wrap="square">
+            <a:spAutoFit/>
+          </a:bodyPr>
+          <a:lstStyle/>
+          <a:p>
+            <a:pPr algn="l">
+              <a:spcAft>
+                <a:spcPts val="400"/>
+              </a:spcAft>
+            </a:pPr>
+            <a:r>
+              <a:rPr sz="2100" b="1">
+                <a:solidFill>
+                  <a:srgbClr val="5C4826"/>
+                </a:solidFill>
+                <a:latin typeface="Calibri"/>
+              </a:rPr>
+              <a:t>Four questions to put to any candidate system</a:t>
+            </a:r>
+          </a:p>
+        </p:txBody>
+      </p:sp>
+      <p:sp>
+        <p:nvSpPr>
+          <p:cNvPr id="4" name="Card"/>
+          <p:cNvSpPr/>
+          <p:nvPr/>
+        </p:nvSpPr>
+        <p:spPr>
+          <a:xfrm>
+            <a:off x="411480" y="1417320"/>
+            <a:ext cx="8321040" cy="896112"/>
+          </a:xfrm>
+          <a:prstGeom prst="rect">
+            <a:avLst/>
+          </a:prstGeom>
+          <a:solidFill>
+            <a:srgbClr val="F5F1E8"/>
+          </a:solidFill>
+          <a:ln>
+            <a:noFill/>
+          </a:ln>
+          <a:effectLst/>
+        </p:spPr>
+        <p:style>
+          <a:lnRef idx="1">
+            <a:schemeClr val="accent1"/>
+          </a:lnRef>
+          <a:fillRef idx="3">
+            <a:schemeClr val="accent1"/>
+          </a:fillRef>
+          <a:effectRef idx="2">
+            <a:schemeClr val="accent1"/>
+          </a:effectRef>
+          <a:fontRef idx="minor">
+            <a:schemeClr val="lt1"/>
+          </a:fontRef>
+        </p:style>
+        <p:txBody>
+          <a:bodyPr rtlCol="0" anchor="ctr" wrap="square"/>
+          <a:lstStyle/>
+          <a:p>
+            <a:pPr algn="ctr"/>
+          </a:p>
+        </p:txBody>
+      </p:sp>
+      <p:sp>
+        <p:nvSpPr>
+          <p:cNvPr id="5" name="RowBody"/>
+          <p:cNvSpPr txBox="1"/>
+          <p:nvPr/>
+        </p:nvSpPr>
+        <p:spPr>
+          <a:xfrm>
+            <a:off x="557784" y="1472184"/>
+            <a:ext cx="8046720" cy="786384"/>
+          </a:xfrm>
+          <a:prstGeom prst="rect">
+            <a:avLst/>
+          </a:prstGeom>
+          <a:noFill/>
+        </p:spPr>
+        <p:txBody>
+          <a:bodyPr wrap="square">
+            <a:spAutoFit/>
+          </a:bodyPr>
+          <a:lstStyle/>
+          <a:p>
+            <a:pPr algn="l">
+              <a:spcAft>
+                <a:spcPts val="100"/>
+              </a:spcAft>
+            </a:pPr>
+            <a:r>
+              <a:rPr sz="2000" b="1">
+                <a:solidFill>
+                  <a:srgbClr val="5C4826"/>
+                </a:solidFill>
+                <a:latin typeface="Calibri"/>
+              </a:rPr>
+              <a:t>Can two clients observe different values at the same time?</a:t>
+            </a:r>
+          </a:p>
+          <a:p>
+            <a:pPr algn="l">
+              <a:spcAft>
+                <a:spcPts val="400"/>
+              </a:spcAft>
+            </a:pPr>
+            <a:r>
+              <a:rPr sz="2000" b="0">
+                <a:solidFill>
+                  <a:srgbClr val="8E6F3E"/>
+                </a:solidFill>
+                <a:latin typeface="Calibri"/>
+              </a:rPr>
+              <a:t>consistency</a:t>
+            </a:r>
+          </a:p>
+        </p:txBody>
+      </p:sp>
+      <p:sp>
+        <p:nvSpPr>
+          <p:cNvPr id="6" name="Card"/>
+          <p:cNvSpPr/>
+          <p:nvPr/>
+        </p:nvSpPr>
+        <p:spPr>
+          <a:xfrm>
+            <a:off x="411480" y="2450591"/>
+            <a:ext cx="8321040" cy="896112"/>
+          </a:xfrm>
+          <a:prstGeom prst="rect">
+            <a:avLst/>
+          </a:prstGeom>
+          <a:solidFill>
+            <a:srgbClr val="FCFAF6"/>
+          </a:solidFill>
+          <a:ln>
+            <a:noFill/>
+          </a:ln>
+          <a:effectLst/>
+        </p:spPr>
+        <p:style>
+          <a:lnRef idx="1">
+            <a:schemeClr val="accent1"/>
+          </a:lnRef>
+          <a:fillRef idx="3">
+            <a:schemeClr val="accent1"/>
+          </a:fillRef>
+          <a:effectRef idx="2">
+            <a:schemeClr val="accent1"/>
+          </a:effectRef>
+          <a:fontRef idx="minor">
+            <a:schemeClr val="lt1"/>
+          </a:fontRef>
+        </p:style>
+        <p:txBody>
+          <a:bodyPr rtlCol="0" anchor="ctr" wrap="square"/>
+          <a:lstStyle/>
+          <a:p>
+            <a:pPr algn="ctr"/>
+          </a:p>
+        </p:txBody>
+      </p:sp>
+      <p:sp>
+        <p:nvSpPr>
+          <p:cNvPr id="7" name="RowBody"/>
+          <p:cNvSpPr txBox="1"/>
+          <p:nvPr/>
+        </p:nvSpPr>
+        <p:spPr>
+          <a:xfrm>
+            <a:off x="557784" y="2505456"/>
+            <a:ext cx="8046720" cy="786384"/>
+          </a:xfrm>
+          <a:prstGeom prst="rect">
+            <a:avLst/>
+          </a:prstGeom>
+          <a:noFill/>
+        </p:spPr>
+        <p:txBody>
+          <a:bodyPr wrap="square">
+            <a:spAutoFit/>
+          </a:bodyPr>
+          <a:lstStyle/>
+          <a:p>
+            <a:pPr algn="l">
+              <a:spcAft>
+                <a:spcPts val="100"/>
+              </a:spcAft>
+            </a:pPr>
+            <a:r>
+              <a:rPr sz="2000" b="1">
+                <a:solidFill>
+                  <a:srgbClr val="5C4826"/>
+                </a:solidFill>
+                <a:latin typeface="Calibri"/>
+              </a:rPr>
+              <a:t>Can a write the system acknowledged ever be lost?</a:t>
+            </a:r>
+          </a:p>
+          <a:p>
+            <a:pPr algn="l">
+              <a:spcAft>
+                <a:spcPts val="400"/>
+              </a:spcAft>
+            </a:pPr>
+            <a:r>
+              <a:rPr sz="2000" b="0">
+                <a:solidFill>
+                  <a:srgbClr val="8E6F3E"/>
+                </a:solidFill>
+                <a:latin typeface="Calibri"/>
+              </a:rPr>
+              <a:t>durability</a:t>
+            </a:r>
+          </a:p>
+        </p:txBody>
+      </p:sp>
+      <p:sp>
+        <p:nvSpPr>
+          <p:cNvPr id="8" name="Card"/>
+          <p:cNvSpPr/>
+          <p:nvPr/>
+        </p:nvSpPr>
+        <p:spPr>
+          <a:xfrm>
+            <a:off x="411480" y="3483863"/>
+            <a:ext cx="8321040" cy="896112"/>
+          </a:xfrm>
+          <a:prstGeom prst="rect">
+            <a:avLst/>
+          </a:prstGeom>
+          <a:solidFill>
+            <a:srgbClr val="F5F1E8"/>
+          </a:solidFill>
+          <a:ln>
+            <a:noFill/>
+          </a:ln>
+          <a:effectLst/>
+        </p:spPr>
+        <p:style>
+          <a:lnRef idx="1">
+            <a:schemeClr val="accent1"/>
+          </a:lnRef>
+          <a:fillRef idx="3">
+            <a:schemeClr val="accent1"/>
+          </a:fillRef>
+          <a:effectRef idx="2">
+            <a:schemeClr val="accent1"/>
+          </a:effectRef>
+          <a:fontRef idx="minor">
+            <a:schemeClr val="lt1"/>
+          </a:fontRef>
+        </p:style>
+        <p:txBody>
+          <a:bodyPr rtlCol="0" anchor="ctr" wrap="square"/>
+          <a:lstStyle/>
+          <a:p>
+            <a:pPr algn="ctr"/>
+          </a:p>
+        </p:txBody>
+      </p:sp>
+      <p:sp>
+        <p:nvSpPr>
+          <p:cNvPr id="9" name="RowBody"/>
+          <p:cNvSpPr txBox="1"/>
+          <p:nvPr/>
+        </p:nvSpPr>
+        <p:spPr>
+          <a:xfrm>
+            <a:off x="557784" y="3538727"/>
+            <a:ext cx="8046720" cy="786384"/>
+          </a:xfrm>
+          <a:prstGeom prst="rect">
+            <a:avLst/>
+          </a:prstGeom>
+          <a:noFill/>
+        </p:spPr>
+        <p:txBody>
+          <a:bodyPr wrap="square">
+            <a:spAutoFit/>
+          </a:bodyPr>
+          <a:lstStyle/>
+          <a:p>
+            <a:pPr algn="l">
+              <a:spcAft>
+                <a:spcPts val="100"/>
+              </a:spcAft>
+            </a:pPr>
+            <a:r>
+              <a:rPr sz="2000" b="1">
+                <a:solidFill>
+                  <a:srgbClr val="5C4826"/>
+                </a:solidFill>
+                <a:latin typeface="Calibri"/>
+              </a:rPr>
+              <a:t>Can two transactions both confirm overlapping reservations?</a:t>
+            </a:r>
+          </a:p>
+          <a:p>
+            <a:pPr algn="l">
+              <a:spcAft>
+                <a:spcPts val="400"/>
+              </a:spcAft>
+            </a:pPr>
+            <a:r>
+              <a:rPr sz="2000" b="0">
+                <a:solidFill>
+                  <a:srgbClr val="8E6F3E"/>
+                </a:solidFill>
+                <a:latin typeface="Calibri"/>
+              </a:rPr>
+              <a:t>isolation</a:t>
+            </a:r>
+          </a:p>
+        </p:txBody>
+      </p:sp>
+      <p:sp>
+        <p:nvSpPr>
+          <p:cNvPr id="10" name="Card"/>
+          <p:cNvSpPr/>
+          <p:nvPr/>
+        </p:nvSpPr>
+        <p:spPr>
+          <a:xfrm>
+            <a:off x="411480" y="4517136"/>
+            <a:ext cx="8321040" cy="896112"/>
+          </a:xfrm>
+          <a:prstGeom prst="rect">
+            <a:avLst/>
+          </a:prstGeom>
+          <a:solidFill>
+            <a:srgbClr val="FCFAF6"/>
+          </a:solidFill>
+          <a:ln>
+            <a:noFill/>
+          </a:ln>
+          <a:effectLst/>
+        </p:spPr>
+        <p:style>
+          <a:lnRef idx="1">
+            <a:schemeClr val="accent1"/>
+          </a:lnRef>
+          <a:fillRef idx="3">
+            <a:schemeClr val="accent1"/>
+          </a:fillRef>
+          <a:effectRef idx="2">
+            <a:schemeClr val="accent1"/>
+          </a:effectRef>
+          <a:fontRef idx="minor">
+            <a:schemeClr val="lt1"/>
+          </a:fontRef>
+        </p:style>
+        <p:txBody>
+          <a:bodyPr rtlCol="0" anchor="ctr" wrap="square"/>
+          <a:lstStyle/>
+          <a:p>
+            <a:pPr algn="ctr"/>
+          </a:p>
+        </p:txBody>
+      </p:sp>
+      <p:sp>
+        <p:nvSpPr>
+          <p:cNvPr id="11" name="RowBody"/>
+          <p:cNvSpPr txBox="1"/>
+          <p:nvPr/>
+        </p:nvSpPr>
+        <p:spPr>
+          <a:xfrm>
+            <a:off x="557784" y="4571999"/>
+            <a:ext cx="8046720" cy="786384"/>
+          </a:xfrm>
+          <a:prstGeom prst="rect">
+            <a:avLst/>
+          </a:prstGeom>
+          <a:noFill/>
+        </p:spPr>
+        <p:txBody>
+          <a:bodyPr wrap="square">
+            <a:spAutoFit/>
+          </a:bodyPr>
+          <a:lstStyle/>
+          <a:p>
+            <a:pPr algn="l">
+              <a:spcAft>
+                <a:spcPts val="100"/>
+              </a:spcAft>
+            </a:pPr>
+            <a:r>
+              <a:rPr sz="2000" b="1">
+                <a:solidFill>
+                  <a:srgbClr val="5C4826"/>
+                </a:solidFill>
+                <a:latin typeface="Calibri"/>
+              </a:rPr>
+              <a:t>Can the database itself enforce our no-overlap invariant?</a:t>
+            </a:r>
+          </a:p>
+          <a:p>
+            <a:pPr algn="l">
+              <a:spcAft>
+                <a:spcPts val="400"/>
+              </a:spcAft>
+            </a:pPr>
+            <a:r>
+              <a:rPr sz="2000" b="0">
+                <a:solidFill>
+                  <a:srgbClr val="8E6F3E"/>
+                </a:solidFill>
+                <a:latin typeface="Calibri"/>
+              </a:rPr>
+              <a:t>where the invariant lives</a:t>
+            </a:r>
+          </a:p>
+        </p:txBody>
+      </p:sp>
+      <p:sp>
+        <p:nvSpPr>
+          <p:cNvPr id="12" name="FooterBand"/>
+          <p:cNvSpPr/>
+          <p:nvPr/>
+        </p:nvSpPr>
+        <p:spPr>
+          <a:xfrm>
+            <a:off x="274320" y="5879592"/>
+            <a:ext cx="8595360" cy="502920"/>
+          </a:xfrm>
+          <a:prstGeom prst="rect">
+            <a:avLst/>
+          </a:prstGeom>
+          <a:solidFill>
+            <a:srgbClr val="8E6F3E"/>
+          </a:solidFill>
+          <a:ln>
+            <a:noFill/>
+          </a:ln>
+          <a:effectLst/>
+        </p:spPr>
+        <p:style>
+          <a:lnRef idx="1">
+            <a:schemeClr val="accent1"/>
+          </a:lnRef>
+          <a:fillRef idx="3">
+            <a:schemeClr val="accent1"/>
+          </a:fillRef>
+          <a:effectRef idx="2">
+            <a:schemeClr val="accent1"/>
+          </a:effectRef>
+          <a:fontRef idx="minor">
+            <a:schemeClr val="lt1"/>
+          </a:fontRef>
+        </p:style>
+        <p:txBody>
+          <a:bodyPr rtlCol="0" anchor="ctr" wrap="square"/>
+          <a:lstStyle/>
+          <a:p>
+            <a:pPr algn="ctr"/>
+          </a:p>
+        </p:txBody>
+      </p:sp>
+      <p:sp>
+        <p:nvSpPr>
+          <p:cNvPr id="13" name="FooterBandText"/>
+          <p:cNvSpPr txBox="1"/>
+          <p:nvPr/>
+        </p:nvSpPr>
+        <p:spPr>
+          <a:xfrm>
+            <a:off x="384048" y="5897880"/>
+            <a:ext cx="8375904" cy="457200"/>
+          </a:xfrm>
+          <a:prstGeom prst="rect">
+            <a:avLst/>
+          </a:prstGeom>
+          <a:noFill/>
+        </p:spPr>
+        <p:txBody>
+          <a:bodyPr wrap="square">
+            <a:spAutoFit/>
+          </a:bodyPr>
+          <a:lstStyle/>
+          <a:p>
+            <a:pPr algn="ctr">
+              <a:spcAft>
+                <a:spcPts val="400"/>
+              </a:spcAft>
+            </a:pPr>
+            <a:r>
+              <a:rPr sz="2000" b="1">
+                <a:solidFill>
+                  <a:srgbClr val="FFFFFF"/>
+                </a:solidFill>
+                <a:latin typeface="Calibri"/>
+              </a:rPr>
+              <a:t>Interrogate guarantees, not product labels</a:t>
+            </a:r>
+          </a:p>
+        </p:txBody>
+      </p:sp>
+    </p:spTree>
+  </p:cSld>
+  <p:clrMapOvr>
+    <a:masterClrMapping/>
+  </p:clrMapOvr>
+</p:sld>
+</file>
+
+<file path=ppt/slides/slide8.xml><?xml version="1.0" encoding="utf-8"?>
+<p:sld xmlns:a="http://schemas.openxmlformats.org/drawingml/2006/main" xmlns:p="http://schemas.openxmlformats.org/presentationml/2006/main" xmlns:r="http://schemas.openxmlformats.org/officeDocument/2006/relationships">
+  <p:cSld>
+    <p:spTree>
+      <p:nvGrpSpPr>
+        <p:cNvPr id="1" name=""/>
+        <p:cNvGrpSpPr/>
+        <p:nvPr/>
+      </p:nvGrpSpPr>
+      <p:grpSpPr/>
+      <p:sp>
+        <p:nvSpPr>
+          <p:cNvPr id="2" name="Title"/>
+          <p:cNvSpPr txBox="1"/>
+          <p:nvPr/>
+        </p:nvSpPr>
+        <p:spPr>
+          <a:xfrm>
+            <a:off x="274320" y="128016"/>
+            <a:ext cx="8595360" cy="594360"/>
+          </a:xfrm>
+          <a:prstGeom prst="rect">
+            <a:avLst/>
+          </a:prstGeom>
+          <a:noFill/>
+        </p:spPr>
+        <p:txBody>
+          <a:bodyPr wrap="square">
+            <a:spAutoFit/>
+          </a:bodyPr>
+          <a:lstStyle/>
+          <a:p>
+            <a:pPr algn="l">
+              <a:spcAft>
+                <a:spcPts val="400"/>
+              </a:spcAft>
+            </a:pPr>
+            <a:r>
+              <a:rPr sz="2400" b="0">
+                <a:solidFill>
+                  <a:srgbClr val="2D2D2D"/>
+                </a:solidFill>
+                <a:latin typeface="Calibri"/>
+              </a:rPr>
+              <a:t>Exercise: place each system in the design space</a:t>
+            </a:r>
+          </a:p>
+        </p:txBody>
+      </p:sp>
+      <p:sp>
+        <p:nvSpPr>
+          <p:cNvPr id="3" name="Card"/>
+          <p:cNvSpPr/>
+          <p:nvPr/>
+        </p:nvSpPr>
+        <p:spPr>
+          <a:xfrm>
+            <a:off x="411480" y="960120"/>
+            <a:ext cx="4069080" cy="4206240"/>
+          </a:xfrm>
+          <a:prstGeom prst="rect">
+            <a:avLst/>
+          </a:prstGeom>
+          <a:solidFill>
+            <a:srgbClr val="F5F1E8"/>
+          </a:solidFill>
+          <a:ln>
+            <a:noFill/>
+          </a:ln>
+          <a:effectLst/>
+        </p:spPr>
+        <p:style>
+          <a:lnRef idx="1">
+            <a:schemeClr val="accent1"/>
+          </a:lnRef>
+          <a:fillRef idx="3">
+            <a:schemeClr val="accent1"/>
+          </a:fillRef>
+          <a:effectRef idx="2">
+            <a:schemeClr val="accent1"/>
+          </a:effectRef>
+          <a:fontRef idx="minor">
+            <a:schemeClr val="lt1"/>
+          </a:fontRef>
+        </p:style>
+        <p:txBody>
+          <a:bodyPr rtlCol="0" anchor="ctr" wrap="square"/>
+          <a:lstStyle/>
+          <a:p>
+            <a:pPr algn="ctr"/>
+          </a:p>
+        </p:txBody>
+      </p:sp>
+      <p:sp>
+        <p:nvSpPr>
+          <p:cNvPr id="4" name="CardBody"/>
+          <p:cNvSpPr txBox="1"/>
+          <p:nvPr/>
+        </p:nvSpPr>
+        <p:spPr>
+          <a:xfrm>
+            <a:off x="557784" y="1051560"/>
+            <a:ext cx="3776472" cy="4023360"/>
+          </a:xfrm>
+          <a:prstGeom prst="rect">
+            <a:avLst/>
+          </a:prstGeom>
+          <a:noFill/>
+        </p:spPr>
+        <p:txBody>
+          <a:bodyPr wrap="square">
+            <a:spAutoFit/>
+          </a:bodyPr>
+          <a:lstStyle/>
+          <a:p>
+            <a:pPr algn="l">
+              <a:spcAft>
+                <a:spcPts val="600"/>
+              </a:spcAft>
+            </a:pPr>
+            <a:r>
+              <a:rPr sz="2000" b="1">
+                <a:solidFill>
+                  <a:srgbClr val="8E6F3E"/>
+                </a:solidFill>
+                <a:latin typeface="Calibri"/>
+              </a:rPr>
+              <a:t>A — ROOM RESERVATIONS</a:t>
+            </a:r>
+          </a:p>
+          <a:p>
+            <a:pPr algn="l">
+              <a:spcAft>
+                <a:spcPts val="400"/>
+              </a:spcAft>
+            </a:pPr>
+            <a:r>
+              <a:rPr sz="2000" b="0">
+                <a:solidFill>
+                  <a:srgbClr val="5C4826"/>
+                </a:solidFill>
+                <a:latin typeface="Calibri"/>
+              </a:rPr>
+              <a:t>Invariant between rows</a:t>
+            </a:r>
+          </a:p>
+          <a:p>
+            <a:pPr algn="l">
+              <a:spcAft>
+                <a:spcPts val="400"/>
+              </a:spcAft>
+            </a:pPr>
+            <a:r>
+              <a:rPr sz="2000" b="0">
+                <a:solidFill>
+                  <a:srgbClr val="5C4826"/>
+                </a:solidFill>
+                <a:latin typeface="Calibri"/>
+              </a:rPr>
+              <a:t>Modest write volume</a:t>
+            </a:r>
+          </a:p>
+          <a:p>
+            <a:pPr algn="l">
+              <a:spcAft>
+                <a:spcPts val="400"/>
+              </a:spcAft>
+            </a:pPr>
+            <a:r>
+              <a:rPr sz="2000" b="0">
+                <a:solidFill>
+                  <a:srgbClr val="5C4826"/>
+                </a:solidFill>
+                <a:latin typeface="Calibri"/>
+              </a:rPr>
+              <a:t>Ad-hoc queries across entities</a:t>
+            </a:r>
+          </a:p>
+          <a:p>
+            <a:pPr algn="l">
+              <a:spcAft>
+                <a:spcPts val="400"/>
+              </a:spcAft>
+            </a:pPr>
+            <a:r>
+              <a:rPr sz="2000" b="0">
+                <a:solidFill>
+                  <a:srgbClr val="5C4826"/>
+                </a:solidFill>
+                <a:latin typeface="Calibri"/>
+              </a:rPr>
+              <a:t>One authoritative copy</a:t>
+            </a:r>
+          </a:p>
+          <a:p>
+            <a:pPr algn="l">
+              <a:spcAft>
+                <a:spcPts val="400"/>
+              </a:spcAft>
+            </a:pPr>
+            <a:r>
+              <a:rPr sz="2000" b="0">
+                <a:solidFill>
+                  <a:srgbClr val="5C4826"/>
+                </a:solidFill>
+                <a:latin typeface="Calibri"/>
+              </a:rPr>
+              <a:t>A lost booking = an angry human</a:t>
+            </a:r>
+          </a:p>
+        </p:txBody>
+      </p:sp>
+      <p:sp>
+        <p:nvSpPr>
+          <p:cNvPr id="5" name="Card"/>
+          <p:cNvSpPr/>
+          <p:nvPr/>
+        </p:nvSpPr>
+        <p:spPr>
+          <a:xfrm>
+            <a:off x="4663440" y="960120"/>
+            <a:ext cx="4069080" cy="4206240"/>
+          </a:xfrm>
+          <a:prstGeom prst="rect">
+            <a:avLst/>
+          </a:prstGeom>
+          <a:solidFill>
+            <a:srgbClr val="FCFAF6"/>
+          </a:solidFill>
+          <a:ln>
+            <a:noFill/>
+          </a:ln>
+          <a:effectLst/>
+        </p:spPr>
+        <p:style>
+          <a:lnRef idx="1">
+            <a:schemeClr val="accent1"/>
+          </a:lnRef>
+          <a:fillRef idx="3">
+            <a:schemeClr val="accent1"/>
+          </a:fillRef>
+          <a:effectRef idx="2">
+            <a:schemeClr val="accent1"/>
+          </a:effectRef>
+          <a:fontRef idx="minor">
+            <a:schemeClr val="lt1"/>
+          </a:fontRef>
+        </p:style>
+        <p:txBody>
+          <a:bodyPr rtlCol="0" anchor="ctr" wrap="square"/>
+          <a:lstStyle/>
+          <a:p>
+            <a:pPr algn="ctr"/>
+          </a:p>
+        </p:txBody>
+      </p:sp>
+      <p:sp>
+        <p:nvSpPr>
+          <p:cNvPr id="6" name="CardBody"/>
+          <p:cNvSpPr txBox="1"/>
+          <p:nvPr/>
+        </p:nvSpPr>
+        <p:spPr>
+          <a:xfrm>
+            <a:off x="4809744" y="1051560"/>
+            <a:ext cx="3776472" cy="4023360"/>
+          </a:xfrm>
+          <a:prstGeom prst="rect">
+            <a:avLst/>
+          </a:prstGeom>
+          <a:noFill/>
+        </p:spPr>
+        <p:txBody>
+          <a:bodyPr wrap="square">
+            <a:spAutoFit/>
+          </a:bodyPr>
+          <a:lstStyle/>
+          <a:p>
+            <a:pPr algn="l">
+              <a:spcAft>
+                <a:spcPts val="600"/>
+              </a:spcAft>
+            </a:pPr>
+            <a:r>
+              <a:rPr sz="2000" b="1">
+                <a:solidFill>
+                  <a:srgbClr val="8E6F3E"/>
+                </a:solidFill>
+                <a:latin typeface="Calibri"/>
+              </a:rPr>
+              <a:t>B — DOOR-SENSOR TELEMETRY</a:t>
+            </a:r>
+          </a:p>
+          <a:p>
+            <a:pPr algn="l">
+              <a:spcAft>
+                <a:spcPts val="400"/>
+              </a:spcAft>
+            </a:pPr>
+            <a:r>
+              <a:rPr sz="2000" b="0">
+                <a:solidFill>
+                  <a:srgbClr val="5C4826"/>
+                </a:solidFill>
+                <a:latin typeface="Calibri"/>
+              </a:rPr>
+              <a:t>Append-only events</a:t>
+            </a:r>
+          </a:p>
+          <a:p>
+            <a:pPr algn="l">
+              <a:spcAft>
+                <a:spcPts val="400"/>
+              </a:spcAft>
+            </a:pPr>
+            <a:r>
+              <a:rPr sz="2000" b="0">
+                <a:solidFill>
+                  <a:srgbClr val="5C4826"/>
+                </a:solidFill>
+                <a:latin typeface="Calibri"/>
+              </a:rPr>
+              <a:t>Enormous write rate</a:t>
+            </a:r>
+          </a:p>
+          <a:p>
+            <a:pPr algn="l">
+              <a:spcAft>
+                <a:spcPts val="400"/>
+              </a:spcAft>
+            </a:pPr>
+            <a:r>
+              <a:rPr sz="2000" b="0">
+                <a:solidFill>
+                  <a:srgbClr val="5C4826"/>
+                </a:solidFill>
+                <a:latin typeface="Calibri"/>
+              </a:rPr>
+              <a:t>Access by device id + time</a:t>
+            </a:r>
+          </a:p>
+          <a:p>
+            <a:pPr algn="l">
+              <a:spcAft>
+                <a:spcPts val="400"/>
+              </a:spcAft>
+            </a:pPr>
+            <a:r>
+              <a:rPr sz="2000" b="0">
+                <a:solidFill>
+                  <a:srgbClr val="5C4826"/>
+                </a:solidFill>
+                <a:latin typeface="Calibri"/>
+              </a:rPr>
+              <a:t>Seconds of lag is fine</a:t>
+            </a:r>
+          </a:p>
+          <a:p>
+            <a:pPr algn="l">
+              <a:spcAft>
+                <a:spcPts val="400"/>
+              </a:spcAft>
+            </a:pPr>
+            <a:r>
+              <a:rPr sz="2000" b="0">
+                <a:solidFill>
+                  <a:srgbClr val="5C4826"/>
+                </a:solidFill>
+                <a:latin typeface="Calibri"/>
+              </a:rPr>
+              <a:t>One lost event is tolerable</a:t>
+            </a:r>
+          </a:p>
+        </p:txBody>
+      </p:sp>
+      <p:sp>
+        <p:nvSpPr>
+          <p:cNvPr id="7" name="FooterBand"/>
+          <p:cNvSpPr/>
+          <p:nvPr/>
+        </p:nvSpPr>
+        <p:spPr>
+          <a:xfrm>
+            <a:off x="274320" y="5879592"/>
+            <a:ext cx="8595360" cy="502920"/>
+          </a:xfrm>
+          <a:prstGeom prst="rect">
+            <a:avLst/>
+          </a:prstGeom>
+          <a:solidFill>
+            <a:srgbClr val="8E6F3E"/>
+          </a:solidFill>
+          <a:ln>
+            <a:noFill/>
+          </a:ln>
+          <a:effectLst/>
+        </p:spPr>
+        <p:style>
+          <a:lnRef idx="1">
+            <a:schemeClr val="accent1"/>
+          </a:lnRef>
+          <a:fillRef idx="3">
+            <a:schemeClr val="accent1"/>
+          </a:fillRef>
+          <a:effectRef idx="2">
+            <a:schemeClr val="accent1"/>
+          </a:effectRef>
+          <a:fontRef idx="minor">
+            <a:schemeClr val="lt1"/>
+          </a:fontRef>
+        </p:style>
+        <p:txBody>
+          <a:bodyPr rtlCol="0" anchor="ctr" wrap="square"/>
+          <a:lstStyle/>
+          <a:p>
+            <a:pPr algn="ctr"/>
+          </a:p>
+        </p:txBody>
+      </p:sp>
+      <p:sp>
+        <p:nvSpPr>
+          <p:cNvPr id="8" name="FooterBandText"/>
+          <p:cNvSpPr txBox="1"/>
+          <p:nvPr/>
+        </p:nvSpPr>
+        <p:spPr>
+          <a:xfrm>
+            <a:off x="384048" y="5897880"/>
+            <a:ext cx="8375904" cy="457200"/>
+          </a:xfrm>
+          <a:prstGeom prst="rect">
+            <a:avLst/>
+          </a:prstGeom>
+          <a:noFill/>
+        </p:spPr>
+        <p:txBody>
+          <a:bodyPr wrap="square">
+            <a:spAutoFit/>
+          </a:bodyPr>
+          <a:lstStyle/>
+          <a:p>
+            <a:pPr algn="ctr">
+              <a:spcAft>
+                <a:spcPts val="400"/>
+              </a:spcAft>
+            </a:pPr>
+            <a:r>
+              <a:rPr sz="2000" b="1">
+                <a:solidFill>
+                  <a:srgbClr val="FFFFFF"/>
+                </a:solidFill>
+                <a:latin typeface="Calibri"/>
+              </a:rPr>
+              <a:t>Different requirements select different points in the space</a:t>
+            </a:r>
+          </a:p>
+        </p:txBody>
+      </p:sp>
+    </p:spTree>
+  </p:cSld>
+  <p:clrMapOvr>
+    <a:masterClrMapping/>
+  </p:clrMapOvr>
+</p:sld>
+</file>
+
 <file path=ppt/theme/theme1.xml><?xml version="1.0" encoding="utf-8"?>
 <a:theme xmlns:a="http://schemas.openxmlformats.org/drawingml/2006/main" name="Purdue1">
   <a:themeElements>

</xml_diff>

<commit_message>
deck 3-2: §3 data modeling and semantics (slides 9-12)
Stage 3 of 6: ER model for USER/RESERVATION/ROOM with the no-overlap
invariant, schema-as-obligations DDL (with the 'which line prevents
double-booking?' trap — none does; overlap is a relation between rows),
normalization as a genuine tradeoff, and valid-model-is-not-correct-
application. 32 of 75 min banked.

Co-Authored-By: Claude Opus 5 <noreply@anthropic.com>
</commit_message>
<xml_diff>
--- a/course/lectures/act-3-software-in-the-world/02-compute-environments-and-data-management/3-2-Data-Management.pptx
+++ b/course/lectures/act-3-software-in-the-world/02-compute-environments-and-data-management/3-2-Data-Management.pptx
@@ -16,6 +16,10 @@
     <p:sldId id="261" r:id="rId12"/>
     <p:sldId id="262" r:id="rId13"/>
     <p:sldId id="263" r:id="rId14"/>
+    <p:sldId id="264" r:id="rId15"/>
+    <p:sldId id="265" r:id="rId16"/>
+    <p:sldId id="266" r:id="rId17"/>
+    <p:sldId id="267" r:id="rId18"/>
   </p:sldIdLst>
   <p:sldSz cx="9144000" cy="6858000" type="screen4x3"/>
   <p:notesSz cx="6858000" cy="9144000"/>
@@ -1538,6 +1542,270 @@
 </p:notes>
 </file>
 
+<file path=ppt/notesSlides/notesSlide10.xml><?xml version="1.0" encoding="utf-8"?>
+<p:notes xmlns:a="http://schemas.openxmlformats.org/drawingml/2006/main" xmlns:p="http://schemas.openxmlformats.org/presentationml/2006/main" xmlns:r="http://schemas.openxmlformats.org/officeDocument/2006/relationships">
+  <p:cSld>
+    <p:spTree>
+      <p:nvGrpSpPr>
+        <p:cNvPr id="1" name=""/>
+        <p:cNvGrpSpPr/>
+        <p:nvPr/>
+      </p:nvGrpSpPr>
+      <p:grpSpPr>
+        <a:xfrm>
+          <a:off x="0" y="0"/>
+          <a:ext cx="0" cy="0"/>
+          <a:chOff x="0" y="0"/>
+          <a:chExt cx="0" cy="0"/>
+        </a:xfrm>
+      </p:grpSpPr>
+      <p:sp>
+        <p:nvSpPr>
+          <p:cNvPr id="2" name="Slide Image Placeholder 1"/>
+          <p:cNvSpPr>
+            <a:spLocks noGrp="1"/>
+          </p:cNvSpPr>
+          <p:nvPr>
+            <p:ph type="sldImg" idx="3"/>
+          </p:nvPr>
+        </p:nvSpPr>
+        <p:spPr/>
+      </p:sp>
+      <p:sp>
+        <p:nvSpPr>
+          <p:cNvPr id="3" name="Notes Placeholder 2"/>
+          <p:cNvSpPr>
+            <a:spLocks noGrp="1"/>
+          </p:cNvSpPr>
+          <p:nvPr>
+            <p:ph type="body" idx="1"/>
+          </p:nvPr>
+        </p:nvSpPr>
+        <p:spPr/>
+        <p:txBody>
+          <a:bodyPr/>
+          <a:lstStyle/>
+          <a:p>
+            <a:r>
+              <a:t>TIMING: 4 minutes.</a:t>
+            </a:r>
+          </a:p>
+          <a:p/>
+          <a:p>
+            <a:r>
+              <a:t>Walk the DDL top to bottom: every line is an obligation the DATABASE now enforces no matter which code path writes — a directness of Modeling-meets-Alignment that application-level validation never achieves. The schema is the model, with authority.</a:t>
+            </a:r>
+          </a:p>
+          <a:p/>
+          <a:p>
+            <a:r>
+              <a:t>Then ask the trap question: "Which line prevents double-booking?" Students will nominate CHECK. Let them argue, then land the red line: a CHECK sees ONE row; a foreign key points from one row to one row. Overlap is a predicate over PAIRS of rows, and nothing in this vocabulary can state it. Do NOT soften this — it is the technical point the lecture is built around, and slide 23 resolves it.</a:t>
+            </a:r>
+          </a:p>
+          <a:p/>
+          <a:p>
+            <a:r>
+              <a:t>(If asked: yes, some engines have exclusion constraints that CAN state it — that is exactly slide 23's first fix. Park it.)</a:t>
+            </a:r>
+          </a:p>
+        </p:txBody>
+      </p:sp>
+      <p:sp>
+        <p:nvSpPr>
+          <p:cNvPr id="4" name="Slide Number Placeholder 3"/>
+          <p:cNvSpPr>
+            <a:spLocks noGrp="1"/>
+          </p:cNvSpPr>
+          <p:nvPr>
+            <p:ph type="sldNum" idx="12"/>
+          </p:nvPr>
+        </p:nvSpPr>
+        <p:spPr/>
+      </p:sp>
+    </p:spTree>
+  </p:cSld>
+  <p:clrMapOvr>
+    <a:masterClrMapping/>
+  </p:clrMapOvr>
+</p:notes>
+</file>
+
+<file path=ppt/notesSlides/notesSlide11.xml><?xml version="1.0" encoding="utf-8"?>
+<p:notes xmlns:a="http://schemas.openxmlformats.org/drawingml/2006/main" xmlns:p="http://schemas.openxmlformats.org/presentationml/2006/main" xmlns:r="http://schemas.openxmlformats.org/officeDocument/2006/relationships">
+  <p:cSld>
+    <p:spTree>
+      <p:nvGrpSpPr>
+        <p:cNvPr id="1" name=""/>
+        <p:cNvGrpSpPr/>
+        <p:nvPr/>
+      </p:nvGrpSpPr>
+      <p:grpSpPr>
+        <a:xfrm>
+          <a:off x="0" y="0"/>
+          <a:ext cx="0" cy="0"/>
+          <a:chOff x="0" y="0"/>
+          <a:chExt cx="0" cy="0"/>
+        </a:xfrm>
+      </p:grpSpPr>
+      <p:sp>
+        <p:nvSpPr>
+          <p:cNvPr id="2" name="Slide Image Placeholder 1"/>
+          <p:cNvSpPr>
+            <a:spLocks noGrp="1"/>
+          </p:cNvSpPr>
+          <p:nvPr>
+            <p:ph type="sldImg" idx="3"/>
+          </p:nvPr>
+        </p:nvSpPr>
+        <p:spPr/>
+      </p:sp>
+      <p:sp>
+        <p:nvSpPr>
+          <p:cNvPr id="3" name="Notes Placeholder 2"/>
+          <p:cNvSpPr>
+            <a:spLocks noGrp="1"/>
+          </p:cNvSpPr>
+          <p:nvPr>
+            <p:ph type="body" idx="1"/>
+          </p:nvPr>
+        </p:nvSpPr>
+        <p:spPr/>
+        <p:txBody>
+          <a:bodyPr/>
+          <a:lstStyle/>
+          <a:p>
+            <a:r>
+              <a:t>TIMING: 3 minutes.</a:t>
+            </a:r>
+          </a:p>
+          <a:p/>
+          <a:p>
+            <a:r>
+              <a:t>Normalization is not a virtue and denormalization is not a sin; they move the same cost between the write path and the read path. Our service renames a room roughly never and lists reservations constantly — a defensible denormalization. A trading system updating prices thousands of times a second makes the opposite call.</a:t>
+            </a:r>
+          </a:p>
+          <a:p/>
+          <a:p>
+            <a:r>
+              <a:t>Connect back to slide 5: document stores denormalize NATIVELY (the room document embeds its reservations); relational systems normalize natively and denormalize deliberately. Same tradeoff, different defaults.</a:t>
+            </a:r>
+          </a:p>
+          <a:p/>
+          <a:p>
+            <a:r>
+              <a:t>One caution forward: every copied fact is a new invariant ("copies agree") that someone must now enforce — the same shape as our overlap invariant, and the same question: WHERE does enforcement live?</a:t>
+            </a:r>
+          </a:p>
+        </p:txBody>
+      </p:sp>
+      <p:sp>
+        <p:nvSpPr>
+          <p:cNvPr id="4" name="Slide Number Placeholder 3"/>
+          <p:cNvSpPr>
+            <a:spLocks noGrp="1"/>
+          </p:cNvSpPr>
+          <p:nvPr>
+            <p:ph type="sldNum" idx="12"/>
+          </p:nvPr>
+        </p:nvSpPr>
+        <p:spPr/>
+      </p:sp>
+    </p:spTree>
+  </p:cSld>
+  <p:clrMapOvr>
+    <a:masterClrMapping/>
+  </p:clrMapOvr>
+</p:notes>
+</file>
+
+<file path=ppt/notesSlides/notesSlide12.xml><?xml version="1.0" encoding="utf-8"?>
+<p:notes xmlns:a="http://schemas.openxmlformats.org/drawingml/2006/main" xmlns:p="http://schemas.openxmlformats.org/presentationml/2006/main" xmlns:r="http://schemas.openxmlformats.org/officeDocument/2006/relationships">
+  <p:cSld>
+    <p:spTree>
+      <p:nvGrpSpPr>
+        <p:cNvPr id="1" name=""/>
+        <p:cNvGrpSpPr/>
+        <p:nvPr/>
+      </p:nvGrpSpPr>
+      <p:grpSpPr>
+        <a:xfrm>
+          <a:off x="0" y="0"/>
+          <a:ext cx="0" cy="0"/>
+          <a:chOff x="0" y="0"/>
+          <a:chExt cx="0" cy="0"/>
+        </a:xfrm>
+      </p:grpSpPr>
+      <p:sp>
+        <p:nvSpPr>
+          <p:cNvPr id="2" name="Slide Image Placeholder 1"/>
+          <p:cNvSpPr>
+            <a:spLocks noGrp="1"/>
+          </p:cNvSpPr>
+          <p:nvPr>
+            <p:ph type="sldImg" idx="3"/>
+          </p:nvPr>
+        </p:nvSpPr>
+        <p:spPr/>
+      </p:sp>
+      <p:sp>
+        <p:nvSpPr>
+          <p:cNvPr id="3" name="Notes Placeholder 2"/>
+          <p:cNvSpPr>
+            <a:spLocks noGrp="1"/>
+          </p:cNvSpPr>
+          <p:nvPr>
+            <p:ph type="body" idx="1"/>
+          </p:nvPr>
+        </p:nvSpPr>
+        <p:spPr/>
+        <p:txBody>
+          <a:bodyPr/>
+          <a:lstStyle/>
+          <a:p>
+            <a:r>
+              <a:t>TIMING: 3 minutes.</a:t>
+            </a:r>
+          </a:p>
+          <a:p/>
+          <a:p>
+            <a:r>
+              <a:t>The two rows on screen are the slide-10 trap made concrete: both pass every declared constraint; together they break the service. Model validity and application correctness are different properties with different enforcement machinery.</a:t>
+            </a:r>
+          </a:p>
+          <a:p/>
+          <a:p>
+            <a:r>
+              <a:t>This is also where ACID folklore starts to wobble — students have heard "C is for Consistency" and assume the database therefore understands their application. It does not: it enforces the constraints actually supplied, and ours cannot yet be supplied in row-local vocabulary. Say that plainly now; slide 20 formalizes it.</a:t>
+            </a:r>
+          </a:p>
+          <a:p/>
+          <a:p>
+            <a:r>
+              <a:t>Transition: before we can fix enforcement, we need the other half of the design space — how we ASK the database questions. Query interfaces, then execution, then back here for concurrency.</a:t>
+            </a:r>
+          </a:p>
+        </p:txBody>
+      </p:sp>
+      <p:sp>
+        <p:nvSpPr>
+          <p:cNvPr id="4" name="Slide Number Placeholder 3"/>
+          <p:cNvSpPr>
+            <a:spLocks noGrp="1"/>
+          </p:cNvSpPr>
+          <p:nvPr>
+            <p:ph type="sldNum" idx="12"/>
+          </p:nvPr>
+        </p:nvSpPr>
+        <p:spPr/>
+      </p:sp>
+    </p:spTree>
+  </p:cSld>
+  <p:clrMapOvr>
+    <a:masterClrMapping/>
+  </p:clrMapOvr>
+</p:notes>
+</file>
+
 <file path=ppt/notesSlides/notesSlide2.xml><?xml version="1.0" encoding="utf-8"?>
 <p:notes xmlns:a="http://schemas.openxmlformats.org/drawingml/2006/main" xmlns:p="http://schemas.openxmlformats.org/presentationml/2006/main" xmlns:r="http://schemas.openxmlformats.org/officeDocument/2006/relationships">
   <p:cSld>
@@ -2118,6 +2386,94 @@
           <a:p>
             <a:r>
               <a:t>The teaching point: B is not "worse engineering" than A — its requirements genuinely do not need what A must pay for. Resist any student framing of A as legacy and B as modern.</a:t>
+            </a:r>
+          </a:p>
+        </p:txBody>
+      </p:sp>
+      <p:sp>
+        <p:nvSpPr>
+          <p:cNvPr id="4" name="Slide Number Placeholder 3"/>
+          <p:cNvSpPr>
+            <a:spLocks noGrp="1"/>
+          </p:cNvSpPr>
+          <p:nvPr>
+            <p:ph type="sldNum" idx="12"/>
+          </p:nvPr>
+        </p:nvSpPr>
+        <p:spPr/>
+      </p:sp>
+    </p:spTree>
+  </p:cSld>
+  <p:clrMapOvr>
+    <a:masterClrMapping/>
+  </p:clrMapOvr>
+</p:notes>
+</file>
+
+<file path=ppt/notesSlides/notesSlide9.xml><?xml version="1.0" encoding="utf-8"?>
+<p:notes xmlns:a="http://schemas.openxmlformats.org/drawingml/2006/main" xmlns:p="http://schemas.openxmlformats.org/presentationml/2006/main" xmlns:r="http://schemas.openxmlformats.org/officeDocument/2006/relationships">
+  <p:cSld>
+    <p:spTree>
+      <p:nvGrpSpPr>
+        <p:cNvPr id="1" name=""/>
+        <p:cNvGrpSpPr/>
+        <p:nvPr/>
+      </p:nvGrpSpPr>
+      <p:grpSpPr>
+        <a:xfrm>
+          <a:off x="0" y="0"/>
+          <a:ext cx="0" cy="0"/>
+          <a:chOff x="0" y="0"/>
+          <a:chExt cx="0" cy="0"/>
+        </a:xfrm>
+      </p:grpSpPr>
+      <p:sp>
+        <p:nvSpPr>
+          <p:cNvPr id="2" name="Slide Image Placeholder 1"/>
+          <p:cNvSpPr>
+            <a:spLocks noGrp="1"/>
+          </p:cNvSpPr>
+          <p:nvPr>
+            <p:ph type="sldImg" idx="3"/>
+          </p:nvPr>
+        </p:nvSpPr>
+        <p:spPr/>
+      </p:sp>
+      <p:sp>
+        <p:nvSpPr>
+          <p:cNvPr id="3" name="Notes Placeholder 2"/>
+          <p:cNvSpPr>
+            <a:spLocks noGrp="1"/>
+          </p:cNvSpPr>
+          <p:nvPr>
+            <p:ph type="body" idx="1"/>
+          </p:nvPr>
+        </p:nvSpPr>
+        <p:spPr/>
+        <p:txBody>
+          <a:bodyPr/>
+          <a:lstStyle/>
+          <a:p>
+            <a:r>
+              <a:t>TIMING: 3 minutes.</a:t>
+            </a:r>
+          </a:p>
+          <a:p/>
+          <a:p>
+            <a:r>
+              <a:t>Act II's modeling discipline, applied: an ER model selects which facts exist and how they relate. One user makes many reservations; one room hosts many reservations; the reservation is the relationship made into an entity.</a:t>
+            </a:r>
+          </a:p>
+          <a:p/>
+          <a:p>
+            <a:r>
+              <a:t>Point at the bolded attributes: starts_at, ends_at, status are there BECAUSE the invariant needs them — a model earns its attributes from the obligations it must support, not from an urge to record everything.</a:t>
+            </a:r>
+          </a:p>
+          <a:p/>
+          <a:p>
+            <a:r>
+              <a:t>Ask: could we model this as ROOM embedding a list of reservations? Yes — that is the document shape from slide 5; the invariant then lives inside one document, which will matter later. The relational shape makes the reservation a first-class row.</a:t>
             </a:r>
           </a:p>
         </p:txBody>
@@ -9516,6 +9872,1584 @@
 </p:sld>
 </file>
 
+<file path=ppt/slides/slide10.xml><?xml version="1.0" encoding="utf-8"?>
+<p:sld xmlns:a="http://schemas.openxmlformats.org/drawingml/2006/main" xmlns:p="http://schemas.openxmlformats.org/presentationml/2006/main" xmlns:r="http://schemas.openxmlformats.org/officeDocument/2006/relationships">
+  <p:cSld>
+    <p:spTree>
+      <p:nvGrpSpPr>
+        <p:cNvPr id="1" name=""/>
+        <p:cNvGrpSpPr/>
+        <p:nvPr/>
+      </p:nvGrpSpPr>
+      <p:grpSpPr/>
+      <p:sp>
+        <p:nvSpPr>
+          <p:cNvPr id="2" name="Title"/>
+          <p:cNvSpPr txBox="1"/>
+          <p:nvPr/>
+        </p:nvSpPr>
+        <p:spPr>
+          <a:xfrm>
+            <a:off x="274320" y="128016"/>
+            <a:ext cx="8595360" cy="594360"/>
+          </a:xfrm>
+          <a:prstGeom prst="rect">
+            <a:avLst/>
+          </a:prstGeom>
+          <a:noFill/>
+        </p:spPr>
+        <p:txBody>
+          <a:bodyPr wrap="square">
+            <a:spAutoFit/>
+          </a:bodyPr>
+          <a:lstStyle/>
+          <a:p>
+            <a:pPr algn="l">
+              <a:spcAft>
+                <a:spcPts val="400"/>
+              </a:spcAft>
+            </a:pPr>
+            <a:r>
+              <a:rPr sz="2400" b="0">
+                <a:solidFill>
+                  <a:srgbClr val="2D2D2D"/>
+                </a:solidFill>
+                <a:latin typeface="Calibri"/>
+              </a:rPr>
+              <a:t>A schema turns the model into enforced obligations</a:t>
+            </a:r>
+          </a:p>
+        </p:txBody>
+      </p:sp>
+      <p:sp>
+        <p:nvSpPr>
+          <p:cNvPr id="3" name="Card"/>
+          <p:cNvSpPr/>
+          <p:nvPr/>
+        </p:nvSpPr>
+        <p:spPr>
+          <a:xfrm>
+            <a:off x="411480" y="960120"/>
+            <a:ext cx="5577840" cy="3017520"/>
+          </a:xfrm>
+          <a:prstGeom prst="rect">
+            <a:avLst/>
+          </a:prstGeom>
+          <a:solidFill>
+            <a:srgbClr val="FCFAF6"/>
+          </a:solidFill>
+          <a:ln>
+            <a:noFill/>
+          </a:ln>
+          <a:effectLst/>
+        </p:spPr>
+        <p:style>
+          <a:lnRef idx="1">
+            <a:schemeClr val="accent1"/>
+          </a:lnRef>
+          <a:fillRef idx="3">
+            <a:schemeClr val="accent1"/>
+          </a:fillRef>
+          <a:effectRef idx="2">
+            <a:schemeClr val="accent1"/>
+          </a:effectRef>
+          <a:fontRef idx="minor">
+            <a:schemeClr val="lt1"/>
+          </a:fontRef>
+        </p:style>
+        <p:txBody>
+          <a:bodyPr rtlCol="0" anchor="ctr" wrap="square"/>
+          <a:lstStyle/>
+          <a:p>
+            <a:pPr algn="ctr"/>
+          </a:p>
+        </p:txBody>
+      </p:sp>
+      <p:sp>
+        <p:nvSpPr>
+          <p:cNvPr id="4" name="Code"/>
+          <p:cNvSpPr txBox="1"/>
+          <p:nvPr/>
+        </p:nvSpPr>
+        <p:spPr>
+          <a:xfrm>
+            <a:off x="557784" y="1051560"/>
+            <a:ext cx="5303520" cy="2834640"/>
+          </a:xfrm>
+          <a:prstGeom prst="rect">
+            <a:avLst/>
+          </a:prstGeom>
+          <a:noFill/>
+        </p:spPr>
+        <p:txBody>
+          <a:bodyPr wrap="square">
+            <a:spAutoFit/>
+          </a:bodyPr>
+          <a:lstStyle/>
+          <a:p>
+            <a:pPr algn="l">
+              <a:spcAft>
+                <a:spcPts val="100"/>
+              </a:spcAft>
+            </a:pPr>
+            <a:r>
+              <a:rPr sz="2000" b="0">
+                <a:solidFill>
+                  <a:srgbClr val="2D2D2D"/>
+                </a:solidFill>
+                <a:latin typeface="Consolas"/>
+              </a:rPr>
+              <a:t>CREATE TABLE reservations (</a:t>
+            </a:r>
+          </a:p>
+          <a:p>
+            <a:pPr algn="l">
+              <a:spcAft>
+                <a:spcPts val="100"/>
+              </a:spcAft>
+            </a:pPr>
+            <a:r>
+              <a:rPr sz="2000" b="0">
+                <a:solidFill>
+                  <a:srgbClr val="2D2D2D"/>
+                </a:solidFill>
+                <a:latin typeface="Consolas"/>
+              </a:rPr>
+              <a:t>  room_id    INT REFERENCES rooms(id),</a:t>
+            </a:r>
+          </a:p>
+          <a:p>
+            <a:pPr algn="l">
+              <a:spcAft>
+                <a:spcPts val="100"/>
+              </a:spcAft>
+            </a:pPr>
+            <a:r>
+              <a:rPr sz="2000" b="0">
+                <a:solidFill>
+                  <a:srgbClr val="2D2D2D"/>
+                </a:solidFill>
+                <a:latin typeface="Consolas"/>
+              </a:rPr>
+              <a:t>  user_id    INT REFERENCES users(id),</a:t>
+            </a:r>
+          </a:p>
+          <a:p>
+            <a:pPr algn="l">
+              <a:spcAft>
+                <a:spcPts val="100"/>
+              </a:spcAft>
+            </a:pPr>
+            <a:r>
+              <a:rPr sz="2000" b="0">
+                <a:solidFill>
+                  <a:srgbClr val="2D2D2D"/>
+                </a:solidFill>
+                <a:latin typeface="Consolas"/>
+              </a:rPr>
+              <a:t>  starts_at  TIMESTAMP NOT NULL,</a:t>
+            </a:r>
+          </a:p>
+          <a:p>
+            <a:pPr algn="l">
+              <a:spcAft>
+                <a:spcPts val="100"/>
+              </a:spcAft>
+            </a:pPr>
+            <a:r>
+              <a:rPr sz="2000" b="0">
+                <a:solidFill>
+                  <a:srgbClr val="2D2D2D"/>
+                </a:solidFill>
+                <a:latin typeface="Consolas"/>
+              </a:rPr>
+              <a:t>  ends_at    TIMESTAMP NOT NULL,</a:t>
+            </a:r>
+          </a:p>
+          <a:p>
+            <a:pPr algn="l">
+              <a:spcAft>
+                <a:spcPts val="100"/>
+              </a:spcAft>
+            </a:pPr>
+            <a:r>
+              <a:rPr sz="2000" b="0">
+                <a:solidFill>
+                  <a:srgbClr val="2D2D2D"/>
+                </a:solidFill>
+                <a:latin typeface="Consolas"/>
+              </a:rPr>
+              <a:t>  status     TEXT NOT NULL,</a:t>
+            </a:r>
+          </a:p>
+          <a:p>
+            <a:pPr algn="l">
+              <a:spcAft>
+                <a:spcPts val="100"/>
+              </a:spcAft>
+            </a:pPr>
+            <a:r>
+              <a:rPr sz="2000" b="0">
+                <a:solidFill>
+                  <a:srgbClr val="2D2D2D"/>
+                </a:solidFill>
+                <a:latin typeface="Consolas"/>
+              </a:rPr>
+              <a:t>  CHECK (starts_at &lt; ends_at)</a:t>
+            </a:r>
+          </a:p>
+          <a:p>
+            <a:pPr algn="l">
+              <a:spcAft>
+                <a:spcPts val="100"/>
+              </a:spcAft>
+            </a:pPr>
+            <a:r>
+              <a:rPr sz="2000" b="0">
+                <a:solidFill>
+                  <a:srgbClr val="2D2D2D"/>
+                </a:solidFill>
+                <a:latin typeface="Consolas"/>
+              </a:rPr>
+              <a:t>);</a:t>
+            </a:r>
+          </a:p>
+        </p:txBody>
+      </p:sp>
+      <p:sp>
+        <p:nvSpPr>
+          <p:cNvPr id="5" name="Card"/>
+          <p:cNvSpPr/>
+          <p:nvPr/>
+        </p:nvSpPr>
+        <p:spPr>
+          <a:xfrm>
+            <a:off x="6172200" y="960120"/>
+            <a:ext cx="2560320" cy="3017520"/>
+          </a:xfrm>
+          <a:prstGeom prst="rect">
+            <a:avLst/>
+          </a:prstGeom>
+          <a:solidFill>
+            <a:srgbClr val="F5F1E8"/>
+          </a:solidFill>
+          <a:ln>
+            <a:noFill/>
+          </a:ln>
+          <a:effectLst/>
+        </p:spPr>
+        <p:style>
+          <a:lnRef idx="1">
+            <a:schemeClr val="accent1"/>
+          </a:lnRef>
+          <a:fillRef idx="3">
+            <a:schemeClr val="accent1"/>
+          </a:fillRef>
+          <a:effectRef idx="2">
+            <a:schemeClr val="accent1"/>
+          </a:effectRef>
+          <a:fontRef idx="minor">
+            <a:schemeClr val="lt1"/>
+          </a:fontRef>
+        </p:style>
+        <p:txBody>
+          <a:bodyPr rtlCol="0" anchor="ctr" wrap="square"/>
+          <a:lstStyle/>
+          <a:p>
+            <a:pPr algn="ctr"/>
+          </a:p>
+        </p:txBody>
+      </p:sp>
+      <p:sp>
+        <p:nvSpPr>
+          <p:cNvPr id="6" name="Annotations"/>
+          <p:cNvSpPr txBox="1"/>
+          <p:nvPr/>
+        </p:nvSpPr>
+        <p:spPr>
+          <a:xfrm>
+            <a:off x="6318504" y="1051560"/>
+            <a:ext cx="2267712" cy="2834640"/>
+          </a:xfrm>
+          <a:prstGeom prst="rect">
+            <a:avLst/>
+          </a:prstGeom>
+          <a:noFill/>
+        </p:spPr>
+        <p:txBody>
+          <a:bodyPr wrap="square">
+            <a:spAutoFit/>
+          </a:bodyPr>
+          <a:lstStyle/>
+          <a:p>
+            <a:pPr algn="l">
+              <a:spcAft>
+                <a:spcPts val="600"/>
+              </a:spcAft>
+            </a:pPr>
+            <a:r>
+              <a:rPr sz="2000" b="1">
+                <a:solidFill>
+                  <a:srgbClr val="8E6F3E"/>
+                </a:solidFill>
+                <a:latin typeface="Calibri"/>
+              </a:rPr>
+              <a:t>REFERENCES</a:t>
+            </a:r>
+            <a:r>
+              <a:rPr sz="2000" b="0">
+                <a:solidFill>
+                  <a:srgbClr val="555960"/>
+                </a:solidFill>
+                <a:latin typeface="Calibri"/>
+              </a:rPr>
+              <a:t> — that row must exist</a:t>
+            </a:r>
+          </a:p>
+          <a:p>
+            <a:pPr algn="l">
+              <a:spcAft>
+                <a:spcPts val="600"/>
+              </a:spcAft>
+            </a:pPr>
+            <a:r>
+              <a:rPr sz="2000" b="1">
+                <a:solidFill>
+                  <a:srgbClr val="8E6F3E"/>
+                </a:solidFill>
+                <a:latin typeface="Calibri"/>
+              </a:rPr>
+              <a:t>NOT NULL</a:t>
+            </a:r>
+            <a:r>
+              <a:rPr sz="2000" b="0">
+                <a:solidFill>
+                  <a:srgbClr val="555960"/>
+                </a:solidFill>
+                <a:latin typeface="Calibri"/>
+              </a:rPr>
+              <a:t> — the fact must be present</a:t>
+            </a:r>
+          </a:p>
+          <a:p>
+            <a:pPr algn="l">
+              <a:spcAft>
+                <a:spcPts val="400"/>
+              </a:spcAft>
+            </a:pPr>
+            <a:r>
+              <a:rPr sz="2000" b="1">
+                <a:solidFill>
+                  <a:srgbClr val="8E6F3E"/>
+                </a:solidFill>
+                <a:latin typeface="Calibri"/>
+              </a:rPr>
+              <a:t>CHECK</a:t>
+            </a:r>
+            <a:r>
+              <a:rPr sz="2000" b="0">
+                <a:solidFill>
+                  <a:srgbClr val="555960"/>
+                </a:solidFill>
+                <a:latin typeface="Calibri"/>
+              </a:rPr>
+              <a:t> — true within one row</a:t>
+            </a:r>
+          </a:p>
+        </p:txBody>
+      </p:sp>
+      <p:sp>
+        <p:nvSpPr>
+          <p:cNvPr id="7" name="Card"/>
+          <p:cNvSpPr/>
+          <p:nvPr/>
+        </p:nvSpPr>
+        <p:spPr>
+          <a:xfrm>
+            <a:off x="411480" y="4160520"/>
+            <a:ext cx="8321040" cy="1417320"/>
+          </a:xfrm>
+          <a:prstGeom prst="rect">
+            <a:avLst/>
+          </a:prstGeom>
+          <a:solidFill>
+            <a:srgbClr val="F5F1E8"/>
+          </a:solidFill>
+          <a:ln>
+            <a:noFill/>
+          </a:ln>
+          <a:effectLst/>
+        </p:spPr>
+        <p:style>
+          <a:lnRef idx="1">
+            <a:schemeClr val="accent1"/>
+          </a:lnRef>
+          <a:fillRef idx="3">
+            <a:schemeClr val="accent1"/>
+          </a:fillRef>
+          <a:effectRef idx="2">
+            <a:schemeClr val="accent1"/>
+          </a:effectRef>
+          <a:fontRef idx="minor">
+            <a:schemeClr val="lt1"/>
+          </a:fontRef>
+        </p:style>
+        <p:txBody>
+          <a:bodyPr rtlCol="0" anchor="ctr" wrap="square"/>
+          <a:lstStyle/>
+          <a:p>
+            <a:pPr algn="ctr"/>
+          </a:p>
+        </p:txBody>
+      </p:sp>
+      <p:sp>
+        <p:nvSpPr>
+          <p:cNvPr id="8" name="NonClaim"/>
+          <p:cNvSpPr txBox="1"/>
+          <p:nvPr/>
+        </p:nvSpPr>
+        <p:spPr>
+          <a:xfrm>
+            <a:off x="557784" y="4233672"/>
+            <a:ext cx="8046720" cy="1280160"/>
+          </a:xfrm>
+          <a:prstGeom prst="rect">
+            <a:avLst/>
+          </a:prstGeom>
+          <a:noFill/>
+        </p:spPr>
+        <p:txBody>
+          <a:bodyPr wrap="square">
+            <a:spAutoFit/>
+          </a:bodyPr>
+          <a:lstStyle/>
+          <a:p>
+            <a:pPr algn="l">
+              <a:spcAft>
+                <a:spcPts val="300"/>
+              </a:spcAft>
+            </a:pPr>
+            <a:r>
+              <a:rPr sz="2000" b="1">
+                <a:solidFill>
+                  <a:srgbClr val="C01B1B"/>
+                </a:solidFill>
+                <a:latin typeface="Calibri"/>
+              </a:rPr>
+              <a:t>Nothing here prevents two CONFIRMED reservations from overlapping</a:t>
+            </a:r>
+          </a:p>
+          <a:p>
+            <a:pPr algn="l">
+              <a:spcAft>
+                <a:spcPts val="400"/>
+              </a:spcAft>
+            </a:pPr>
+            <a:r>
+              <a:rPr sz="2000" b="0">
+                <a:solidFill>
+                  <a:srgbClr val="555960"/>
+                </a:solidFill>
+                <a:latin typeface="Calibri"/>
+              </a:rPr>
+              <a:t>Each declared constraint governs one row — overlap is a relation BETWEEN rows.</a:t>
+            </a:r>
+          </a:p>
+        </p:txBody>
+      </p:sp>
+      <p:sp>
+        <p:nvSpPr>
+          <p:cNvPr id="9" name="FooterBand"/>
+          <p:cNvSpPr/>
+          <p:nvPr/>
+        </p:nvSpPr>
+        <p:spPr>
+          <a:xfrm>
+            <a:off x="274320" y="5879592"/>
+            <a:ext cx="8595360" cy="502920"/>
+          </a:xfrm>
+          <a:prstGeom prst="rect">
+            <a:avLst/>
+          </a:prstGeom>
+          <a:solidFill>
+            <a:srgbClr val="8E6F3E"/>
+          </a:solidFill>
+          <a:ln>
+            <a:noFill/>
+          </a:ln>
+          <a:effectLst/>
+        </p:spPr>
+        <p:style>
+          <a:lnRef idx="1">
+            <a:schemeClr val="accent1"/>
+          </a:lnRef>
+          <a:fillRef idx="3">
+            <a:schemeClr val="accent1"/>
+          </a:fillRef>
+          <a:effectRef idx="2">
+            <a:schemeClr val="accent1"/>
+          </a:effectRef>
+          <a:fontRef idx="minor">
+            <a:schemeClr val="lt1"/>
+          </a:fontRef>
+        </p:style>
+        <p:txBody>
+          <a:bodyPr rtlCol="0" anchor="ctr" wrap="square"/>
+          <a:lstStyle/>
+          <a:p>
+            <a:pPr algn="ctr"/>
+          </a:p>
+        </p:txBody>
+      </p:sp>
+      <p:sp>
+        <p:nvSpPr>
+          <p:cNvPr id="10" name="FooterBandText"/>
+          <p:cNvSpPr txBox="1"/>
+          <p:nvPr/>
+        </p:nvSpPr>
+        <p:spPr>
+          <a:xfrm>
+            <a:off x="384048" y="5897880"/>
+            <a:ext cx="8375904" cy="457200"/>
+          </a:xfrm>
+          <a:prstGeom prst="rect">
+            <a:avLst/>
+          </a:prstGeom>
+          <a:noFill/>
+        </p:spPr>
+        <p:txBody>
+          <a:bodyPr wrap="square">
+            <a:spAutoFit/>
+          </a:bodyPr>
+          <a:lstStyle/>
+          <a:p>
+            <a:pPr algn="ctr">
+              <a:spcAft>
+                <a:spcPts val="400"/>
+              </a:spcAft>
+            </a:pPr>
+            <a:r>
+              <a:rPr sz="2000" b="1">
+                <a:solidFill>
+                  <a:srgbClr val="FFFFFF"/>
+                </a:solidFill>
+                <a:latin typeface="Calibri"/>
+              </a:rPr>
+              <a:t>A schema is enforced obligations — but only those you can state in it</a:t>
+            </a:r>
+          </a:p>
+        </p:txBody>
+      </p:sp>
+    </p:spTree>
+  </p:cSld>
+  <p:clrMapOvr>
+    <a:masterClrMapping/>
+  </p:clrMapOvr>
+</p:sld>
+</file>
+
+<file path=ppt/slides/slide11.xml><?xml version="1.0" encoding="utf-8"?>
+<p:sld xmlns:a="http://schemas.openxmlformats.org/drawingml/2006/main" xmlns:p="http://schemas.openxmlformats.org/presentationml/2006/main" xmlns:r="http://schemas.openxmlformats.org/officeDocument/2006/relationships">
+  <p:cSld>
+    <p:spTree>
+      <p:nvGrpSpPr>
+        <p:cNvPr id="1" name=""/>
+        <p:cNvGrpSpPr/>
+        <p:nvPr/>
+      </p:nvGrpSpPr>
+      <p:grpSpPr/>
+      <p:sp>
+        <p:nvSpPr>
+          <p:cNvPr id="2" name="Title"/>
+          <p:cNvSpPr txBox="1"/>
+          <p:nvPr/>
+        </p:nvSpPr>
+        <p:spPr>
+          <a:xfrm>
+            <a:off x="274320" y="128016"/>
+            <a:ext cx="8595360" cy="594360"/>
+          </a:xfrm>
+          <a:prstGeom prst="rect">
+            <a:avLst/>
+          </a:prstGeom>
+          <a:noFill/>
+        </p:spPr>
+        <p:txBody>
+          <a:bodyPr wrap="square">
+            <a:spAutoFit/>
+          </a:bodyPr>
+          <a:lstStyle/>
+          <a:p>
+            <a:pPr algn="l">
+              <a:spcAft>
+                <a:spcPts val="400"/>
+              </a:spcAft>
+            </a:pPr>
+            <a:r>
+              <a:rPr sz="2400" b="0">
+                <a:solidFill>
+                  <a:srgbClr val="2D2D2D"/>
+                </a:solidFill>
+                <a:latin typeface="Calibri"/>
+              </a:rPr>
+              <a:t>Normalization vs denormalization is a genuine tradeoff</a:t>
+            </a:r>
+          </a:p>
+        </p:txBody>
+      </p:sp>
+      <p:sp>
+        <p:nvSpPr>
+          <p:cNvPr id="3" name="Card"/>
+          <p:cNvSpPr/>
+          <p:nvPr/>
+        </p:nvSpPr>
+        <p:spPr>
+          <a:xfrm>
+            <a:off x="411480" y="960120"/>
+            <a:ext cx="4069080" cy="2377440"/>
+          </a:xfrm>
+          <a:prstGeom prst="rect">
+            <a:avLst/>
+          </a:prstGeom>
+          <a:solidFill>
+            <a:srgbClr val="FCFAF6"/>
+          </a:solidFill>
+          <a:ln>
+            <a:noFill/>
+          </a:ln>
+          <a:effectLst/>
+        </p:spPr>
+        <p:style>
+          <a:lnRef idx="1">
+            <a:schemeClr val="accent1"/>
+          </a:lnRef>
+          <a:fillRef idx="3">
+            <a:schemeClr val="accent1"/>
+          </a:fillRef>
+          <a:effectRef idx="2">
+            <a:schemeClr val="accent1"/>
+          </a:effectRef>
+          <a:fontRef idx="minor">
+            <a:schemeClr val="lt1"/>
+          </a:fontRef>
+        </p:style>
+        <p:txBody>
+          <a:bodyPr rtlCol="0" anchor="ctr" wrap="square"/>
+          <a:lstStyle/>
+          <a:p>
+            <a:pPr algn="ctr"/>
+          </a:p>
+        </p:txBody>
+      </p:sp>
+      <p:sp>
+        <p:nvSpPr>
+          <p:cNvPr id="4" name="CardBody"/>
+          <p:cNvSpPr txBox="1"/>
+          <p:nvPr/>
+        </p:nvSpPr>
+        <p:spPr>
+          <a:xfrm>
+            <a:off x="557784" y="1051560"/>
+            <a:ext cx="3776472" cy="2194560"/>
+          </a:xfrm>
+          <a:prstGeom prst="rect">
+            <a:avLst/>
+          </a:prstGeom>
+          <a:noFill/>
+        </p:spPr>
+        <p:txBody>
+          <a:bodyPr wrap="square">
+            <a:spAutoFit/>
+          </a:bodyPr>
+          <a:lstStyle/>
+          <a:p>
+            <a:pPr algn="l">
+              <a:spcAft>
+                <a:spcPts val="400"/>
+              </a:spcAft>
+            </a:pPr>
+            <a:r>
+              <a:rPr sz="2000" b="1">
+                <a:solidFill>
+                  <a:srgbClr val="8E6F3E"/>
+                </a:solidFill>
+                <a:latin typeface="Calibri"/>
+              </a:rPr>
+              <a:t>NORMALIZED</a:t>
+            </a:r>
+          </a:p>
+          <a:p>
+            <a:pPr algn="l">
+              <a:spcAft>
+                <a:spcPts val="400"/>
+              </a:spcAft>
+            </a:pPr>
+            <a:r>
+              <a:rPr sz="2000" b="1">
+                <a:solidFill>
+                  <a:srgbClr val="5C4826"/>
+                </a:solidFill>
+                <a:latin typeface="Calibri"/>
+              </a:rPr>
+              <a:t>One fact lives in one place</a:t>
+            </a:r>
+          </a:p>
+          <a:p>
+            <a:pPr algn="l">
+              <a:spcAft>
+                <a:spcPts val="400"/>
+              </a:spcAft>
+            </a:pPr>
+            <a:r>
+              <a:rPr sz="2000" b="0">
+                <a:solidFill>
+                  <a:srgbClr val="555960"/>
+                </a:solidFill>
+                <a:latin typeface="Calibri"/>
+              </a:rPr>
+              <a:t>Room name stored once, in rooms</a:t>
+            </a:r>
+          </a:p>
+          <a:p>
+            <a:pPr algn="l">
+              <a:spcAft>
+                <a:spcPts val="400"/>
+              </a:spcAft>
+            </a:pPr>
+            <a:r>
+              <a:rPr sz="2000" b="0">
+                <a:solidFill>
+                  <a:srgbClr val="555960"/>
+                </a:solidFill>
+                <a:latin typeface="Calibri"/>
+              </a:rPr>
+              <a:t>Writes: cheap and safe</a:t>
+            </a:r>
+          </a:p>
+          <a:p>
+            <a:pPr algn="l">
+              <a:spcAft>
+                <a:spcPts val="400"/>
+              </a:spcAft>
+            </a:pPr>
+            <a:r>
+              <a:rPr sz="2000" b="0">
+                <a:solidFill>
+                  <a:srgbClr val="555960"/>
+                </a:solidFill>
+                <a:latin typeface="Calibri"/>
+              </a:rPr>
+              <a:t>Reads: join to assemble the page</a:t>
+            </a:r>
+          </a:p>
+        </p:txBody>
+      </p:sp>
+      <p:sp>
+        <p:nvSpPr>
+          <p:cNvPr id="5" name="Card"/>
+          <p:cNvSpPr/>
+          <p:nvPr/>
+        </p:nvSpPr>
+        <p:spPr>
+          <a:xfrm>
+            <a:off x="4663440" y="960120"/>
+            <a:ext cx="4069080" cy="2377440"/>
+          </a:xfrm>
+          <a:prstGeom prst="rect">
+            <a:avLst/>
+          </a:prstGeom>
+          <a:solidFill>
+            <a:srgbClr val="FCFAF6"/>
+          </a:solidFill>
+          <a:ln>
+            <a:noFill/>
+          </a:ln>
+          <a:effectLst/>
+        </p:spPr>
+        <p:style>
+          <a:lnRef idx="1">
+            <a:schemeClr val="accent1"/>
+          </a:lnRef>
+          <a:fillRef idx="3">
+            <a:schemeClr val="accent1"/>
+          </a:fillRef>
+          <a:effectRef idx="2">
+            <a:schemeClr val="accent1"/>
+          </a:effectRef>
+          <a:fontRef idx="minor">
+            <a:schemeClr val="lt1"/>
+          </a:fontRef>
+        </p:style>
+        <p:txBody>
+          <a:bodyPr rtlCol="0" anchor="ctr" wrap="square"/>
+          <a:lstStyle/>
+          <a:p>
+            <a:pPr algn="ctr"/>
+          </a:p>
+        </p:txBody>
+      </p:sp>
+      <p:sp>
+        <p:nvSpPr>
+          <p:cNvPr id="6" name="CardBody"/>
+          <p:cNvSpPr txBox="1"/>
+          <p:nvPr/>
+        </p:nvSpPr>
+        <p:spPr>
+          <a:xfrm>
+            <a:off x="4809744" y="1051560"/>
+            <a:ext cx="3776472" cy="2194560"/>
+          </a:xfrm>
+          <a:prstGeom prst="rect">
+            <a:avLst/>
+          </a:prstGeom>
+          <a:noFill/>
+        </p:spPr>
+        <p:txBody>
+          <a:bodyPr wrap="square">
+            <a:spAutoFit/>
+          </a:bodyPr>
+          <a:lstStyle/>
+          <a:p>
+            <a:pPr algn="l">
+              <a:spcAft>
+                <a:spcPts val="400"/>
+              </a:spcAft>
+            </a:pPr>
+            <a:r>
+              <a:rPr sz="2000" b="1">
+                <a:solidFill>
+                  <a:srgbClr val="8E6F3E"/>
+                </a:solidFill>
+                <a:latin typeface="Calibri"/>
+              </a:rPr>
+              <a:t>DENORMALIZED</a:t>
+            </a:r>
+          </a:p>
+          <a:p>
+            <a:pPr algn="l">
+              <a:spcAft>
+                <a:spcPts val="400"/>
+              </a:spcAft>
+            </a:pPr>
+            <a:r>
+              <a:rPr sz="2000" b="1">
+                <a:solidFill>
+                  <a:srgbClr val="5C4826"/>
+                </a:solidFill>
+                <a:latin typeface="Calibri"/>
+              </a:rPr>
+              <a:t>Facts copied to where they are read</a:t>
+            </a:r>
+          </a:p>
+          <a:p>
+            <a:pPr algn="l">
+              <a:spcAft>
+                <a:spcPts val="400"/>
+              </a:spcAft>
+            </a:pPr>
+            <a:r>
+              <a:rPr sz="2000" b="0">
+                <a:solidFill>
+                  <a:srgbClr val="555960"/>
+                </a:solidFill>
+                <a:latin typeface="Calibri"/>
+              </a:rPr>
+              <a:t>Room name copied into each reservation</a:t>
+            </a:r>
+          </a:p>
+          <a:p>
+            <a:pPr algn="l">
+              <a:spcAft>
+                <a:spcPts val="400"/>
+              </a:spcAft>
+            </a:pPr>
+            <a:r>
+              <a:rPr sz="2000" b="0">
+                <a:solidFill>
+                  <a:srgbClr val="555960"/>
+                </a:solidFill>
+                <a:latin typeface="Calibri"/>
+              </a:rPr>
+              <a:t>Reads: one fetch, no join</a:t>
+            </a:r>
+          </a:p>
+          <a:p>
+            <a:pPr algn="l">
+              <a:spcAft>
+                <a:spcPts val="400"/>
+              </a:spcAft>
+            </a:pPr>
+            <a:r>
+              <a:rPr sz="2000" b="0">
+                <a:solidFill>
+                  <a:srgbClr val="555960"/>
+                </a:solidFill>
+                <a:latin typeface="Calibri"/>
+              </a:rPr>
+              <a:t>Writes: must update every copy</a:t>
+            </a:r>
+          </a:p>
+        </p:txBody>
+      </p:sp>
+      <p:sp>
+        <p:nvSpPr>
+          <p:cNvPr id="7" name="Card"/>
+          <p:cNvSpPr/>
+          <p:nvPr/>
+        </p:nvSpPr>
+        <p:spPr>
+          <a:xfrm>
+            <a:off x="411480" y="3566160"/>
+            <a:ext cx="8321040" cy="1508760"/>
+          </a:xfrm>
+          <a:prstGeom prst="rect">
+            <a:avLst/>
+          </a:prstGeom>
+          <a:solidFill>
+            <a:srgbClr val="F5F1E8"/>
+          </a:solidFill>
+          <a:ln>
+            <a:noFill/>
+          </a:ln>
+          <a:effectLst/>
+        </p:spPr>
+        <p:style>
+          <a:lnRef idx="1">
+            <a:schemeClr val="accent1"/>
+          </a:lnRef>
+          <a:fillRef idx="3">
+            <a:schemeClr val="accent1"/>
+          </a:fillRef>
+          <a:effectRef idx="2">
+            <a:schemeClr val="accent1"/>
+          </a:effectRef>
+          <a:fontRef idx="minor">
+            <a:schemeClr val="lt1"/>
+          </a:fontRef>
+        </p:style>
+        <p:txBody>
+          <a:bodyPr rtlCol="0" anchor="ctr" wrap="square"/>
+          <a:lstStyle/>
+          <a:p>
+            <a:pPr algn="ctr"/>
+          </a:p>
+        </p:txBody>
+      </p:sp>
+      <p:sp>
+        <p:nvSpPr>
+          <p:cNvPr id="8" name="CardBody"/>
+          <p:cNvSpPr txBox="1"/>
+          <p:nvPr/>
+        </p:nvSpPr>
+        <p:spPr>
+          <a:xfrm>
+            <a:off x="557784" y="3639312"/>
+            <a:ext cx="8046720" cy="1371600"/>
+          </a:xfrm>
+          <a:prstGeom prst="rect">
+            <a:avLst/>
+          </a:prstGeom>
+          <a:noFill/>
+        </p:spPr>
+        <p:txBody>
+          <a:bodyPr wrap="square">
+            <a:spAutoFit/>
+          </a:bodyPr>
+          <a:lstStyle/>
+          <a:p>
+            <a:pPr algn="l">
+              <a:spcAft>
+                <a:spcPts val="300"/>
+              </a:spcAft>
+            </a:pPr>
+            <a:r>
+              <a:rPr sz="2000" b="1">
+                <a:solidFill>
+                  <a:srgbClr val="5C4826"/>
+                </a:solidFill>
+                <a:latin typeface="Calibri"/>
+              </a:rPr>
+              <a:t>The reservations page shows a room name beside every booking</a:t>
+            </a:r>
+          </a:p>
+          <a:p>
+            <a:pPr algn="l">
+              <a:spcAft>
+                <a:spcPts val="400"/>
+              </a:spcAft>
+            </a:pPr>
+            <a:r>
+              <a:rPr sz="2000" b="0">
+                <a:solidFill>
+                  <a:srgbClr val="555960"/>
+                </a:solidFill>
+                <a:latin typeface="Calibri"/>
+              </a:rPr>
+              <a:t>Join on every read, or copy and own the copies' staleness. The read/write mix settles it — not a doctrine.</a:t>
+            </a:r>
+          </a:p>
+        </p:txBody>
+      </p:sp>
+      <p:sp>
+        <p:nvSpPr>
+          <p:cNvPr id="9" name="FooterBand"/>
+          <p:cNvSpPr/>
+          <p:nvPr/>
+        </p:nvSpPr>
+        <p:spPr>
+          <a:xfrm>
+            <a:off x="274320" y="5879592"/>
+            <a:ext cx="8595360" cy="502920"/>
+          </a:xfrm>
+          <a:prstGeom prst="rect">
+            <a:avLst/>
+          </a:prstGeom>
+          <a:solidFill>
+            <a:srgbClr val="8E6F3E"/>
+          </a:solidFill>
+          <a:ln>
+            <a:noFill/>
+          </a:ln>
+          <a:effectLst/>
+        </p:spPr>
+        <p:style>
+          <a:lnRef idx="1">
+            <a:schemeClr val="accent1"/>
+          </a:lnRef>
+          <a:fillRef idx="3">
+            <a:schemeClr val="accent1"/>
+          </a:fillRef>
+          <a:effectRef idx="2">
+            <a:schemeClr val="accent1"/>
+          </a:effectRef>
+          <a:fontRef idx="minor">
+            <a:schemeClr val="lt1"/>
+          </a:fontRef>
+        </p:style>
+        <p:txBody>
+          <a:bodyPr rtlCol="0" anchor="ctr" wrap="square"/>
+          <a:lstStyle/>
+          <a:p>
+            <a:pPr algn="ctr"/>
+          </a:p>
+        </p:txBody>
+      </p:sp>
+      <p:sp>
+        <p:nvSpPr>
+          <p:cNvPr id="10" name="FooterBandText"/>
+          <p:cNvSpPr txBox="1"/>
+          <p:nvPr/>
+        </p:nvSpPr>
+        <p:spPr>
+          <a:xfrm>
+            <a:off x="384048" y="5897880"/>
+            <a:ext cx="8375904" cy="457200"/>
+          </a:xfrm>
+          <a:prstGeom prst="rect">
+            <a:avLst/>
+          </a:prstGeom>
+          <a:noFill/>
+        </p:spPr>
+        <p:txBody>
+          <a:bodyPr wrap="square">
+            <a:spAutoFit/>
+          </a:bodyPr>
+          <a:lstStyle/>
+          <a:p>
+            <a:pPr algn="ctr">
+              <a:spcAft>
+                <a:spcPts val="400"/>
+              </a:spcAft>
+            </a:pPr>
+            <a:r>
+              <a:rPr sz="2000" b="1">
+                <a:solidFill>
+                  <a:srgbClr val="FFFFFF"/>
+                </a:solidFill>
+                <a:latin typeface="Calibri"/>
+              </a:rPr>
+              <a:t>Choose where you pay: on every write or on every read</a:t>
+            </a:r>
+          </a:p>
+        </p:txBody>
+      </p:sp>
+    </p:spTree>
+  </p:cSld>
+  <p:clrMapOvr>
+    <a:masterClrMapping/>
+  </p:clrMapOvr>
+</p:sld>
+</file>
+
+<file path=ppt/slides/slide12.xml><?xml version="1.0" encoding="utf-8"?>
+<p:sld xmlns:a="http://schemas.openxmlformats.org/drawingml/2006/main" xmlns:p="http://schemas.openxmlformats.org/presentationml/2006/main" xmlns:r="http://schemas.openxmlformats.org/officeDocument/2006/relationships">
+  <p:cSld>
+    <p:spTree>
+      <p:nvGrpSpPr>
+        <p:cNvPr id="1" name=""/>
+        <p:cNvGrpSpPr/>
+        <p:nvPr/>
+      </p:nvGrpSpPr>
+      <p:grpSpPr/>
+      <p:sp>
+        <p:nvSpPr>
+          <p:cNvPr id="2" name="Title"/>
+          <p:cNvSpPr txBox="1"/>
+          <p:nvPr/>
+        </p:nvSpPr>
+        <p:spPr>
+          <a:xfrm>
+            <a:off x="274320" y="128016"/>
+            <a:ext cx="8595360" cy="594360"/>
+          </a:xfrm>
+          <a:prstGeom prst="rect">
+            <a:avLst/>
+          </a:prstGeom>
+          <a:noFill/>
+        </p:spPr>
+        <p:txBody>
+          <a:bodyPr wrap="square">
+            <a:spAutoFit/>
+          </a:bodyPr>
+          <a:lstStyle/>
+          <a:p>
+            <a:pPr algn="l">
+              <a:spcAft>
+                <a:spcPts val="400"/>
+              </a:spcAft>
+            </a:pPr>
+            <a:r>
+              <a:rPr sz="2400" b="0">
+                <a:solidFill>
+                  <a:srgbClr val="2D2D2D"/>
+                </a:solidFill>
+                <a:latin typeface="Calibri"/>
+              </a:rPr>
+              <a:t>A valid data model is not a correct application</a:t>
+            </a:r>
+          </a:p>
+        </p:txBody>
+      </p:sp>
+      <p:sp>
+        <p:nvSpPr>
+          <p:cNvPr id="3" name="Card"/>
+          <p:cNvSpPr/>
+          <p:nvPr/>
+        </p:nvSpPr>
+        <p:spPr>
+          <a:xfrm>
+            <a:off x="411480" y="960120"/>
+            <a:ext cx="4846320" cy="2377440"/>
+          </a:xfrm>
+          <a:prstGeom prst="rect">
+            <a:avLst/>
+          </a:prstGeom>
+          <a:solidFill>
+            <a:srgbClr val="F5F1E8"/>
+          </a:solidFill>
+          <a:ln>
+            <a:noFill/>
+          </a:ln>
+          <a:effectLst/>
+        </p:spPr>
+        <p:style>
+          <a:lnRef idx="1">
+            <a:schemeClr val="accent1"/>
+          </a:lnRef>
+          <a:fillRef idx="3">
+            <a:schemeClr val="accent1"/>
+          </a:fillRef>
+          <a:effectRef idx="2">
+            <a:schemeClr val="accent1"/>
+          </a:effectRef>
+          <a:fontRef idx="minor">
+            <a:schemeClr val="lt1"/>
+          </a:fontRef>
+        </p:style>
+        <p:txBody>
+          <a:bodyPr rtlCol="0" anchor="ctr" wrap="square"/>
+          <a:lstStyle/>
+          <a:p>
+            <a:pPr algn="ctr"/>
+          </a:p>
+        </p:txBody>
+      </p:sp>
+      <p:sp>
+        <p:nvSpPr>
+          <p:cNvPr id="4" name="CardBody"/>
+          <p:cNvSpPr txBox="1"/>
+          <p:nvPr/>
+        </p:nvSpPr>
+        <p:spPr>
+          <a:xfrm>
+            <a:off x="557784" y="1051560"/>
+            <a:ext cx="4553712" cy="2194560"/>
+          </a:xfrm>
+          <a:prstGeom prst="rect">
+            <a:avLst/>
+          </a:prstGeom>
+          <a:noFill/>
+        </p:spPr>
+        <p:txBody>
+          <a:bodyPr wrap="square">
+            <a:spAutoFit/>
+          </a:bodyPr>
+          <a:lstStyle/>
+          <a:p>
+            <a:pPr algn="l">
+              <a:spcAft>
+                <a:spcPts val="500"/>
+              </a:spcAft>
+            </a:pPr>
+            <a:r>
+              <a:rPr sz="2000" b="1">
+                <a:solidFill>
+                  <a:srgbClr val="8E6F3E"/>
+                </a:solidFill>
+                <a:latin typeface="Calibri"/>
+              </a:rPr>
+              <a:t>EVERY ROW VALID</a:t>
+            </a:r>
+          </a:p>
+          <a:p>
+            <a:pPr algn="l">
+              <a:spcAft>
+                <a:spcPts val="200"/>
+              </a:spcAft>
+            </a:pPr>
+            <a:r>
+              <a:rPr sz="2000" b="0">
+                <a:solidFill>
+                  <a:srgbClr val="2D2D2D"/>
+                </a:solidFill>
+                <a:latin typeface="Consolas"/>
+              </a:rPr>
+              <a:t>117 · 10:00–11:00 · CONFIRMED</a:t>
+            </a:r>
+          </a:p>
+          <a:p>
+            <a:pPr algn="l">
+              <a:spcAft>
+                <a:spcPts val="500"/>
+              </a:spcAft>
+            </a:pPr>
+            <a:r>
+              <a:rPr sz="2000" b="0">
+                <a:solidFill>
+                  <a:srgbClr val="2D2D2D"/>
+                </a:solidFill>
+                <a:latin typeface="Consolas"/>
+              </a:rPr>
+              <a:t>117 · 10:30–11:30 · CONFIRMED</a:t>
+            </a:r>
+          </a:p>
+          <a:p>
+            <a:pPr algn="l">
+              <a:spcAft>
+                <a:spcPts val="400"/>
+              </a:spcAft>
+            </a:pPr>
+            <a:r>
+              <a:rPr sz="2000" b="0">
+                <a:solidFill>
+                  <a:srgbClr val="555960"/>
+                </a:solidFill>
+                <a:latin typeface="Calibri"/>
+              </a:rPr>
+              <a:t>Every constraint from the schema passes, row by row</a:t>
+            </a:r>
+          </a:p>
+        </p:txBody>
+      </p:sp>
+      <p:sp>
+        <p:nvSpPr>
+          <p:cNvPr id="5" name="Card"/>
+          <p:cNvSpPr/>
+          <p:nvPr/>
+        </p:nvSpPr>
+        <p:spPr>
+          <a:xfrm>
+            <a:off x="5440680" y="960120"/>
+            <a:ext cx="3291840" cy="2377440"/>
+          </a:xfrm>
+          <a:prstGeom prst="rect">
+            <a:avLst/>
+          </a:prstGeom>
+          <a:solidFill>
+            <a:srgbClr val="F5F1E8"/>
+          </a:solidFill>
+          <a:ln>
+            <a:noFill/>
+          </a:ln>
+          <a:effectLst/>
+        </p:spPr>
+        <p:style>
+          <a:lnRef idx="1">
+            <a:schemeClr val="accent1"/>
+          </a:lnRef>
+          <a:fillRef idx="3">
+            <a:schemeClr val="accent1"/>
+          </a:fillRef>
+          <a:effectRef idx="2">
+            <a:schemeClr val="accent1"/>
+          </a:effectRef>
+          <a:fontRef idx="minor">
+            <a:schemeClr val="lt1"/>
+          </a:fontRef>
+        </p:style>
+        <p:txBody>
+          <a:bodyPr rtlCol="0" anchor="ctr" wrap="square"/>
+          <a:lstStyle/>
+          <a:p>
+            <a:pPr algn="ctr"/>
+          </a:p>
+        </p:txBody>
+      </p:sp>
+      <p:sp>
+        <p:nvSpPr>
+          <p:cNvPr id="6" name="CardBody"/>
+          <p:cNvSpPr txBox="1"/>
+          <p:nvPr/>
+        </p:nvSpPr>
+        <p:spPr>
+          <a:xfrm>
+            <a:off x="5586984" y="1051560"/>
+            <a:ext cx="2999232" cy="2194560"/>
+          </a:xfrm>
+          <a:prstGeom prst="rect">
+            <a:avLst/>
+          </a:prstGeom>
+          <a:noFill/>
+        </p:spPr>
+        <p:txBody>
+          <a:bodyPr wrap="square">
+            <a:spAutoFit/>
+          </a:bodyPr>
+          <a:lstStyle/>
+          <a:p>
+            <a:pPr algn="l">
+              <a:spcAft>
+                <a:spcPts val="500"/>
+              </a:spcAft>
+            </a:pPr>
+            <a:r>
+              <a:rPr sz="2000" b="1">
+                <a:solidFill>
+                  <a:srgbClr val="C01B1B"/>
+                </a:solidFill>
+                <a:latin typeface="Calibri"/>
+              </a:rPr>
+              <a:t>…and the invariant is violated</a:t>
+            </a:r>
+          </a:p>
+          <a:p>
+            <a:pPr algn="l">
+              <a:spcAft>
+                <a:spcPts val="400"/>
+              </a:spcAft>
+            </a:pPr>
+            <a:r>
+              <a:rPr sz="2000" b="0">
+                <a:solidFill>
+                  <a:srgbClr val="555960"/>
+                </a:solidFill>
+                <a:latin typeface="Calibri"/>
+              </a:rPr>
+              <a:t>Overlap is a property of the pair, not of either row</a:t>
+            </a:r>
+          </a:p>
+        </p:txBody>
+      </p:sp>
+      <p:sp>
+        <p:nvSpPr>
+          <p:cNvPr id="7" name="Card"/>
+          <p:cNvSpPr/>
+          <p:nvPr/>
+        </p:nvSpPr>
+        <p:spPr>
+          <a:xfrm>
+            <a:off x="411480" y="3566160"/>
+            <a:ext cx="8321040" cy="1508760"/>
+          </a:xfrm>
+          <a:prstGeom prst="rect">
+            <a:avLst/>
+          </a:prstGeom>
+          <a:solidFill>
+            <a:srgbClr val="FCFAF6"/>
+          </a:solidFill>
+          <a:ln>
+            <a:noFill/>
+          </a:ln>
+          <a:effectLst/>
+        </p:spPr>
+        <p:style>
+          <a:lnRef idx="1">
+            <a:schemeClr val="accent1"/>
+          </a:lnRef>
+          <a:fillRef idx="3">
+            <a:schemeClr val="accent1"/>
+          </a:fillRef>
+          <a:effectRef idx="2">
+            <a:schemeClr val="accent1"/>
+          </a:effectRef>
+          <a:fontRef idx="minor">
+            <a:schemeClr val="lt1"/>
+          </a:fontRef>
+        </p:style>
+        <p:txBody>
+          <a:bodyPr rtlCol="0" anchor="ctr" wrap="square"/>
+          <a:lstStyle/>
+          <a:p>
+            <a:pPr algn="ctr"/>
+          </a:p>
+        </p:txBody>
+      </p:sp>
+      <p:sp>
+        <p:nvSpPr>
+          <p:cNvPr id="8" name="CardBody"/>
+          <p:cNvSpPr txBox="1"/>
+          <p:nvPr/>
+        </p:nvSpPr>
+        <p:spPr>
+          <a:xfrm>
+            <a:off x="557784" y="3639312"/>
+            <a:ext cx="8046720" cy="1371600"/>
+          </a:xfrm>
+          <a:prstGeom prst="rect">
+            <a:avLst/>
+          </a:prstGeom>
+          <a:noFill/>
+        </p:spPr>
+        <p:txBody>
+          <a:bodyPr wrap="square">
+            <a:spAutoFit/>
+          </a:bodyPr>
+          <a:lstStyle/>
+          <a:p>
+            <a:pPr algn="l">
+              <a:spcAft>
+                <a:spcPts val="300"/>
+              </a:spcAft>
+            </a:pPr>
+            <a:r>
+              <a:rPr sz="2000" b="1">
+                <a:solidFill>
+                  <a:srgbClr val="5C4826"/>
+                </a:solidFill>
+                <a:latin typeface="Calibri"/>
+              </a:rPr>
+              <a:t>Validity is judged per row; correctness constrains relations between rows</a:t>
+            </a:r>
+          </a:p>
+          <a:p>
+            <a:pPr algn="l">
+              <a:spcAft>
+                <a:spcPts val="400"/>
+              </a:spcAft>
+            </a:pPr>
+            <a:r>
+              <a:rPr sz="2000" b="0">
+                <a:solidFill>
+                  <a:srgbClr val="555960"/>
+                </a:solidFill>
+                <a:latin typeface="Calibri"/>
+              </a:rPr>
+              <a:t>…and, once requests overlap in time, relations between operations. That is §5.</a:t>
+            </a:r>
+          </a:p>
+        </p:txBody>
+      </p:sp>
+      <p:sp>
+        <p:nvSpPr>
+          <p:cNvPr id="9" name="FooterBand"/>
+          <p:cNvSpPr/>
+          <p:nvPr/>
+        </p:nvSpPr>
+        <p:spPr>
+          <a:xfrm>
+            <a:off x="274320" y="5879592"/>
+            <a:ext cx="8595360" cy="502920"/>
+          </a:xfrm>
+          <a:prstGeom prst="rect">
+            <a:avLst/>
+          </a:prstGeom>
+          <a:solidFill>
+            <a:srgbClr val="8E6F3E"/>
+          </a:solidFill>
+          <a:ln>
+            <a:noFill/>
+          </a:ln>
+          <a:effectLst/>
+        </p:spPr>
+        <p:style>
+          <a:lnRef idx="1">
+            <a:schemeClr val="accent1"/>
+          </a:lnRef>
+          <a:fillRef idx="3">
+            <a:schemeClr val="accent1"/>
+          </a:fillRef>
+          <a:effectRef idx="2">
+            <a:schemeClr val="accent1"/>
+          </a:effectRef>
+          <a:fontRef idx="minor">
+            <a:schemeClr val="lt1"/>
+          </a:fontRef>
+        </p:style>
+        <p:txBody>
+          <a:bodyPr rtlCol="0" anchor="ctr" wrap="square"/>
+          <a:lstStyle/>
+          <a:p>
+            <a:pPr algn="ctr"/>
+          </a:p>
+        </p:txBody>
+      </p:sp>
+      <p:sp>
+        <p:nvSpPr>
+          <p:cNvPr id="10" name="FooterBandText"/>
+          <p:cNvSpPr txBox="1"/>
+          <p:nvPr/>
+        </p:nvSpPr>
+        <p:spPr>
+          <a:xfrm>
+            <a:off x="384048" y="5897880"/>
+            <a:ext cx="8375904" cy="457200"/>
+          </a:xfrm>
+          <a:prstGeom prst="rect">
+            <a:avLst/>
+          </a:prstGeom>
+          <a:noFill/>
+        </p:spPr>
+        <p:txBody>
+          <a:bodyPr wrap="square">
+            <a:spAutoFit/>
+          </a:bodyPr>
+          <a:lstStyle/>
+          <a:p>
+            <a:pPr algn="ctr">
+              <a:spcAft>
+                <a:spcPts val="400"/>
+              </a:spcAft>
+            </a:pPr>
+            <a:r>
+              <a:rPr sz="2000" b="1">
+                <a:solidFill>
+                  <a:srgbClr val="FFFFFF"/>
+                </a:solidFill>
+                <a:latin typeface="Calibri"/>
+              </a:rPr>
+              <a:t>A database full of valid rows can still be a broken application</a:t>
+            </a:r>
+          </a:p>
+        </p:txBody>
+      </p:sp>
+    </p:spTree>
+  </p:cSld>
+  <p:clrMapOvr>
+    <a:masterClrMapping/>
+  </p:clrMapOvr>
+</p:sld>
+</file>
+
 <file path=ppt/slides/slide2.xml><?xml version="1.0" encoding="utf-8"?>
 <p:sld xmlns:a="http://schemas.openxmlformats.org/drawingml/2006/main" xmlns:p="http://schemas.openxmlformats.org/presentationml/2006/main" xmlns:r="http://schemas.openxmlformats.org/officeDocument/2006/relationships">
   <p:cSld>
@@ -13705,6 +15639,957 @@
                 <a:latin typeface="Calibri"/>
               </a:rPr>
               <a:t>Different requirements select different points in the space</a:t>
+            </a:r>
+          </a:p>
+        </p:txBody>
+      </p:sp>
+    </p:spTree>
+  </p:cSld>
+  <p:clrMapOvr>
+    <a:masterClrMapping/>
+  </p:clrMapOvr>
+</p:sld>
+</file>
+
+<file path=ppt/slides/slide9.xml><?xml version="1.0" encoding="utf-8"?>
+<p:sld xmlns:a="http://schemas.openxmlformats.org/drawingml/2006/main" xmlns:p="http://schemas.openxmlformats.org/presentationml/2006/main" xmlns:r="http://schemas.openxmlformats.org/officeDocument/2006/relationships">
+  <p:cSld>
+    <p:spTree>
+      <p:nvGrpSpPr>
+        <p:cNvPr id="1" name=""/>
+        <p:cNvGrpSpPr/>
+        <p:nvPr/>
+      </p:nvGrpSpPr>
+      <p:grpSpPr/>
+      <p:sp>
+        <p:nvSpPr>
+          <p:cNvPr id="2" name="Title"/>
+          <p:cNvSpPr txBox="1"/>
+          <p:nvPr/>
+        </p:nvSpPr>
+        <p:spPr>
+          <a:xfrm>
+            <a:off x="274320" y="128016"/>
+            <a:ext cx="8595360" cy="594360"/>
+          </a:xfrm>
+          <a:prstGeom prst="rect">
+            <a:avLst/>
+          </a:prstGeom>
+          <a:noFill/>
+        </p:spPr>
+        <p:txBody>
+          <a:bodyPr wrap="square">
+            <a:spAutoFit/>
+          </a:bodyPr>
+          <a:lstStyle/>
+          <a:p>
+            <a:pPr algn="l">
+              <a:spcAft>
+                <a:spcPts val="400"/>
+              </a:spcAft>
+            </a:pPr>
+            <a:r>
+              <a:rPr sz="2400" b="0">
+                <a:solidFill>
+                  <a:srgbClr val="2D2D2D"/>
+                </a:solidFill>
+                <a:latin typeface="Calibri"/>
+              </a:rPr>
+              <a:t>Modeling the domain: entities and relationships</a:t>
+            </a:r>
+          </a:p>
+        </p:txBody>
+      </p:sp>
+      <p:sp>
+        <p:nvSpPr>
+          <p:cNvPr id="3" name="Block"/>
+          <p:cNvSpPr/>
+          <p:nvPr/>
+        </p:nvSpPr>
+        <p:spPr>
+          <a:xfrm>
+            <a:off x="640080" y="1417320"/>
+            <a:ext cx="1828800" cy="685800"/>
+          </a:xfrm>
+          <a:prstGeom prst="rect">
+            <a:avLst/>
+          </a:prstGeom>
+          <a:solidFill>
+            <a:srgbClr val="8E6F3E"/>
+          </a:solidFill>
+          <a:ln>
+            <a:noFill/>
+          </a:ln>
+          <a:effectLst/>
+        </p:spPr>
+        <p:style>
+          <a:lnRef idx="1">
+            <a:schemeClr val="accent1"/>
+          </a:lnRef>
+          <a:fillRef idx="3">
+            <a:schemeClr val="accent1"/>
+          </a:fillRef>
+          <a:effectRef idx="2">
+            <a:schemeClr val="accent1"/>
+          </a:effectRef>
+          <a:fontRef idx="minor">
+            <a:schemeClr val="lt1"/>
+          </a:fontRef>
+        </p:style>
+        <p:txBody>
+          <a:bodyPr rtlCol="0" anchor="ctr" wrap="square"/>
+          <a:lstStyle/>
+          <a:p>
+            <a:pPr algn="ctr">
+              <a:spcAft>
+                <a:spcPts val="0"/>
+              </a:spcAft>
+            </a:pPr>
+            <a:r>
+              <a:rPr sz="2000" b="1">
+                <a:solidFill>
+                  <a:srgbClr val="FFFFFF"/>
+                </a:solidFill>
+                <a:latin typeface="Calibri"/>
+              </a:rPr>
+              <a:t>USER</a:t>
+            </a:r>
+          </a:p>
+        </p:txBody>
+      </p:sp>
+      <p:sp>
+        <p:nvSpPr>
+          <p:cNvPr id="4" name="Block"/>
+          <p:cNvSpPr/>
+          <p:nvPr/>
+        </p:nvSpPr>
+        <p:spPr>
+          <a:xfrm>
+            <a:off x="3611880" y="1417320"/>
+            <a:ext cx="2103120" cy="685800"/>
+          </a:xfrm>
+          <a:prstGeom prst="rect">
+            <a:avLst/>
+          </a:prstGeom>
+          <a:solidFill>
+            <a:srgbClr val="8E6F3E"/>
+          </a:solidFill>
+          <a:ln>
+            <a:noFill/>
+          </a:ln>
+          <a:effectLst/>
+        </p:spPr>
+        <p:style>
+          <a:lnRef idx="1">
+            <a:schemeClr val="accent1"/>
+          </a:lnRef>
+          <a:fillRef idx="3">
+            <a:schemeClr val="accent1"/>
+          </a:fillRef>
+          <a:effectRef idx="2">
+            <a:schemeClr val="accent1"/>
+          </a:effectRef>
+          <a:fontRef idx="minor">
+            <a:schemeClr val="lt1"/>
+          </a:fontRef>
+        </p:style>
+        <p:txBody>
+          <a:bodyPr rtlCol="0" anchor="ctr" wrap="square"/>
+          <a:lstStyle/>
+          <a:p>
+            <a:pPr algn="ctr">
+              <a:spcAft>
+                <a:spcPts val="0"/>
+              </a:spcAft>
+            </a:pPr>
+            <a:r>
+              <a:rPr sz="2000" b="1">
+                <a:solidFill>
+                  <a:srgbClr val="FFFFFF"/>
+                </a:solidFill>
+                <a:latin typeface="Calibri"/>
+              </a:rPr>
+              <a:t>RESERVATION</a:t>
+            </a:r>
+          </a:p>
+        </p:txBody>
+      </p:sp>
+      <p:sp>
+        <p:nvSpPr>
+          <p:cNvPr id="5" name="Block"/>
+          <p:cNvSpPr/>
+          <p:nvPr/>
+        </p:nvSpPr>
+        <p:spPr>
+          <a:xfrm>
+            <a:off x="6675120" y="1417320"/>
+            <a:ext cx="1828800" cy="685800"/>
+          </a:xfrm>
+          <a:prstGeom prst="rect">
+            <a:avLst/>
+          </a:prstGeom>
+          <a:solidFill>
+            <a:srgbClr val="8E6F3E"/>
+          </a:solidFill>
+          <a:ln>
+            <a:noFill/>
+          </a:ln>
+          <a:effectLst/>
+        </p:spPr>
+        <p:style>
+          <a:lnRef idx="1">
+            <a:schemeClr val="accent1"/>
+          </a:lnRef>
+          <a:fillRef idx="3">
+            <a:schemeClr val="accent1"/>
+          </a:fillRef>
+          <a:effectRef idx="2">
+            <a:schemeClr val="accent1"/>
+          </a:effectRef>
+          <a:fontRef idx="minor">
+            <a:schemeClr val="lt1"/>
+          </a:fontRef>
+        </p:style>
+        <p:txBody>
+          <a:bodyPr rtlCol="0" anchor="ctr" wrap="square"/>
+          <a:lstStyle/>
+          <a:p>
+            <a:pPr algn="ctr">
+              <a:spcAft>
+                <a:spcPts val="0"/>
+              </a:spcAft>
+            </a:pPr>
+            <a:r>
+              <a:rPr sz="2000" b="1">
+                <a:solidFill>
+                  <a:srgbClr val="FFFFFF"/>
+                </a:solidFill>
+                <a:latin typeface="Calibri"/>
+              </a:rPr>
+              <a:t>ROOM</a:t>
+            </a:r>
+          </a:p>
+        </p:txBody>
+      </p:sp>
+      <p:sp>
+        <p:nvSpPr>
+          <p:cNvPr id="6" name="RelLabel"/>
+          <p:cNvSpPr txBox="1"/>
+          <p:nvPr/>
+        </p:nvSpPr>
+        <p:spPr>
+          <a:xfrm>
+            <a:off x="2468880" y="960120"/>
+            <a:ext cx="1143000" cy="365760"/>
+          </a:xfrm>
+          <a:prstGeom prst="rect">
+            <a:avLst/>
+          </a:prstGeom>
+          <a:noFill/>
+        </p:spPr>
+        <p:txBody>
+          <a:bodyPr wrap="square">
+            <a:spAutoFit/>
+          </a:bodyPr>
+          <a:lstStyle/>
+          <a:p>
+            <a:pPr algn="ctr">
+              <a:spcAft>
+                <a:spcPts val="400"/>
+              </a:spcAft>
+            </a:pPr>
+            <a:r>
+              <a:rPr sz="2000" b="1">
+                <a:solidFill>
+                  <a:srgbClr val="555960"/>
+                </a:solidFill>
+                <a:latin typeface="Calibri"/>
+              </a:rPr>
+              <a:t>1 : N</a:t>
+            </a:r>
+          </a:p>
+        </p:txBody>
+      </p:sp>
+      <p:sp>
+        <p:nvSpPr>
+          <p:cNvPr id="7" name="RelLabel"/>
+          <p:cNvSpPr txBox="1"/>
+          <p:nvPr/>
+        </p:nvSpPr>
+        <p:spPr>
+          <a:xfrm>
+            <a:off x="5715000" y="960120"/>
+            <a:ext cx="960120" cy="365760"/>
+          </a:xfrm>
+          <a:prstGeom prst="rect">
+            <a:avLst/>
+          </a:prstGeom>
+          <a:noFill/>
+        </p:spPr>
+        <p:txBody>
+          <a:bodyPr wrap="square">
+            <a:spAutoFit/>
+          </a:bodyPr>
+          <a:lstStyle/>
+          <a:p>
+            <a:pPr algn="ctr">
+              <a:spcAft>
+                <a:spcPts val="400"/>
+              </a:spcAft>
+            </a:pPr>
+            <a:r>
+              <a:rPr sz="2000" b="1">
+                <a:solidFill>
+                  <a:srgbClr val="555960"/>
+                </a:solidFill>
+                <a:latin typeface="Calibri"/>
+              </a:rPr>
+              <a:t>N : 1</a:t>
+            </a:r>
+          </a:p>
+        </p:txBody>
+      </p:sp>
+      <p:cxnSp>
+        <p:nvCxnSpPr>
+          <p:cNvPr id="8" name="RelLine"/>
+          <p:cNvCxnSpPr/>
+          <p:nvPr/>
+        </p:nvCxnSpPr>
+        <p:spPr>
+          <a:xfrm>
+            <a:off x="2468880" y="1760220"/>
+            <a:ext cx="1143000" cy="0"/>
+          </a:xfrm>
+          <a:prstGeom prst="line">
+            <a:avLst/>
+          </a:prstGeom>
+          <a:ln w="31750">
+            <a:solidFill>
+              <a:srgbClr val="8E6F3E"/>
+            </a:solidFill>
+          </a:ln>
+        </p:spPr>
+        <p:style>
+          <a:lnRef idx="2">
+            <a:schemeClr val="accent1"/>
+          </a:lnRef>
+          <a:fillRef idx="0">
+            <a:schemeClr val="accent1"/>
+          </a:fillRef>
+          <a:effectRef idx="1">
+            <a:schemeClr val="accent1"/>
+          </a:effectRef>
+          <a:fontRef idx="minor">
+            <a:schemeClr val="tx1"/>
+          </a:fontRef>
+        </p:style>
+      </p:cxnSp>
+      <p:cxnSp>
+        <p:nvCxnSpPr>
+          <p:cNvPr id="9" name="RelLine"/>
+          <p:cNvCxnSpPr/>
+          <p:nvPr/>
+        </p:nvCxnSpPr>
+        <p:spPr>
+          <a:xfrm>
+            <a:off x="5715000" y="1760220"/>
+            <a:ext cx="960120" cy="0"/>
+          </a:xfrm>
+          <a:prstGeom prst="line">
+            <a:avLst/>
+          </a:prstGeom>
+          <a:ln w="31750">
+            <a:solidFill>
+              <a:srgbClr val="8E6F3E"/>
+            </a:solidFill>
+          </a:ln>
+        </p:spPr>
+        <p:style>
+          <a:lnRef idx="2">
+            <a:schemeClr val="accent1"/>
+          </a:lnRef>
+          <a:fillRef idx="0">
+            <a:schemeClr val="accent1"/>
+          </a:fillRef>
+          <a:effectRef idx="1">
+            <a:schemeClr val="accent1"/>
+          </a:effectRef>
+          <a:fontRef idx="minor">
+            <a:schemeClr val="tx1"/>
+          </a:fontRef>
+        </p:style>
+      </p:cxnSp>
+      <p:sp>
+        <p:nvSpPr>
+          <p:cNvPr id="10" name="Card"/>
+          <p:cNvSpPr/>
+          <p:nvPr/>
+        </p:nvSpPr>
+        <p:spPr>
+          <a:xfrm>
+            <a:off x="411480" y="2377440"/>
+            <a:ext cx="2377440" cy="1463040"/>
+          </a:xfrm>
+          <a:prstGeom prst="rect">
+            <a:avLst/>
+          </a:prstGeom>
+          <a:solidFill>
+            <a:srgbClr val="F5F1E8"/>
+          </a:solidFill>
+          <a:ln>
+            <a:noFill/>
+          </a:ln>
+          <a:effectLst/>
+        </p:spPr>
+        <p:style>
+          <a:lnRef idx="1">
+            <a:schemeClr val="accent1"/>
+          </a:lnRef>
+          <a:fillRef idx="3">
+            <a:schemeClr val="accent1"/>
+          </a:fillRef>
+          <a:effectRef idx="2">
+            <a:schemeClr val="accent1"/>
+          </a:effectRef>
+          <a:fontRef idx="minor">
+            <a:schemeClr val="lt1"/>
+          </a:fontRef>
+        </p:style>
+        <p:txBody>
+          <a:bodyPr rtlCol="0" anchor="ctr" wrap="square"/>
+          <a:lstStyle/>
+          <a:p>
+            <a:pPr algn="ctr"/>
+          </a:p>
+        </p:txBody>
+      </p:sp>
+      <p:sp>
+        <p:nvSpPr>
+          <p:cNvPr id="11" name="AttrList"/>
+          <p:cNvSpPr txBox="1"/>
+          <p:nvPr/>
+        </p:nvSpPr>
+        <p:spPr>
+          <a:xfrm>
+            <a:off x="557784" y="2450592"/>
+            <a:ext cx="2084831" cy="1316736"/>
+          </a:xfrm>
+          <a:prstGeom prst="rect">
+            <a:avLst/>
+          </a:prstGeom>
+          <a:noFill/>
+        </p:spPr>
+        <p:txBody>
+          <a:bodyPr wrap="square">
+            <a:spAutoFit/>
+          </a:bodyPr>
+          <a:lstStyle/>
+          <a:p>
+            <a:pPr algn="l">
+              <a:spcAft>
+                <a:spcPts val="400"/>
+              </a:spcAft>
+            </a:pPr>
+            <a:r>
+              <a:rPr sz="2000" b="0">
+                <a:solidFill>
+                  <a:srgbClr val="555960"/>
+                </a:solidFill>
+                <a:latin typeface="Calibri"/>
+              </a:rPr>
+              <a:t>id</a:t>
+            </a:r>
+          </a:p>
+          <a:p>
+            <a:pPr algn="l">
+              <a:spcAft>
+                <a:spcPts val="400"/>
+              </a:spcAft>
+            </a:pPr>
+            <a:r>
+              <a:rPr sz="2000" b="0">
+                <a:solidFill>
+                  <a:srgbClr val="555960"/>
+                </a:solidFill>
+                <a:latin typeface="Calibri"/>
+              </a:rPr>
+              <a:t>name</a:t>
+            </a:r>
+          </a:p>
+          <a:p>
+            <a:pPr algn="l">
+              <a:spcAft>
+                <a:spcPts val="400"/>
+              </a:spcAft>
+            </a:pPr>
+            <a:r>
+              <a:rPr sz="2000" b="0">
+                <a:solidFill>
+                  <a:srgbClr val="555960"/>
+                </a:solidFill>
+                <a:latin typeface="Calibri"/>
+              </a:rPr>
+              <a:t>email</a:t>
+            </a:r>
+          </a:p>
+        </p:txBody>
+      </p:sp>
+      <p:sp>
+        <p:nvSpPr>
+          <p:cNvPr id="12" name="Card"/>
+          <p:cNvSpPr/>
+          <p:nvPr/>
+        </p:nvSpPr>
+        <p:spPr>
+          <a:xfrm>
+            <a:off x="3383280" y="2377440"/>
+            <a:ext cx="2651760" cy="2148840"/>
+          </a:xfrm>
+          <a:prstGeom prst="rect">
+            <a:avLst/>
+          </a:prstGeom>
+          <a:solidFill>
+            <a:srgbClr val="F5F1E8"/>
+          </a:solidFill>
+          <a:ln>
+            <a:noFill/>
+          </a:ln>
+          <a:effectLst/>
+        </p:spPr>
+        <p:style>
+          <a:lnRef idx="1">
+            <a:schemeClr val="accent1"/>
+          </a:lnRef>
+          <a:fillRef idx="3">
+            <a:schemeClr val="accent1"/>
+          </a:fillRef>
+          <a:effectRef idx="2">
+            <a:schemeClr val="accent1"/>
+          </a:effectRef>
+          <a:fontRef idx="minor">
+            <a:schemeClr val="lt1"/>
+          </a:fontRef>
+        </p:style>
+        <p:txBody>
+          <a:bodyPr rtlCol="0" anchor="ctr" wrap="square"/>
+          <a:lstStyle/>
+          <a:p>
+            <a:pPr algn="ctr"/>
+          </a:p>
+        </p:txBody>
+      </p:sp>
+      <p:sp>
+        <p:nvSpPr>
+          <p:cNvPr id="13" name="AttrList"/>
+          <p:cNvSpPr txBox="1"/>
+          <p:nvPr/>
+        </p:nvSpPr>
+        <p:spPr>
+          <a:xfrm>
+            <a:off x="3529584" y="2450592"/>
+            <a:ext cx="2359152" cy="2011680"/>
+          </a:xfrm>
+          <a:prstGeom prst="rect">
+            <a:avLst/>
+          </a:prstGeom>
+          <a:noFill/>
+        </p:spPr>
+        <p:txBody>
+          <a:bodyPr wrap="square">
+            <a:spAutoFit/>
+          </a:bodyPr>
+          <a:lstStyle/>
+          <a:p>
+            <a:pPr algn="l">
+              <a:spcAft>
+                <a:spcPts val="400"/>
+              </a:spcAft>
+            </a:pPr>
+            <a:r>
+              <a:rPr sz="2000" b="0">
+                <a:solidFill>
+                  <a:srgbClr val="555960"/>
+                </a:solidFill>
+                <a:latin typeface="Calibri"/>
+              </a:rPr>
+              <a:t>id</a:t>
+            </a:r>
+          </a:p>
+          <a:p>
+            <a:pPr algn="l">
+              <a:spcAft>
+                <a:spcPts val="400"/>
+              </a:spcAft>
+            </a:pPr>
+            <a:r>
+              <a:rPr sz="2000" b="0">
+                <a:solidFill>
+                  <a:srgbClr val="555960"/>
+                </a:solidFill>
+                <a:latin typeface="Calibri"/>
+              </a:rPr>
+              <a:t>room_id</a:t>
+            </a:r>
+          </a:p>
+          <a:p>
+            <a:pPr algn="l">
+              <a:spcAft>
+                <a:spcPts val="400"/>
+              </a:spcAft>
+            </a:pPr>
+            <a:r>
+              <a:rPr sz="2000" b="0">
+                <a:solidFill>
+                  <a:srgbClr val="555960"/>
+                </a:solidFill>
+                <a:latin typeface="Calibri"/>
+              </a:rPr>
+              <a:t>user_id</a:t>
+            </a:r>
+          </a:p>
+          <a:p>
+            <a:pPr algn="l">
+              <a:spcAft>
+                <a:spcPts val="400"/>
+              </a:spcAft>
+            </a:pPr>
+            <a:r>
+              <a:rPr sz="2000" b="1">
+                <a:solidFill>
+                  <a:srgbClr val="5C4826"/>
+                </a:solidFill>
+                <a:latin typeface="Calibri"/>
+              </a:rPr>
+              <a:t>starts_at</a:t>
+            </a:r>
+          </a:p>
+          <a:p>
+            <a:pPr algn="l">
+              <a:spcAft>
+                <a:spcPts val="400"/>
+              </a:spcAft>
+            </a:pPr>
+            <a:r>
+              <a:rPr sz="2000" b="1">
+                <a:solidFill>
+                  <a:srgbClr val="5C4826"/>
+                </a:solidFill>
+                <a:latin typeface="Calibri"/>
+              </a:rPr>
+              <a:t>ends_at</a:t>
+            </a:r>
+          </a:p>
+          <a:p>
+            <a:pPr algn="l">
+              <a:spcAft>
+                <a:spcPts val="400"/>
+              </a:spcAft>
+            </a:pPr>
+            <a:r>
+              <a:rPr sz="2000" b="1">
+                <a:solidFill>
+                  <a:srgbClr val="5C4826"/>
+                </a:solidFill>
+                <a:latin typeface="Calibri"/>
+              </a:rPr>
+              <a:t>status</a:t>
+            </a:r>
+          </a:p>
+        </p:txBody>
+      </p:sp>
+      <p:sp>
+        <p:nvSpPr>
+          <p:cNvPr id="14" name="Card"/>
+          <p:cNvSpPr/>
+          <p:nvPr/>
+        </p:nvSpPr>
+        <p:spPr>
+          <a:xfrm>
+            <a:off x="6446520" y="2377440"/>
+            <a:ext cx="2286000" cy="1463040"/>
+          </a:xfrm>
+          <a:prstGeom prst="rect">
+            <a:avLst/>
+          </a:prstGeom>
+          <a:solidFill>
+            <a:srgbClr val="F5F1E8"/>
+          </a:solidFill>
+          <a:ln>
+            <a:noFill/>
+          </a:ln>
+          <a:effectLst/>
+        </p:spPr>
+        <p:style>
+          <a:lnRef idx="1">
+            <a:schemeClr val="accent1"/>
+          </a:lnRef>
+          <a:fillRef idx="3">
+            <a:schemeClr val="accent1"/>
+          </a:fillRef>
+          <a:effectRef idx="2">
+            <a:schemeClr val="accent1"/>
+          </a:effectRef>
+          <a:fontRef idx="minor">
+            <a:schemeClr val="lt1"/>
+          </a:fontRef>
+        </p:style>
+        <p:txBody>
+          <a:bodyPr rtlCol="0" anchor="ctr" wrap="square"/>
+          <a:lstStyle/>
+          <a:p>
+            <a:pPr algn="ctr"/>
+          </a:p>
+        </p:txBody>
+      </p:sp>
+      <p:sp>
+        <p:nvSpPr>
+          <p:cNvPr id="15" name="AttrList"/>
+          <p:cNvSpPr txBox="1"/>
+          <p:nvPr/>
+        </p:nvSpPr>
+        <p:spPr>
+          <a:xfrm>
+            <a:off x="6592824" y="2450592"/>
+            <a:ext cx="1993392" cy="1316736"/>
+          </a:xfrm>
+          <a:prstGeom prst="rect">
+            <a:avLst/>
+          </a:prstGeom>
+          <a:noFill/>
+        </p:spPr>
+        <p:txBody>
+          <a:bodyPr wrap="square">
+            <a:spAutoFit/>
+          </a:bodyPr>
+          <a:lstStyle/>
+          <a:p>
+            <a:pPr algn="l">
+              <a:spcAft>
+                <a:spcPts val="400"/>
+              </a:spcAft>
+            </a:pPr>
+            <a:r>
+              <a:rPr sz="2000" b="0">
+                <a:solidFill>
+                  <a:srgbClr val="555960"/>
+                </a:solidFill>
+                <a:latin typeface="Calibri"/>
+              </a:rPr>
+              <a:t>id</a:t>
+            </a:r>
+          </a:p>
+          <a:p>
+            <a:pPr algn="l">
+              <a:spcAft>
+                <a:spcPts val="400"/>
+              </a:spcAft>
+            </a:pPr>
+            <a:r>
+              <a:rPr sz="2000" b="0">
+                <a:solidFill>
+                  <a:srgbClr val="555960"/>
+                </a:solidFill>
+                <a:latin typeface="Calibri"/>
+              </a:rPr>
+              <a:t>name</a:t>
+            </a:r>
+          </a:p>
+          <a:p>
+            <a:pPr algn="l">
+              <a:spcAft>
+                <a:spcPts val="400"/>
+              </a:spcAft>
+            </a:pPr>
+            <a:r>
+              <a:rPr sz="2000" b="0">
+                <a:solidFill>
+                  <a:srgbClr val="555960"/>
+                </a:solidFill>
+                <a:latin typeface="Calibri"/>
+              </a:rPr>
+              <a:t>capacity</a:t>
+            </a:r>
+          </a:p>
+        </p:txBody>
+      </p:sp>
+      <p:sp>
+        <p:nvSpPr>
+          <p:cNvPr id="16" name="Card"/>
+          <p:cNvSpPr/>
+          <p:nvPr/>
+        </p:nvSpPr>
+        <p:spPr>
+          <a:xfrm>
+            <a:off x="411480" y="4754880"/>
+            <a:ext cx="8321040" cy="960120"/>
+          </a:xfrm>
+          <a:prstGeom prst="rect">
+            <a:avLst/>
+          </a:prstGeom>
+          <a:solidFill>
+            <a:srgbClr val="FCFAF6"/>
+          </a:solidFill>
+          <a:ln>
+            <a:noFill/>
+          </a:ln>
+          <a:effectLst/>
+        </p:spPr>
+        <p:style>
+          <a:lnRef idx="1">
+            <a:schemeClr val="accent1"/>
+          </a:lnRef>
+          <a:fillRef idx="3">
+            <a:schemeClr val="accent1"/>
+          </a:fillRef>
+          <a:effectRef idx="2">
+            <a:schemeClr val="accent1"/>
+          </a:effectRef>
+          <a:fontRef idx="minor">
+            <a:schemeClr val="lt1"/>
+          </a:fontRef>
+        </p:style>
+        <p:txBody>
+          <a:bodyPr rtlCol="0" anchor="ctr" wrap="square"/>
+          <a:lstStyle/>
+          <a:p>
+            <a:pPr algn="ctr"/>
+          </a:p>
+        </p:txBody>
+      </p:sp>
+      <p:sp>
+        <p:nvSpPr>
+          <p:cNvPr id="17" name="Invariant"/>
+          <p:cNvSpPr txBox="1"/>
+          <p:nvPr/>
+        </p:nvSpPr>
+        <p:spPr>
+          <a:xfrm>
+            <a:off x="557784" y="4809744"/>
+            <a:ext cx="8046720" cy="859536"/>
+          </a:xfrm>
+          <a:prstGeom prst="rect">
+            <a:avLst/>
+          </a:prstGeom>
+          <a:noFill/>
+        </p:spPr>
+        <p:txBody>
+          <a:bodyPr wrap="square">
+            <a:spAutoFit/>
+          </a:bodyPr>
+          <a:lstStyle/>
+          <a:p>
+            <a:pPr algn="l">
+              <a:spcAft>
+                <a:spcPts val="200"/>
+              </a:spcAft>
+            </a:pPr>
+            <a:r>
+              <a:rPr sz="2000" b="1">
+                <a:solidFill>
+                  <a:srgbClr val="5C4826"/>
+                </a:solidFill>
+                <a:latin typeface="Calibri"/>
+              </a:rPr>
+              <a:t>INVARIANT — a room must not have overlapping CONFIRMED reservations</a:t>
+            </a:r>
+          </a:p>
+          <a:p>
+            <a:pPr algn="l">
+              <a:spcAft>
+                <a:spcPts val="400"/>
+              </a:spcAft>
+            </a:pPr>
+            <a:r>
+              <a:rPr sz="2000" b="0">
+                <a:solidFill>
+                  <a:srgbClr val="555960"/>
+                </a:solidFill>
+                <a:latin typeface="Calibri"/>
+              </a:rPr>
+              <a:t>The model supplies its vocabulary: room_id, starts_at, ends_at, status</a:t>
+            </a:r>
+          </a:p>
+        </p:txBody>
+      </p:sp>
+      <p:sp>
+        <p:nvSpPr>
+          <p:cNvPr id="18" name="FooterBand"/>
+          <p:cNvSpPr/>
+          <p:nvPr/>
+        </p:nvSpPr>
+        <p:spPr>
+          <a:xfrm>
+            <a:off x="274320" y="5879592"/>
+            <a:ext cx="8595360" cy="502920"/>
+          </a:xfrm>
+          <a:prstGeom prst="rect">
+            <a:avLst/>
+          </a:prstGeom>
+          <a:solidFill>
+            <a:srgbClr val="8E6F3E"/>
+          </a:solidFill>
+          <a:ln>
+            <a:noFill/>
+          </a:ln>
+          <a:effectLst/>
+        </p:spPr>
+        <p:style>
+          <a:lnRef idx="1">
+            <a:schemeClr val="accent1"/>
+          </a:lnRef>
+          <a:fillRef idx="3">
+            <a:schemeClr val="accent1"/>
+          </a:fillRef>
+          <a:effectRef idx="2">
+            <a:schemeClr val="accent1"/>
+          </a:effectRef>
+          <a:fontRef idx="minor">
+            <a:schemeClr val="lt1"/>
+          </a:fontRef>
+        </p:style>
+        <p:txBody>
+          <a:bodyPr rtlCol="0" anchor="ctr" wrap="square"/>
+          <a:lstStyle/>
+          <a:p>
+            <a:pPr algn="ctr"/>
+          </a:p>
+        </p:txBody>
+      </p:sp>
+      <p:sp>
+        <p:nvSpPr>
+          <p:cNvPr id="19" name="FooterBandText"/>
+          <p:cNvSpPr txBox="1"/>
+          <p:nvPr/>
+        </p:nvSpPr>
+        <p:spPr>
+          <a:xfrm>
+            <a:off x="384048" y="5897880"/>
+            <a:ext cx="8375904" cy="457200"/>
+          </a:xfrm>
+          <a:prstGeom prst="rect">
+            <a:avLst/>
+          </a:prstGeom>
+          <a:noFill/>
+        </p:spPr>
+        <p:txBody>
+          <a:bodyPr wrap="square">
+            <a:spAutoFit/>
+          </a:bodyPr>
+          <a:lstStyle/>
+          <a:p>
+            <a:pPr algn="ctr">
+              <a:spcAft>
+                <a:spcPts val="400"/>
+              </a:spcAft>
+            </a:pPr>
+            <a:r>
+              <a:rPr sz="2000" b="1">
+                <a:solidFill>
+                  <a:srgbClr val="FFFFFF"/>
+                </a:solidFill>
+                <a:latin typeface="Calibri"/>
+              </a:rPr>
+              <a:t>The ER model chooses what the system can talk about</a:t>
             </a:r>
           </a:p>
         </p:txBody>

</xml_diff>

<commit_message>
deck 3-2: §4 query interfaces and execution (slides 13-18)
Stage 4 of 6: SQL-as-WHAT with the overlap predicate, illustrative ORM
with buys/costs, the layering slide (ORM vs SQL dissolved), the query
execution pipeline (optimization filed under EXECUTION, explicitly not
under transactions), scan-vs-index costs, and N+1 with the
agent-generated-code warning. 47 of 75 min banked.

Co-Authored-By: Claude Opus 5 <noreply@anthropic.com>
</commit_message>
<xml_diff>
--- a/course/lectures/act-3-software-in-the-world/02-compute-environments-and-data-management/3-2-Data-Management.pptx
+++ b/course/lectures/act-3-software-in-the-world/02-compute-environments-and-data-management/3-2-Data-Management.pptx
@@ -20,6 +20,12 @@
     <p:sldId id="265" r:id="rId16"/>
     <p:sldId id="266" r:id="rId17"/>
     <p:sldId id="267" r:id="rId18"/>
+    <p:sldId id="268" r:id="rId19"/>
+    <p:sldId id="269" r:id="rId20"/>
+    <p:sldId id="270" r:id="rId21"/>
+    <p:sldId id="271" r:id="rId22"/>
+    <p:sldId id="272" r:id="rId23"/>
+    <p:sldId id="273" r:id="rId24"/>
   </p:sldIdLst>
   <p:sldSz cx="9144000" cy="6858000" type="screen4x3"/>
   <p:notesSz cx="6858000" cy="9144000"/>
@@ -1782,6 +1788,534 @@
           <a:p>
             <a:r>
               <a:t>Transition: before we can fix enforcement, we need the other half of the design space — how we ASK the database questions. Query interfaces, then execution, then back here for concurrency.</a:t>
+            </a:r>
+          </a:p>
+        </p:txBody>
+      </p:sp>
+      <p:sp>
+        <p:nvSpPr>
+          <p:cNvPr id="4" name="Slide Number Placeholder 3"/>
+          <p:cNvSpPr>
+            <a:spLocks noGrp="1"/>
+          </p:cNvSpPr>
+          <p:nvPr>
+            <p:ph type="sldNum" idx="12"/>
+          </p:nvPr>
+        </p:nvSpPr>
+        <p:spPr/>
+      </p:sp>
+    </p:spTree>
+  </p:cSld>
+  <p:clrMapOvr>
+    <a:masterClrMapping/>
+  </p:clrMapOvr>
+</p:notes>
+</file>
+
+<file path=ppt/notesSlides/notesSlide13.xml><?xml version="1.0" encoding="utf-8"?>
+<p:notes xmlns:a="http://schemas.openxmlformats.org/drawingml/2006/main" xmlns:p="http://schemas.openxmlformats.org/presentationml/2006/main" xmlns:r="http://schemas.openxmlformats.org/officeDocument/2006/relationships">
+  <p:cSld>
+    <p:spTree>
+      <p:nvGrpSpPr>
+        <p:cNvPr id="1" name=""/>
+        <p:cNvGrpSpPr/>
+        <p:nvPr/>
+      </p:nvGrpSpPr>
+      <p:grpSpPr>
+        <a:xfrm>
+          <a:off x="0" y="0"/>
+          <a:ext cx="0" cy="0"/>
+          <a:chOff x="0" y="0"/>
+          <a:chExt cx="0" cy="0"/>
+        </a:xfrm>
+      </p:grpSpPr>
+      <p:sp>
+        <p:nvSpPr>
+          <p:cNvPr id="2" name="Slide Image Placeholder 1"/>
+          <p:cNvSpPr>
+            <a:spLocks noGrp="1"/>
+          </p:cNvSpPr>
+          <p:nvPr>
+            <p:ph type="sldImg" idx="3"/>
+          </p:nvPr>
+        </p:nvSpPr>
+        <p:spPr/>
+      </p:sp>
+      <p:sp>
+        <p:nvSpPr>
+          <p:cNvPr id="3" name="Notes Placeholder 2"/>
+          <p:cNvSpPr>
+            <a:spLocks noGrp="1"/>
+          </p:cNvSpPr>
+          <p:nvPr>
+            <p:ph type="body" idx="1"/>
+          </p:nvPr>
+        </p:nvSpPr>
+        <p:spPr/>
+        <p:txBody>
+          <a:bodyPr/>
+          <a:lstStyle/>
+          <a:p>
+            <a:r>
+              <a:t>TIMING: 2 minutes.</a:t>
+            </a:r>
+          </a:p>
+          <a:p/>
+          <a:p>
+            <a:r>
+              <a:t>Read the WHERE clause aloud as a sentence: "any CONFIRMED reservation for this room whose interval overlaps mine." Two minutes on the overlap predicate is time well spent — students reliably get interval overlap wrong (they test only endpoints-inside). Draw two intervals on the board if needed.</a:t>
+            </a:r>
+          </a:p>
+          <a:p/>
+          <a:p>
+            <a:r>
+              <a:t>The declarative point sets up execution: because the query is only a specification, the engine is FREE to choose access paths — and obligated to pick well. That freedom is where both performance (slides 16-17) and the race (slide 19) come from: nothing in this text says WHEN it runs relative to anyone else's insert.</a:t>
+            </a:r>
+          </a:p>
+          <a:p/>
+          <a:p>
+            <a:r>
+              <a:t>Keep SQL syntax discussion to these few minutes — the design space, not the dialect, is the lecture.</a:t>
+            </a:r>
+          </a:p>
+        </p:txBody>
+      </p:sp>
+      <p:sp>
+        <p:nvSpPr>
+          <p:cNvPr id="4" name="Slide Number Placeholder 3"/>
+          <p:cNvSpPr>
+            <a:spLocks noGrp="1"/>
+          </p:cNvSpPr>
+          <p:nvPr>
+            <p:ph type="sldNum" idx="12"/>
+          </p:nvPr>
+        </p:nvSpPr>
+        <p:spPr/>
+      </p:sp>
+    </p:spTree>
+  </p:cSld>
+  <p:clrMapOvr>
+    <a:masterClrMapping/>
+  </p:clrMapOvr>
+</p:notes>
+</file>
+
+<file path=ppt/notesSlides/notesSlide14.xml><?xml version="1.0" encoding="utf-8"?>
+<p:notes xmlns:a="http://schemas.openxmlformats.org/drawingml/2006/main" xmlns:p="http://schemas.openxmlformats.org/presentationml/2006/main" xmlns:r="http://schemas.openxmlformats.org/officeDocument/2006/relationships">
+  <p:cSld>
+    <p:spTree>
+      <p:nvGrpSpPr>
+        <p:cNvPr id="1" name=""/>
+        <p:cNvGrpSpPr/>
+        <p:nvPr/>
+      </p:nvGrpSpPr>
+      <p:grpSpPr>
+        <a:xfrm>
+          <a:off x="0" y="0"/>
+          <a:ext cx="0" cy="0"/>
+          <a:chOff x="0" y="0"/>
+          <a:chExt cx="0" cy="0"/>
+        </a:xfrm>
+      </p:grpSpPr>
+      <p:sp>
+        <p:nvSpPr>
+          <p:cNvPr id="2" name="Slide Image Placeholder 1"/>
+          <p:cNvSpPr>
+            <a:spLocks noGrp="1"/>
+          </p:cNvSpPr>
+          <p:nvPr>
+            <p:ph type="sldImg" idx="3"/>
+          </p:nvPr>
+        </p:nvSpPr>
+        <p:spPr/>
+      </p:sp>
+      <p:sp>
+        <p:nvSpPr>
+          <p:cNvPr id="3" name="Notes Placeholder 2"/>
+          <p:cNvSpPr>
+            <a:spLocks noGrp="1"/>
+          </p:cNvSpPr>
+          <p:nvPr>
+            <p:ph type="body" idx="1"/>
+          </p:nvPr>
+        </p:nvSpPr>
+        <p:spPr/>
+        <p:txBody>
+          <a:bodyPr/>
+          <a:lstStyle/>
+          <a:p>
+            <a:r>
+              <a:t>TIMING: 2 minutes.</a:t>
+            </a:r>
+          </a:p>
+          <a:p/>
+          <a:p>
+            <a:r>
+              <a:t>Same overlap query as the previous slide, now written against objects. Stress the slide label: this is pseudo-ORM; SQLAlchemy, Django, Hibernate, Prisma each spell it differently, and teaching one dialect is not the point.</a:t>
+            </a:r>
+          </a:p>
+          <a:p/>
+          <a:p>
+            <a:r>
+              <a:t>Both columns are true at once. The buys are real (teams ship faster, mapping bugs drop); the costs are structural, not bugs to be fixed in the next release — an abstraction over a different data model MUST leak somewhere (objects have identity and references; rows have keys and values).</a:t>
+            </a:r>
+          </a:p>
+          <a:p/>
+          <a:p>
+            <a:r>
+              <a:t>Resist the class splitting into ORM-always and ORM-never camps for two minutes — the next slide dissolves the rivalry by placing them at different layers.</a:t>
+            </a:r>
+          </a:p>
+        </p:txBody>
+      </p:sp>
+      <p:sp>
+        <p:nvSpPr>
+          <p:cNvPr id="4" name="Slide Number Placeholder 3"/>
+          <p:cNvSpPr>
+            <a:spLocks noGrp="1"/>
+          </p:cNvSpPr>
+          <p:nvPr>
+            <p:ph type="sldNum" idx="12"/>
+          </p:nvPr>
+        </p:nvSpPr>
+        <p:spPr/>
+      </p:sp>
+    </p:spTree>
+  </p:cSld>
+  <p:clrMapOvr>
+    <a:masterClrMapping/>
+  </p:clrMapOvr>
+</p:notes>
+</file>
+
+<file path=ppt/notesSlides/notesSlide15.xml><?xml version="1.0" encoding="utf-8"?>
+<p:notes xmlns:a="http://schemas.openxmlformats.org/drawingml/2006/main" xmlns:p="http://schemas.openxmlformats.org/presentationml/2006/main" xmlns:r="http://schemas.openxmlformats.org/officeDocument/2006/relationships">
+  <p:cSld>
+    <p:spTree>
+      <p:nvGrpSpPr>
+        <p:cNvPr id="1" name=""/>
+        <p:cNvGrpSpPr/>
+        <p:nvPr/>
+      </p:nvGrpSpPr>
+      <p:grpSpPr>
+        <a:xfrm>
+          <a:off x="0" y="0"/>
+          <a:ext cx="0" cy="0"/>
+          <a:chOff x="0" y="0"/>
+          <a:chExt cx="0" cy="0"/>
+        </a:xfrm>
+      </p:grpSpPr>
+      <p:sp>
+        <p:nvSpPr>
+          <p:cNvPr id="2" name="Slide Image Placeholder 1"/>
+          <p:cNvSpPr>
+            <a:spLocks noGrp="1"/>
+          </p:cNvSpPr>
+          <p:nvPr>
+            <p:ph type="sldImg" idx="3"/>
+          </p:nvPr>
+        </p:nvSpPr>
+        <p:spPr/>
+      </p:sp>
+      <p:sp>
+        <p:nvSpPr>
+          <p:cNvPr id="3" name="Notes Placeholder 2"/>
+          <p:cNvSpPr>
+            <a:spLocks noGrp="1"/>
+          </p:cNvSpPr>
+          <p:nvPr>
+            <p:ph type="body" idx="1"/>
+          </p:nvPr>
+        </p:nvSpPr>
+        <p:spPr/>
+        <p:txBody>
+          <a:bodyPr/>
+          <a:lstStyle/>
+          <a:p>
+            <a:r>
+              <a:t>TIMING: 3 minutes.</a:t>
+            </a:r>
+          </a:p>
+          <a:p/>
+          <a:p>
+            <a:r>
+              <a:t>One of the four slides that carry the lecture. The stack kills the false dichotomy from the previous slide: every ORM query BECOMES SQL; every SQL query BECOMES an engine plan. Choosing "ORM or SQL" is choosing your authoring layer, nothing more — correctness and cost are decided below, and remain yours.</a:t>
+            </a:r>
+          </a:p>
+          <a:p/>
+          <a:p>
+            <a:r>
+              <a:t>Practical corollary to say out loud: when the ORM is slow or wrong, you debug by reading DOWNWARD — the emitted SQL, then the plan. An engineer who can only read the top layer cannot diagnose the system. This mirrors Act II's delegation lesson: delegating the writing does not delegate the accountability.</a:t>
+            </a:r>
+          </a:p>
+          <a:p/>
+          <a:p>
+            <a:r>
+              <a:t>Ask: where in this stack did our overlap invariant go? (Nowhere yet — it is still only in our heads and in one WHERE clause. Keep that discomfort alive until slide 23.)</a:t>
+            </a:r>
+          </a:p>
+        </p:txBody>
+      </p:sp>
+      <p:sp>
+        <p:nvSpPr>
+          <p:cNvPr id="4" name="Slide Number Placeholder 3"/>
+          <p:cNvSpPr>
+            <a:spLocks noGrp="1"/>
+          </p:cNvSpPr>
+          <p:nvPr>
+            <p:ph type="sldNum" idx="12"/>
+          </p:nvPr>
+        </p:nvSpPr>
+        <p:spPr/>
+      </p:sp>
+    </p:spTree>
+  </p:cSld>
+  <p:clrMapOvr>
+    <a:masterClrMapping/>
+  </p:clrMapOvr>
+</p:notes>
+</file>
+
+<file path=ppt/notesSlides/notesSlide16.xml><?xml version="1.0" encoding="utf-8"?>
+<p:notes xmlns:a="http://schemas.openxmlformats.org/drawingml/2006/main" xmlns:p="http://schemas.openxmlformats.org/presentationml/2006/main" xmlns:r="http://schemas.openxmlformats.org/officeDocument/2006/relationships">
+  <p:cSld>
+    <p:spTree>
+      <p:nvGrpSpPr>
+        <p:cNvPr id="1" name=""/>
+        <p:cNvGrpSpPr/>
+        <p:nvPr/>
+      </p:nvGrpSpPr>
+      <p:grpSpPr>
+        <a:xfrm>
+          <a:off x="0" y="0"/>
+          <a:ext cx="0" cy="0"/>
+          <a:chOff x="0" y="0"/>
+          <a:chExt cx="0" cy="0"/>
+        </a:xfrm>
+      </p:grpSpPr>
+      <p:sp>
+        <p:nvSpPr>
+          <p:cNvPr id="2" name="Slide Image Placeholder 1"/>
+          <p:cNvSpPr>
+            <a:spLocks noGrp="1"/>
+          </p:cNvSpPr>
+          <p:nvPr>
+            <p:ph type="sldImg" idx="3"/>
+          </p:nvPr>
+        </p:nvSpPr>
+        <p:spPr/>
+      </p:sp>
+      <p:sp>
+        <p:nvSpPr>
+          <p:cNvPr id="3" name="Notes Placeholder 2"/>
+          <p:cNvSpPr>
+            <a:spLocks noGrp="1"/>
+          </p:cNvSpPr>
+          <p:nvPr>
+            <p:ph type="body" idx="1"/>
+          </p:nvPr>
+        </p:nvSpPr>
+        <p:spPr/>
+        <p:txBody>
+          <a:bodyPr/>
+          <a:lstStyle/>
+          <a:p>
+            <a:r>
+              <a:t>TIMING: 4 minutes.</a:t>
+            </a:r>
+          </a:p>
+          <a:p/>
+          <a:p>
+            <a:r>
+              <a:t>One of the four slides that carry the lecture. Walk the pipeline once: parse and validate against the schema; a logical plan (relational algebra — what to combine); the optimizer compares candidate plans using statistics; a physical plan (which index, which join algorithm); execution; results.</a:t>
+            </a:r>
+          </a:p>
+          <a:p/>
+          <a:p>
+            <a:r>
+              <a:t>Students should leave knowing EXPLAIN exists: every serious engine will show you the chosen plan, and reading it is how slide 17's difference is diagnosed.</a:t>
+            </a:r>
+          </a:p>
+          <a:p/>
+          <a:p>
+            <a:r>
+              <a:t>PLACEMENT NOTE, deliberate and worth saying: query optimization belongs HERE, under execution — it is about running ONE query efficiently. Transactions (§5) are about which CONCURRENT HISTORIES are permitted. They interact (locking can change plan costs) but they solve different problems. Filing optimization under transactions is a category error.</a:t>
+            </a:r>
+          </a:p>
+        </p:txBody>
+      </p:sp>
+      <p:sp>
+        <p:nvSpPr>
+          <p:cNvPr id="4" name="Slide Number Placeholder 3"/>
+          <p:cNvSpPr>
+            <a:spLocks noGrp="1"/>
+          </p:cNvSpPr>
+          <p:nvPr>
+            <p:ph type="sldNum" idx="12"/>
+          </p:nvPr>
+        </p:nvSpPr>
+        <p:spPr/>
+      </p:sp>
+    </p:spTree>
+  </p:cSld>
+  <p:clrMapOvr>
+    <a:masterClrMapping/>
+  </p:clrMapOvr>
+</p:notes>
+</file>
+
+<file path=ppt/notesSlides/notesSlide17.xml><?xml version="1.0" encoding="utf-8"?>
+<p:notes xmlns:a="http://schemas.openxmlformats.org/drawingml/2006/main" xmlns:p="http://schemas.openxmlformats.org/presentationml/2006/main" xmlns:r="http://schemas.openxmlformats.org/officeDocument/2006/relationships">
+  <p:cSld>
+    <p:spTree>
+      <p:nvGrpSpPr>
+        <p:cNvPr id="1" name=""/>
+        <p:cNvGrpSpPr/>
+        <p:nvPr/>
+      </p:nvGrpSpPr>
+      <p:grpSpPr>
+        <a:xfrm>
+          <a:off x="0" y="0"/>
+          <a:ext cx="0" cy="0"/>
+          <a:chOff x="0" y="0"/>
+          <a:chExt cx="0" cy="0"/>
+        </a:xfrm>
+      </p:grpSpPr>
+      <p:sp>
+        <p:nvSpPr>
+          <p:cNvPr id="2" name="Slide Image Placeholder 1"/>
+          <p:cNvSpPr>
+            <a:spLocks noGrp="1"/>
+          </p:cNvSpPr>
+          <p:nvPr>
+            <p:ph type="sldImg" idx="3"/>
+          </p:nvPr>
+        </p:nvSpPr>
+        <p:spPr/>
+      </p:sp>
+      <p:sp>
+        <p:nvSpPr>
+          <p:cNvPr id="3" name="Notes Placeholder 2"/>
+          <p:cNvSpPr>
+            <a:spLocks noGrp="1"/>
+          </p:cNvSpPr>
+          <p:nvPr>
+            <p:ph type="body" idx="1"/>
+          </p:nvPr>
+        </p:nvSpPr>
+        <p:spPr/>
+        <p:txBody>
+          <a:bodyPr/>
+          <a:lstStyle/>
+          <a:p>
+            <a:r>
+              <a:t>TIMING: 2 minutes.</a:t>
+            </a:r>
+          </a:p>
+          <a:p/>
+          <a:p>
+            <a:r>
+              <a:t>The numbers are illustrative, not benchmarks — the shape is what matters: linear-in-table versus logarithmic-plus-answer-size. On the previous slide's pipeline, the ONLY thing that changed is what the optimizer could choose from.</a:t>
+            </a:r>
+          </a:p>
+          <a:p/>
+          <a:p>
+            <a:r>
+              <a:t>Ask which columns our overlap query wants indexed (room_id, then time). Then the other edge: every insert now maintains the index too — a write-heavy telemetry table (slide 8's system B) might rightly carry fewer indexes. Design decision, access pattern in, index out.</a:t>
+            </a:r>
+          </a:p>
+        </p:txBody>
+      </p:sp>
+      <p:sp>
+        <p:nvSpPr>
+          <p:cNvPr id="4" name="Slide Number Placeholder 3"/>
+          <p:cNvSpPr>
+            <a:spLocks noGrp="1"/>
+          </p:cNvSpPr>
+          <p:nvPr>
+            <p:ph type="sldNum" idx="12"/>
+          </p:nvPr>
+        </p:nvSpPr>
+        <p:spPr/>
+      </p:sp>
+    </p:spTree>
+  </p:cSld>
+  <p:clrMapOvr>
+    <a:masterClrMapping/>
+  </p:clrMapOvr>
+</p:notes>
+</file>
+
+<file path=ppt/notesSlides/notesSlide18.xml><?xml version="1.0" encoding="utf-8"?>
+<p:notes xmlns:a="http://schemas.openxmlformats.org/drawingml/2006/main" xmlns:p="http://schemas.openxmlformats.org/presentationml/2006/main" xmlns:r="http://schemas.openxmlformats.org/officeDocument/2006/relationships">
+  <p:cSld>
+    <p:spTree>
+      <p:nvGrpSpPr>
+        <p:cNvPr id="1" name=""/>
+        <p:cNvGrpSpPr/>
+        <p:nvPr/>
+      </p:nvGrpSpPr>
+      <p:grpSpPr>
+        <a:xfrm>
+          <a:off x="0" y="0"/>
+          <a:ext cx="0" cy="0"/>
+          <a:chOff x="0" y="0"/>
+          <a:chExt cx="0" cy="0"/>
+        </a:xfrm>
+      </p:grpSpPr>
+      <p:sp>
+        <p:nvSpPr>
+          <p:cNvPr id="2" name="Slide Image Placeholder 1"/>
+          <p:cNvSpPr>
+            <a:spLocks noGrp="1"/>
+          </p:cNvSpPr>
+          <p:nvPr>
+            <p:ph type="sldImg" idx="3"/>
+          </p:nvPr>
+        </p:nvSpPr>
+        <p:spPr/>
+      </p:sp>
+      <p:sp>
+        <p:nvSpPr>
+          <p:cNvPr id="3" name="Notes Placeholder 2"/>
+          <p:cNvSpPr>
+            <a:spLocks noGrp="1"/>
+          </p:cNvSpPr>
+          <p:nvPr>
+            <p:ph type="body" idx="1"/>
+          </p:nvPr>
+        </p:nvSpPr>
+        <p:spPr/>
+        <p:txBody>
+          <a:bodyPr/>
+          <a:lstStyle/>
+          <a:p>
+            <a:r>
+              <a:t>TIMING: 2 minutes.</a:t>
+            </a:r>
+          </a:p>
+          <a:p/>
+          <a:p>
+            <a:r>
+              <a:t>The loop is CORRECT — every test passes, the page renders. The defect is the shape of the access: one query per row, each paying a full round trip. It appears exactly where the ORM made row access invisible (r.room.name looks like a field read, is a query).</a:t>
+            </a:r>
+          </a:p>
+          <a:p/>
+          <a:p>
+            <a:r>
+              <a:t>Detection is observational, not static: query logs, APM dashboards, or an ORM's echo mode; count queries per request and be suspicious of counts that scale with result size.</a:t>
+            </a:r>
+          </a:p>
+          <a:p/>
+          <a:p>
+            <a:r>
+              <a:t>The agent point is Act II's lesson again: generated code satisfies the stated spec. "Functionally correct" was the stated spec; access pattern was not. If you want it, state it and check it — review the emitted SQL.</a:t>
+            </a:r>
+          </a:p>
+          <a:p/>
+          <a:p>
+            <a:r>
+              <a:t>Transition: everything so far assumed one request at a time. Drop that assumption.</a:t>
             </a:r>
           </a:p>
         </p:txBody>
@@ -11450,6 +11984,3630 @@
 </p:sld>
 </file>
 
+<file path=ppt/slides/slide13.xml><?xml version="1.0" encoding="utf-8"?>
+<p:sld xmlns:a="http://schemas.openxmlformats.org/drawingml/2006/main" xmlns:p="http://schemas.openxmlformats.org/presentationml/2006/main" xmlns:r="http://schemas.openxmlformats.org/officeDocument/2006/relationships">
+  <p:cSld>
+    <p:spTree>
+      <p:nvGrpSpPr>
+        <p:cNvPr id="1" name=""/>
+        <p:cNvGrpSpPr/>
+        <p:nvPr/>
+      </p:nvGrpSpPr>
+      <p:grpSpPr/>
+      <p:sp>
+        <p:nvSpPr>
+          <p:cNvPr id="2" name="Title"/>
+          <p:cNvSpPr txBox="1"/>
+          <p:nvPr/>
+        </p:nvSpPr>
+        <p:spPr>
+          <a:xfrm>
+            <a:off x="274320" y="128016"/>
+            <a:ext cx="8595360" cy="594360"/>
+          </a:xfrm>
+          <a:prstGeom prst="rect">
+            <a:avLst/>
+          </a:prstGeom>
+          <a:noFill/>
+        </p:spPr>
+        <p:txBody>
+          <a:bodyPr wrap="square">
+            <a:spAutoFit/>
+          </a:bodyPr>
+          <a:lstStyle/>
+          <a:p>
+            <a:pPr algn="l">
+              <a:spcAft>
+                <a:spcPts val="400"/>
+              </a:spcAft>
+            </a:pPr>
+            <a:r>
+              <a:rPr sz="2400" b="0">
+                <a:solidFill>
+                  <a:srgbClr val="2D2D2D"/>
+                </a:solidFill>
+                <a:latin typeface="Calibri"/>
+              </a:rPr>
+              <a:t>SQL states WHAT you want, not HOW to get it</a:t>
+            </a:r>
+          </a:p>
+        </p:txBody>
+      </p:sp>
+      <p:sp>
+        <p:nvSpPr>
+          <p:cNvPr id="3" name="Card"/>
+          <p:cNvSpPr/>
+          <p:nvPr/>
+        </p:nvSpPr>
+        <p:spPr>
+          <a:xfrm>
+            <a:off x="411480" y="960120"/>
+            <a:ext cx="4846320" cy="2834640"/>
+          </a:xfrm>
+          <a:prstGeom prst="rect">
+            <a:avLst/>
+          </a:prstGeom>
+          <a:solidFill>
+            <a:srgbClr val="FCFAF6"/>
+          </a:solidFill>
+          <a:ln>
+            <a:noFill/>
+          </a:ln>
+          <a:effectLst/>
+        </p:spPr>
+        <p:style>
+          <a:lnRef idx="1">
+            <a:schemeClr val="accent1"/>
+          </a:lnRef>
+          <a:fillRef idx="3">
+            <a:schemeClr val="accent1"/>
+          </a:fillRef>
+          <a:effectRef idx="2">
+            <a:schemeClr val="accent1"/>
+          </a:effectRef>
+          <a:fontRef idx="minor">
+            <a:schemeClr val="lt1"/>
+          </a:fontRef>
+        </p:style>
+        <p:txBody>
+          <a:bodyPr rtlCol="0" anchor="ctr" wrap="square"/>
+          <a:lstStyle/>
+          <a:p>
+            <a:pPr algn="ctr"/>
+          </a:p>
+        </p:txBody>
+      </p:sp>
+      <p:sp>
+        <p:nvSpPr>
+          <p:cNvPr id="4" name="Code"/>
+          <p:cNvSpPr txBox="1"/>
+          <p:nvPr/>
+        </p:nvSpPr>
+        <p:spPr>
+          <a:xfrm>
+            <a:off x="557784" y="1051560"/>
+            <a:ext cx="4553712" cy="2651760"/>
+          </a:xfrm>
+          <a:prstGeom prst="rect">
+            <a:avLst/>
+          </a:prstGeom>
+          <a:noFill/>
+        </p:spPr>
+        <p:txBody>
+          <a:bodyPr wrap="square">
+            <a:spAutoFit/>
+          </a:bodyPr>
+          <a:lstStyle/>
+          <a:p>
+            <a:pPr algn="l">
+              <a:spcAft>
+                <a:spcPts val="200"/>
+              </a:spcAft>
+            </a:pPr>
+            <a:r>
+              <a:rPr sz="2000" b="0">
+                <a:solidFill>
+                  <a:srgbClr val="2D2D2D"/>
+                </a:solidFill>
+                <a:latin typeface="Consolas"/>
+              </a:rPr>
+              <a:t>SELECT 1</a:t>
+            </a:r>
+          </a:p>
+          <a:p>
+            <a:pPr algn="l">
+              <a:spcAft>
+                <a:spcPts val="200"/>
+              </a:spcAft>
+            </a:pPr>
+            <a:r>
+              <a:rPr sz="2000" b="0">
+                <a:solidFill>
+                  <a:srgbClr val="2D2D2D"/>
+                </a:solidFill>
+                <a:latin typeface="Consolas"/>
+              </a:rPr>
+              <a:t>FROM reservations</a:t>
+            </a:r>
+          </a:p>
+          <a:p>
+            <a:pPr algn="l">
+              <a:spcAft>
+                <a:spcPts val="200"/>
+              </a:spcAft>
+            </a:pPr>
+            <a:r>
+              <a:rPr sz="2000" b="0">
+                <a:solidFill>
+                  <a:srgbClr val="2D2D2D"/>
+                </a:solidFill>
+                <a:latin typeface="Consolas"/>
+              </a:rPr>
+              <a:t>WHERE room_id = :room</a:t>
+            </a:r>
+          </a:p>
+          <a:p>
+            <a:pPr algn="l">
+              <a:spcAft>
+                <a:spcPts val="200"/>
+              </a:spcAft>
+            </a:pPr>
+            <a:r>
+              <a:rPr sz="2000" b="0">
+                <a:solidFill>
+                  <a:srgbClr val="2D2D2D"/>
+                </a:solidFill>
+                <a:latin typeface="Consolas"/>
+              </a:rPr>
+              <a:t>  AND status  = 'CONFIRMED'</a:t>
+            </a:r>
+          </a:p>
+          <a:p>
+            <a:pPr algn="l">
+              <a:spcAft>
+                <a:spcPts val="200"/>
+              </a:spcAft>
+            </a:pPr>
+            <a:r>
+              <a:rPr sz="2000" b="0">
+                <a:solidFill>
+                  <a:srgbClr val="2D2D2D"/>
+                </a:solidFill>
+                <a:latin typeface="Consolas"/>
+              </a:rPr>
+              <a:t>  AND starts_at &lt; :ends</a:t>
+            </a:r>
+          </a:p>
+          <a:p>
+            <a:pPr algn="l">
+              <a:spcAft>
+                <a:spcPts val="200"/>
+              </a:spcAft>
+            </a:pPr>
+            <a:r>
+              <a:rPr sz="2000" b="0">
+                <a:solidFill>
+                  <a:srgbClr val="2D2D2D"/>
+                </a:solidFill>
+                <a:latin typeface="Consolas"/>
+              </a:rPr>
+              <a:t>  AND ends_at   &gt; :starts;</a:t>
+            </a:r>
+          </a:p>
+        </p:txBody>
+      </p:sp>
+      <p:sp>
+        <p:nvSpPr>
+          <p:cNvPr id="5" name="Card"/>
+          <p:cNvSpPr/>
+          <p:nvPr/>
+        </p:nvSpPr>
+        <p:spPr>
+          <a:xfrm>
+            <a:off x="5440680" y="960120"/>
+            <a:ext cx="3291840" cy="2834640"/>
+          </a:xfrm>
+          <a:prstGeom prst="rect">
+            <a:avLst/>
+          </a:prstGeom>
+          <a:solidFill>
+            <a:srgbClr val="F5F1E8"/>
+          </a:solidFill>
+          <a:ln>
+            <a:noFill/>
+          </a:ln>
+          <a:effectLst/>
+        </p:spPr>
+        <p:style>
+          <a:lnRef idx="1">
+            <a:schemeClr val="accent1"/>
+          </a:lnRef>
+          <a:fillRef idx="3">
+            <a:schemeClr val="accent1"/>
+          </a:fillRef>
+          <a:effectRef idx="2">
+            <a:schemeClr val="accent1"/>
+          </a:effectRef>
+          <a:fontRef idx="minor">
+            <a:schemeClr val="lt1"/>
+          </a:fontRef>
+        </p:style>
+        <p:txBody>
+          <a:bodyPr rtlCol="0" anchor="ctr" wrap="square"/>
+          <a:lstStyle/>
+          <a:p>
+            <a:pPr algn="ctr"/>
+          </a:p>
+        </p:txBody>
+      </p:sp>
+      <p:sp>
+        <p:nvSpPr>
+          <p:cNvPr id="6" name="CardBody"/>
+          <p:cNvSpPr txBox="1"/>
+          <p:nvPr/>
+        </p:nvSpPr>
+        <p:spPr>
+          <a:xfrm>
+            <a:off x="5586984" y="1051560"/>
+            <a:ext cx="2999232" cy="2651760"/>
+          </a:xfrm>
+          <a:prstGeom prst="rect">
+            <a:avLst/>
+          </a:prstGeom>
+          <a:noFill/>
+        </p:spPr>
+        <p:txBody>
+          <a:bodyPr wrap="square">
+            <a:spAutoFit/>
+          </a:bodyPr>
+          <a:lstStyle/>
+          <a:p>
+            <a:pPr algn="l">
+              <a:spcAft>
+                <a:spcPts val="500"/>
+              </a:spcAft>
+            </a:pPr>
+            <a:r>
+              <a:rPr sz="2000" b="1">
+                <a:solidFill>
+                  <a:srgbClr val="8E6F3E"/>
+                </a:solidFill>
+                <a:latin typeface="Calibri"/>
+              </a:rPr>
+              <a:t>DECLARATIVE</a:t>
+            </a:r>
+          </a:p>
+          <a:p>
+            <a:pPr algn="l">
+              <a:spcAft>
+                <a:spcPts val="400"/>
+              </a:spcAft>
+            </a:pPr>
+            <a:r>
+              <a:rPr sz="2000" b="0">
+                <a:solidFill>
+                  <a:srgbClr val="5C4826"/>
+                </a:solidFill>
+                <a:latin typeface="Calibri"/>
+              </a:rPr>
+              <a:t>Names the rows wanted</a:t>
+            </a:r>
+          </a:p>
+          <a:p>
+            <a:pPr algn="l">
+              <a:spcAft>
+                <a:spcPts val="400"/>
+              </a:spcAft>
+            </a:pPr>
+            <a:r>
+              <a:rPr sz="2000" b="0">
+                <a:solidFill>
+                  <a:srgbClr val="555960"/>
+                </a:solidFill>
+                <a:latin typeface="Calibri"/>
+              </a:rPr>
+              <a:t>Says nothing about scans, indexes, or order</a:t>
+            </a:r>
+          </a:p>
+          <a:p>
+            <a:pPr algn="l">
+              <a:spcAft>
+                <a:spcPts val="400"/>
+              </a:spcAft>
+            </a:pPr>
+            <a:r>
+              <a:rPr sz="2000" b="0">
+                <a:solidFill>
+                  <a:srgbClr val="555960"/>
+                </a:solidFill>
+                <a:latin typeface="Calibri"/>
+              </a:rPr>
+              <a:t>The engine chooses HOW — slide 16</a:t>
+            </a:r>
+          </a:p>
+        </p:txBody>
+      </p:sp>
+      <p:sp>
+        <p:nvSpPr>
+          <p:cNvPr id="7" name="Card"/>
+          <p:cNvSpPr/>
+          <p:nvPr/>
+        </p:nvSpPr>
+        <p:spPr>
+          <a:xfrm>
+            <a:off x="411480" y="4023360"/>
+            <a:ext cx="8321040" cy="1234440"/>
+          </a:xfrm>
+          <a:prstGeom prst="rect">
+            <a:avLst/>
+          </a:prstGeom>
+          <a:solidFill>
+            <a:srgbClr val="FCFAF6"/>
+          </a:solidFill>
+          <a:ln>
+            <a:noFill/>
+          </a:ln>
+          <a:effectLst/>
+        </p:spPr>
+        <p:style>
+          <a:lnRef idx="1">
+            <a:schemeClr val="accent1"/>
+          </a:lnRef>
+          <a:fillRef idx="3">
+            <a:schemeClr val="accent1"/>
+          </a:fillRef>
+          <a:effectRef idx="2">
+            <a:schemeClr val="accent1"/>
+          </a:effectRef>
+          <a:fontRef idx="minor">
+            <a:schemeClr val="lt1"/>
+          </a:fontRef>
+        </p:style>
+        <p:txBody>
+          <a:bodyPr rtlCol="0" anchor="ctr" wrap="square"/>
+          <a:lstStyle/>
+          <a:p>
+            <a:pPr algn="ctr"/>
+          </a:p>
+        </p:txBody>
+      </p:sp>
+      <p:sp>
+        <p:nvSpPr>
+          <p:cNvPr id="8" name="CardBody"/>
+          <p:cNvSpPr txBox="1"/>
+          <p:nvPr/>
+        </p:nvSpPr>
+        <p:spPr>
+          <a:xfrm>
+            <a:off x="557784" y="4096512"/>
+            <a:ext cx="8046720" cy="1097280"/>
+          </a:xfrm>
+          <a:prstGeom prst="rect">
+            <a:avLst/>
+          </a:prstGeom>
+          <a:noFill/>
+        </p:spPr>
+        <p:txBody>
+          <a:bodyPr wrap="square">
+            <a:spAutoFit/>
+          </a:bodyPr>
+          <a:lstStyle/>
+          <a:p>
+            <a:pPr algn="l">
+              <a:spcAft>
+                <a:spcPts val="300"/>
+              </a:spcAft>
+            </a:pPr>
+            <a:r>
+              <a:rPr sz="2000" b="1">
+                <a:solidFill>
+                  <a:srgbClr val="5C4826"/>
+                </a:solidFill>
+                <a:latin typeface="Calibri"/>
+              </a:rPr>
+              <a:t>The overlap test:  A.starts &lt; B.ends  AND  A.ends &gt; B.starts</a:t>
+            </a:r>
+          </a:p>
+          <a:p>
+            <a:pPr algn="l">
+              <a:spcAft>
+                <a:spcPts val="400"/>
+              </a:spcAft>
+            </a:pPr>
+            <a:r>
+              <a:rPr sz="2000" b="0">
+                <a:solidFill>
+                  <a:srgbClr val="555960"/>
+                </a:solidFill>
+                <a:latin typeface="Calibri"/>
+              </a:rPr>
+              <a:t>This predicate is the invariant in query form — it returns on slides 19 and 23.</a:t>
+            </a:r>
+          </a:p>
+        </p:txBody>
+      </p:sp>
+      <p:sp>
+        <p:nvSpPr>
+          <p:cNvPr id="9" name="FooterBand"/>
+          <p:cNvSpPr/>
+          <p:nvPr/>
+        </p:nvSpPr>
+        <p:spPr>
+          <a:xfrm>
+            <a:off x="274320" y="5879592"/>
+            <a:ext cx="8595360" cy="502920"/>
+          </a:xfrm>
+          <a:prstGeom prst="rect">
+            <a:avLst/>
+          </a:prstGeom>
+          <a:solidFill>
+            <a:srgbClr val="8E6F3E"/>
+          </a:solidFill>
+          <a:ln>
+            <a:noFill/>
+          </a:ln>
+          <a:effectLst/>
+        </p:spPr>
+        <p:style>
+          <a:lnRef idx="1">
+            <a:schemeClr val="accent1"/>
+          </a:lnRef>
+          <a:fillRef idx="3">
+            <a:schemeClr val="accent1"/>
+          </a:fillRef>
+          <a:effectRef idx="2">
+            <a:schemeClr val="accent1"/>
+          </a:effectRef>
+          <a:fontRef idx="minor">
+            <a:schemeClr val="lt1"/>
+          </a:fontRef>
+        </p:style>
+        <p:txBody>
+          <a:bodyPr rtlCol="0" anchor="ctr" wrap="square"/>
+          <a:lstStyle/>
+          <a:p>
+            <a:pPr algn="ctr"/>
+          </a:p>
+        </p:txBody>
+      </p:sp>
+      <p:sp>
+        <p:nvSpPr>
+          <p:cNvPr id="10" name="FooterBandText"/>
+          <p:cNvSpPr txBox="1"/>
+          <p:nvPr/>
+        </p:nvSpPr>
+        <p:spPr>
+          <a:xfrm>
+            <a:off x="384048" y="5897880"/>
+            <a:ext cx="8375904" cy="457200"/>
+          </a:xfrm>
+          <a:prstGeom prst="rect">
+            <a:avLst/>
+          </a:prstGeom>
+          <a:noFill/>
+        </p:spPr>
+        <p:txBody>
+          <a:bodyPr wrap="square">
+            <a:spAutoFit/>
+          </a:bodyPr>
+          <a:lstStyle/>
+          <a:p>
+            <a:pPr algn="ctr">
+              <a:spcAft>
+                <a:spcPts val="400"/>
+              </a:spcAft>
+            </a:pPr>
+            <a:r>
+              <a:rPr sz="2000" b="1">
+                <a:solidFill>
+                  <a:srgbClr val="FFFFFF"/>
+                </a:solidFill>
+                <a:latin typeface="Calibri"/>
+              </a:rPr>
+              <a:t>A query is a specification — execution is the engine's design space</a:t>
+            </a:r>
+          </a:p>
+        </p:txBody>
+      </p:sp>
+    </p:spTree>
+  </p:cSld>
+  <p:clrMapOvr>
+    <a:masterClrMapping/>
+  </p:clrMapOvr>
+</p:sld>
+</file>
+
+<file path=ppt/slides/slide14.xml><?xml version="1.0" encoding="utf-8"?>
+<p:sld xmlns:a="http://schemas.openxmlformats.org/drawingml/2006/main" xmlns:p="http://schemas.openxmlformats.org/presentationml/2006/main" xmlns:r="http://schemas.openxmlformats.org/officeDocument/2006/relationships">
+  <p:cSld>
+    <p:spTree>
+      <p:nvGrpSpPr>
+        <p:cNvPr id="1" name=""/>
+        <p:cNvGrpSpPr/>
+        <p:nvPr/>
+      </p:nvGrpSpPr>
+      <p:grpSpPr/>
+      <p:sp>
+        <p:nvSpPr>
+          <p:cNvPr id="2" name="Title"/>
+          <p:cNvSpPr txBox="1"/>
+          <p:nvPr/>
+        </p:nvSpPr>
+        <p:spPr>
+          <a:xfrm>
+            <a:off x="274320" y="128016"/>
+            <a:ext cx="8595360" cy="594360"/>
+          </a:xfrm>
+          <a:prstGeom prst="rect">
+            <a:avLst/>
+          </a:prstGeom>
+          <a:noFill/>
+        </p:spPr>
+        <p:txBody>
+          <a:bodyPr wrap="square">
+            <a:spAutoFit/>
+          </a:bodyPr>
+          <a:lstStyle/>
+          <a:p>
+            <a:pPr algn="l">
+              <a:spcAft>
+                <a:spcPts val="400"/>
+              </a:spcAft>
+            </a:pPr>
+            <a:r>
+              <a:rPr sz="2400" b="0">
+                <a:solidFill>
+                  <a:srgbClr val="2D2D2D"/>
+                </a:solidFill>
+                <a:latin typeface="Calibri"/>
+              </a:rPr>
+              <a:t>An ORM maps your objects to stored data</a:t>
+            </a:r>
+          </a:p>
+        </p:txBody>
+      </p:sp>
+      <p:sp>
+        <p:nvSpPr>
+          <p:cNvPr id="3" name="Label"/>
+          <p:cNvSpPr txBox="1"/>
+          <p:nvPr/>
+        </p:nvSpPr>
+        <p:spPr>
+          <a:xfrm>
+            <a:off x="411480" y="841248"/>
+            <a:ext cx="8321040" cy="365760"/>
+          </a:xfrm>
+          <a:prstGeom prst="rect">
+            <a:avLst/>
+          </a:prstGeom>
+          <a:noFill/>
+        </p:spPr>
+        <p:txBody>
+          <a:bodyPr wrap="square">
+            <a:spAutoFit/>
+          </a:bodyPr>
+          <a:lstStyle/>
+          <a:p>
+            <a:pPr algn="l">
+              <a:spcAft>
+                <a:spcPts val="400"/>
+              </a:spcAft>
+            </a:pPr>
+            <a:r>
+              <a:rPr sz="2000" b="1">
+                <a:solidFill>
+                  <a:srgbClr val="8E6F3E"/>
+                </a:solidFill>
+                <a:latin typeface="Calibri"/>
+              </a:rPr>
+              <a:t>Illustrative — real syntax depends on the library</a:t>
+            </a:r>
+          </a:p>
+        </p:txBody>
+      </p:sp>
+      <p:sp>
+        <p:nvSpPr>
+          <p:cNvPr id="4" name="Card"/>
+          <p:cNvSpPr/>
+          <p:nvPr/>
+        </p:nvSpPr>
+        <p:spPr>
+          <a:xfrm>
+            <a:off x="411480" y="1298448"/>
+            <a:ext cx="4846320" cy="2468880"/>
+          </a:xfrm>
+          <a:prstGeom prst="rect">
+            <a:avLst/>
+          </a:prstGeom>
+          <a:solidFill>
+            <a:srgbClr val="FCFAF6"/>
+          </a:solidFill>
+          <a:ln>
+            <a:noFill/>
+          </a:ln>
+          <a:effectLst/>
+        </p:spPr>
+        <p:style>
+          <a:lnRef idx="1">
+            <a:schemeClr val="accent1"/>
+          </a:lnRef>
+          <a:fillRef idx="3">
+            <a:schemeClr val="accent1"/>
+          </a:fillRef>
+          <a:effectRef idx="2">
+            <a:schemeClr val="accent1"/>
+          </a:effectRef>
+          <a:fontRef idx="minor">
+            <a:schemeClr val="lt1"/>
+          </a:fontRef>
+        </p:style>
+        <p:txBody>
+          <a:bodyPr rtlCol="0" anchor="ctr" wrap="square"/>
+          <a:lstStyle/>
+          <a:p>
+            <a:pPr algn="ctr"/>
+          </a:p>
+        </p:txBody>
+      </p:sp>
+      <p:sp>
+        <p:nvSpPr>
+          <p:cNvPr id="5" name="Code"/>
+          <p:cNvSpPr txBox="1"/>
+          <p:nvPr/>
+        </p:nvSpPr>
+        <p:spPr>
+          <a:xfrm>
+            <a:off x="557784" y="1389888"/>
+            <a:ext cx="4553712" cy="2286000"/>
+          </a:xfrm>
+          <a:prstGeom prst="rect">
+            <a:avLst/>
+          </a:prstGeom>
+          <a:noFill/>
+        </p:spPr>
+        <p:txBody>
+          <a:bodyPr wrap="square">
+            <a:spAutoFit/>
+          </a:bodyPr>
+          <a:lstStyle/>
+          <a:p>
+            <a:pPr algn="l">
+              <a:spcAft>
+                <a:spcPts val="200"/>
+              </a:spcAft>
+            </a:pPr>
+            <a:r>
+              <a:rPr sz="2000" b="0">
+                <a:solidFill>
+                  <a:srgbClr val="2D2D2D"/>
+                </a:solidFill>
+                <a:latin typeface="Consolas"/>
+              </a:rPr>
+              <a:t>conflict = (Reservation.query</a:t>
+            </a:r>
+          </a:p>
+          <a:p>
+            <a:pPr algn="l">
+              <a:spcAft>
+                <a:spcPts val="200"/>
+              </a:spcAft>
+            </a:pPr>
+            <a:r>
+              <a:rPr sz="2000" b="0">
+                <a:solidFill>
+                  <a:srgbClr val="2D2D2D"/>
+                </a:solidFill>
+                <a:latin typeface="Consolas"/>
+              </a:rPr>
+              <a:t>  .filter_by(room_id=room,</a:t>
+            </a:r>
+          </a:p>
+          <a:p>
+            <a:pPr algn="l">
+              <a:spcAft>
+                <a:spcPts val="200"/>
+              </a:spcAft>
+            </a:pPr>
+            <a:r>
+              <a:rPr sz="2000" b="0">
+                <a:solidFill>
+                  <a:srgbClr val="2D2D2D"/>
+                </a:solidFill>
+                <a:latin typeface="Consolas"/>
+              </a:rPr>
+              <a:t>             status='CONFIRMED')</a:t>
+            </a:r>
+          </a:p>
+          <a:p>
+            <a:pPr algn="l">
+              <a:spcAft>
+                <a:spcPts val="200"/>
+              </a:spcAft>
+            </a:pPr>
+            <a:r>
+              <a:rPr sz="2000" b="0">
+                <a:solidFill>
+                  <a:srgbClr val="2D2D2D"/>
+                </a:solidFill>
+                <a:latin typeface="Consolas"/>
+              </a:rPr>
+              <a:t>  .filter(R.starts_at &lt; ends,</a:t>
+            </a:r>
+          </a:p>
+          <a:p>
+            <a:pPr algn="l">
+              <a:spcAft>
+                <a:spcPts val="200"/>
+              </a:spcAft>
+            </a:pPr>
+            <a:r>
+              <a:rPr sz="2000" b="0">
+                <a:solidFill>
+                  <a:srgbClr val="2D2D2D"/>
+                </a:solidFill>
+                <a:latin typeface="Consolas"/>
+              </a:rPr>
+              <a:t>          R.ends_at   &gt; starts)</a:t>
+            </a:r>
+          </a:p>
+          <a:p>
+            <a:pPr algn="l">
+              <a:spcAft>
+                <a:spcPts val="200"/>
+              </a:spcAft>
+            </a:pPr>
+            <a:r>
+              <a:rPr sz="2000" b="0">
+                <a:solidFill>
+                  <a:srgbClr val="2D2D2D"/>
+                </a:solidFill>
+                <a:latin typeface="Consolas"/>
+              </a:rPr>
+              <a:t>  .first())</a:t>
+            </a:r>
+          </a:p>
+        </p:txBody>
+      </p:sp>
+      <p:sp>
+        <p:nvSpPr>
+          <p:cNvPr id="6" name="Card"/>
+          <p:cNvSpPr/>
+          <p:nvPr/>
+        </p:nvSpPr>
+        <p:spPr>
+          <a:xfrm>
+            <a:off x="5440680" y="1298448"/>
+            <a:ext cx="3291840" cy="2468880"/>
+          </a:xfrm>
+          <a:prstGeom prst="rect">
+            <a:avLst/>
+          </a:prstGeom>
+          <a:solidFill>
+            <a:srgbClr val="F5F1E8"/>
+          </a:solidFill>
+          <a:ln>
+            <a:noFill/>
+          </a:ln>
+          <a:effectLst/>
+        </p:spPr>
+        <p:style>
+          <a:lnRef idx="1">
+            <a:schemeClr val="accent1"/>
+          </a:lnRef>
+          <a:fillRef idx="3">
+            <a:schemeClr val="accent1"/>
+          </a:fillRef>
+          <a:effectRef idx="2">
+            <a:schemeClr val="accent1"/>
+          </a:effectRef>
+          <a:fontRef idx="minor">
+            <a:schemeClr val="lt1"/>
+          </a:fontRef>
+        </p:style>
+        <p:txBody>
+          <a:bodyPr rtlCol="0" anchor="ctr" wrap="square"/>
+          <a:lstStyle/>
+          <a:p>
+            <a:pPr algn="ctr"/>
+          </a:p>
+        </p:txBody>
+      </p:sp>
+      <p:sp>
+        <p:nvSpPr>
+          <p:cNvPr id="7" name="CardBody"/>
+          <p:cNvSpPr txBox="1"/>
+          <p:nvPr/>
+        </p:nvSpPr>
+        <p:spPr>
+          <a:xfrm>
+            <a:off x="5586984" y="1389888"/>
+            <a:ext cx="2999232" cy="2286000"/>
+          </a:xfrm>
+          <a:prstGeom prst="rect">
+            <a:avLst/>
+          </a:prstGeom>
+          <a:noFill/>
+        </p:spPr>
+        <p:txBody>
+          <a:bodyPr wrap="square">
+            <a:spAutoFit/>
+          </a:bodyPr>
+          <a:lstStyle/>
+          <a:p>
+            <a:pPr algn="l">
+              <a:spcAft>
+                <a:spcPts val="500"/>
+              </a:spcAft>
+            </a:pPr>
+            <a:r>
+              <a:rPr sz="2000" b="1">
+                <a:solidFill>
+                  <a:srgbClr val="8E6F3E"/>
+                </a:solidFill>
+                <a:latin typeface="Calibri"/>
+              </a:rPr>
+              <a:t>WHAT IT BUYS</a:t>
+            </a:r>
+          </a:p>
+          <a:p>
+            <a:pPr algn="l">
+              <a:spcAft>
+                <a:spcPts val="400"/>
+              </a:spcAft>
+            </a:pPr>
+            <a:r>
+              <a:rPr sz="2000" b="0">
+                <a:solidFill>
+                  <a:srgbClr val="5C4826"/>
+                </a:solidFill>
+                <a:latin typeface="Calibri"/>
+              </a:rPr>
+              <a:t>Objects in your language</a:t>
+            </a:r>
+          </a:p>
+          <a:p>
+            <a:pPr algn="l">
+              <a:spcAft>
+                <a:spcPts val="400"/>
+              </a:spcAft>
+            </a:pPr>
+            <a:r>
+              <a:rPr sz="2000" b="0">
+                <a:solidFill>
+                  <a:srgbClr val="5C4826"/>
+                </a:solidFill>
+                <a:latin typeface="Calibri"/>
+              </a:rPr>
+              <a:t>Mapping and sessions handled</a:t>
+            </a:r>
+          </a:p>
+          <a:p>
+            <a:pPr algn="l">
+              <a:spcAft>
+                <a:spcPts val="400"/>
+              </a:spcAft>
+            </a:pPr>
+            <a:r>
+              <a:rPr sz="2000" b="0">
+                <a:solidFill>
+                  <a:srgbClr val="5C4826"/>
+                </a:solidFill>
+                <a:latin typeface="Calibri"/>
+              </a:rPr>
+              <a:t>Less boilerplate</a:t>
+            </a:r>
+          </a:p>
+        </p:txBody>
+      </p:sp>
+      <p:sp>
+        <p:nvSpPr>
+          <p:cNvPr id="8" name="Card"/>
+          <p:cNvSpPr/>
+          <p:nvPr/>
+        </p:nvSpPr>
+        <p:spPr>
+          <a:xfrm>
+            <a:off x="411480" y="3950208"/>
+            <a:ext cx="8321040" cy="1627632"/>
+          </a:xfrm>
+          <a:prstGeom prst="rect">
+            <a:avLst/>
+          </a:prstGeom>
+          <a:solidFill>
+            <a:srgbClr val="F5F1E8"/>
+          </a:solidFill>
+          <a:ln>
+            <a:noFill/>
+          </a:ln>
+          <a:effectLst/>
+        </p:spPr>
+        <p:style>
+          <a:lnRef idx="1">
+            <a:schemeClr val="accent1"/>
+          </a:lnRef>
+          <a:fillRef idx="3">
+            <a:schemeClr val="accent1"/>
+          </a:fillRef>
+          <a:effectRef idx="2">
+            <a:schemeClr val="accent1"/>
+          </a:effectRef>
+          <a:fontRef idx="minor">
+            <a:schemeClr val="lt1"/>
+          </a:fontRef>
+        </p:style>
+        <p:txBody>
+          <a:bodyPr rtlCol="0" anchor="ctr" wrap="square"/>
+          <a:lstStyle/>
+          <a:p>
+            <a:pPr algn="ctr"/>
+          </a:p>
+        </p:txBody>
+      </p:sp>
+      <p:sp>
+        <p:nvSpPr>
+          <p:cNvPr id="9" name="CardBody"/>
+          <p:cNvSpPr txBox="1"/>
+          <p:nvPr/>
+        </p:nvSpPr>
+        <p:spPr>
+          <a:xfrm>
+            <a:off x="557784" y="4023360"/>
+            <a:ext cx="8046720" cy="1481328"/>
+          </a:xfrm>
+          <a:prstGeom prst="rect">
+            <a:avLst/>
+          </a:prstGeom>
+          <a:noFill/>
+        </p:spPr>
+        <p:txBody>
+          <a:bodyPr wrap="square">
+            <a:spAutoFit/>
+          </a:bodyPr>
+          <a:lstStyle/>
+          <a:p>
+            <a:pPr algn="l">
+              <a:spcAft>
+                <a:spcPts val="300"/>
+              </a:spcAft>
+            </a:pPr>
+            <a:r>
+              <a:rPr sz="2000" b="1">
+                <a:solidFill>
+                  <a:srgbClr val="8E6F3E"/>
+                </a:solidFill>
+                <a:latin typeface="Calibri"/>
+              </a:rPr>
+              <a:t>WHAT IT COSTS</a:t>
+            </a:r>
+          </a:p>
+          <a:p>
+            <a:pPr algn="l">
+              <a:spcAft>
+                <a:spcPts val="400"/>
+              </a:spcAft>
+            </a:pPr>
+            <a:r>
+              <a:rPr sz="2000" b="0">
+                <a:solidFill>
+                  <a:srgbClr val="555960"/>
+                </a:solidFill>
+                <a:latin typeface="Calibri"/>
+              </a:rPr>
+              <a:t>Leaky: you still must know the SQL it emits</a:t>
+            </a:r>
+          </a:p>
+          <a:p>
+            <a:pPr algn="l">
+              <a:spcAft>
+                <a:spcPts val="400"/>
+              </a:spcAft>
+            </a:pPr>
+            <a:r>
+              <a:rPr sz="2000" b="0">
+                <a:solidFill>
+                  <a:srgbClr val="555960"/>
+                </a:solidFill>
+                <a:latin typeface="Calibri"/>
+              </a:rPr>
+              <a:t>Generated queries can be inefficient — the N+1 trap, slide 18</a:t>
+            </a:r>
+          </a:p>
+          <a:p>
+            <a:pPr algn="l">
+              <a:spcAft>
+                <a:spcPts val="400"/>
+              </a:spcAft>
+            </a:pPr>
+            <a:r>
+              <a:rPr sz="2000" b="0">
+                <a:solidFill>
+                  <a:srgbClr val="555960"/>
+                </a:solidFill>
+                <a:latin typeface="Calibri"/>
+              </a:rPr>
+              <a:t>Database-specific operations get awkward</a:t>
+            </a:r>
+          </a:p>
+        </p:txBody>
+      </p:sp>
+      <p:sp>
+        <p:nvSpPr>
+          <p:cNvPr id="10" name="FooterBand"/>
+          <p:cNvSpPr/>
+          <p:nvPr/>
+        </p:nvSpPr>
+        <p:spPr>
+          <a:xfrm>
+            <a:off x="274320" y="5879592"/>
+            <a:ext cx="8595360" cy="502920"/>
+          </a:xfrm>
+          <a:prstGeom prst="rect">
+            <a:avLst/>
+          </a:prstGeom>
+          <a:solidFill>
+            <a:srgbClr val="8E6F3E"/>
+          </a:solidFill>
+          <a:ln>
+            <a:noFill/>
+          </a:ln>
+          <a:effectLst/>
+        </p:spPr>
+        <p:style>
+          <a:lnRef idx="1">
+            <a:schemeClr val="accent1"/>
+          </a:lnRef>
+          <a:fillRef idx="3">
+            <a:schemeClr val="accent1"/>
+          </a:fillRef>
+          <a:effectRef idx="2">
+            <a:schemeClr val="accent1"/>
+          </a:effectRef>
+          <a:fontRef idx="minor">
+            <a:schemeClr val="lt1"/>
+          </a:fontRef>
+        </p:style>
+        <p:txBody>
+          <a:bodyPr rtlCol="0" anchor="ctr" wrap="square"/>
+          <a:lstStyle/>
+          <a:p>
+            <a:pPr algn="ctr"/>
+          </a:p>
+        </p:txBody>
+      </p:sp>
+      <p:sp>
+        <p:nvSpPr>
+          <p:cNvPr id="11" name="FooterBandText"/>
+          <p:cNvSpPr txBox="1"/>
+          <p:nvPr/>
+        </p:nvSpPr>
+        <p:spPr>
+          <a:xfrm>
+            <a:off x="384048" y="5897880"/>
+            <a:ext cx="8375904" cy="457200"/>
+          </a:xfrm>
+          <a:prstGeom prst="rect">
+            <a:avLst/>
+          </a:prstGeom>
+          <a:noFill/>
+        </p:spPr>
+        <p:txBody>
+          <a:bodyPr wrap="square">
+            <a:spAutoFit/>
+          </a:bodyPr>
+          <a:lstStyle/>
+          <a:p>
+            <a:pPr algn="ctr">
+              <a:spcAft>
+                <a:spcPts val="400"/>
+              </a:spcAft>
+            </a:pPr>
+            <a:r>
+              <a:rPr sz="2000" b="1">
+                <a:solidFill>
+                  <a:srgbClr val="FFFFFF"/>
+                </a:solidFill>
+                <a:latin typeface="Calibri"/>
+              </a:rPr>
+              <a:t>A convenience layer over the query language — not a replacement</a:t>
+            </a:r>
+          </a:p>
+        </p:txBody>
+      </p:sp>
+    </p:spTree>
+  </p:cSld>
+  <p:clrMapOvr>
+    <a:masterClrMapping/>
+  </p:clrMapOvr>
+</p:sld>
+</file>
+
+<file path=ppt/slides/slide15.xml><?xml version="1.0" encoding="utf-8"?>
+<p:sld xmlns:a="http://schemas.openxmlformats.org/drawingml/2006/main" xmlns:p="http://schemas.openxmlformats.org/presentationml/2006/main" xmlns:r="http://schemas.openxmlformats.org/officeDocument/2006/relationships">
+  <p:cSld>
+    <p:spTree>
+      <p:nvGrpSpPr>
+        <p:cNvPr id="1" name=""/>
+        <p:cNvGrpSpPr/>
+        <p:nvPr/>
+      </p:nvGrpSpPr>
+      <p:grpSpPr/>
+      <p:sp>
+        <p:nvSpPr>
+          <p:cNvPr id="2" name="Title"/>
+          <p:cNvSpPr txBox="1"/>
+          <p:nvPr/>
+        </p:nvSpPr>
+        <p:spPr>
+          <a:xfrm>
+            <a:off x="274320" y="128016"/>
+            <a:ext cx="8595360" cy="594360"/>
+          </a:xfrm>
+          <a:prstGeom prst="rect">
+            <a:avLst/>
+          </a:prstGeom>
+          <a:noFill/>
+        </p:spPr>
+        <p:txBody>
+          <a:bodyPr wrap="square">
+            <a:spAutoFit/>
+          </a:bodyPr>
+          <a:lstStyle/>
+          <a:p>
+            <a:pPr algn="l">
+              <a:spcAft>
+                <a:spcPts val="400"/>
+              </a:spcAft>
+            </a:pPr>
+            <a:r>
+              <a:rPr sz="2400" b="0">
+                <a:solidFill>
+                  <a:srgbClr val="2D2D2D"/>
+                </a:solidFill>
+                <a:latin typeface="Calibri"/>
+              </a:rPr>
+              <a:t>Query language and ORM live at different layers</a:t>
+            </a:r>
+          </a:p>
+        </p:txBody>
+      </p:sp>
+      <p:sp>
+        <p:nvSpPr>
+          <p:cNvPr id="3" name="Block"/>
+          <p:cNvSpPr/>
+          <p:nvPr/>
+        </p:nvSpPr>
+        <p:spPr>
+          <a:xfrm>
+            <a:off x="914400" y="914400"/>
+            <a:ext cx="4206240" cy="640080"/>
+          </a:xfrm>
+          <a:prstGeom prst="rect">
+            <a:avLst/>
+          </a:prstGeom>
+          <a:solidFill>
+            <a:srgbClr val="8E6F3E"/>
+          </a:solidFill>
+          <a:ln>
+            <a:noFill/>
+          </a:ln>
+          <a:effectLst/>
+        </p:spPr>
+        <p:style>
+          <a:lnRef idx="1">
+            <a:schemeClr val="accent1"/>
+          </a:lnRef>
+          <a:fillRef idx="3">
+            <a:schemeClr val="accent1"/>
+          </a:fillRef>
+          <a:effectRef idx="2">
+            <a:schemeClr val="accent1"/>
+          </a:effectRef>
+          <a:fontRef idx="minor">
+            <a:schemeClr val="lt1"/>
+          </a:fontRef>
+        </p:style>
+        <p:txBody>
+          <a:bodyPr rtlCol="0" anchor="ctr" wrap="square"/>
+          <a:lstStyle/>
+          <a:p>
+            <a:pPr algn="ctr">
+              <a:spcAft>
+                <a:spcPts val="0"/>
+              </a:spcAft>
+            </a:pPr>
+            <a:r>
+              <a:rPr sz="2000" b="1">
+                <a:solidFill>
+                  <a:srgbClr val="FFFFFF"/>
+                </a:solidFill>
+                <a:latin typeface="Calibri"/>
+              </a:rPr>
+              <a:t>Application objects</a:t>
+            </a:r>
+          </a:p>
+        </p:txBody>
+      </p:sp>
+      <p:sp>
+        <p:nvSpPr>
+          <p:cNvPr id="4" name="Arrow"/>
+          <p:cNvSpPr/>
+          <p:nvPr/>
+        </p:nvSpPr>
+        <p:spPr>
+          <a:xfrm>
+            <a:off x="2834640" y="1572768"/>
+            <a:ext cx="365760" cy="192024"/>
+          </a:xfrm>
+          <a:prstGeom prst="downArrow">
+            <a:avLst/>
+          </a:prstGeom>
+          <a:solidFill>
+            <a:srgbClr val="8E6F3E"/>
+          </a:solidFill>
+          <a:ln>
+            <a:noFill/>
+          </a:ln>
+          <a:effectLst/>
+        </p:spPr>
+        <p:style>
+          <a:lnRef idx="1">
+            <a:schemeClr val="accent1"/>
+          </a:lnRef>
+          <a:fillRef idx="3">
+            <a:schemeClr val="accent1"/>
+          </a:fillRef>
+          <a:effectRef idx="2">
+            <a:schemeClr val="accent1"/>
+          </a:effectRef>
+          <a:fontRef idx="minor">
+            <a:schemeClr val="lt1"/>
+          </a:fontRef>
+        </p:style>
+        <p:txBody>
+          <a:bodyPr rtlCol="0" anchor="ctr" wrap="square"/>
+          <a:lstStyle/>
+          <a:p>
+            <a:pPr algn="ctr"/>
+          </a:p>
+        </p:txBody>
+      </p:sp>
+      <p:sp>
+        <p:nvSpPr>
+          <p:cNvPr id="5" name="Block"/>
+          <p:cNvSpPr/>
+          <p:nvPr/>
+        </p:nvSpPr>
+        <p:spPr>
+          <a:xfrm>
+            <a:off x="914400" y="1783080"/>
+            <a:ext cx="4206240" cy="640080"/>
+          </a:xfrm>
+          <a:prstGeom prst="rect">
+            <a:avLst/>
+          </a:prstGeom>
+          <a:solidFill>
+            <a:srgbClr val="8E6F3E"/>
+          </a:solidFill>
+          <a:ln>
+            <a:noFill/>
+          </a:ln>
+          <a:effectLst/>
+        </p:spPr>
+        <p:style>
+          <a:lnRef idx="1">
+            <a:schemeClr val="accent1"/>
+          </a:lnRef>
+          <a:fillRef idx="3">
+            <a:schemeClr val="accent1"/>
+          </a:fillRef>
+          <a:effectRef idx="2">
+            <a:schemeClr val="accent1"/>
+          </a:effectRef>
+          <a:fontRef idx="minor">
+            <a:schemeClr val="lt1"/>
+          </a:fontRef>
+        </p:style>
+        <p:txBody>
+          <a:bodyPr rtlCol="0" anchor="ctr" wrap="square"/>
+          <a:lstStyle/>
+          <a:p>
+            <a:pPr algn="ctr">
+              <a:spcAft>
+                <a:spcPts val="0"/>
+              </a:spcAft>
+            </a:pPr>
+            <a:r>
+              <a:rPr sz="2000" b="1">
+                <a:solidFill>
+                  <a:srgbClr val="FFFFFF"/>
+                </a:solidFill>
+                <a:latin typeface="Calibri"/>
+              </a:rPr>
+              <a:t>ORM — maps objects to rows; emits SQL</a:t>
+            </a:r>
+          </a:p>
+        </p:txBody>
+      </p:sp>
+      <p:sp>
+        <p:nvSpPr>
+          <p:cNvPr id="6" name="Arrow"/>
+          <p:cNvSpPr/>
+          <p:nvPr/>
+        </p:nvSpPr>
+        <p:spPr>
+          <a:xfrm>
+            <a:off x="2834640" y="2441448"/>
+            <a:ext cx="365760" cy="192024"/>
+          </a:xfrm>
+          <a:prstGeom prst="downArrow">
+            <a:avLst/>
+          </a:prstGeom>
+          <a:solidFill>
+            <a:srgbClr val="8E6F3E"/>
+          </a:solidFill>
+          <a:ln>
+            <a:noFill/>
+          </a:ln>
+          <a:effectLst/>
+        </p:spPr>
+        <p:style>
+          <a:lnRef idx="1">
+            <a:schemeClr val="accent1"/>
+          </a:lnRef>
+          <a:fillRef idx="3">
+            <a:schemeClr val="accent1"/>
+          </a:fillRef>
+          <a:effectRef idx="2">
+            <a:schemeClr val="accent1"/>
+          </a:effectRef>
+          <a:fontRef idx="minor">
+            <a:schemeClr val="lt1"/>
+          </a:fontRef>
+        </p:style>
+        <p:txBody>
+          <a:bodyPr rtlCol="0" anchor="ctr" wrap="square"/>
+          <a:lstStyle/>
+          <a:p>
+            <a:pPr algn="ctr"/>
+          </a:p>
+        </p:txBody>
+      </p:sp>
+      <p:sp>
+        <p:nvSpPr>
+          <p:cNvPr id="7" name="Block"/>
+          <p:cNvSpPr/>
+          <p:nvPr/>
+        </p:nvSpPr>
+        <p:spPr>
+          <a:xfrm>
+            <a:off x="914400" y="2651760"/>
+            <a:ext cx="4206240" cy="640080"/>
+          </a:xfrm>
+          <a:prstGeom prst="rect">
+            <a:avLst/>
+          </a:prstGeom>
+          <a:solidFill>
+            <a:srgbClr val="8E6F3E"/>
+          </a:solidFill>
+          <a:ln>
+            <a:noFill/>
+          </a:ln>
+          <a:effectLst/>
+        </p:spPr>
+        <p:style>
+          <a:lnRef idx="1">
+            <a:schemeClr val="accent1"/>
+          </a:lnRef>
+          <a:fillRef idx="3">
+            <a:schemeClr val="accent1"/>
+          </a:fillRef>
+          <a:effectRef idx="2">
+            <a:schemeClr val="accent1"/>
+          </a:effectRef>
+          <a:fontRef idx="minor">
+            <a:schemeClr val="lt1"/>
+          </a:fontRef>
+        </p:style>
+        <p:txBody>
+          <a:bodyPr rtlCol="0" anchor="ctr" wrap="square"/>
+          <a:lstStyle/>
+          <a:p>
+            <a:pPr algn="ctr">
+              <a:spcAft>
+                <a:spcPts val="0"/>
+              </a:spcAft>
+            </a:pPr>
+            <a:r>
+              <a:rPr sz="2000" b="1">
+                <a:solidFill>
+                  <a:srgbClr val="FFFFFF"/>
+                </a:solidFill>
+                <a:latin typeface="Calibri"/>
+              </a:rPr>
+              <a:t>SQL — the declarative WHAT</a:t>
+            </a:r>
+          </a:p>
+        </p:txBody>
+      </p:sp>
+      <p:sp>
+        <p:nvSpPr>
+          <p:cNvPr id="8" name="Arrow"/>
+          <p:cNvSpPr/>
+          <p:nvPr/>
+        </p:nvSpPr>
+        <p:spPr>
+          <a:xfrm>
+            <a:off x="2834640" y="3310128"/>
+            <a:ext cx="365760" cy="192024"/>
+          </a:xfrm>
+          <a:prstGeom prst="downArrow">
+            <a:avLst/>
+          </a:prstGeom>
+          <a:solidFill>
+            <a:srgbClr val="8E6F3E"/>
+          </a:solidFill>
+          <a:ln>
+            <a:noFill/>
+          </a:ln>
+          <a:effectLst/>
+        </p:spPr>
+        <p:style>
+          <a:lnRef idx="1">
+            <a:schemeClr val="accent1"/>
+          </a:lnRef>
+          <a:fillRef idx="3">
+            <a:schemeClr val="accent1"/>
+          </a:fillRef>
+          <a:effectRef idx="2">
+            <a:schemeClr val="accent1"/>
+          </a:effectRef>
+          <a:fontRef idx="minor">
+            <a:schemeClr val="lt1"/>
+          </a:fontRef>
+        </p:style>
+        <p:txBody>
+          <a:bodyPr rtlCol="0" anchor="ctr" wrap="square"/>
+          <a:lstStyle/>
+          <a:p>
+            <a:pPr algn="ctr"/>
+          </a:p>
+        </p:txBody>
+      </p:sp>
+      <p:sp>
+        <p:nvSpPr>
+          <p:cNvPr id="9" name="Block"/>
+          <p:cNvSpPr/>
+          <p:nvPr/>
+        </p:nvSpPr>
+        <p:spPr>
+          <a:xfrm>
+            <a:off x="914400" y="3520440"/>
+            <a:ext cx="4206240" cy="640080"/>
+          </a:xfrm>
+          <a:prstGeom prst="rect">
+            <a:avLst/>
+          </a:prstGeom>
+          <a:solidFill>
+            <a:srgbClr val="8E6F3E"/>
+          </a:solidFill>
+          <a:ln>
+            <a:noFill/>
+          </a:ln>
+          <a:effectLst/>
+        </p:spPr>
+        <p:style>
+          <a:lnRef idx="1">
+            <a:schemeClr val="accent1"/>
+          </a:lnRef>
+          <a:fillRef idx="3">
+            <a:schemeClr val="accent1"/>
+          </a:fillRef>
+          <a:effectRef idx="2">
+            <a:schemeClr val="accent1"/>
+          </a:effectRef>
+          <a:fontRef idx="minor">
+            <a:schemeClr val="lt1"/>
+          </a:fontRef>
+        </p:style>
+        <p:txBody>
+          <a:bodyPr rtlCol="0" anchor="ctr" wrap="square"/>
+          <a:lstStyle/>
+          <a:p>
+            <a:pPr algn="ctr">
+              <a:spcAft>
+                <a:spcPts val="0"/>
+              </a:spcAft>
+            </a:pPr>
+            <a:r>
+              <a:rPr sz="2000" b="1">
+                <a:solidFill>
+                  <a:srgbClr val="FFFFFF"/>
+                </a:solidFill>
+                <a:latin typeface="Calibri"/>
+              </a:rPr>
+              <a:t>Engine — plans and executes (HOW)</a:t>
+            </a:r>
+          </a:p>
+        </p:txBody>
+      </p:sp>
+      <p:sp>
+        <p:nvSpPr>
+          <p:cNvPr id="10" name="Arrow"/>
+          <p:cNvSpPr/>
+          <p:nvPr/>
+        </p:nvSpPr>
+        <p:spPr>
+          <a:xfrm>
+            <a:off x="2834640" y="4178808"/>
+            <a:ext cx="365760" cy="192024"/>
+          </a:xfrm>
+          <a:prstGeom prst="downArrow">
+            <a:avLst/>
+          </a:prstGeom>
+          <a:solidFill>
+            <a:srgbClr val="8E6F3E"/>
+          </a:solidFill>
+          <a:ln>
+            <a:noFill/>
+          </a:ln>
+          <a:effectLst/>
+        </p:spPr>
+        <p:style>
+          <a:lnRef idx="1">
+            <a:schemeClr val="accent1"/>
+          </a:lnRef>
+          <a:fillRef idx="3">
+            <a:schemeClr val="accent1"/>
+          </a:fillRef>
+          <a:effectRef idx="2">
+            <a:schemeClr val="accent1"/>
+          </a:effectRef>
+          <a:fontRef idx="minor">
+            <a:schemeClr val="lt1"/>
+          </a:fontRef>
+        </p:style>
+        <p:txBody>
+          <a:bodyPr rtlCol="0" anchor="ctr" wrap="square"/>
+          <a:lstStyle/>
+          <a:p>
+            <a:pPr algn="ctr"/>
+          </a:p>
+        </p:txBody>
+      </p:sp>
+      <p:sp>
+        <p:nvSpPr>
+          <p:cNvPr id="11" name="Block"/>
+          <p:cNvSpPr/>
+          <p:nvPr/>
+        </p:nvSpPr>
+        <p:spPr>
+          <a:xfrm>
+            <a:off x="914400" y="4389120"/>
+            <a:ext cx="4206240" cy="640080"/>
+          </a:xfrm>
+          <a:prstGeom prst="rect">
+            <a:avLst/>
+          </a:prstGeom>
+          <a:solidFill>
+            <a:srgbClr val="8E6F3E"/>
+          </a:solidFill>
+          <a:ln>
+            <a:noFill/>
+          </a:ln>
+          <a:effectLst/>
+        </p:spPr>
+        <p:style>
+          <a:lnRef idx="1">
+            <a:schemeClr val="accent1"/>
+          </a:lnRef>
+          <a:fillRef idx="3">
+            <a:schemeClr val="accent1"/>
+          </a:fillRef>
+          <a:effectRef idx="2">
+            <a:schemeClr val="accent1"/>
+          </a:effectRef>
+          <a:fontRef idx="minor">
+            <a:schemeClr val="lt1"/>
+          </a:fontRef>
+        </p:style>
+        <p:txBody>
+          <a:bodyPr rtlCol="0" anchor="ctr" wrap="square"/>
+          <a:lstStyle/>
+          <a:p>
+            <a:pPr algn="ctr">
+              <a:spcAft>
+                <a:spcPts val="0"/>
+              </a:spcAft>
+            </a:pPr>
+            <a:r>
+              <a:rPr sz="2000" b="1">
+                <a:solidFill>
+                  <a:srgbClr val="FFFFFF"/>
+                </a:solidFill>
+                <a:latin typeface="Calibri"/>
+              </a:rPr>
+              <a:t>Stored data — pages, rows, indexes</a:t>
+            </a:r>
+          </a:p>
+        </p:txBody>
+      </p:sp>
+      <p:sp>
+        <p:nvSpPr>
+          <p:cNvPr id="12" name="Card"/>
+          <p:cNvSpPr/>
+          <p:nvPr/>
+        </p:nvSpPr>
+        <p:spPr>
+          <a:xfrm>
+            <a:off x="5486400" y="1280160"/>
+            <a:ext cx="3246120" cy="3566160"/>
+          </a:xfrm>
+          <a:prstGeom prst="rect">
+            <a:avLst/>
+          </a:prstGeom>
+          <a:solidFill>
+            <a:srgbClr val="F5F1E8"/>
+          </a:solidFill>
+          <a:ln>
+            <a:noFill/>
+          </a:ln>
+          <a:effectLst/>
+        </p:spPr>
+        <p:style>
+          <a:lnRef idx="1">
+            <a:schemeClr val="accent1"/>
+          </a:lnRef>
+          <a:fillRef idx="3">
+            <a:schemeClr val="accent1"/>
+          </a:fillRef>
+          <a:effectRef idx="2">
+            <a:schemeClr val="accent1"/>
+          </a:effectRef>
+          <a:fontRef idx="minor">
+            <a:schemeClr val="lt1"/>
+          </a:fontRef>
+        </p:style>
+        <p:txBody>
+          <a:bodyPr rtlCol="0" anchor="ctr" wrap="square"/>
+          <a:lstStyle/>
+          <a:p>
+            <a:pPr algn="ctr"/>
+          </a:p>
+        </p:txBody>
+      </p:sp>
+      <p:sp>
+        <p:nvSpPr>
+          <p:cNvPr id="13" name="CardBody"/>
+          <p:cNvSpPr txBox="1"/>
+          <p:nvPr/>
+        </p:nvSpPr>
+        <p:spPr>
+          <a:xfrm>
+            <a:off x="5632704" y="1371600"/>
+            <a:ext cx="2953512" cy="3383280"/>
+          </a:xfrm>
+          <a:prstGeom prst="rect">
+            <a:avLst/>
+          </a:prstGeom>
+          <a:noFill/>
+        </p:spPr>
+        <p:txBody>
+          <a:bodyPr wrap="square">
+            <a:spAutoFit/>
+          </a:bodyPr>
+          <a:lstStyle/>
+          <a:p>
+            <a:pPr algn="l">
+              <a:spcAft>
+                <a:spcPts val="600"/>
+              </a:spcAft>
+            </a:pPr>
+            <a:r>
+              <a:rPr sz="2000" b="1">
+                <a:solidFill>
+                  <a:srgbClr val="5C4826"/>
+                </a:solidFill>
+                <a:latin typeface="Calibri"/>
+              </a:rPr>
+              <a:t>“ORM vs SQL” is a layering question, not a rivalry</a:t>
+            </a:r>
+          </a:p>
+          <a:p>
+            <a:pPr algn="l">
+              <a:spcAft>
+                <a:spcPts val="600"/>
+              </a:spcAft>
+            </a:pPr>
+            <a:r>
+              <a:rPr sz="2000" b="0">
+                <a:solidFill>
+                  <a:srgbClr val="555960"/>
+                </a:solidFill>
+                <a:latin typeface="Calibri"/>
+              </a:rPr>
+              <a:t>The ORM emits SQL; the engine never sees your objects.</a:t>
+            </a:r>
+          </a:p>
+          <a:p>
+            <a:pPr algn="l">
+              <a:spcAft>
+                <a:spcPts val="400"/>
+              </a:spcAft>
+            </a:pPr>
+            <a:r>
+              <a:rPr sz="2000" b="0">
+                <a:solidFill>
+                  <a:srgbClr val="555960"/>
+                </a:solidFill>
+                <a:latin typeface="Calibri"/>
+              </a:rPr>
+              <a:t>You choose the layer where you write your intent — you still own what every layer below does with it.</a:t>
+            </a:r>
+          </a:p>
+        </p:txBody>
+      </p:sp>
+      <p:sp>
+        <p:nvSpPr>
+          <p:cNvPr id="14" name="FooterBand"/>
+          <p:cNvSpPr/>
+          <p:nvPr/>
+        </p:nvSpPr>
+        <p:spPr>
+          <a:xfrm>
+            <a:off x="274320" y="5879592"/>
+            <a:ext cx="8595360" cy="502920"/>
+          </a:xfrm>
+          <a:prstGeom prst="rect">
+            <a:avLst/>
+          </a:prstGeom>
+          <a:solidFill>
+            <a:srgbClr val="8E6F3E"/>
+          </a:solidFill>
+          <a:ln>
+            <a:noFill/>
+          </a:ln>
+          <a:effectLst/>
+        </p:spPr>
+        <p:style>
+          <a:lnRef idx="1">
+            <a:schemeClr val="accent1"/>
+          </a:lnRef>
+          <a:fillRef idx="3">
+            <a:schemeClr val="accent1"/>
+          </a:fillRef>
+          <a:effectRef idx="2">
+            <a:schemeClr val="accent1"/>
+          </a:effectRef>
+          <a:fontRef idx="minor">
+            <a:schemeClr val="lt1"/>
+          </a:fontRef>
+        </p:style>
+        <p:txBody>
+          <a:bodyPr rtlCol="0" anchor="ctr" wrap="square"/>
+          <a:lstStyle/>
+          <a:p>
+            <a:pPr algn="ctr"/>
+          </a:p>
+        </p:txBody>
+      </p:sp>
+      <p:sp>
+        <p:nvSpPr>
+          <p:cNvPr id="15" name="FooterBandText"/>
+          <p:cNvSpPr txBox="1"/>
+          <p:nvPr/>
+        </p:nvSpPr>
+        <p:spPr>
+          <a:xfrm>
+            <a:off x="384048" y="5897880"/>
+            <a:ext cx="8375904" cy="457200"/>
+          </a:xfrm>
+          <a:prstGeom prst="rect">
+            <a:avLst/>
+          </a:prstGeom>
+          <a:noFill/>
+        </p:spPr>
+        <p:txBody>
+          <a:bodyPr wrap="square">
+            <a:spAutoFit/>
+          </a:bodyPr>
+          <a:lstStyle/>
+          <a:p>
+            <a:pPr algn="ctr">
+              <a:spcAft>
+                <a:spcPts val="400"/>
+              </a:spcAft>
+            </a:pPr>
+            <a:r>
+              <a:rPr sz="2000" b="1">
+                <a:solidFill>
+                  <a:srgbClr val="FFFFFF"/>
+                </a:solidFill>
+                <a:latin typeface="Calibri"/>
+              </a:rPr>
+              <a:t>Different layers of one pipeline — not competing answers</a:t>
+            </a:r>
+          </a:p>
+        </p:txBody>
+      </p:sp>
+    </p:spTree>
+  </p:cSld>
+  <p:clrMapOvr>
+    <a:masterClrMapping/>
+  </p:clrMapOvr>
+</p:sld>
+</file>
+
+<file path=ppt/slides/slide16.xml><?xml version="1.0" encoding="utf-8"?>
+<p:sld xmlns:a="http://schemas.openxmlformats.org/drawingml/2006/main" xmlns:p="http://schemas.openxmlformats.org/presentationml/2006/main" xmlns:r="http://schemas.openxmlformats.org/officeDocument/2006/relationships">
+  <p:cSld>
+    <p:spTree>
+      <p:nvGrpSpPr>
+        <p:cNvPr id="1" name=""/>
+        <p:cNvGrpSpPr/>
+        <p:nvPr/>
+      </p:nvGrpSpPr>
+      <p:grpSpPr/>
+      <p:sp>
+        <p:nvSpPr>
+          <p:cNvPr id="2" name="Title"/>
+          <p:cNvSpPr txBox="1"/>
+          <p:nvPr/>
+        </p:nvSpPr>
+        <p:spPr>
+          <a:xfrm>
+            <a:off x="274320" y="128016"/>
+            <a:ext cx="8595360" cy="594360"/>
+          </a:xfrm>
+          <a:prstGeom prst="rect">
+            <a:avLst/>
+          </a:prstGeom>
+          <a:noFill/>
+        </p:spPr>
+        <p:txBody>
+          <a:bodyPr wrap="square">
+            <a:spAutoFit/>
+          </a:bodyPr>
+          <a:lstStyle/>
+          <a:p>
+            <a:pPr algn="l">
+              <a:spcAft>
+                <a:spcPts val="400"/>
+              </a:spcAft>
+            </a:pPr>
+            <a:r>
+              <a:rPr sz="2400" b="0">
+                <a:solidFill>
+                  <a:srgbClr val="2D2D2D"/>
+                </a:solidFill>
+                <a:latin typeface="Calibri"/>
+              </a:rPr>
+              <a:t>How the engine executes your query</a:t>
+            </a:r>
+          </a:p>
+        </p:txBody>
+      </p:sp>
+      <p:sp>
+        <p:nvSpPr>
+          <p:cNvPr id="3" name="Block"/>
+          <p:cNvSpPr/>
+          <p:nvPr/>
+        </p:nvSpPr>
+        <p:spPr>
+          <a:xfrm>
+            <a:off x="411480" y="1097280"/>
+            <a:ext cx="2468880" cy="731520"/>
+          </a:xfrm>
+          <a:prstGeom prst="rect">
+            <a:avLst/>
+          </a:prstGeom>
+          <a:solidFill>
+            <a:srgbClr val="8E6F3E"/>
+          </a:solidFill>
+          <a:ln>
+            <a:noFill/>
+          </a:ln>
+          <a:effectLst/>
+        </p:spPr>
+        <p:style>
+          <a:lnRef idx="1">
+            <a:schemeClr val="accent1"/>
+          </a:lnRef>
+          <a:fillRef idx="3">
+            <a:schemeClr val="accent1"/>
+          </a:fillRef>
+          <a:effectRef idx="2">
+            <a:schemeClr val="accent1"/>
+          </a:effectRef>
+          <a:fontRef idx="minor">
+            <a:schemeClr val="lt1"/>
+          </a:fontRef>
+        </p:style>
+        <p:txBody>
+          <a:bodyPr rtlCol="0" anchor="ctr" wrap="square"/>
+          <a:lstStyle/>
+          <a:p>
+            <a:pPr algn="ctr">
+              <a:spcAft>
+                <a:spcPts val="0"/>
+              </a:spcAft>
+            </a:pPr>
+            <a:r>
+              <a:rPr sz="2000" b="1">
+                <a:solidFill>
+                  <a:srgbClr val="FFFFFF"/>
+                </a:solidFill>
+                <a:latin typeface="Calibri"/>
+              </a:rPr>
+              <a:t>Parse &amp; validate</a:t>
+            </a:r>
+          </a:p>
+        </p:txBody>
+      </p:sp>
+      <p:sp>
+        <p:nvSpPr>
+          <p:cNvPr id="4" name="Block"/>
+          <p:cNvSpPr/>
+          <p:nvPr/>
+        </p:nvSpPr>
+        <p:spPr>
+          <a:xfrm>
+            <a:off x="3337560" y="1097280"/>
+            <a:ext cx="2468880" cy="731520"/>
+          </a:xfrm>
+          <a:prstGeom prst="rect">
+            <a:avLst/>
+          </a:prstGeom>
+          <a:solidFill>
+            <a:srgbClr val="8E6F3E"/>
+          </a:solidFill>
+          <a:ln>
+            <a:noFill/>
+          </a:ln>
+          <a:effectLst/>
+        </p:spPr>
+        <p:style>
+          <a:lnRef idx="1">
+            <a:schemeClr val="accent1"/>
+          </a:lnRef>
+          <a:fillRef idx="3">
+            <a:schemeClr val="accent1"/>
+          </a:fillRef>
+          <a:effectRef idx="2">
+            <a:schemeClr val="accent1"/>
+          </a:effectRef>
+          <a:fontRef idx="minor">
+            <a:schemeClr val="lt1"/>
+          </a:fontRef>
+        </p:style>
+        <p:txBody>
+          <a:bodyPr rtlCol="0" anchor="ctr" wrap="square"/>
+          <a:lstStyle/>
+          <a:p>
+            <a:pPr algn="ctr">
+              <a:spcAft>
+                <a:spcPts val="0"/>
+              </a:spcAft>
+            </a:pPr>
+            <a:r>
+              <a:rPr sz="2000" b="1">
+                <a:solidFill>
+                  <a:srgbClr val="FFFFFF"/>
+                </a:solidFill>
+                <a:latin typeface="Calibri"/>
+              </a:rPr>
+              <a:t>Logical plan</a:t>
+            </a:r>
+          </a:p>
+        </p:txBody>
+      </p:sp>
+      <p:sp>
+        <p:nvSpPr>
+          <p:cNvPr id="5" name="Block"/>
+          <p:cNvSpPr/>
+          <p:nvPr/>
+        </p:nvSpPr>
+        <p:spPr>
+          <a:xfrm>
+            <a:off x="6263640" y="1097280"/>
+            <a:ext cx="2468880" cy="731520"/>
+          </a:xfrm>
+          <a:prstGeom prst="rect">
+            <a:avLst/>
+          </a:prstGeom>
+          <a:solidFill>
+            <a:srgbClr val="8E6F3E"/>
+          </a:solidFill>
+          <a:ln>
+            <a:noFill/>
+          </a:ln>
+          <a:effectLst/>
+        </p:spPr>
+        <p:style>
+          <a:lnRef idx="1">
+            <a:schemeClr val="accent1"/>
+          </a:lnRef>
+          <a:fillRef idx="3">
+            <a:schemeClr val="accent1"/>
+          </a:fillRef>
+          <a:effectRef idx="2">
+            <a:schemeClr val="accent1"/>
+          </a:effectRef>
+          <a:fontRef idx="minor">
+            <a:schemeClr val="lt1"/>
+          </a:fontRef>
+        </p:style>
+        <p:txBody>
+          <a:bodyPr rtlCol="0" anchor="ctr" wrap="square"/>
+          <a:lstStyle/>
+          <a:p>
+            <a:pPr algn="ctr">
+              <a:spcAft>
+                <a:spcPts val="0"/>
+              </a:spcAft>
+            </a:pPr>
+            <a:r>
+              <a:rPr sz="2000" b="1">
+                <a:solidFill>
+                  <a:srgbClr val="FFFFFF"/>
+                </a:solidFill>
+                <a:latin typeface="Calibri"/>
+              </a:rPr>
+              <a:t>Optimizer</a:t>
+            </a:r>
+          </a:p>
+        </p:txBody>
+      </p:sp>
+      <p:sp>
+        <p:nvSpPr>
+          <p:cNvPr id="6" name="Arrow"/>
+          <p:cNvSpPr/>
+          <p:nvPr/>
+        </p:nvSpPr>
+        <p:spPr>
+          <a:xfrm>
+            <a:off x="2907792" y="1371600"/>
+            <a:ext cx="402336" cy="201168"/>
+          </a:xfrm>
+          <a:prstGeom prst="rightArrow">
+            <a:avLst/>
+          </a:prstGeom>
+          <a:solidFill>
+            <a:srgbClr val="8E6F3E"/>
+          </a:solidFill>
+          <a:ln>
+            <a:noFill/>
+          </a:ln>
+          <a:effectLst/>
+        </p:spPr>
+        <p:style>
+          <a:lnRef idx="1">
+            <a:schemeClr val="accent1"/>
+          </a:lnRef>
+          <a:fillRef idx="3">
+            <a:schemeClr val="accent1"/>
+          </a:fillRef>
+          <a:effectRef idx="2">
+            <a:schemeClr val="accent1"/>
+          </a:effectRef>
+          <a:fontRef idx="minor">
+            <a:schemeClr val="lt1"/>
+          </a:fontRef>
+        </p:style>
+        <p:txBody>
+          <a:bodyPr rtlCol="0" anchor="ctr" wrap="square"/>
+          <a:lstStyle/>
+          <a:p>
+            <a:pPr algn="ctr"/>
+          </a:p>
+        </p:txBody>
+      </p:sp>
+      <p:sp>
+        <p:nvSpPr>
+          <p:cNvPr id="7" name="Arrow"/>
+          <p:cNvSpPr/>
+          <p:nvPr/>
+        </p:nvSpPr>
+        <p:spPr>
+          <a:xfrm>
+            <a:off x="5833872" y="1371600"/>
+            <a:ext cx="402336" cy="201168"/>
+          </a:xfrm>
+          <a:prstGeom prst="rightArrow">
+            <a:avLst/>
+          </a:prstGeom>
+          <a:solidFill>
+            <a:srgbClr val="8E6F3E"/>
+          </a:solidFill>
+          <a:ln>
+            <a:noFill/>
+          </a:ln>
+          <a:effectLst/>
+        </p:spPr>
+        <p:style>
+          <a:lnRef idx="1">
+            <a:schemeClr val="accent1"/>
+          </a:lnRef>
+          <a:fillRef idx="3">
+            <a:schemeClr val="accent1"/>
+          </a:fillRef>
+          <a:effectRef idx="2">
+            <a:schemeClr val="accent1"/>
+          </a:effectRef>
+          <a:fontRef idx="minor">
+            <a:schemeClr val="lt1"/>
+          </a:fontRef>
+        </p:style>
+        <p:txBody>
+          <a:bodyPr rtlCol="0" anchor="ctr" wrap="square"/>
+          <a:lstStyle/>
+          <a:p>
+            <a:pPr algn="ctr"/>
+          </a:p>
+        </p:txBody>
+      </p:sp>
+      <p:sp>
+        <p:nvSpPr>
+          <p:cNvPr id="8" name="Arrow"/>
+          <p:cNvSpPr/>
+          <p:nvPr/>
+        </p:nvSpPr>
+        <p:spPr>
+          <a:xfrm>
+            <a:off x="7315200" y="1901952"/>
+            <a:ext cx="365760" cy="676656"/>
+          </a:xfrm>
+          <a:prstGeom prst="downArrow">
+            <a:avLst/>
+          </a:prstGeom>
+          <a:solidFill>
+            <a:srgbClr val="8E6F3E"/>
+          </a:solidFill>
+          <a:ln>
+            <a:noFill/>
+          </a:ln>
+          <a:effectLst/>
+        </p:spPr>
+        <p:style>
+          <a:lnRef idx="1">
+            <a:schemeClr val="accent1"/>
+          </a:lnRef>
+          <a:fillRef idx="3">
+            <a:schemeClr val="accent1"/>
+          </a:fillRef>
+          <a:effectRef idx="2">
+            <a:schemeClr val="accent1"/>
+          </a:effectRef>
+          <a:fontRef idx="minor">
+            <a:schemeClr val="lt1"/>
+          </a:fontRef>
+        </p:style>
+        <p:txBody>
+          <a:bodyPr rtlCol="0" anchor="ctr" wrap="square"/>
+          <a:lstStyle/>
+          <a:p>
+            <a:pPr algn="ctr"/>
+          </a:p>
+        </p:txBody>
+      </p:sp>
+      <p:sp>
+        <p:nvSpPr>
+          <p:cNvPr id="9" name="Block"/>
+          <p:cNvSpPr/>
+          <p:nvPr/>
+        </p:nvSpPr>
+        <p:spPr>
+          <a:xfrm>
+            <a:off x="6263640" y="2651760"/>
+            <a:ext cx="2468880" cy="731520"/>
+          </a:xfrm>
+          <a:prstGeom prst="rect">
+            <a:avLst/>
+          </a:prstGeom>
+          <a:solidFill>
+            <a:srgbClr val="8E6F3E"/>
+          </a:solidFill>
+          <a:ln>
+            <a:noFill/>
+          </a:ln>
+          <a:effectLst/>
+        </p:spPr>
+        <p:style>
+          <a:lnRef idx="1">
+            <a:schemeClr val="accent1"/>
+          </a:lnRef>
+          <a:fillRef idx="3">
+            <a:schemeClr val="accent1"/>
+          </a:fillRef>
+          <a:effectRef idx="2">
+            <a:schemeClr val="accent1"/>
+          </a:effectRef>
+          <a:fontRef idx="minor">
+            <a:schemeClr val="lt1"/>
+          </a:fontRef>
+        </p:style>
+        <p:txBody>
+          <a:bodyPr rtlCol="0" anchor="ctr" wrap="square"/>
+          <a:lstStyle/>
+          <a:p>
+            <a:pPr algn="ctr">
+              <a:spcAft>
+                <a:spcPts val="0"/>
+              </a:spcAft>
+            </a:pPr>
+            <a:r>
+              <a:rPr sz="2000" b="1">
+                <a:solidFill>
+                  <a:srgbClr val="FFFFFF"/>
+                </a:solidFill>
+                <a:latin typeface="Calibri"/>
+              </a:rPr>
+              <a:t>Physical plan</a:t>
+            </a:r>
+          </a:p>
+        </p:txBody>
+      </p:sp>
+      <p:sp>
+        <p:nvSpPr>
+          <p:cNvPr id="10" name="Block"/>
+          <p:cNvSpPr/>
+          <p:nvPr/>
+        </p:nvSpPr>
+        <p:spPr>
+          <a:xfrm>
+            <a:off x="3337560" y="2651760"/>
+            <a:ext cx="2468880" cy="731520"/>
+          </a:xfrm>
+          <a:prstGeom prst="rect">
+            <a:avLst/>
+          </a:prstGeom>
+          <a:solidFill>
+            <a:srgbClr val="8E6F3E"/>
+          </a:solidFill>
+          <a:ln>
+            <a:noFill/>
+          </a:ln>
+          <a:effectLst/>
+        </p:spPr>
+        <p:style>
+          <a:lnRef idx="1">
+            <a:schemeClr val="accent1"/>
+          </a:lnRef>
+          <a:fillRef idx="3">
+            <a:schemeClr val="accent1"/>
+          </a:fillRef>
+          <a:effectRef idx="2">
+            <a:schemeClr val="accent1"/>
+          </a:effectRef>
+          <a:fontRef idx="minor">
+            <a:schemeClr val="lt1"/>
+          </a:fontRef>
+        </p:style>
+        <p:txBody>
+          <a:bodyPr rtlCol="0" anchor="ctr" wrap="square"/>
+          <a:lstStyle/>
+          <a:p>
+            <a:pPr algn="ctr">
+              <a:spcAft>
+                <a:spcPts val="0"/>
+              </a:spcAft>
+            </a:pPr>
+            <a:r>
+              <a:rPr sz="2000" b="1">
+                <a:solidFill>
+                  <a:srgbClr val="FFFFFF"/>
+                </a:solidFill>
+                <a:latin typeface="Calibri"/>
+              </a:rPr>
+              <a:t>Execute: scan · index · join</a:t>
+            </a:r>
+          </a:p>
+        </p:txBody>
+      </p:sp>
+      <p:sp>
+        <p:nvSpPr>
+          <p:cNvPr id="11" name="Block"/>
+          <p:cNvSpPr/>
+          <p:nvPr/>
+        </p:nvSpPr>
+        <p:spPr>
+          <a:xfrm>
+            <a:off x="411480" y="2651760"/>
+            <a:ext cx="2468880" cy="731520"/>
+          </a:xfrm>
+          <a:prstGeom prst="rect">
+            <a:avLst/>
+          </a:prstGeom>
+          <a:solidFill>
+            <a:srgbClr val="8E6F3E"/>
+          </a:solidFill>
+          <a:ln>
+            <a:noFill/>
+          </a:ln>
+          <a:effectLst/>
+        </p:spPr>
+        <p:style>
+          <a:lnRef idx="1">
+            <a:schemeClr val="accent1"/>
+          </a:lnRef>
+          <a:fillRef idx="3">
+            <a:schemeClr val="accent1"/>
+          </a:fillRef>
+          <a:effectRef idx="2">
+            <a:schemeClr val="accent1"/>
+          </a:effectRef>
+          <a:fontRef idx="minor">
+            <a:schemeClr val="lt1"/>
+          </a:fontRef>
+        </p:style>
+        <p:txBody>
+          <a:bodyPr rtlCol="0" anchor="ctr" wrap="square"/>
+          <a:lstStyle/>
+          <a:p>
+            <a:pPr algn="ctr">
+              <a:spcAft>
+                <a:spcPts val="0"/>
+              </a:spcAft>
+            </a:pPr>
+            <a:r>
+              <a:rPr sz="2000" b="1">
+                <a:solidFill>
+                  <a:srgbClr val="FFFFFF"/>
+                </a:solidFill>
+                <a:latin typeface="Calibri"/>
+              </a:rPr>
+              <a:t>Results</a:t>
+            </a:r>
+          </a:p>
+        </p:txBody>
+      </p:sp>
+      <p:sp>
+        <p:nvSpPr>
+          <p:cNvPr id="12" name="Arrow"/>
+          <p:cNvSpPr/>
+          <p:nvPr/>
+        </p:nvSpPr>
+        <p:spPr>
+          <a:xfrm>
+            <a:off x="5833872" y="2926080"/>
+            <a:ext cx="402336" cy="201168"/>
+          </a:xfrm>
+          <a:prstGeom prst="leftArrow">
+            <a:avLst/>
+          </a:prstGeom>
+          <a:solidFill>
+            <a:srgbClr val="8E6F3E"/>
+          </a:solidFill>
+          <a:ln>
+            <a:noFill/>
+          </a:ln>
+          <a:effectLst/>
+        </p:spPr>
+        <p:style>
+          <a:lnRef idx="1">
+            <a:schemeClr val="accent1"/>
+          </a:lnRef>
+          <a:fillRef idx="3">
+            <a:schemeClr val="accent1"/>
+          </a:fillRef>
+          <a:effectRef idx="2">
+            <a:schemeClr val="accent1"/>
+          </a:effectRef>
+          <a:fontRef idx="minor">
+            <a:schemeClr val="lt1"/>
+          </a:fontRef>
+        </p:style>
+        <p:txBody>
+          <a:bodyPr rtlCol="0" anchor="ctr" wrap="square"/>
+          <a:lstStyle/>
+          <a:p>
+            <a:pPr algn="ctr"/>
+          </a:p>
+        </p:txBody>
+      </p:sp>
+      <p:sp>
+        <p:nvSpPr>
+          <p:cNvPr id="13" name="Arrow"/>
+          <p:cNvSpPr/>
+          <p:nvPr/>
+        </p:nvSpPr>
+        <p:spPr>
+          <a:xfrm>
+            <a:off x="2907792" y="2926080"/>
+            <a:ext cx="402336" cy="201168"/>
+          </a:xfrm>
+          <a:prstGeom prst="leftArrow">
+            <a:avLst/>
+          </a:prstGeom>
+          <a:solidFill>
+            <a:srgbClr val="8E6F3E"/>
+          </a:solidFill>
+          <a:ln>
+            <a:noFill/>
+          </a:ln>
+          <a:effectLst/>
+        </p:spPr>
+        <p:style>
+          <a:lnRef idx="1">
+            <a:schemeClr val="accent1"/>
+          </a:lnRef>
+          <a:fillRef idx="3">
+            <a:schemeClr val="accent1"/>
+          </a:fillRef>
+          <a:effectRef idx="2">
+            <a:schemeClr val="accent1"/>
+          </a:effectRef>
+          <a:fontRef idx="minor">
+            <a:schemeClr val="lt1"/>
+          </a:fontRef>
+        </p:style>
+        <p:txBody>
+          <a:bodyPr rtlCol="0" anchor="ctr" wrap="square"/>
+          <a:lstStyle/>
+          <a:p>
+            <a:pPr algn="ctr"/>
+          </a:p>
+        </p:txBody>
+      </p:sp>
+      <p:sp>
+        <p:nvSpPr>
+          <p:cNvPr id="14" name="Card"/>
+          <p:cNvSpPr/>
+          <p:nvPr/>
+        </p:nvSpPr>
+        <p:spPr>
+          <a:xfrm>
+            <a:off x="411480" y="3794760"/>
+            <a:ext cx="8321040" cy="1325880"/>
+          </a:xfrm>
+          <a:prstGeom prst="rect">
+            <a:avLst/>
+          </a:prstGeom>
+          <a:solidFill>
+            <a:srgbClr val="F5F1E8"/>
+          </a:solidFill>
+          <a:ln>
+            <a:noFill/>
+          </a:ln>
+          <a:effectLst/>
+        </p:spPr>
+        <p:style>
+          <a:lnRef idx="1">
+            <a:schemeClr val="accent1"/>
+          </a:lnRef>
+          <a:fillRef idx="3">
+            <a:schemeClr val="accent1"/>
+          </a:fillRef>
+          <a:effectRef idx="2">
+            <a:schemeClr val="accent1"/>
+          </a:effectRef>
+          <a:fontRef idx="minor">
+            <a:schemeClr val="lt1"/>
+          </a:fontRef>
+        </p:style>
+        <p:txBody>
+          <a:bodyPr rtlCol="0" anchor="ctr" wrap="square"/>
+          <a:lstStyle/>
+          <a:p>
+            <a:pPr algn="ctr"/>
+          </a:p>
+        </p:txBody>
+      </p:sp>
+      <p:sp>
+        <p:nvSpPr>
+          <p:cNvPr id="15" name="CardBody"/>
+          <p:cNvSpPr txBox="1"/>
+          <p:nvPr/>
+        </p:nvSpPr>
+        <p:spPr>
+          <a:xfrm>
+            <a:off x="557784" y="3867912"/>
+            <a:ext cx="8046720" cy="1188720"/>
+          </a:xfrm>
+          <a:prstGeom prst="rect">
+            <a:avLst/>
+          </a:prstGeom>
+          <a:noFill/>
+        </p:spPr>
+        <p:txBody>
+          <a:bodyPr wrap="square">
+            <a:spAutoFit/>
+          </a:bodyPr>
+          <a:lstStyle/>
+          <a:p>
+            <a:pPr algn="l">
+              <a:spcAft>
+                <a:spcPts val="300"/>
+              </a:spcAft>
+            </a:pPr>
+            <a:r>
+              <a:rPr sz="2000" b="1">
+                <a:solidFill>
+                  <a:srgbClr val="5C4826"/>
+                </a:solidFill>
+                <a:latin typeface="Calibri"/>
+              </a:rPr>
+              <a:t>The optimizer chooses among plans using statistics about YOUR data</a:t>
+            </a:r>
+          </a:p>
+          <a:p>
+            <a:pPr algn="l">
+              <a:spcAft>
+                <a:spcPts val="400"/>
+              </a:spcAft>
+            </a:pPr>
+            <a:r>
+              <a:rPr sz="2000" b="0">
+                <a:solidFill>
+                  <a:srgbClr val="555960"/>
+                </a:solidFill>
+                <a:latin typeface="Calibri"/>
+              </a:rPr>
+              <a:t>Same SQL, thousandfold cost differences — the lever is the physical design you supply: indexes, layout, fresh statistics.</a:t>
+            </a:r>
+          </a:p>
+        </p:txBody>
+      </p:sp>
+      <p:sp>
+        <p:nvSpPr>
+          <p:cNvPr id="16" name="FooterBand"/>
+          <p:cNvSpPr/>
+          <p:nvPr/>
+        </p:nvSpPr>
+        <p:spPr>
+          <a:xfrm>
+            <a:off x="274320" y="5879592"/>
+            <a:ext cx="8595360" cy="502920"/>
+          </a:xfrm>
+          <a:prstGeom prst="rect">
+            <a:avLst/>
+          </a:prstGeom>
+          <a:solidFill>
+            <a:srgbClr val="8E6F3E"/>
+          </a:solidFill>
+          <a:ln>
+            <a:noFill/>
+          </a:ln>
+          <a:effectLst/>
+        </p:spPr>
+        <p:style>
+          <a:lnRef idx="1">
+            <a:schemeClr val="accent1"/>
+          </a:lnRef>
+          <a:fillRef idx="3">
+            <a:schemeClr val="accent1"/>
+          </a:fillRef>
+          <a:effectRef idx="2">
+            <a:schemeClr val="accent1"/>
+          </a:effectRef>
+          <a:fontRef idx="minor">
+            <a:schemeClr val="lt1"/>
+          </a:fontRef>
+        </p:style>
+        <p:txBody>
+          <a:bodyPr rtlCol="0" anchor="ctr" wrap="square"/>
+          <a:lstStyle/>
+          <a:p>
+            <a:pPr algn="ctr"/>
+          </a:p>
+        </p:txBody>
+      </p:sp>
+      <p:sp>
+        <p:nvSpPr>
+          <p:cNvPr id="17" name="FooterBandText"/>
+          <p:cNvSpPr txBox="1"/>
+          <p:nvPr/>
+        </p:nvSpPr>
+        <p:spPr>
+          <a:xfrm>
+            <a:off x="384048" y="5897880"/>
+            <a:ext cx="8375904" cy="457200"/>
+          </a:xfrm>
+          <a:prstGeom prst="rect">
+            <a:avLst/>
+          </a:prstGeom>
+          <a:noFill/>
+        </p:spPr>
+        <p:txBody>
+          <a:bodyPr wrap="square">
+            <a:spAutoFit/>
+          </a:bodyPr>
+          <a:lstStyle/>
+          <a:p>
+            <a:pPr algn="ctr">
+              <a:spcAft>
+                <a:spcPts val="400"/>
+              </a:spcAft>
+            </a:pPr>
+            <a:r>
+              <a:rPr sz="2000" b="1">
+                <a:solidFill>
+                  <a:srgbClr val="FFFFFF"/>
+                </a:solidFill>
+                <a:latin typeface="Calibri"/>
+              </a:rPr>
+              <a:t>You wrote WHAT; the engine picks HOW from what you gave it</a:t>
+            </a:r>
+          </a:p>
+        </p:txBody>
+      </p:sp>
+    </p:spTree>
+  </p:cSld>
+  <p:clrMapOvr>
+    <a:masterClrMapping/>
+  </p:clrMapOvr>
+</p:sld>
+</file>
+
+<file path=ppt/slides/slide17.xml><?xml version="1.0" encoding="utf-8"?>
+<p:sld xmlns:a="http://schemas.openxmlformats.org/drawingml/2006/main" xmlns:p="http://schemas.openxmlformats.org/presentationml/2006/main" xmlns:r="http://schemas.openxmlformats.org/officeDocument/2006/relationships">
+  <p:cSld>
+    <p:spTree>
+      <p:nvGrpSpPr>
+        <p:cNvPr id="1" name=""/>
+        <p:cNvGrpSpPr/>
+        <p:nvPr/>
+      </p:nvGrpSpPr>
+      <p:grpSpPr/>
+      <p:sp>
+        <p:nvSpPr>
+          <p:cNvPr id="2" name="Title"/>
+          <p:cNvSpPr txBox="1"/>
+          <p:nvPr/>
+        </p:nvSpPr>
+        <p:spPr>
+          <a:xfrm>
+            <a:off x="274320" y="128016"/>
+            <a:ext cx="8595360" cy="594360"/>
+          </a:xfrm>
+          <a:prstGeom prst="rect">
+            <a:avLst/>
+          </a:prstGeom>
+          <a:noFill/>
+        </p:spPr>
+        <p:txBody>
+          <a:bodyPr wrap="square">
+            <a:spAutoFit/>
+          </a:bodyPr>
+          <a:lstStyle/>
+          <a:p>
+            <a:pPr algn="l">
+              <a:spcAft>
+                <a:spcPts val="400"/>
+              </a:spcAft>
+            </a:pPr>
+            <a:r>
+              <a:rPr sz="2400" b="0">
+                <a:solidFill>
+                  <a:srgbClr val="2D2D2D"/>
+                </a:solidFill>
+                <a:latin typeface="Calibri"/>
+              </a:rPr>
+              <a:t>One query, two plans, very different costs</a:t>
+            </a:r>
+          </a:p>
+        </p:txBody>
+      </p:sp>
+      <p:sp>
+        <p:nvSpPr>
+          <p:cNvPr id="3" name="Card"/>
+          <p:cNvSpPr/>
+          <p:nvPr/>
+        </p:nvSpPr>
+        <p:spPr>
+          <a:xfrm>
+            <a:off x="411480" y="960120"/>
+            <a:ext cx="4069080" cy="2560320"/>
+          </a:xfrm>
+          <a:prstGeom prst="rect">
+            <a:avLst/>
+          </a:prstGeom>
+          <a:solidFill>
+            <a:srgbClr val="FCFAF6"/>
+          </a:solidFill>
+          <a:ln>
+            <a:noFill/>
+          </a:ln>
+          <a:effectLst/>
+        </p:spPr>
+        <p:style>
+          <a:lnRef idx="1">
+            <a:schemeClr val="accent1"/>
+          </a:lnRef>
+          <a:fillRef idx="3">
+            <a:schemeClr val="accent1"/>
+          </a:fillRef>
+          <a:effectRef idx="2">
+            <a:schemeClr val="accent1"/>
+          </a:effectRef>
+          <a:fontRef idx="minor">
+            <a:schemeClr val="lt1"/>
+          </a:fontRef>
+        </p:style>
+        <p:txBody>
+          <a:bodyPr rtlCol="0" anchor="ctr" wrap="square"/>
+          <a:lstStyle/>
+          <a:p>
+            <a:pPr algn="ctr"/>
+          </a:p>
+        </p:txBody>
+      </p:sp>
+      <p:sp>
+        <p:nvSpPr>
+          <p:cNvPr id="4" name="CardBody"/>
+          <p:cNvSpPr txBox="1"/>
+          <p:nvPr/>
+        </p:nvSpPr>
+        <p:spPr>
+          <a:xfrm>
+            <a:off x="557784" y="1051560"/>
+            <a:ext cx="3776472" cy="2377440"/>
+          </a:xfrm>
+          <a:prstGeom prst="rect">
+            <a:avLst/>
+          </a:prstGeom>
+          <a:noFill/>
+        </p:spPr>
+        <p:txBody>
+          <a:bodyPr wrap="square">
+            <a:spAutoFit/>
+          </a:bodyPr>
+          <a:lstStyle/>
+          <a:p>
+            <a:pPr algn="l">
+              <a:spcAft>
+                <a:spcPts val="500"/>
+              </a:spcAft>
+            </a:pPr>
+            <a:r>
+              <a:rPr sz="2000" b="1">
+                <a:solidFill>
+                  <a:srgbClr val="8E6F3E"/>
+                </a:solidFill>
+                <a:latin typeface="Calibri"/>
+              </a:rPr>
+              <a:t>SEQUENTIAL SCAN</a:t>
+            </a:r>
+          </a:p>
+          <a:p>
+            <a:pPr algn="l">
+              <a:spcAft>
+                <a:spcPts val="400"/>
+              </a:spcAft>
+            </a:pPr>
+            <a:r>
+              <a:rPr sz="2000" b="1">
+                <a:solidFill>
+                  <a:srgbClr val="5C4826"/>
+                </a:solidFill>
+                <a:latin typeface="Calibri"/>
+              </a:rPr>
+              <a:t>Read all 2,000,000 rows, test each</a:t>
+            </a:r>
+          </a:p>
+          <a:p>
+            <a:pPr algn="l">
+              <a:spcAft>
+                <a:spcPts val="400"/>
+              </a:spcAft>
+            </a:pPr>
+            <a:r>
+              <a:rPr sz="2000" b="0">
+                <a:solidFill>
+                  <a:srgbClr val="555960"/>
+                </a:solidFill>
+                <a:latin typeface="Calibri"/>
+              </a:rPr>
+              <a:t>Cost grows with the table, not with the answer</a:t>
+            </a:r>
+          </a:p>
+          <a:p>
+            <a:pPr algn="l">
+              <a:spcAft>
+                <a:spcPts val="400"/>
+              </a:spcAft>
+            </a:pPr>
+            <a:r>
+              <a:rPr sz="2000" b="0">
+                <a:solidFill>
+                  <a:srgbClr val="555960"/>
+                </a:solidFill>
+                <a:latin typeface="Calibri"/>
+              </a:rPr>
+              <a:t>~ seconds</a:t>
+            </a:r>
+          </a:p>
+        </p:txBody>
+      </p:sp>
+      <p:sp>
+        <p:nvSpPr>
+          <p:cNvPr id="5" name="Card"/>
+          <p:cNvSpPr/>
+          <p:nvPr/>
+        </p:nvSpPr>
+        <p:spPr>
+          <a:xfrm>
+            <a:off x="4663440" y="960120"/>
+            <a:ext cx="4069080" cy="2560320"/>
+          </a:xfrm>
+          <a:prstGeom prst="rect">
+            <a:avLst/>
+          </a:prstGeom>
+          <a:solidFill>
+            <a:srgbClr val="FCFAF6"/>
+          </a:solidFill>
+          <a:ln>
+            <a:noFill/>
+          </a:ln>
+          <a:effectLst/>
+        </p:spPr>
+        <p:style>
+          <a:lnRef idx="1">
+            <a:schemeClr val="accent1"/>
+          </a:lnRef>
+          <a:fillRef idx="3">
+            <a:schemeClr val="accent1"/>
+          </a:fillRef>
+          <a:effectRef idx="2">
+            <a:schemeClr val="accent1"/>
+          </a:effectRef>
+          <a:fontRef idx="minor">
+            <a:schemeClr val="lt1"/>
+          </a:fontRef>
+        </p:style>
+        <p:txBody>
+          <a:bodyPr rtlCol="0" anchor="ctr" wrap="square"/>
+          <a:lstStyle/>
+          <a:p>
+            <a:pPr algn="ctr"/>
+          </a:p>
+        </p:txBody>
+      </p:sp>
+      <p:sp>
+        <p:nvSpPr>
+          <p:cNvPr id="6" name="CardBody"/>
+          <p:cNvSpPr txBox="1"/>
+          <p:nvPr/>
+        </p:nvSpPr>
+        <p:spPr>
+          <a:xfrm>
+            <a:off x="4809744" y="1051560"/>
+            <a:ext cx="3776472" cy="2377440"/>
+          </a:xfrm>
+          <a:prstGeom prst="rect">
+            <a:avLst/>
+          </a:prstGeom>
+          <a:noFill/>
+        </p:spPr>
+        <p:txBody>
+          <a:bodyPr wrap="square">
+            <a:spAutoFit/>
+          </a:bodyPr>
+          <a:lstStyle/>
+          <a:p>
+            <a:pPr algn="l">
+              <a:spcAft>
+                <a:spcPts val="500"/>
+              </a:spcAft>
+            </a:pPr>
+            <a:r>
+              <a:rPr sz="2000" b="1">
+                <a:solidFill>
+                  <a:srgbClr val="8E6F3E"/>
+                </a:solidFill>
+                <a:latin typeface="Calibri"/>
+              </a:rPr>
+              <a:t>INDEX RANGE SCAN</a:t>
+            </a:r>
+          </a:p>
+          <a:p>
+            <a:pPr algn="l">
+              <a:spcAft>
+                <a:spcPts val="400"/>
+              </a:spcAft>
+            </a:pPr>
+            <a:r>
+              <a:rPr sz="2000" b="1">
+                <a:solidFill>
+                  <a:srgbClr val="5C4826"/>
+                </a:solidFill>
+                <a:latin typeface="Calibri"/>
+              </a:rPr>
+              <a:t>Index on (room_id, starts_at)</a:t>
+            </a:r>
+          </a:p>
+          <a:p>
+            <a:pPr algn="l">
+              <a:spcAft>
+                <a:spcPts val="400"/>
+              </a:spcAft>
+            </a:pPr>
+            <a:r>
+              <a:rPr sz="2000" b="0">
+                <a:solidFill>
+                  <a:srgbClr val="555960"/>
+                </a:solidFill>
+                <a:latin typeface="Calibri"/>
+              </a:rPr>
+              <a:t>Jump to this room's time window: ~12 rows touched</a:t>
+            </a:r>
+          </a:p>
+          <a:p>
+            <a:pPr algn="l">
+              <a:spcAft>
+                <a:spcPts val="400"/>
+              </a:spcAft>
+            </a:pPr>
+            <a:r>
+              <a:rPr sz="2000" b="0">
+                <a:solidFill>
+                  <a:srgbClr val="555960"/>
+                </a:solidFill>
+                <a:latin typeface="Calibri"/>
+              </a:rPr>
+              <a:t>~ milliseconds</a:t>
+            </a:r>
+          </a:p>
+        </p:txBody>
+      </p:sp>
+      <p:sp>
+        <p:nvSpPr>
+          <p:cNvPr id="7" name="Card"/>
+          <p:cNvSpPr/>
+          <p:nvPr/>
+        </p:nvSpPr>
+        <p:spPr>
+          <a:xfrm>
+            <a:off x="411480" y="3749039"/>
+            <a:ext cx="8321040" cy="1371600"/>
+          </a:xfrm>
+          <a:prstGeom prst="rect">
+            <a:avLst/>
+          </a:prstGeom>
+          <a:solidFill>
+            <a:srgbClr val="F5F1E8"/>
+          </a:solidFill>
+          <a:ln>
+            <a:noFill/>
+          </a:ln>
+          <a:effectLst/>
+        </p:spPr>
+        <p:style>
+          <a:lnRef idx="1">
+            <a:schemeClr val="accent1"/>
+          </a:lnRef>
+          <a:fillRef idx="3">
+            <a:schemeClr val="accent1"/>
+          </a:fillRef>
+          <a:effectRef idx="2">
+            <a:schemeClr val="accent1"/>
+          </a:effectRef>
+          <a:fontRef idx="minor">
+            <a:schemeClr val="lt1"/>
+          </a:fontRef>
+        </p:style>
+        <p:txBody>
+          <a:bodyPr rtlCol="0" anchor="ctr" wrap="square"/>
+          <a:lstStyle/>
+          <a:p>
+            <a:pPr algn="ctr"/>
+          </a:p>
+        </p:txBody>
+      </p:sp>
+      <p:sp>
+        <p:nvSpPr>
+          <p:cNvPr id="8" name="CardBody"/>
+          <p:cNvSpPr txBox="1"/>
+          <p:nvPr/>
+        </p:nvSpPr>
+        <p:spPr>
+          <a:xfrm>
+            <a:off x="557784" y="3822191"/>
+            <a:ext cx="8046720" cy="1234440"/>
+          </a:xfrm>
+          <a:prstGeom prst="rect">
+            <a:avLst/>
+          </a:prstGeom>
+          <a:noFill/>
+        </p:spPr>
+        <p:txBody>
+          <a:bodyPr wrap="square">
+            <a:spAutoFit/>
+          </a:bodyPr>
+          <a:lstStyle/>
+          <a:p>
+            <a:pPr algn="l">
+              <a:spcAft>
+                <a:spcPts val="300"/>
+              </a:spcAft>
+            </a:pPr>
+            <a:r>
+              <a:rPr sz="2000" b="1">
+                <a:solidFill>
+                  <a:srgbClr val="5C4826"/>
+                </a:solidFill>
+                <a:latin typeface="Calibri"/>
+              </a:rPr>
+              <a:t>Same query text — the index changed the plan</a:t>
+            </a:r>
+          </a:p>
+          <a:p>
+            <a:pPr algn="l">
+              <a:spcAft>
+                <a:spcPts val="400"/>
+              </a:spcAft>
+            </a:pPr>
+            <a:r>
+              <a:rPr sz="2000" b="0">
+                <a:solidFill>
+                  <a:srgbClr val="555960"/>
+                </a:solidFill>
+                <a:latin typeface="Calibri"/>
+              </a:rPr>
+              <a:t>An index is bought, not free: faster reads, paid for on every write, chosen per access pattern.</a:t>
+            </a:r>
+          </a:p>
+        </p:txBody>
+      </p:sp>
+      <p:sp>
+        <p:nvSpPr>
+          <p:cNvPr id="9" name="FooterBand"/>
+          <p:cNvSpPr/>
+          <p:nvPr/>
+        </p:nvSpPr>
+        <p:spPr>
+          <a:xfrm>
+            <a:off x="274320" y="5879592"/>
+            <a:ext cx="8595360" cy="502920"/>
+          </a:xfrm>
+          <a:prstGeom prst="rect">
+            <a:avLst/>
+          </a:prstGeom>
+          <a:solidFill>
+            <a:srgbClr val="8E6F3E"/>
+          </a:solidFill>
+          <a:ln>
+            <a:noFill/>
+          </a:ln>
+          <a:effectLst/>
+        </p:spPr>
+        <p:style>
+          <a:lnRef idx="1">
+            <a:schemeClr val="accent1"/>
+          </a:lnRef>
+          <a:fillRef idx="3">
+            <a:schemeClr val="accent1"/>
+          </a:fillRef>
+          <a:effectRef idx="2">
+            <a:schemeClr val="accent1"/>
+          </a:effectRef>
+          <a:fontRef idx="minor">
+            <a:schemeClr val="lt1"/>
+          </a:fontRef>
+        </p:style>
+        <p:txBody>
+          <a:bodyPr rtlCol="0" anchor="ctr" wrap="square"/>
+          <a:lstStyle/>
+          <a:p>
+            <a:pPr algn="ctr"/>
+          </a:p>
+        </p:txBody>
+      </p:sp>
+      <p:sp>
+        <p:nvSpPr>
+          <p:cNvPr id="10" name="FooterBandText"/>
+          <p:cNvSpPr txBox="1"/>
+          <p:nvPr/>
+        </p:nvSpPr>
+        <p:spPr>
+          <a:xfrm>
+            <a:off x="384048" y="5897880"/>
+            <a:ext cx="8375904" cy="457200"/>
+          </a:xfrm>
+          <a:prstGeom prst="rect">
+            <a:avLst/>
+          </a:prstGeom>
+          <a:noFill/>
+        </p:spPr>
+        <p:txBody>
+          <a:bodyPr wrap="square">
+            <a:spAutoFit/>
+          </a:bodyPr>
+          <a:lstStyle/>
+          <a:p>
+            <a:pPr algn="ctr">
+              <a:spcAft>
+                <a:spcPts val="400"/>
+              </a:spcAft>
+            </a:pPr>
+            <a:r>
+              <a:rPr sz="2000" b="1">
+                <a:solidFill>
+                  <a:srgbClr val="FFFFFF"/>
+                </a:solidFill>
+                <a:latin typeface="Calibri"/>
+              </a:rPr>
+              <a:t>Indexes are design decisions, not tuning afterthoughts</a:t>
+            </a:r>
+          </a:p>
+        </p:txBody>
+      </p:sp>
+    </p:spTree>
+  </p:cSld>
+  <p:clrMapOvr>
+    <a:masterClrMapping/>
+  </p:clrMapOvr>
+</p:sld>
+</file>
+
+<file path=ppt/slides/slide18.xml><?xml version="1.0" encoding="utf-8"?>
+<p:sld xmlns:a="http://schemas.openxmlformats.org/drawingml/2006/main" xmlns:p="http://schemas.openxmlformats.org/presentationml/2006/main" xmlns:r="http://schemas.openxmlformats.org/officeDocument/2006/relationships">
+  <p:cSld>
+    <p:spTree>
+      <p:nvGrpSpPr>
+        <p:cNvPr id="1" name=""/>
+        <p:cNvGrpSpPr/>
+        <p:nvPr/>
+      </p:nvGrpSpPr>
+      <p:grpSpPr/>
+      <p:sp>
+        <p:nvSpPr>
+          <p:cNvPr id="2" name="Title"/>
+          <p:cNvSpPr txBox="1"/>
+          <p:nvPr/>
+        </p:nvSpPr>
+        <p:spPr>
+          <a:xfrm>
+            <a:off x="274320" y="128016"/>
+            <a:ext cx="8595360" cy="594360"/>
+          </a:xfrm>
+          <a:prstGeom prst="rect">
+            <a:avLst/>
+          </a:prstGeom>
+          <a:noFill/>
+        </p:spPr>
+        <p:txBody>
+          <a:bodyPr wrap="square">
+            <a:spAutoFit/>
+          </a:bodyPr>
+          <a:lstStyle/>
+          <a:p>
+            <a:pPr algn="l">
+              <a:spcAft>
+                <a:spcPts val="400"/>
+              </a:spcAft>
+            </a:pPr>
+            <a:r>
+              <a:rPr sz="2400" b="0">
+                <a:solidFill>
+                  <a:srgbClr val="2D2D2D"/>
+                </a:solidFill>
+                <a:latin typeface="Calibri"/>
+              </a:rPr>
+              <a:t>The N+1 problem: correct code, terrible access pattern</a:t>
+            </a:r>
+          </a:p>
+        </p:txBody>
+      </p:sp>
+      <p:sp>
+        <p:nvSpPr>
+          <p:cNvPr id="3" name="Card"/>
+          <p:cNvSpPr/>
+          <p:nvPr/>
+        </p:nvSpPr>
+        <p:spPr>
+          <a:xfrm>
+            <a:off x="411480" y="960120"/>
+            <a:ext cx="4846320" cy="1783080"/>
+          </a:xfrm>
+          <a:prstGeom prst="rect">
+            <a:avLst/>
+          </a:prstGeom>
+          <a:solidFill>
+            <a:srgbClr val="FCFAF6"/>
+          </a:solidFill>
+          <a:ln>
+            <a:noFill/>
+          </a:ln>
+          <a:effectLst/>
+        </p:spPr>
+        <p:style>
+          <a:lnRef idx="1">
+            <a:schemeClr val="accent1"/>
+          </a:lnRef>
+          <a:fillRef idx="3">
+            <a:schemeClr val="accent1"/>
+          </a:fillRef>
+          <a:effectRef idx="2">
+            <a:schemeClr val="accent1"/>
+          </a:effectRef>
+          <a:fontRef idx="minor">
+            <a:schemeClr val="lt1"/>
+          </a:fontRef>
+        </p:style>
+        <p:txBody>
+          <a:bodyPr rtlCol="0" anchor="ctr" wrap="square"/>
+          <a:lstStyle/>
+          <a:p>
+            <a:pPr algn="ctr"/>
+          </a:p>
+        </p:txBody>
+      </p:sp>
+      <p:sp>
+        <p:nvSpPr>
+          <p:cNvPr id="4" name="Code"/>
+          <p:cNvSpPr txBox="1"/>
+          <p:nvPr/>
+        </p:nvSpPr>
+        <p:spPr>
+          <a:xfrm>
+            <a:off x="557784" y="1051560"/>
+            <a:ext cx="4553712" cy="1600200"/>
+          </a:xfrm>
+          <a:prstGeom prst="rect">
+            <a:avLst/>
+          </a:prstGeom>
+          <a:noFill/>
+        </p:spPr>
+        <p:txBody>
+          <a:bodyPr wrap="square">
+            <a:spAutoFit/>
+          </a:bodyPr>
+          <a:lstStyle/>
+          <a:p>
+            <a:pPr algn="l">
+              <a:spcAft>
+                <a:spcPts val="200"/>
+              </a:spcAft>
+            </a:pPr>
+            <a:r>
+              <a:rPr sz="2000" b="0">
+                <a:solidFill>
+                  <a:srgbClr val="2D2D2D"/>
+                </a:solidFill>
+                <a:latin typeface="Consolas"/>
+              </a:rPr>
+              <a:t>for r in reservations:   # 1 query</a:t>
+            </a:r>
+          </a:p>
+          <a:p>
+            <a:pPr algn="l">
+              <a:spcAft>
+                <a:spcPts val="200"/>
+              </a:spcAft>
+            </a:pPr>
+            <a:r>
+              <a:rPr sz="2000" b="0">
+                <a:solidFill>
+                  <a:srgbClr val="2D2D2D"/>
+                </a:solidFill>
+                <a:latin typeface="Consolas"/>
+              </a:rPr>
+              <a:t>    print(r.room.name)   # +1 each</a:t>
+            </a:r>
+          </a:p>
+          <a:p>
+            <a:pPr algn="l">
+              <a:spcAft>
+                <a:spcPts val="200"/>
+              </a:spcAft>
+            </a:pPr>
+            <a:r>
+              <a:rPr sz="2000" b="0">
+                <a:solidFill>
+                  <a:srgbClr val="2D2D2D"/>
+                </a:solidFill>
+                <a:latin typeface="Consolas"/>
+              </a:rPr>
+              <a:t># 200 reservations -&gt; 201 queries</a:t>
+            </a:r>
+          </a:p>
+        </p:txBody>
+      </p:sp>
+      <p:sp>
+        <p:nvSpPr>
+          <p:cNvPr id="5" name="Card"/>
+          <p:cNvSpPr/>
+          <p:nvPr/>
+        </p:nvSpPr>
+        <p:spPr>
+          <a:xfrm>
+            <a:off x="5440680" y="960120"/>
+            <a:ext cx="3291840" cy="1783080"/>
+          </a:xfrm>
+          <a:prstGeom prst="rect">
+            <a:avLst/>
+          </a:prstGeom>
+          <a:solidFill>
+            <a:srgbClr val="F5F1E8"/>
+          </a:solidFill>
+          <a:ln>
+            <a:noFill/>
+          </a:ln>
+          <a:effectLst/>
+        </p:spPr>
+        <p:style>
+          <a:lnRef idx="1">
+            <a:schemeClr val="accent1"/>
+          </a:lnRef>
+          <a:fillRef idx="3">
+            <a:schemeClr val="accent1"/>
+          </a:fillRef>
+          <a:effectRef idx="2">
+            <a:schemeClr val="accent1"/>
+          </a:effectRef>
+          <a:fontRef idx="minor">
+            <a:schemeClr val="lt1"/>
+          </a:fontRef>
+        </p:style>
+        <p:txBody>
+          <a:bodyPr rtlCol="0" anchor="ctr" wrap="square"/>
+          <a:lstStyle/>
+          <a:p>
+            <a:pPr algn="ctr"/>
+          </a:p>
+        </p:txBody>
+      </p:sp>
+      <p:sp>
+        <p:nvSpPr>
+          <p:cNvPr id="6" name="CardBody"/>
+          <p:cNvSpPr txBox="1"/>
+          <p:nvPr/>
+        </p:nvSpPr>
+        <p:spPr>
+          <a:xfrm>
+            <a:off x="5586984" y="1051560"/>
+            <a:ext cx="2999232" cy="1600200"/>
+          </a:xfrm>
+          <a:prstGeom prst="rect">
+            <a:avLst/>
+          </a:prstGeom>
+          <a:noFill/>
+        </p:spPr>
+        <p:txBody>
+          <a:bodyPr wrap="square">
+            <a:spAutoFit/>
+          </a:bodyPr>
+          <a:lstStyle/>
+          <a:p>
+            <a:pPr algn="l">
+              <a:spcAft>
+                <a:spcPts val="400"/>
+              </a:spcAft>
+            </a:pPr>
+            <a:r>
+              <a:rPr sz="2000" b="1">
+                <a:solidFill>
+                  <a:srgbClr val="5C4826"/>
+                </a:solidFill>
+                <a:latin typeface="Calibri"/>
+              </a:rPr>
+              <a:t>Batched instead</a:t>
+            </a:r>
+          </a:p>
+          <a:p>
+            <a:pPr algn="l">
+              <a:spcAft>
+                <a:spcPts val="400"/>
+              </a:spcAft>
+            </a:pPr>
+            <a:r>
+              <a:rPr sz="2000" b="0">
+                <a:solidFill>
+                  <a:srgbClr val="555960"/>
+                </a:solidFill>
+                <a:latin typeface="Calibri"/>
+              </a:rPr>
+              <a:t>One JOIN (or prefetch) → one round trip</a:t>
+            </a:r>
+          </a:p>
+        </p:txBody>
+      </p:sp>
+      <p:sp>
+        <p:nvSpPr>
+          <p:cNvPr id="7" name="Card"/>
+          <p:cNvSpPr/>
+          <p:nvPr/>
+        </p:nvSpPr>
+        <p:spPr>
+          <a:xfrm>
+            <a:off x="411480" y="2971800"/>
+            <a:ext cx="8321040" cy="1554480"/>
+          </a:xfrm>
+          <a:prstGeom prst="rect">
+            <a:avLst/>
+          </a:prstGeom>
+          <a:solidFill>
+            <a:srgbClr val="F5F1E8"/>
+          </a:solidFill>
+          <a:ln>
+            <a:noFill/>
+          </a:ln>
+          <a:effectLst/>
+        </p:spPr>
+        <p:style>
+          <a:lnRef idx="1">
+            <a:schemeClr val="accent1"/>
+          </a:lnRef>
+          <a:fillRef idx="3">
+            <a:schemeClr val="accent1"/>
+          </a:fillRef>
+          <a:effectRef idx="2">
+            <a:schemeClr val="accent1"/>
+          </a:effectRef>
+          <a:fontRef idx="minor">
+            <a:schemeClr val="lt1"/>
+          </a:fontRef>
+        </p:style>
+        <p:txBody>
+          <a:bodyPr rtlCol="0" anchor="ctr" wrap="square"/>
+          <a:lstStyle/>
+          <a:p>
+            <a:pPr algn="ctr"/>
+          </a:p>
+        </p:txBody>
+      </p:sp>
+      <p:sp>
+        <p:nvSpPr>
+          <p:cNvPr id="8" name="CardBody"/>
+          <p:cNvSpPr txBox="1"/>
+          <p:nvPr/>
+        </p:nvSpPr>
+        <p:spPr>
+          <a:xfrm>
+            <a:off x="557784" y="3044952"/>
+            <a:ext cx="8046720" cy="1417320"/>
+          </a:xfrm>
+          <a:prstGeom prst="rect">
+            <a:avLst/>
+          </a:prstGeom>
+          <a:noFill/>
+        </p:spPr>
+        <p:txBody>
+          <a:bodyPr wrap="square">
+            <a:spAutoFit/>
+          </a:bodyPr>
+          <a:lstStyle/>
+          <a:p>
+            <a:pPr algn="l">
+              <a:spcAft>
+                <a:spcPts val="300"/>
+              </a:spcAft>
+            </a:pPr>
+            <a:r>
+              <a:rPr sz="2000" b="1">
+                <a:solidFill>
+                  <a:srgbClr val="8E6F3E"/>
+                </a:solidFill>
+                <a:latin typeface="Calibri"/>
+              </a:rPr>
+              <a:t>WHY THIS BITES IN 2026</a:t>
+            </a:r>
+          </a:p>
+          <a:p>
+            <a:pPr algn="l">
+              <a:spcAft>
+                <a:spcPts val="300"/>
+              </a:spcAft>
+            </a:pPr>
+            <a:r>
+              <a:rPr sz="2000" b="0">
+                <a:solidFill>
+                  <a:srgbClr val="555960"/>
+                </a:solidFill>
+                <a:latin typeface="Calibri"/>
+              </a:rPr>
+              <a:t>ORM-generated and agent-generated code is typically functionally correct and access-pattern naive.</a:t>
+            </a:r>
+          </a:p>
+          <a:p>
+            <a:pPr algn="l">
+              <a:spcAft>
+                <a:spcPts val="400"/>
+              </a:spcAft>
+            </a:pPr>
+            <a:r>
+              <a:rPr sz="2000" b="1">
+                <a:solidFill>
+                  <a:srgbClr val="5C4826"/>
+                </a:solidFill>
+                <a:latin typeface="Calibri"/>
+              </a:rPr>
+              <a:t>Review the queries the code EMITS, not just the code.</a:t>
+            </a:r>
+          </a:p>
+        </p:txBody>
+      </p:sp>
+      <p:sp>
+        <p:nvSpPr>
+          <p:cNvPr id="9" name="FooterBand"/>
+          <p:cNvSpPr/>
+          <p:nvPr/>
+        </p:nvSpPr>
+        <p:spPr>
+          <a:xfrm>
+            <a:off x="274320" y="5879592"/>
+            <a:ext cx="8595360" cy="502920"/>
+          </a:xfrm>
+          <a:prstGeom prst="rect">
+            <a:avLst/>
+          </a:prstGeom>
+          <a:solidFill>
+            <a:srgbClr val="8E6F3E"/>
+          </a:solidFill>
+          <a:ln>
+            <a:noFill/>
+          </a:ln>
+          <a:effectLst/>
+        </p:spPr>
+        <p:style>
+          <a:lnRef idx="1">
+            <a:schemeClr val="accent1"/>
+          </a:lnRef>
+          <a:fillRef idx="3">
+            <a:schemeClr val="accent1"/>
+          </a:fillRef>
+          <a:effectRef idx="2">
+            <a:schemeClr val="accent1"/>
+          </a:effectRef>
+          <a:fontRef idx="minor">
+            <a:schemeClr val="lt1"/>
+          </a:fontRef>
+        </p:style>
+        <p:txBody>
+          <a:bodyPr rtlCol="0" anchor="ctr" wrap="square"/>
+          <a:lstStyle/>
+          <a:p>
+            <a:pPr algn="ctr"/>
+          </a:p>
+        </p:txBody>
+      </p:sp>
+      <p:sp>
+        <p:nvSpPr>
+          <p:cNvPr id="10" name="FooterBandText"/>
+          <p:cNvSpPr txBox="1"/>
+          <p:nvPr/>
+        </p:nvSpPr>
+        <p:spPr>
+          <a:xfrm>
+            <a:off x="384048" y="5897880"/>
+            <a:ext cx="8375904" cy="457200"/>
+          </a:xfrm>
+          <a:prstGeom prst="rect">
+            <a:avLst/>
+          </a:prstGeom>
+          <a:noFill/>
+        </p:spPr>
+        <p:txBody>
+          <a:bodyPr wrap="square">
+            <a:spAutoFit/>
+          </a:bodyPr>
+          <a:lstStyle/>
+          <a:p>
+            <a:pPr algn="ctr">
+              <a:spcAft>
+                <a:spcPts val="400"/>
+              </a:spcAft>
+            </a:pPr>
+            <a:r>
+              <a:rPr sz="2000" b="1">
+                <a:solidFill>
+                  <a:srgbClr val="FFFFFF"/>
+                </a:solidFill>
+                <a:latin typeface="Calibri"/>
+              </a:rPr>
+              <a:t>Tests for correctness will not catch an access-pattern defect</a:t>
+            </a:r>
+          </a:p>
+        </p:txBody>
+      </p:sp>
+    </p:spTree>
+  </p:cSld>
+  <p:clrMapOvr>
+    <a:masterClrMapping/>
+  </p:clrMapOvr>
+</p:sld>
+</file>
+
 <file path=ppt/slides/slide2.xml><?xml version="1.0" encoding="utf-8"?>
 <p:sld xmlns:a="http://schemas.openxmlformats.org/drawingml/2006/main" xmlns:p="http://schemas.openxmlformats.org/presentationml/2006/main" xmlns:r="http://schemas.openxmlformats.org/officeDocument/2006/relationships">
   <p:cSld>

</xml_diff>

<commit_message>
deck 3-2: §5 transactions and concurrency (slides 19-24)
Stage 5 of 6: the double-booking race (the deck's most-timed slide, 5
min — both requests locally correct, defect in the interleaving), ACID
with the C-is-not-your-invariants red line, isolation as a policy over
histories, levels incl. write-skew-under-snapshot, the three real fixes
(exclusion constraint / serializable+retry / explicit locking) compared
by where the invariant lives, and the cost slide. 65 of 75 min banked.

Co-Authored-By: Claude Opus 5 <noreply@anthropic.com>
</commit_message>
<xml_diff>
--- a/course/lectures/act-3-software-in-the-world/02-compute-environments-and-data-management/3-2-Data-Management.pptx
+++ b/course/lectures/act-3-software-in-the-world/02-compute-environments-and-data-management/3-2-Data-Management.pptx
@@ -26,6 +26,12 @@
     <p:sldId id="271" r:id="rId22"/>
     <p:sldId id="272" r:id="rId23"/>
     <p:sldId id="273" r:id="rId24"/>
+    <p:sldId id="274" r:id="rId25"/>
+    <p:sldId id="275" r:id="rId26"/>
+    <p:sldId id="276" r:id="rId27"/>
+    <p:sldId id="277" r:id="rId28"/>
+    <p:sldId id="278" r:id="rId29"/>
+    <p:sldId id="279" r:id="rId6"/>
   </p:sldIdLst>
   <p:sldSz cx="9144000" cy="6858000" type="screen4x3"/>
   <p:notesSz cx="6858000" cy="9144000"/>
@@ -2340,6 +2346,106 @@
 </p:notes>
 </file>
 
+<file path=ppt/notesSlides/notesSlide19.xml><?xml version="1.0" encoding="utf-8"?>
+<p:notes xmlns:a="http://schemas.openxmlformats.org/drawingml/2006/main" xmlns:p="http://schemas.openxmlformats.org/presentationml/2006/main" xmlns:r="http://schemas.openxmlformats.org/officeDocument/2006/relationships">
+  <p:cSld>
+    <p:spTree>
+      <p:nvGrpSpPr>
+        <p:cNvPr id="1" name=""/>
+        <p:cNvGrpSpPr/>
+        <p:nvPr/>
+      </p:nvGrpSpPr>
+      <p:grpSpPr>
+        <a:xfrm>
+          <a:off x="0" y="0"/>
+          <a:ext cx="0" cy="0"/>
+          <a:chOff x="0" y="0"/>
+          <a:chExt cx="0" cy="0"/>
+        </a:xfrm>
+      </p:grpSpPr>
+      <p:sp>
+        <p:nvSpPr>
+          <p:cNvPr id="2" name="Slide Image Placeholder 1"/>
+          <p:cNvSpPr>
+            <a:spLocks noGrp="1"/>
+          </p:cNvSpPr>
+          <p:nvPr>
+            <p:ph type="sldImg" idx="3"/>
+          </p:nvPr>
+        </p:nvSpPr>
+        <p:spPr/>
+      </p:sp>
+      <p:sp>
+        <p:nvSpPr>
+          <p:cNvPr id="3" name="Notes Placeholder 2"/>
+          <p:cNvSpPr>
+            <a:spLocks noGrp="1"/>
+          </p:cNvSpPr>
+          <p:nvPr>
+            <p:ph type="body" idx="1"/>
+          </p:nvPr>
+        </p:nvSpPr>
+        <p:spPr/>
+        <p:txBody>
+          <a:bodyPr/>
+          <a:lstStyle/>
+          <a:p>
+            <a:r>
+              <a:t>TIMING: 5 minutes.</a:t>
+            </a:r>
+          </a:p>
+          <a:p/>
+          <a:p>
+            <a:r>
+              <a:t>The most important slide of the lecture — walk it slowly, twice.</a:t>
+            </a:r>
+          </a:p>
+          <a:p/>
+          <a:p>
+            <a:r>
+              <a:t>First pass: read each request's code shape (check for conflicts, then insert — the obvious algorithm, and the one students wrote in their heads on slide 13). Second pass: walk the interleaving t1→t4. At t1 and t2 BOTH checks run against a table with neither insert present; both see "no conflict"; both inserts then commit. Check-then-act, torn by time.</a:t>
+            </a:r>
+          </a:p>
+          <a:p/>
+          <a:p>
+            <a:r>
+              <a:t>Dwell on where the bug is: not in A, not in B, not in SQL, not in the driver. Each request is locally correct. The defect lives only in the INTERLEAVING — a property of the pair of executions, exactly as the violation on slide 12 was a property of the pair of rows. Correct-looking code cannot fix this from inside one request: re-checking after insert, double-checking before — every variant just moves the window.</a:t>
+            </a:r>
+          </a:p>
+          <a:p/>
+          <a:p>
+            <a:r>
+              <a:t>Ask: "who tested this?" Both requests pass every unit test and every sequential integration test. This is why concurrency is an ENGINEERING obligation — you must choose machinery (slide 23) rather than write more careful local code. Agents generating locally-correct check-then-act code will walk straight into this.</a:t>
+            </a:r>
+          </a:p>
+          <a:p/>
+          <a:p>
+            <a:r>
+              <a:t>Do NOT let anyone claim a foreign key or CHECK would have stopped it — slide 10 established why not; it resurfaces with the fixes on slide 23.</a:t>
+            </a:r>
+          </a:p>
+        </p:txBody>
+      </p:sp>
+      <p:sp>
+        <p:nvSpPr>
+          <p:cNvPr id="4" name="Slide Number Placeholder 3"/>
+          <p:cNvSpPr>
+            <a:spLocks noGrp="1"/>
+          </p:cNvSpPr>
+          <p:nvPr>
+            <p:ph type="sldNum" idx="12"/>
+          </p:nvPr>
+        </p:nvSpPr>
+        <p:spPr/>
+      </p:sp>
+    </p:spTree>
+  </p:cSld>
+  <p:clrMapOvr>
+    <a:masterClrMapping/>
+  </p:clrMapOvr>
+</p:notes>
+</file>
+
 <file path=ppt/notesSlides/notesSlide2.xml><?xml version="1.0" encoding="utf-8"?>
 <p:notes xmlns:a="http://schemas.openxmlformats.org/drawingml/2006/main" xmlns:p="http://schemas.openxmlformats.org/presentationml/2006/main" xmlns:r="http://schemas.openxmlformats.org/officeDocument/2006/relationships">
   <p:cSld>
@@ -2404,6 +2510,464 @@
           <a:p>
             <a:r>
               <a:t>Do not let "database" mean "SQL server" yet — next slide names the component abstractly.</a:t>
+            </a:r>
+          </a:p>
+        </p:txBody>
+      </p:sp>
+      <p:sp>
+        <p:nvSpPr>
+          <p:cNvPr id="4" name="Slide Number Placeholder 3"/>
+          <p:cNvSpPr>
+            <a:spLocks noGrp="1"/>
+          </p:cNvSpPr>
+          <p:nvPr>
+            <p:ph type="sldNum" idx="12"/>
+          </p:nvPr>
+        </p:nvSpPr>
+        <p:spPr/>
+      </p:sp>
+    </p:spTree>
+  </p:cSld>
+  <p:clrMapOvr>
+    <a:masterClrMapping/>
+  </p:clrMapOvr>
+</p:notes>
+</file>
+
+<file path=ppt/notesSlides/notesSlide20.xml><?xml version="1.0" encoding="utf-8"?>
+<p:notes xmlns:a="http://schemas.openxmlformats.org/drawingml/2006/main" xmlns:p="http://schemas.openxmlformats.org/presentationml/2006/main" xmlns:r="http://schemas.openxmlformats.org/officeDocument/2006/relationships">
+  <p:cSld>
+    <p:spTree>
+      <p:nvGrpSpPr>
+        <p:cNvPr id="1" name=""/>
+        <p:cNvGrpSpPr/>
+        <p:nvPr/>
+      </p:nvGrpSpPr>
+      <p:grpSpPr>
+        <a:xfrm>
+          <a:off x="0" y="0"/>
+          <a:ext cx="0" cy="0"/>
+          <a:chOff x="0" y="0"/>
+          <a:chExt cx="0" cy="0"/>
+        </a:xfrm>
+      </p:grpSpPr>
+      <p:sp>
+        <p:nvSpPr>
+          <p:cNvPr id="2" name="Slide Image Placeholder 1"/>
+          <p:cNvSpPr>
+            <a:spLocks noGrp="1"/>
+          </p:cNvSpPr>
+          <p:nvPr>
+            <p:ph type="sldImg" idx="3"/>
+          </p:nvPr>
+        </p:nvSpPr>
+        <p:spPr/>
+      </p:sp>
+      <p:sp>
+        <p:nvSpPr>
+          <p:cNvPr id="3" name="Notes Placeholder 2"/>
+          <p:cNvSpPr>
+            <a:spLocks noGrp="1"/>
+          </p:cNvSpPr>
+          <p:nvPr>
+            <p:ph type="body" idx="1"/>
+          </p:nvPr>
+        </p:nvSpPr>
+        <p:spPr/>
+        <p:txBody>
+          <a:bodyPr/>
+          <a:lstStyle/>
+          <a:p>
+            <a:r>
+              <a:t>TIMING: 3 minutes.</a:t>
+            </a:r>
+          </a:p>
+          <a:p/>
+          <a:p>
+            <a:r>
+              <a:t>Each letter is real and valuable — do not teach ACID cynically. Atomicity alone removes a whole failure class (the half-written reservation). Durability is why slide 2's restart stopped being fatal.</a:t>
+            </a:r>
+          </a:p>
+          <a:p/>
+          <a:p>
+            <a:r>
+              <a:t>The red line is the third named non-claim of the lecture, and students arrive believing it: "the database is ACID, therefore my data is consistent." Consistency here is a technical term — declared constraints and transaction logic — not a warranty about intentions. Slide 19's race ran inside perfectly ACID transactions at default isolation: atomic, durable, each constraint held. The system did everything it promised. The promise just did not include our invariant.</a:t>
+            </a:r>
+          </a:p>
+          <a:p/>
+          <a:p>
+            <a:r>
+              <a:t>Isolation is the letter with a dial, and the next two slides turn it.</a:t>
+            </a:r>
+          </a:p>
+        </p:txBody>
+      </p:sp>
+      <p:sp>
+        <p:nvSpPr>
+          <p:cNvPr id="4" name="Slide Number Placeholder 3"/>
+          <p:cNvSpPr>
+            <a:spLocks noGrp="1"/>
+          </p:cNvSpPr>
+          <p:nvPr>
+            <p:ph type="sldNum" idx="12"/>
+          </p:nvPr>
+        </p:nvSpPr>
+        <p:spPr/>
+      </p:sp>
+    </p:spTree>
+  </p:cSld>
+  <p:clrMapOvr>
+    <a:masterClrMapping/>
+  </p:clrMapOvr>
+</p:notes>
+</file>
+
+<file path=ppt/notesSlides/notesSlide21.xml><?xml version="1.0" encoding="utf-8"?>
+<p:notes xmlns:a="http://schemas.openxmlformats.org/drawingml/2006/main" xmlns:p="http://schemas.openxmlformats.org/presentationml/2006/main" xmlns:r="http://schemas.openxmlformats.org/officeDocument/2006/relationships">
+  <p:cSld>
+    <p:spTree>
+      <p:nvGrpSpPr>
+        <p:cNvPr id="1" name=""/>
+        <p:cNvGrpSpPr/>
+        <p:nvPr/>
+      </p:nvGrpSpPr>
+      <p:grpSpPr>
+        <a:xfrm>
+          <a:off x="0" y="0"/>
+          <a:ext cx="0" cy="0"/>
+          <a:chOff x="0" y="0"/>
+          <a:chExt cx="0" cy="0"/>
+        </a:xfrm>
+      </p:grpSpPr>
+      <p:sp>
+        <p:nvSpPr>
+          <p:cNvPr id="2" name="Slide Image Placeholder 1"/>
+          <p:cNvSpPr>
+            <a:spLocks noGrp="1"/>
+          </p:cNvSpPr>
+          <p:nvPr>
+            <p:ph type="sldImg" idx="3"/>
+          </p:nvPr>
+        </p:nvSpPr>
+        <p:spPr/>
+      </p:sp>
+      <p:sp>
+        <p:nvSpPr>
+          <p:cNvPr id="3" name="Notes Placeholder 2"/>
+          <p:cNvSpPr>
+            <a:spLocks noGrp="1"/>
+          </p:cNvSpPr>
+          <p:nvPr>
+            <p:ph type="body" idx="1"/>
+          </p:nvPr>
+        </p:nvSpPr>
+        <p:spPr/>
+        <p:txBody>
+          <a:bodyPr/>
+          <a:lstStyle/>
+          <a:p>
+            <a:r>
+              <a:t>TIMING: 3 minutes.</a:t>
+            </a:r>
+          </a:p>
+          <a:p/>
+          <a:p>
+            <a:r>
+              <a:t>The nested bars are a set diagram: all interleavings; the subset your isolation level admits; the serializable core. An isolation level is a POLICY over histories — the same object Act II's state machines reasoned about: define the reachable executions, then ask whether every one preserves the invariant.</a:t>
+            </a:r>
+          </a:p>
+          <a:p/>
+          <a:p>
+            <a:r>
+              <a:t>Serializability's definition deserves precision: the system may interleave however it likes, provided the outcome is equivalent to SOME serial order. That is why it rescues check-then-act: in any serial order, the second request's check runs after the first's insert.</a:t>
+            </a:r>
+          </a:p>
+          <a:p/>
+          <a:p>
+            <a:r>
+              <a:t>What it costs — and why engines do not default to it — is the next slide. Keep the taxonomy OUT of this slide; here there is only "permitted histories," narrower or wider.</a:t>
+            </a:r>
+          </a:p>
+        </p:txBody>
+      </p:sp>
+      <p:sp>
+        <p:nvSpPr>
+          <p:cNvPr id="4" name="Slide Number Placeholder 3"/>
+          <p:cNvSpPr>
+            <a:spLocks noGrp="1"/>
+          </p:cNvSpPr>
+          <p:nvPr>
+            <p:ph type="sldNum" idx="12"/>
+          </p:nvPr>
+        </p:nvSpPr>
+        <p:spPr/>
+      </p:sp>
+    </p:spTree>
+  </p:cSld>
+  <p:clrMapOvr>
+    <a:masterClrMapping/>
+  </p:clrMapOvr>
+</p:notes>
+</file>
+
+<file path=ppt/notesSlides/notesSlide22.xml><?xml version="1.0" encoding="utf-8"?>
+<p:notes xmlns:a="http://schemas.openxmlformats.org/drawingml/2006/main" xmlns:p="http://schemas.openxmlformats.org/presentationml/2006/main" xmlns:r="http://schemas.openxmlformats.org/officeDocument/2006/relationships">
+  <p:cSld>
+    <p:spTree>
+      <p:nvGrpSpPr>
+        <p:cNvPr id="1" name=""/>
+        <p:cNvGrpSpPr/>
+        <p:nvPr/>
+      </p:nvGrpSpPr>
+      <p:grpSpPr>
+        <a:xfrm>
+          <a:off x="0" y="0"/>
+          <a:ext cx="0" cy="0"/>
+          <a:chOff x="0" y="0"/>
+          <a:chExt cx="0" cy="0"/>
+        </a:xfrm>
+      </p:grpSpPr>
+      <p:sp>
+        <p:nvSpPr>
+          <p:cNvPr id="2" name="Slide Image Placeholder 1"/>
+          <p:cNvSpPr>
+            <a:spLocks noGrp="1"/>
+          </p:cNvSpPr>
+          <p:nvPr>
+            <p:ph type="sldImg" idx="3"/>
+          </p:nvPr>
+        </p:nvSpPr>
+        <p:spPr/>
+      </p:sp>
+      <p:sp>
+        <p:nvSpPr>
+          <p:cNvPr id="3" name="Notes Placeholder 2"/>
+          <p:cNvSpPr>
+            <a:spLocks noGrp="1"/>
+          </p:cNvSpPr>
+          <p:nvPr>
+            <p:ph type="body" idx="1"/>
+          </p:nvPr>
+        </p:nvSpPr>
+        <p:spPr/>
+        <p:txBody>
+          <a:bodyPr/>
+          <a:lstStyle/>
+          <a:p>
+            <a:r>
+              <a:t>TIMING: 2 minutes.</a:t>
+            </a:r>
+          </a:p>
+          <a:p/>
+          <a:p>
+            <a:r>
+              <a:t>Two minutes, not twenty — the full anomaly taxonomy is a databases-course topic; today's point is only that the dial exists and where OUR race sits on it.</a:t>
+            </a:r>
+          </a:p>
+          <a:p/>
+          <a:p>
+            <a:r>
+              <a:t>The middle row is the one that surprises: snapshot isolation feels strong ("I read a consistent frozen view!") and still permits the race, because neither transaction WRITES what the other READ — both checked a range, both inserted new rows. That pattern is write skew; one sentence of vocabulary, no more.</a:t>
+            </a:r>
+          </a:p>
+          <a:p/>
+          <a:p>
+            <a:r>
+              <a:t>So "we use transactions" does not settle slide 19. Either the level excludes the history (bottom row, with retry costs), or the invariant needs a different home — next slide.</a:t>
+            </a:r>
+          </a:p>
+        </p:txBody>
+      </p:sp>
+      <p:sp>
+        <p:nvSpPr>
+          <p:cNvPr id="4" name="Slide Number Placeholder 3"/>
+          <p:cNvSpPr>
+            <a:spLocks noGrp="1"/>
+          </p:cNvSpPr>
+          <p:nvPr>
+            <p:ph type="sldNum" idx="12"/>
+          </p:nvPr>
+        </p:nvSpPr>
+        <p:spPr/>
+      </p:sp>
+    </p:spTree>
+  </p:cSld>
+  <p:clrMapOvr>
+    <a:masterClrMapping/>
+  </p:clrMapOvr>
+</p:notes>
+</file>
+
+<file path=ppt/notesSlides/notesSlide23.xml><?xml version="1.0" encoding="utf-8"?>
+<p:notes xmlns:a="http://schemas.openxmlformats.org/drawingml/2006/main" xmlns:p="http://schemas.openxmlformats.org/presentationml/2006/main" xmlns:r="http://schemas.openxmlformats.org/officeDocument/2006/relationships">
+  <p:cSld>
+    <p:spTree>
+      <p:nvGrpSpPr>
+        <p:cNvPr id="1" name=""/>
+        <p:cNvGrpSpPr/>
+        <p:nvPr/>
+      </p:nvGrpSpPr>
+      <p:grpSpPr>
+        <a:xfrm>
+          <a:off x="0" y="0"/>
+          <a:ext cx="0" cy="0"/>
+          <a:chOff x="0" y="0"/>
+          <a:chExt cx="0" cy="0"/>
+        </a:xfrm>
+      </p:grpSpPr>
+      <p:sp>
+        <p:nvSpPr>
+          <p:cNvPr id="2" name="Slide Image Placeholder 1"/>
+          <p:cNvSpPr>
+            <a:spLocks noGrp="1"/>
+          </p:cNvSpPr>
+          <p:nvPr>
+            <p:ph type="sldImg" idx="3"/>
+          </p:nvPr>
+        </p:nvSpPr>
+        <p:spPr/>
+      </p:sp>
+      <p:sp>
+        <p:nvSpPr>
+          <p:cNvPr id="3" name="Notes Placeholder 2"/>
+          <p:cNvSpPr>
+            <a:spLocks noGrp="1"/>
+          </p:cNvSpPr>
+          <p:nvPr>
+            <p:ph type="body" idx="1"/>
+          </p:nvPr>
+        </p:nvSpPr>
+        <p:spPr/>
+        <p:txBody>
+          <a:bodyPr/>
+          <a:lstStyle/>
+          <a:p>
+            <a:r>
+              <a:t>TIMING: 3 minutes.</a:t>
+            </a:r>
+          </a:p>
+          <a:p/>
+          <a:p>
+            <a:r>
+              <a:t>The payoff slide. Compare the three fixes by ONE axis: where the invariant is REPRESENTED and ENFORCED.</a:t>
+            </a:r>
+          </a:p>
+          <a:p/>
+          <a:p>
+            <a:r>
+              <a:t>(1) Exclusion constraint — the invariant lives in the schema, like slide 10's obligations. Strongest home: enforced no matter which code path, ORM, or agent writes. It exists because interval overlap can be stated as an operator (&amp;&amp;) the engine can index; a plain CHECK still cannot see a second row. Cost: not portable across engines.</a:t>
+            </a:r>
+          </a:p>
+          <a:p/>
+          <a:p>
+            <a:r>
+              <a:t>(2) Serializable + retry — the invariant stays implicit in your check-then-act logic; the isolation contract guarantees the history is safe. General (works for ANY invariant you can code), but the obligation moves to the application: aborts are normal, retry or lose requests.</a:t>
+            </a:r>
+          </a:p>
+          <a:p/>
+          <a:p>
+            <a:r>
+              <a:t>(3) Explicit locking — you serialize room 117's writers yourself. Transparent, portable, and brittle: the invariant now lives in a convention every future code path must remember. (Our own codebase analog: conventions rot; constraints don't.)</a:t>
+            </a:r>
+          </a:p>
+          <a:p/>
+          <a:p>
+            <a:r>
+              <a:t>The red line is the fourth named non-claim, stated once more because students WILL reach for "just add a constraint" — the point is WHICH KIND of constraint can even see the pair.</a:t>
+            </a:r>
+          </a:p>
+          <a:p/>
+          <a:p>
+            <a:r>
+              <a:t>If asked about the document-model alternative: embedding reservations in the room document makes the invariant single-document, enforced by a compare-and-swap on one object — a legitimate fourth point in the space, with its own costs (hot document, cross-room queries).</a:t>
+            </a:r>
+          </a:p>
+        </p:txBody>
+      </p:sp>
+      <p:sp>
+        <p:nvSpPr>
+          <p:cNvPr id="4" name="Slide Number Placeholder 3"/>
+          <p:cNvSpPr>
+            <a:spLocks noGrp="1"/>
+          </p:cNvSpPr>
+          <p:nvPr>
+            <p:ph type="sldNum" idx="12"/>
+          </p:nvPr>
+        </p:nvSpPr>
+        <p:spPr/>
+      </p:sp>
+    </p:spTree>
+  </p:cSld>
+  <p:clrMapOvr>
+    <a:masterClrMapping/>
+  </p:clrMapOvr>
+</p:notes>
+</file>
+
+<file path=ppt/notesSlides/notesSlide24.xml><?xml version="1.0" encoding="utf-8"?>
+<p:notes xmlns:a="http://schemas.openxmlformats.org/drawingml/2006/main" xmlns:p="http://schemas.openxmlformats.org/presentationml/2006/main" xmlns:r="http://schemas.openxmlformats.org/officeDocument/2006/relationships">
+  <p:cSld>
+    <p:spTree>
+      <p:nvGrpSpPr>
+        <p:cNvPr id="1" name=""/>
+        <p:cNvGrpSpPr/>
+        <p:nvPr/>
+      </p:nvGrpSpPr>
+      <p:grpSpPr>
+        <a:xfrm>
+          <a:off x="0" y="0"/>
+          <a:ext cx="0" cy="0"/>
+          <a:chOff x="0" y="0"/>
+          <a:chExt cx="0" cy="0"/>
+        </a:xfrm>
+      </p:grpSpPr>
+      <p:sp>
+        <p:nvSpPr>
+          <p:cNvPr id="2" name="Slide Image Placeholder 1"/>
+          <p:cNvSpPr>
+            <a:spLocks noGrp="1"/>
+          </p:cNvSpPr>
+          <p:nvPr>
+            <p:ph type="sldImg" idx="3"/>
+          </p:nvPr>
+        </p:nvSpPr>
+        <p:spPr/>
+      </p:sp>
+      <p:sp>
+        <p:nvSpPr>
+          <p:cNvPr id="3" name="Notes Placeholder 2"/>
+          <p:cNvSpPr>
+            <a:spLocks noGrp="1"/>
+          </p:cNvSpPr>
+          <p:nvPr>
+            <p:ph type="body" idx="1"/>
+          </p:nvPr>
+        </p:nvSpPr>
+        <p:spPr/>
+        <p:txBody>
+          <a:bodyPr/>
+          <a:lstStyle/>
+          <a:p>
+            <a:r>
+              <a:t>TIMING: 2 minutes.</a:t>
+            </a:r>
+          </a:p>
+          <a:p/>
+          <a:p>
+            <a:r>
+              <a:t>Close the section by pricing it. Every fix on the previous slide narrows permitted histories, and narrowing has mechanical costs: waiting (locks), aborted work (retries), and a throughput ceiling on hot objects. None of this is pathology — it is the machinery doing what you asked.</a:t>
+            </a:r>
+          </a:p>
+          <a:p/>
+          <a:p>
+            <a:r>
+              <a:t>This reframes slide 6 honestly: systems that relax isolation or consistency are not "wrong"; they are paying less because their requirements exclude fewer histories. The folk rule from slide 6 fails precisely because it reads a price list as a morality tale.</a:t>
+            </a:r>
+          </a:p>
+          <a:p/>
+          <a:p>
+            <a:r>
+              <a:t>Handoff: "how much does it cost under OUR workload?" is a measurement question — Performance &amp; Reliability, two lectures from now.</a:t>
             </a:r>
           </a:p>
         </p:txBody>
@@ -15608,6 +16172,587 @@
 </p:sld>
 </file>
 
+<file path=ppt/slides/slide19.xml><?xml version="1.0" encoding="utf-8"?>
+<p:sld xmlns:a="http://schemas.openxmlformats.org/drawingml/2006/main" xmlns:p="http://schemas.openxmlformats.org/presentationml/2006/main" xmlns:r="http://schemas.openxmlformats.org/officeDocument/2006/relationships">
+  <p:cSld>
+    <p:spTree>
+      <p:nvGrpSpPr>
+        <p:cNvPr id="1" name=""/>
+        <p:cNvGrpSpPr/>
+        <p:nvPr/>
+      </p:nvGrpSpPr>
+      <p:grpSpPr/>
+      <p:sp>
+        <p:nvSpPr>
+          <p:cNvPr id="2" name="Title"/>
+          <p:cNvSpPr txBox="1"/>
+          <p:nvPr/>
+        </p:nvSpPr>
+        <p:spPr>
+          <a:xfrm>
+            <a:off x="274320" y="128016"/>
+            <a:ext cx="8595360" cy="594360"/>
+          </a:xfrm>
+          <a:prstGeom prst="rect">
+            <a:avLst/>
+          </a:prstGeom>
+          <a:noFill/>
+        </p:spPr>
+        <p:txBody>
+          <a:bodyPr wrap="square">
+            <a:spAutoFit/>
+          </a:bodyPr>
+          <a:lstStyle/>
+          <a:p>
+            <a:pPr algn="l">
+              <a:spcAft>
+                <a:spcPts val="400"/>
+              </a:spcAft>
+            </a:pPr>
+            <a:r>
+              <a:rPr sz="2400" b="0">
+                <a:solidFill>
+                  <a:srgbClr val="2D2D2D"/>
+                </a:solidFill>
+                <a:latin typeface="Calibri"/>
+              </a:rPr>
+              <a:t>Double-booking: two correct requests, one broken invariant</a:t>
+            </a:r>
+          </a:p>
+        </p:txBody>
+      </p:sp>
+      <p:sp>
+        <p:nvSpPr>
+          <p:cNvPr id="3" name="Block"/>
+          <p:cNvSpPr/>
+          <p:nvPr/>
+        </p:nvSpPr>
+        <p:spPr>
+          <a:xfrm>
+            <a:off x="411480" y="868680"/>
+            <a:ext cx="4069080" cy="640080"/>
+          </a:xfrm>
+          <a:prstGeom prst="rect">
+            <a:avLst/>
+          </a:prstGeom>
+          <a:solidFill>
+            <a:srgbClr val="8E6F3E"/>
+          </a:solidFill>
+          <a:ln>
+            <a:noFill/>
+          </a:ln>
+          <a:effectLst/>
+        </p:spPr>
+        <p:style>
+          <a:lnRef idx="1">
+            <a:schemeClr val="accent1"/>
+          </a:lnRef>
+          <a:fillRef idx="3">
+            <a:schemeClr val="accent1"/>
+          </a:fillRef>
+          <a:effectRef idx="2">
+            <a:schemeClr val="accent1"/>
+          </a:effectRef>
+          <a:fontRef idx="minor">
+            <a:schemeClr val="lt1"/>
+          </a:fontRef>
+        </p:style>
+        <p:txBody>
+          <a:bodyPr rtlCol="0" anchor="ctr" wrap="square"/>
+          <a:lstStyle/>
+          <a:p>
+            <a:pPr algn="ctr">
+              <a:spcAft>
+                <a:spcPts val="0"/>
+              </a:spcAft>
+            </a:pPr>
+            <a:r>
+              <a:rPr sz="2000" b="1">
+                <a:solidFill>
+                  <a:srgbClr val="FFFFFF"/>
+                </a:solidFill>
+                <a:latin typeface="Calibri"/>
+              </a:rPr>
+              <a:t>REQUEST A — room 117, 10:00–11:00</a:t>
+            </a:r>
+          </a:p>
+        </p:txBody>
+      </p:sp>
+      <p:sp>
+        <p:nvSpPr>
+          <p:cNvPr id="4" name="Block"/>
+          <p:cNvSpPr/>
+          <p:nvPr/>
+        </p:nvSpPr>
+        <p:spPr>
+          <a:xfrm>
+            <a:off x="4663440" y="868680"/>
+            <a:ext cx="4069080" cy="640080"/>
+          </a:xfrm>
+          <a:prstGeom prst="rect">
+            <a:avLst/>
+          </a:prstGeom>
+          <a:solidFill>
+            <a:srgbClr val="8E6F3E"/>
+          </a:solidFill>
+          <a:ln>
+            <a:noFill/>
+          </a:ln>
+          <a:effectLst/>
+        </p:spPr>
+        <p:style>
+          <a:lnRef idx="1">
+            <a:schemeClr val="accent1"/>
+          </a:lnRef>
+          <a:fillRef idx="3">
+            <a:schemeClr val="accent1"/>
+          </a:fillRef>
+          <a:effectRef idx="2">
+            <a:schemeClr val="accent1"/>
+          </a:effectRef>
+          <a:fontRef idx="minor">
+            <a:schemeClr val="lt1"/>
+          </a:fontRef>
+        </p:style>
+        <p:txBody>
+          <a:bodyPr rtlCol="0" anchor="ctr" wrap="square"/>
+          <a:lstStyle/>
+          <a:p>
+            <a:pPr algn="ctr">
+              <a:spcAft>
+                <a:spcPts val="0"/>
+              </a:spcAft>
+            </a:pPr>
+            <a:r>
+              <a:rPr sz="2000" b="1">
+                <a:solidFill>
+                  <a:srgbClr val="FFFFFF"/>
+                </a:solidFill>
+                <a:latin typeface="Calibri"/>
+              </a:rPr>
+              <a:t>REQUEST B — room 117, 10:30–11:30</a:t>
+            </a:r>
+          </a:p>
+        </p:txBody>
+      </p:sp>
+      <p:sp>
+        <p:nvSpPr>
+          <p:cNvPr id="5" name="Block"/>
+          <p:cNvSpPr/>
+          <p:nvPr/>
+        </p:nvSpPr>
+        <p:spPr>
+          <a:xfrm>
+            <a:off x="411480" y="1645920"/>
+            <a:ext cx="4069080" cy="640080"/>
+          </a:xfrm>
+          <a:prstGeom prst="rect">
+            <a:avLst/>
+          </a:prstGeom>
+          <a:solidFill>
+            <a:srgbClr val="F5F1E8"/>
+          </a:solidFill>
+          <a:ln>
+            <a:noFill/>
+          </a:ln>
+          <a:effectLst/>
+        </p:spPr>
+        <p:style>
+          <a:lnRef idx="1">
+            <a:schemeClr val="accent1"/>
+          </a:lnRef>
+          <a:fillRef idx="3">
+            <a:schemeClr val="accent1"/>
+          </a:fillRef>
+          <a:effectRef idx="2">
+            <a:schemeClr val="accent1"/>
+          </a:effectRef>
+          <a:fontRef idx="minor">
+            <a:schemeClr val="lt1"/>
+          </a:fontRef>
+        </p:style>
+        <p:txBody>
+          <a:bodyPr rtlCol="0" anchor="ctr" wrap="square"/>
+          <a:lstStyle/>
+          <a:p>
+            <a:pPr algn="l">
+              <a:spcAft>
+                <a:spcPts val="0"/>
+              </a:spcAft>
+            </a:pPr>
+            <a:r>
+              <a:rPr sz="2000" b="1">
+                <a:solidFill>
+                  <a:srgbClr val="5C4826"/>
+                </a:solidFill>
+                <a:latin typeface="Calibri"/>
+              </a:rPr>
+              <a:t>t1 · check 10:00–11:00 → no conflict</a:t>
+            </a:r>
+          </a:p>
+        </p:txBody>
+      </p:sp>
+      <p:sp>
+        <p:nvSpPr>
+          <p:cNvPr id="6" name="Block"/>
+          <p:cNvSpPr/>
+          <p:nvPr/>
+        </p:nvSpPr>
+        <p:spPr>
+          <a:xfrm>
+            <a:off x="4663440" y="2377440"/>
+            <a:ext cx="4069080" cy="640080"/>
+          </a:xfrm>
+          <a:prstGeom prst="rect">
+            <a:avLst/>
+          </a:prstGeom>
+          <a:solidFill>
+            <a:srgbClr val="F5F1E8"/>
+          </a:solidFill>
+          <a:ln>
+            <a:noFill/>
+          </a:ln>
+          <a:effectLst/>
+        </p:spPr>
+        <p:style>
+          <a:lnRef idx="1">
+            <a:schemeClr val="accent1"/>
+          </a:lnRef>
+          <a:fillRef idx="3">
+            <a:schemeClr val="accent1"/>
+          </a:fillRef>
+          <a:effectRef idx="2">
+            <a:schemeClr val="accent1"/>
+          </a:effectRef>
+          <a:fontRef idx="minor">
+            <a:schemeClr val="lt1"/>
+          </a:fontRef>
+        </p:style>
+        <p:txBody>
+          <a:bodyPr rtlCol="0" anchor="ctr" wrap="square"/>
+          <a:lstStyle/>
+          <a:p>
+            <a:pPr algn="l">
+              <a:spcAft>
+                <a:spcPts val="0"/>
+              </a:spcAft>
+            </a:pPr>
+            <a:r>
+              <a:rPr sz="2000" b="1">
+                <a:solidFill>
+                  <a:srgbClr val="5C4826"/>
+                </a:solidFill>
+                <a:latin typeface="Calibri"/>
+              </a:rPr>
+              <a:t>t2 · check 10:30–11:30 → no conflict</a:t>
+            </a:r>
+          </a:p>
+        </p:txBody>
+      </p:sp>
+      <p:sp>
+        <p:nvSpPr>
+          <p:cNvPr id="7" name="Block"/>
+          <p:cNvSpPr/>
+          <p:nvPr/>
+        </p:nvSpPr>
+        <p:spPr>
+          <a:xfrm>
+            <a:off x="411480" y="3108960"/>
+            <a:ext cx="4069080" cy="640080"/>
+          </a:xfrm>
+          <a:prstGeom prst="rect">
+            <a:avLst/>
+          </a:prstGeom>
+          <a:solidFill>
+            <a:srgbClr val="F5F1E8"/>
+          </a:solidFill>
+          <a:ln>
+            <a:noFill/>
+          </a:ln>
+          <a:effectLst/>
+        </p:spPr>
+        <p:style>
+          <a:lnRef idx="1">
+            <a:schemeClr val="accent1"/>
+          </a:lnRef>
+          <a:fillRef idx="3">
+            <a:schemeClr val="accent1"/>
+          </a:fillRef>
+          <a:effectRef idx="2">
+            <a:schemeClr val="accent1"/>
+          </a:effectRef>
+          <a:fontRef idx="minor">
+            <a:schemeClr val="lt1"/>
+          </a:fontRef>
+        </p:style>
+        <p:txBody>
+          <a:bodyPr rtlCol="0" anchor="ctr" wrap="square"/>
+          <a:lstStyle/>
+          <a:p>
+            <a:pPr algn="l">
+              <a:spcAft>
+                <a:spcPts val="0"/>
+              </a:spcAft>
+            </a:pPr>
+            <a:r>
+              <a:rPr sz="2000" b="1">
+                <a:solidFill>
+                  <a:srgbClr val="5C4826"/>
+                </a:solidFill>
+                <a:latin typeface="Calibri"/>
+              </a:rPr>
+              <a:t>t3 · INSERT CONFIRMED — commit ✓</a:t>
+            </a:r>
+          </a:p>
+        </p:txBody>
+      </p:sp>
+      <p:sp>
+        <p:nvSpPr>
+          <p:cNvPr id="8" name="Block"/>
+          <p:cNvSpPr/>
+          <p:nvPr/>
+        </p:nvSpPr>
+        <p:spPr>
+          <a:xfrm>
+            <a:off x="4663440" y="3840480"/>
+            <a:ext cx="4069080" cy="640080"/>
+          </a:xfrm>
+          <a:prstGeom prst="rect">
+            <a:avLst/>
+          </a:prstGeom>
+          <a:solidFill>
+            <a:srgbClr val="F5F1E8"/>
+          </a:solidFill>
+          <a:ln>
+            <a:noFill/>
+          </a:ln>
+          <a:effectLst/>
+        </p:spPr>
+        <p:style>
+          <a:lnRef idx="1">
+            <a:schemeClr val="accent1"/>
+          </a:lnRef>
+          <a:fillRef idx="3">
+            <a:schemeClr val="accent1"/>
+          </a:fillRef>
+          <a:effectRef idx="2">
+            <a:schemeClr val="accent1"/>
+          </a:effectRef>
+          <a:fontRef idx="minor">
+            <a:schemeClr val="lt1"/>
+          </a:fontRef>
+        </p:style>
+        <p:txBody>
+          <a:bodyPr rtlCol="0" anchor="ctr" wrap="square"/>
+          <a:lstStyle/>
+          <a:p>
+            <a:pPr algn="l">
+              <a:spcAft>
+                <a:spcPts val="0"/>
+              </a:spcAft>
+            </a:pPr>
+            <a:r>
+              <a:rPr sz="2000" b="1">
+                <a:solidFill>
+                  <a:srgbClr val="5C4826"/>
+                </a:solidFill>
+                <a:latin typeface="Calibri"/>
+              </a:rPr>
+              <a:t>t4 · INSERT CONFIRMED — commit ✓</a:t>
+            </a:r>
+          </a:p>
+        </p:txBody>
+      </p:sp>
+      <p:sp>
+        <p:nvSpPr>
+          <p:cNvPr id="9" name="Card"/>
+          <p:cNvSpPr/>
+          <p:nvPr/>
+        </p:nvSpPr>
+        <p:spPr>
+          <a:xfrm>
+            <a:off x="411480" y="4617720"/>
+            <a:ext cx="8321040" cy="1188720"/>
+          </a:xfrm>
+          <a:prstGeom prst="rect">
+            <a:avLst/>
+          </a:prstGeom>
+          <a:solidFill>
+            <a:srgbClr val="F5F1E8"/>
+          </a:solidFill>
+          <a:ln>
+            <a:noFill/>
+          </a:ln>
+          <a:effectLst/>
+        </p:spPr>
+        <p:style>
+          <a:lnRef idx="1">
+            <a:schemeClr val="accent1"/>
+          </a:lnRef>
+          <a:fillRef idx="3">
+            <a:schemeClr val="accent1"/>
+          </a:fillRef>
+          <a:effectRef idx="2">
+            <a:schemeClr val="accent1"/>
+          </a:effectRef>
+          <a:fontRef idx="minor">
+            <a:schemeClr val="lt1"/>
+          </a:fontRef>
+        </p:style>
+        <p:txBody>
+          <a:bodyPr rtlCol="0" anchor="ctr" wrap="square"/>
+          <a:lstStyle/>
+          <a:p>
+            <a:pPr algn="ctr"/>
+          </a:p>
+        </p:txBody>
+      </p:sp>
+      <p:sp>
+        <p:nvSpPr>
+          <p:cNvPr id="10" name="Verdict"/>
+          <p:cNvSpPr txBox="1"/>
+          <p:nvPr/>
+        </p:nvSpPr>
+        <p:spPr>
+          <a:xfrm>
+            <a:off x="557784" y="4672584"/>
+            <a:ext cx="8046720" cy="1078992"/>
+          </a:xfrm>
+          <a:prstGeom prst="rect">
+            <a:avLst/>
+          </a:prstGeom>
+          <a:noFill/>
+        </p:spPr>
+        <p:txBody>
+          <a:bodyPr wrap="square">
+            <a:spAutoFit/>
+          </a:bodyPr>
+          <a:lstStyle/>
+          <a:p>
+            <a:pPr algn="l">
+              <a:spcAft>
+                <a:spcPts val="200"/>
+              </a:spcAft>
+            </a:pPr>
+            <a:r>
+              <a:rPr sz="2000" b="1">
+                <a:solidFill>
+                  <a:srgbClr val="C01B1B"/>
+                </a:solidFill>
+                <a:latin typeface="Calibri"/>
+              </a:rPr>
+              <a:t>Both commits succeed. Room 117 is double-booked.</a:t>
+            </a:r>
+          </a:p>
+          <a:p>
+            <a:pPr algn="l">
+              <a:spcAft>
+                <a:spcPts val="400"/>
+              </a:spcAft>
+            </a:pPr>
+            <a:r>
+              <a:rPr sz="2000" b="0">
+                <a:solidFill>
+                  <a:srgbClr val="555960"/>
+                </a:solidFill>
+                <a:latin typeface="Calibri"/>
+              </a:rPr>
+              <a:t>No statement failed, no constraint fired — and each request, read alone, follows the intended algorithm exactly.</a:t>
+            </a:r>
+          </a:p>
+        </p:txBody>
+      </p:sp>
+      <p:sp>
+        <p:nvSpPr>
+          <p:cNvPr id="11" name="FooterBand"/>
+          <p:cNvSpPr/>
+          <p:nvPr/>
+        </p:nvSpPr>
+        <p:spPr>
+          <a:xfrm>
+            <a:off x="274320" y="5879592"/>
+            <a:ext cx="8595360" cy="502920"/>
+          </a:xfrm>
+          <a:prstGeom prst="rect">
+            <a:avLst/>
+          </a:prstGeom>
+          <a:solidFill>
+            <a:srgbClr val="8E6F3E"/>
+          </a:solidFill>
+          <a:ln>
+            <a:noFill/>
+          </a:ln>
+          <a:effectLst/>
+        </p:spPr>
+        <p:style>
+          <a:lnRef idx="1">
+            <a:schemeClr val="accent1"/>
+          </a:lnRef>
+          <a:fillRef idx="3">
+            <a:schemeClr val="accent1"/>
+          </a:fillRef>
+          <a:effectRef idx="2">
+            <a:schemeClr val="accent1"/>
+          </a:effectRef>
+          <a:fontRef idx="minor">
+            <a:schemeClr val="lt1"/>
+          </a:fontRef>
+        </p:style>
+        <p:txBody>
+          <a:bodyPr rtlCol="0" anchor="ctr" wrap="square"/>
+          <a:lstStyle/>
+          <a:p>
+            <a:pPr algn="ctr"/>
+          </a:p>
+        </p:txBody>
+      </p:sp>
+      <p:sp>
+        <p:nvSpPr>
+          <p:cNvPr id="12" name="FooterBandText"/>
+          <p:cNvSpPr txBox="1"/>
+          <p:nvPr/>
+        </p:nvSpPr>
+        <p:spPr>
+          <a:xfrm>
+            <a:off x="384048" y="5897880"/>
+            <a:ext cx="8375904" cy="457200"/>
+          </a:xfrm>
+          <a:prstGeom prst="rect">
+            <a:avLst/>
+          </a:prstGeom>
+          <a:noFill/>
+        </p:spPr>
+        <p:txBody>
+          <a:bodyPr wrap="square">
+            <a:spAutoFit/>
+          </a:bodyPr>
+          <a:lstStyle/>
+          <a:p>
+            <a:pPr algn="ctr">
+              <a:spcAft>
+                <a:spcPts val="400"/>
+              </a:spcAft>
+            </a:pPr>
+            <a:r>
+              <a:rPr sz="2000" b="1">
+                <a:solidFill>
+                  <a:srgbClr val="FFFFFF"/>
+                </a:solidFill>
+                <a:latin typeface="Calibri"/>
+              </a:rPr>
+              <a:t>Locally correct code cannot alone preserve a global invariant</a:t>
+            </a:r>
+          </a:p>
+        </p:txBody>
+      </p:sp>
+    </p:spTree>
+  </p:cSld>
+  <p:clrMapOvr>
+    <a:masterClrMapping/>
+  </p:clrMapOvr>
+</p:sld>
+</file>
+
 <file path=ppt/slides/slide2.xml><?xml version="1.0" encoding="utf-8"?>
 <p:sld xmlns:a="http://schemas.openxmlformats.org/drawingml/2006/main" xmlns:p="http://schemas.openxmlformats.org/presentationml/2006/main" xmlns:r="http://schemas.openxmlformats.org/officeDocument/2006/relationships">
   <p:cSld>
@@ -16237,6 +17382,2969 @@
                 <a:latin typeface="Calibri"/>
               </a:rPr>
               <a:t>Three separable requirements — each can be met without the others</a:t>
+            </a:r>
+          </a:p>
+        </p:txBody>
+      </p:sp>
+    </p:spTree>
+  </p:cSld>
+  <p:clrMapOvr>
+    <a:masterClrMapping/>
+  </p:clrMapOvr>
+</p:sld>
+</file>
+
+<file path=ppt/slides/slide20.xml><?xml version="1.0" encoding="utf-8"?>
+<p:sld xmlns:a="http://schemas.openxmlformats.org/drawingml/2006/main" xmlns:p="http://schemas.openxmlformats.org/presentationml/2006/main" xmlns:r="http://schemas.openxmlformats.org/officeDocument/2006/relationships">
+  <p:cSld>
+    <p:spTree>
+      <p:nvGrpSpPr>
+        <p:cNvPr id="1" name=""/>
+        <p:cNvGrpSpPr/>
+        <p:nvPr/>
+      </p:nvGrpSpPr>
+      <p:grpSpPr/>
+      <p:sp>
+        <p:nvSpPr>
+          <p:cNvPr id="2" name="Title"/>
+          <p:cNvSpPr txBox="1"/>
+          <p:nvPr/>
+        </p:nvSpPr>
+        <p:spPr>
+          <a:xfrm>
+            <a:off x="274320" y="128016"/>
+            <a:ext cx="8595360" cy="594360"/>
+          </a:xfrm>
+          <a:prstGeom prst="rect">
+            <a:avLst/>
+          </a:prstGeom>
+          <a:noFill/>
+        </p:spPr>
+        <p:txBody>
+          <a:bodyPr wrap="square">
+            <a:spAutoFit/>
+          </a:bodyPr>
+          <a:lstStyle/>
+          <a:p>
+            <a:pPr algn="l">
+              <a:spcAft>
+                <a:spcPts val="400"/>
+              </a:spcAft>
+            </a:pPr>
+            <a:r>
+              <a:rPr sz="2400" b="0">
+                <a:solidFill>
+                  <a:srgbClr val="2D2D2D"/>
+                </a:solidFill>
+                <a:latin typeface="Calibri"/>
+              </a:rPr>
+              <a:t>ACID: what the database actually promises</a:t>
+            </a:r>
+          </a:p>
+        </p:txBody>
+      </p:sp>
+      <p:sp>
+        <p:nvSpPr>
+          <p:cNvPr id="3" name="Card"/>
+          <p:cNvSpPr/>
+          <p:nvPr/>
+        </p:nvSpPr>
+        <p:spPr>
+          <a:xfrm>
+            <a:off x="411480" y="914400"/>
+            <a:ext cx="8321040" cy="713232"/>
+          </a:xfrm>
+          <a:prstGeom prst="rect">
+            <a:avLst/>
+          </a:prstGeom>
+          <a:solidFill>
+            <a:srgbClr val="F5F1E8"/>
+          </a:solidFill>
+          <a:ln>
+            <a:noFill/>
+          </a:ln>
+          <a:effectLst/>
+        </p:spPr>
+        <p:style>
+          <a:lnRef idx="1">
+            <a:schemeClr val="accent1"/>
+          </a:lnRef>
+          <a:fillRef idx="3">
+            <a:schemeClr val="accent1"/>
+          </a:fillRef>
+          <a:effectRef idx="2">
+            <a:schemeClr val="accent1"/>
+          </a:effectRef>
+          <a:fontRef idx="minor">
+            <a:schemeClr val="lt1"/>
+          </a:fontRef>
+        </p:style>
+        <p:txBody>
+          <a:bodyPr rtlCol="0" anchor="ctr" wrap="square"/>
+          <a:lstStyle/>
+          <a:p>
+            <a:pPr algn="ctr"/>
+          </a:p>
+        </p:txBody>
+      </p:sp>
+      <p:sp>
+        <p:nvSpPr>
+          <p:cNvPr id="4" name="RowLabel"/>
+          <p:cNvSpPr txBox="1"/>
+          <p:nvPr/>
+        </p:nvSpPr>
+        <p:spPr>
+          <a:xfrm>
+            <a:off x="557784" y="950976"/>
+            <a:ext cx="2103120" cy="640080"/>
+          </a:xfrm>
+          <a:prstGeom prst="rect">
+            <a:avLst/>
+          </a:prstGeom>
+          <a:noFill/>
+        </p:spPr>
+        <p:txBody>
+          <a:bodyPr wrap="square" anchor="ctr">
+            <a:spAutoFit/>
+          </a:bodyPr>
+          <a:lstStyle/>
+          <a:p>
+            <a:pPr algn="l">
+              <a:spcAft>
+                <a:spcPts val="400"/>
+              </a:spcAft>
+            </a:pPr>
+            <a:r>
+              <a:rPr sz="2000" b="1">
+                <a:solidFill>
+                  <a:srgbClr val="8E6F3E"/>
+                </a:solidFill>
+                <a:latin typeface="Calibri"/>
+              </a:rPr>
+              <a:t>Atomicity</a:t>
+            </a:r>
+          </a:p>
+        </p:txBody>
+      </p:sp>
+      <p:sp>
+        <p:nvSpPr>
+          <p:cNvPr id="5" name="RowBody"/>
+          <p:cNvSpPr txBox="1"/>
+          <p:nvPr/>
+        </p:nvSpPr>
+        <p:spPr>
+          <a:xfrm>
+            <a:off x="2752344" y="950976"/>
+            <a:ext cx="5833872" cy="640080"/>
+          </a:xfrm>
+          <a:prstGeom prst="rect">
+            <a:avLst/>
+          </a:prstGeom>
+          <a:noFill/>
+        </p:spPr>
+        <p:txBody>
+          <a:bodyPr wrap="square" anchor="ctr">
+            <a:spAutoFit/>
+          </a:bodyPr>
+          <a:lstStyle/>
+          <a:p>
+            <a:pPr algn="l">
+              <a:spcAft>
+                <a:spcPts val="400"/>
+              </a:spcAft>
+            </a:pPr>
+            <a:r>
+              <a:rPr sz="2000" b="0">
+                <a:solidFill>
+                  <a:srgbClr val="5C4826"/>
+                </a:solidFill>
+                <a:latin typeface="Calibri"/>
+              </a:rPr>
+              <a:t>All of a transaction's writes commit, or none do</a:t>
+            </a:r>
+          </a:p>
+        </p:txBody>
+      </p:sp>
+      <p:sp>
+        <p:nvSpPr>
+          <p:cNvPr id="6" name="Card"/>
+          <p:cNvSpPr/>
+          <p:nvPr/>
+        </p:nvSpPr>
+        <p:spPr>
+          <a:xfrm>
+            <a:off x="411480" y="1719072"/>
+            <a:ext cx="8321040" cy="713232"/>
+          </a:xfrm>
+          <a:prstGeom prst="rect">
+            <a:avLst/>
+          </a:prstGeom>
+          <a:solidFill>
+            <a:srgbClr val="FCFAF6"/>
+          </a:solidFill>
+          <a:ln>
+            <a:noFill/>
+          </a:ln>
+          <a:effectLst/>
+        </p:spPr>
+        <p:style>
+          <a:lnRef idx="1">
+            <a:schemeClr val="accent1"/>
+          </a:lnRef>
+          <a:fillRef idx="3">
+            <a:schemeClr val="accent1"/>
+          </a:fillRef>
+          <a:effectRef idx="2">
+            <a:schemeClr val="accent1"/>
+          </a:effectRef>
+          <a:fontRef idx="minor">
+            <a:schemeClr val="lt1"/>
+          </a:fontRef>
+        </p:style>
+        <p:txBody>
+          <a:bodyPr rtlCol="0" anchor="ctr" wrap="square"/>
+          <a:lstStyle/>
+          <a:p>
+            <a:pPr algn="ctr"/>
+          </a:p>
+        </p:txBody>
+      </p:sp>
+      <p:sp>
+        <p:nvSpPr>
+          <p:cNvPr id="7" name="RowLabel"/>
+          <p:cNvSpPr txBox="1"/>
+          <p:nvPr/>
+        </p:nvSpPr>
+        <p:spPr>
+          <a:xfrm>
+            <a:off x="557784" y="1755648"/>
+            <a:ext cx="2103120" cy="640080"/>
+          </a:xfrm>
+          <a:prstGeom prst="rect">
+            <a:avLst/>
+          </a:prstGeom>
+          <a:noFill/>
+        </p:spPr>
+        <p:txBody>
+          <a:bodyPr wrap="square" anchor="ctr">
+            <a:spAutoFit/>
+          </a:bodyPr>
+          <a:lstStyle/>
+          <a:p>
+            <a:pPr algn="l">
+              <a:spcAft>
+                <a:spcPts val="400"/>
+              </a:spcAft>
+            </a:pPr>
+            <a:r>
+              <a:rPr sz="2000" b="1">
+                <a:solidFill>
+                  <a:srgbClr val="8E6F3E"/>
+                </a:solidFill>
+                <a:latin typeface="Calibri"/>
+              </a:rPr>
+              <a:t>Consistency</a:t>
+            </a:r>
+          </a:p>
+        </p:txBody>
+      </p:sp>
+      <p:sp>
+        <p:nvSpPr>
+          <p:cNvPr id="8" name="RowBody"/>
+          <p:cNvSpPr txBox="1"/>
+          <p:nvPr/>
+        </p:nvSpPr>
+        <p:spPr>
+          <a:xfrm>
+            <a:off x="2752344" y="1755648"/>
+            <a:ext cx="5833872" cy="640080"/>
+          </a:xfrm>
+          <a:prstGeom prst="rect">
+            <a:avLst/>
+          </a:prstGeom>
+          <a:noFill/>
+        </p:spPr>
+        <p:txBody>
+          <a:bodyPr wrap="square" anchor="ctr">
+            <a:spAutoFit/>
+          </a:bodyPr>
+          <a:lstStyle/>
+          <a:p>
+            <a:pPr algn="l">
+              <a:spcAft>
+                <a:spcPts val="400"/>
+              </a:spcAft>
+            </a:pPr>
+            <a:r>
+              <a:rPr sz="2000" b="0">
+                <a:solidFill>
+                  <a:srgbClr val="5C4826"/>
+                </a:solidFill>
+                <a:latin typeface="Calibri"/>
+              </a:rPr>
+              <a:t>Declared constraints hold at commit — the ones YOU declared</a:t>
+            </a:r>
+          </a:p>
+        </p:txBody>
+      </p:sp>
+      <p:sp>
+        <p:nvSpPr>
+          <p:cNvPr id="9" name="Card"/>
+          <p:cNvSpPr/>
+          <p:nvPr/>
+        </p:nvSpPr>
+        <p:spPr>
+          <a:xfrm>
+            <a:off x="411480" y="2523744"/>
+            <a:ext cx="8321040" cy="713232"/>
+          </a:xfrm>
+          <a:prstGeom prst="rect">
+            <a:avLst/>
+          </a:prstGeom>
+          <a:solidFill>
+            <a:srgbClr val="F5F1E8"/>
+          </a:solidFill>
+          <a:ln>
+            <a:noFill/>
+          </a:ln>
+          <a:effectLst/>
+        </p:spPr>
+        <p:style>
+          <a:lnRef idx="1">
+            <a:schemeClr val="accent1"/>
+          </a:lnRef>
+          <a:fillRef idx="3">
+            <a:schemeClr val="accent1"/>
+          </a:fillRef>
+          <a:effectRef idx="2">
+            <a:schemeClr val="accent1"/>
+          </a:effectRef>
+          <a:fontRef idx="minor">
+            <a:schemeClr val="lt1"/>
+          </a:fontRef>
+        </p:style>
+        <p:txBody>
+          <a:bodyPr rtlCol="0" anchor="ctr" wrap="square"/>
+          <a:lstStyle/>
+          <a:p>
+            <a:pPr algn="ctr"/>
+          </a:p>
+        </p:txBody>
+      </p:sp>
+      <p:sp>
+        <p:nvSpPr>
+          <p:cNvPr id="10" name="RowLabel"/>
+          <p:cNvSpPr txBox="1"/>
+          <p:nvPr/>
+        </p:nvSpPr>
+        <p:spPr>
+          <a:xfrm>
+            <a:off x="557784" y="2560320"/>
+            <a:ext cx="2103120" cy="640080"/>
+          </a:xfrm>
+          <a:prstGeom prst="rect">
+            <a:avLst/>
+          </a:prstGeom>
+          <a:noFill/>
+        </p:spPr>
+        <p:txBody>
+          <a:bodyPr wrap="square" anchor="ctr">
+            <a:spAutoFit/>
+          </a:bodyPr>
+          <a:lstStyle/>
+          <a:p>
+            <a:pPr algn="l">
+              <a:spcAft>
+                <a:spcPts val="400"/>
+              </a:spcAft>
+            </a:pPr>
+            <a:r>
+              <a:rPr sz="2000" b="1">
+                <a:solidFill>
+                  <a:srgbClr val="8E6F3E"/>
+                </a:solidFill>
+                <a:latin typeface="Calibri"/>
+              </a:rPr>
+              <a:t>Isolation</a:t>
+            </a:r>
+          </a:p>
+        </p:txBody>
+      </p:sp>
+      <p:sp>
+        <p:nvSpPr>
+          <p:cNvPr id="11" name="RowBody"/>
+          <p:cNvSpPr txBox="1"/>
+          <p:nvPr/>
+        </p:nvSpPr>
+        <p:spPr>
+          <a:xfrm>
+            <a:off x="2752344" y="2560320"/>
+            <a:ext cx="5833872" cy="640080"/>
+          </a:xfrm>
+          <a:prstGeom prst="rect">
+            <a:avLst/>
+          </a:prstGeom>
+          <a:noFill/>
+        </p:spPr>
+        <p:txBody>
+          <a:bodyPr wrap="square" anchor="ctr">
+            <a:spAutoFit/>
+          </a:bodyPr>
+          <a:lstStyle/>
+          <a:p>
+            <a:pPr algn="l">
+              <a:spcAft>
+                <a:spcPts val="400"/>
+              </a:spcAft>
+            </a:pPr>
+            <a:r>
+              <a:rPr sz="2000" b="0">
+                <a:solidFill>
+                  <a:srgbClr val="5C4826"/>
+                </a:solidFill>
+                <a:latin typeface="Calibri"/>
+              </a:rPr>
+              <a:t>Concurrent transactions interact only in permitted ways</a:t>
+            </a:r>
+          </a:p>
+        </p:txBody>
+      </p:sp>
+      <p:sp>
+        <p:nvSpPr>
+          <p:cNvPr id="12" name="Card"/>
+          <p:cNvSpPr/>
+          <p:nvPr/>
+        </p:nvSpPr>
+        <p:spPr>
+          <a:xfrm>
+            <a:off x="411480" y="3328415"/>
+            <a:ext cx="8321040" cy="713232"/>
+          </a:xfrm>
+          <a:prstGeom prst="rect">
+            <a:avLst/>
+          </a:prstGeom>
+          <a:solidFill>
+            <a:srgbClr val="FCFAF6"/>
+          </a:solidFill>
+          <a:ln>
+            <a:noFill/>
+          </a:ln>
+          <a:effectLst/>
+        </p:spPr>
+        <p:style>
+          <a:lnRef idx="1">
+            <a:schemeClr val="accent1"/>
+          </a:lnRef>
+          <a:fillRef idx="3">
+            <a:schemeClr val="accent1"/>
+          </a:fillRef>
+          <a:effectRef idx="2">
+            <a:schemeClr val="accent1"/>
+          </a:effectRef>
+          <a:fontRef idx="minor">
+            <a:schemeClr val="lt1"/>
+          </a:fontRef>
+        </p:style>
+        <p:txBody>
+          <a:bodyPr rtlCol="0" anchor="ctr" wrap="square"/>
+          <a:lstStyle/>
+          <a:p>
+            <a:pPr algn="ctr"/>
+          </a:p>
+        </p:txBody>
+      </p:sp>
+      <p:sp>
+        <p:nvSpPr>
+          <p:cNvPr id="13" name="RowLabel"/>
+          <p:cNvSpPr txBox="1"/>
+          <p:nvPr/>
+        </p:nvSpPr>
+        <p:spPr>
+          <a:xfrm>
+            <a:off x="557784" y="3364991"/>
+            <a:ext cx="2103120" cy="640080"/>
+          </a:xfrm>
+          <a:prstGeom prst="rect">
+            <a:avLst/>
+          </a:prstGeom>
+          <a:noFill/>
+        </p:spPr>
+        <p:txBody>
+          <a:bodyPr wrap="square" anchor="ctr">
+            <a:spAutoFit/>
+          </a:bodyPr>
+          <a:lstStyle/>
+          <a:p>
+            <a:pPr algn="l">
+              <a:spcAft>
+                <a:spcPts val="400"/>
+              </a:spcAft>
+            </a:pPr>
+            <a:r>
+              <a:rPr sz="2000" b="1">
+                <a:solidFill>
+                  <a:srgbClr val="8E6F3E"/>
+                </a:solidFill>
+                <a:latin typeface="Calibri"/>
+              </a:rPr>
+              <a:t>Durability</a:t>
+            </a:r>
+          </a:p>
+        </p:txBody>
+      </p:sp>
+      <p:sp>
+        <p:nvSpPr>
+          <p:cNvPr id="14" name="RowBody"/>
+          <p:cNvSpPr txBox="1"/>
+          <p:nvPr/>
+        </p:nvSpPr>
+        <p:spPr>
+          <a:xfrm>
+            <a:off x="2752344" y="3364991"/>
+            <a:ext cx="5833872" cy="640080"/>
+          </a:xfrm>
+          <a:prstGeom prst="rect">
+            <a:avLst/>
+          </a:prstGeom>
+          <a:noFill/>
+        </p:spPr>
+        <p:txBody>
+          <a:bodyPr wrap="square" anchor="ctr">
+            <a:spAutoFit/>
+          </a:bodyPr>
+          <a:lstStyle/>
+          <a:p>
+            <a:pPr algn="l">
+              <a:spcAft>
+                <a:spcPts val="400"/>
+              </a:spcAft>
+            </a:pPr>
+            <a:r>
+              <a:rPr sz="2000" b="0">
+                <a:solidFill>
+                  <a:srgbClr val="5C4826"/>
+                </a:solidFill>
+                <a:latin typeface="Calibri"/>
+              </a:rPr>
+              <a:t>A committed write survives crashes</a:t>
+            </a:r>
+          </a:p>
+        </p:txBody>
+      </p:sp>
+      <p:sp>
+        <p:nvSpPr>
+          <p:cNvPr id="15" name="Card"/>
+          <p:cNvSpPr/>
+          <p:nvPr/>
+        </p:nvSpPr>
+        <p:spPr>
+          <a:xfrm>
+            <a:off x="411480" y="4224528"/>
+            <a:ext cx="8321040" cy="1444752"/>
+          </a:xfrm>
+          <a:prstGeom prst="rect">
+            <a:avLst/>
+          </a:prstGeom>
+          <a:solidFill>
+            <a:srgbClr val="F5F1E8"/>
+          </a:solidFill>
+          <a:ln>
+            <a:noFill/>
+          </a:ln>
+          <a:effectLst/>
+        </p:spPr>
+        <p:style>
+          <a:lnRef idx="1">
+            <a:schemeClr val="accent1"/>
+          </a:lnRef>
+          <a:fillRef idx="3">
+            <a:schemeClr val="accent1"/>
+          </a:fillRef>
+          <a:effectRef idx="2">
+            <a:schemeClr val="accent1"/>
+          </a:effectRef>
+          <a:fontRef idx="minor">
+            <a:schemeClr val="lt1"/>
+          </a:fontRef>
+        </p:style>
+        <p:txBody>
+          <a:bodyPr rtlCol="0" anchor="ctr" wrap="square"/>
+          <a:lstStyle/>
+          <a:p>
+            <a:pPr algn="ctr"/>
+          </a:p>
+        </p:txBody>
+      </p:sp>
+      <p:sp>
+        <p:nvSpPr>
+          <p:cNvPr id="16" name="NonClaim"/>
+          <p:cNvSpPr txBox="1"/>
+          <p:nvPr/>
+        </p:nvSpPr>
+        <p:spPr>
+          <a:xfrm>
+            <a:off x="557784" y="4297680"/>
+            <a:ext cx="8046720" cy="1298448"/>
+          </a:xfrm>
+          <a:prstGeom prst="rect">
+            <a:avLst/>
+          </a:prstGeom>
+          <a:noFill/>
+        </p:spPr>
+        <p:txBody>
+          <a:bodyPr wrap="square">
+            <a:spAutoFit/>
+          </a:bodyPr>
+          <a:lstStyle/>
+          <a:p>
+            <a:pPr algn="l">
+              <a:spcAft>
+                <a:spcPts val="300"/>
+              </a:spcAft>
+            </a:pPr>
+            <a:r>
+              <a:rPr sz="2000" b="1">
+                <a:solidFill>
+                  <a:srgbClr val="C01B1B"/>
+                </a:solidFill>
+                <a:latin typeface="Calibri"/>
+              </a:rPr>
+              <a:t>“C” does not mean the database understands your application</a:t>
+            </a:r>
+          </a:p>
+          <a:p>
+            <a:pPr algn="l">
+              <a:spcAft>
+                <a:spcPts val="400"/>
+              </a:spcAft>
+            </a:pPr>
+            <a:r>
+              <a:rPr sz="2000" b="0">
+                <a:solidFill>
+                  <a:srgbClr val="555960"/>
+                </a:solidFill>
+                <a:latin typeface="Calibri"/>
+              </a:rPr>
+              <a:t>It enforces the constraints you supplied. Our overlap invariant was never supplied — ACID held, and the race still landed.</a:t>
+            </a:r>
+          </a:p>
+        </p:txBody>
+      </p:sp>
+      <p:sp>
+        <p:nvSpPr>
+          <p:cNvPr id="17" name="FooterBand"/>
+          <p:cNvSpPr/>
+          <p:nvPr/>
+        </p:nvSpPr>
+        <p:spPr>
+          <a:xfrm>
+            <a:off x="274320" y="5879592"/>
+            <a:ext cx="8595360" cy="502920"/>
+          </a:xfrm>
+          <a:prstGeom prst="rect">
+            <a:avLst/>
+          </a:prstGeom>
+          <a:solidFill>
+            <a:srgbClr val="8E6F3E"/>
+          </a:solidFill>
+          <a:ln>
+            <a:noFill/>
+          </a:ln>
+          <a:effectLst/>
+        </p:spPr>
+        <p:style>
+          <a:lnRef idx="1">
+            <a:schemeClr val="accent1"/>
+          </a:lnRef>
+          <a:fillRef idx="3">
+            <a:schemeClr val="accent1"/>
+          </a:fillRef>
+          <a:effectRef idx="2">
+            <a:schemeClr val="accent1"/>
+          </a:effectRef>
+          <a:fontRef idx="minor">
+            <a:schemeClr val="lt1"/>
+          </a:fontRef>
+        </p:style>
+        <p:txBody>
+          <a:bodyPr rtlCol="0" anchor="ctr" wrap="square"/>
+          <a:lstStyle/>
+          <a:p>
+            <a:pPr algn="ctr"/>
+          </a:p>
+        </p:txBody>
+      </p:sp>
+      <p:sp>
+        <p:nvSpPr>
+          <p:cNvPr id="18" name="FooterBandText"/>
+          <p:cNvSpPr txBox="1"/>
+          <p:nvPr/>
+        </p:nvSpPr>
+        <p:spPr>
+          <a:xfrm>
+            <a:off x="384048" y="5897880"/>
+            <a:ext cx="8375904" cy="457200"/>
+          </a:xfrm>
+          <a:prstGeom prst="rect">
+            <a:avLst/>
+          </a:prstGeom>
+          <a:noFill/>
+        </p:spPr>
+        <p:txBody>
+          <a:bodyPr wrap="square">
+            <a:spAutoFit/>
+          </a:bodyPr>
+          <a:lstStyle/>
+          <a:p>
+            <a:pPr algn="ctr">
+              <a:spcAft>
+                <a:spcPts val="400"/>
+              </a:spcAft>
+            </a:pPr>
+            <a:r>
+              <a:rPr sz="2000" b="1">
+                <a:solidFill>
+                  <a:srgbClr val="FFFFFF"/>
+                </a:solidFill>
+                <a:latin typeface="Calibri"/>
+              </a:rPr>
+              <a:t>ACID is a transaction contract, not a proof of your invariants</a:t>
+            </a:r>
+          </a:p>
+        </p:txBody>
+      </p:sp>
+    </p:spTree>
+  </p:cSld>
+  <p:clrMapOvr>
+    <a:masterClrMapping/>
+  </p:clrMapOvr>
+</p:sld>
+</file>
+
+<file path=ppt/slides/slide21.xml><?xml version="1.0" encoding="utf-8"?>
+<p:sld xmlns:a="http://schemas.openxmlformats.org/drawingml/2006/main" xmlns:p="http://schemas.openxmlformats.org/presentationml/2006/main" xmlns:r="http://schemas.openxmlformats.org/officeDocument/2006/relationships">
+  <p:cSld>
+    <p:spTree>
+      <p:nvGrpSpPr>
+        <p:cNvPr id="1" name=""/>
+        <p:cNvGrpSpPr/>
+        <p:nvPr/>
+      </p:nvGrpSpPr>
+      <p:grpSpPr/>
+      <p:sp>
+        <p:nvSpPr>
+          <p:cNvPr id="2" name="Title"/>
+          <p:cNvSpPr txBox="1"/>
+          <p:nvPr/>
+        </p:nvSpPr>
+        <p:spPr>
+          <a:xfrm>
+            <a:off x="274320" y="128016"/>
+            <a:ext cx="8595360" cy="594360"/>
+          </a:xfrm>
+          <a:prstGeom prst="rect">
+            <a:avLst/>
+          </a:prstGeom>
+          <a:noFill/>
+        </p:spPr>
+        <p:txBody>
+          <a:bodyPr wrap="square">
+            <a:spAutoFit/>
+          </a:bodyPr>
+          <a:lstStyle/>
+          <a:p>
+            <a:pPr algn="l">
+              <a:spcAft>
+                <a:spcPts val="400"/>
+              </a:spcAft>
+            </a:pPr>
+            <a:r>
+              <a:rPr sz="2400" b="0">
+                <a:solidFill>
+                  <a:srgbClr val="2D2D2D"/>
+                </a:solidFill>
+                <a:latin typeface="Calibri"/>
+              </a:rPr>
+              <a:t>Isolation decides which concurrent histories can happen</a:t>
+            </a:r>
+          </a:p>
+        </p:txBody>
+      </p:sp>
+      <p:sp>
+        <p:nvSpPr>
+          <p:cNvPr id="3" name="Block"/>
+          <p:cNvSpPr/>
+          <p:nvPr/>
+        </p:nvSpPr>
+        <p:spPr>
+          <a:xfrm>
+            <a:off x="411480" y="1005840"/>
+            <a:ext cx="8321040" cy="822960"/>
+          </a:xfrm>
+          <a:prstGeom prst="rect">
+            <a:avLst/>
+          </a:prstGeom>
+          <a:solidFill>
+            <a:srgbClr val="FCFAF6"/>
+          </a:solidFill>
+          <a:ln>
+            <a:noFill/>
+          </a:ln>
+          <a:effectLst/>
+        </p:spPr>
+        <p:style>
+          <a:lnRef idx="1">
+            <a:schemeClr val="accent1"/>
+          </a:lnRef>
+          <a:fillRef idx="3">
+            <a:schemeClr val="accent1"/>
+          </a:fillRef>
+          <a:effectRef idx="2">
+            <a:schemeClr val="accent1"/>
+          </a:effectRef>
+          <a:fontRef idx="minor">
+            <a:schemeClr val="lt1"/>
+          </a:fontRef>
+        </p:style>
+        <p:txBody>
+          <a:bodyPr rtlCol="0" anchor="ctr" wrap="square"/>
+          <a:lstStyle/>
+          <a:p>
+            <a:pPr algn="ctr">
+              <a:spcAft>
+                <a:spcPts val="0"/>
+              </a:spcAft>
+            </a:pPr>
+            <a:r>
+              <a:rPr sz="2000" b="1">
+                <a:solidFill>
+                  <a:srgbClr val="555960"/>
+                </a:solidFill>
+                <a:latin typeface="Calibri"/>
+              </a:rPr>
+              <a:t>All interleavings of concurrent transactions</a:t>
+            </a:r>
+          </a:p>
+        </p:txBody>
+      </p:sp>
+      <p:sp>
+        <p:nvSpPr>
+          <p:cNvPr id="4" name="Block"/>
+          <p:cNvSpPr/>
+          <p:nvPr/>
+        </p:nvSpPr>
+        <p:spPr>
+          <a:xfrm>
+            <a:off x="1463040" y="2057400"/>
+            <a:ext cx="6217920" cy="822960"/>
+          </a:xfrm>
+          <a:prstGeom prst="rect">
+            <a:avLst/>
+          </a:prstGeom>
+          <a:solidFill>
+            <a:srgbClr val="F5F1E8"/>
+          </a:solidFill>
+          <a:ln>
+            <a:noFill/>
+          </a:ln>
+          <a:effectLst/>
+        </p:spPr>
+        <p:style>
+          <a:lnRef idx="1">
+            <a:schemeClr val="accent1"/>
+          </a:lnRef>
+          <a:fillRef idx="3">
+            <a:schemeClr val="accent1"/>
+          </a:fillRef>
+          <a:effectRef idx="2">
+            <a:schemeClr val="accent1"/>
+          </a:effectRef>
+          <a:fontRef idx="minor">
+            <a:schemeClr val="lt1"/>
+          </a:fontRef>
+        </p:style>
+        <p:txBody>
+          <a:bodyPr rtlCol="0" anchor="ctr" wrap="square"/>
+          <a:lstStyle/>
+          <a:p>
+            <a:pPr algn="ctr">
+              <a:spcAft>
+                <a:spcPts val="0"/>
+              </a:spcAft>
+            </a:pPr>
+            <a:r>
+              <a:rPr sz="2000" b="1">
+                <a:solidFill>
+                  <a:srgbClr val="5C4826"/>
+                </a:solidFill>
+                <a:latin typeface="Calibri"/>
+              </a:rPr>
+              <a:t>Histories your isolation level permits</a:t>
+            </a:r>
+          </a:p>
+        </p:txBody>
+      </p:sp>
+      <p:sp>
+        <p:nvSpPr>
+          <p:cNvPr id="5" name="Block"/>
+          <p:cNvSpPr/>
+          <p:nvPr/>
+        </p:nvSpPr>
+        <p:spPr>
+          <a:xfrm>
+            <a:off x="2514600" y="3108960"/>
+            <a:ext cx="4114800" cy="868680"/>
+          </a:xfrm>
+          <a:prstGeom prst="rect">
+            <a:avLst/>
+          </a:prstGeom>
+          <a:solidFill>
+            <a:srgbClr val="8E6F3E"/>
+          </a:solidFill>
+          <a:ln>
+            <a:noFill/>
+          </a:ln>
+          <a:effectLst/>
+        </p:spPr>
+        <p:style>
+          <a:lnRef idx="1">
+            <a:schemeClr val="accent1"/>
+          </a:lnRef>
+          <a:fillRef idx="3">
+            <a:schemeClr val="accent1"/>
+          </a:fillRef>
+          <a:effectRef idx="2">
+            <a:schemeClr val="accent1"/>
+          </a:effectRef>
+          <a:fontRef idx="minor">
+            <a:schemeClr val="lt1"/>
+          </a:fontRef>
+        </p:style>
+        <p:txBody>
+          <a:bodyPr rtlCol="0" anchor="ctr" wrap="square"/>
+          <a:lstStyle/>
+          <a:p>
+            <a:pPr algn="ctr">
+              <a:spcAft>
+                <a:spcPts val="0"/>
+              </a:spcAft>
+            </a:pPr>
+            <a:r>
+              <a:rPr sz="2000" b="1">
+                <a:solidFill>
+                  <a:srgbClr val="FFFFFF"/>
+                </a:solidFill>
+                <a:latin typeface="Calibri"/>
+              </a:rPr>
+              <a:t>SERIALIZABLE — equivalent to some one-at-a-time order</a:t>
+            </a:r>
+          </a:p>
+        </p:txBody>
+      </p:sp>
+      <p:sp>
+        <p:nvSpPr>
+          <p:cNvPr id="6" name="Card"/>
+          <p:cNvSpPr/>
+          <p:nvPr/>
+        </p:nvSpPr>
+        <p:spPr>
+          <a:xfrm>
+            <a:off x="411480" y="4251960"/>
+            <a:ext cx="8321040" cy="1417320"/>
+          </a:xfrm>
+          <a:prstGeom prst="rect">
+            <a:avLst/>
+          </a:prstGeom>
+          <a:solidFill>
+            <a:srgbClr val="F5F1E8"/>
+          </a:solidFill>
+          <a:ln>
+            <a:noFill/>
+          </a:ln>
+          <a:effectLst/>
+        </p:spPr>
+        <p:style>
+          <a:lnRef idx="1">
+            <a:schemeClr val="accent1"/>
+          </a:lnRef>
+          <a:fillRef idx="3">
+            <a:schemeClr val="accent1"/>
+          </a:fillRef>
+          <a:effectRef idx="2">
+            <a:schemeClr val="accent1"/>
+          </a:effectRef>
+          <a:fontRef idx="minor">
+            <a:schemeClr val="lt1"/>
+          </a:fontRef>
+        </p:style>
+        <p:txBody>
+          <a:bodyPr rtlCol="0" anchor="ctr" wrap="square"/>
+          <a:lstStyle/>
+          <a:p>
+            <a:pPr algn="ctr"/>
+          </a:p>
+        </p:txBody>
+      </p:sp>
+      <p:sp>
+        <p:nvSpPr>
+          <p:cNvPr id="7" name="CardBody"/>
+          <p:cNvSpPr txBox="1"/>
+          <p:nvPr/>
+        </p:nvSpPr>
+        <p:spPr>
+          <a:xfrm>
+            <a:off x="557784" y="4325112"/>
+            <a:ext cx="8046720" cy="1280160"/>
+          </a:xfrm>
+          <a:prstGeom prst="rect">
+            <a:avLst/>
+          </a:prstGeom>
+          <a:noFill/>
+        </p:spPr>
+        <p:txBody>
+          <a:bodyPr wrap="square">
+            <a:spAutoFit/>
+          </a:bodyPr>
+          <a:lstStyle/>
+          <a:p>
+            <a:pPr algn="l">
+              <a:spcAft>
+                <a:spcPts val="300"/>
+              </a:spcAft>
+            </a:pPr>
+            <a:r>
+              <a:rPr sz="2000" b="1">
+                <a:solidFill>
+                  <a:srgbClr val="5C4826"/>
+                </a:solidFill>
+                <a:latin typeface="Calibri"/>
+              </a:rPr>
+              <a:t>Act II's move again: correctness = every permitted history preserves the invariant</a:t>
+            </a:r>
+          </a:p>
+          <a:p>
+            <a:pPr algn="l">
+              <a:spcAft>
+                <a:spcPts val="400"/>
+              </a:spcAft>
+            </a:pPr>
+            <a:r>
+              <a:rPr sz="2000" b="0">
+                <a:solidFill>
+                  <a:srgbClr val="555960"/>
+                </a:solidFill>
+                <a:latin typeface="Calibri"/>
+              </a:rPr>
+              <a:t>Under serializability our race cannot happen: one request must appear to run second — and then its check sees the other's row.</a:t>
+            </a:r>
+          </a:p>
+        </p:txBody>
+      </p:sp>
+      <p:sp>
+        <p:nvSpPr>
+          <p:cNvPr id="8" name="FooterBand"/>
+          <p:cNvSpPr/>
+          <p:nvPr/>
+        </p:nvSpPr>
+        <p:spPr>
+          <a:xfrm>
+            <a:off x="274320" y="5879592"/>
+            <a:ext cx="8595360" cy="502920"/>
+          </a:xfrm>
+          <a:prstGeom prst="rect">
+            <a:avLst/>
+          </a:prstGeom>
+          <a:solidFill>
+            <a:srgbClr val="8E6F3E"/>
+          </a:solidFill>
+          <a:ln>
+            <a:noFill/>
+          </a:ln>
+          <a:effectLst/>
+        </p:spPr>
+        <p:style>
+          <a:lnRef idx="1">
+            <a:schemeClr val="accent1"/>
+          </a:lnRef>
+          <a:fillRef idx="3">
+            <a:schemeClr val="accent1"/>
+          </a:fillRef>
+          <a:effectRef idx="2">
+            <a:schemeClr val="accent1"/>
+          </a:effectRef>
+          <a:fontRef idx="minor">
+            <a:schemeClr val="lt1"/>
+          </a:fontRef>
+        </p:style>
+        <p:txBody>
+          <a:bodyPr rtlCol="0" anchor="ctr" wrap="square"/>
+          <a:lstStyle/>
+          <a:p>
+            <a:pPr algn="ctr"/>
+          </a:p>
+        </p:txBody>
+      </p:sp>
+      <p:sp>
+        <p:nvSpPr>
+          <p:cNvPr id="9" name="FooterBandText"/>
+          <p:cNvSpPr txBox="1"/>
+          <p:nvPr/>
+        </p:nvSpPr>
+        <p:spPr>
+          <a:xfrm>
+            <a:off x="384048" y="5897880"/>
+            <a:ext cx="8375904" cy="457200"/>
+          </a:xfrm>
+          <a:prstGeom prst="rect">
+            <a:avLst/>
+          </a:prstGeom>
+          <a:noFill/>
+        </p:spPr>
+        <p:txBody>
+          <a:bodyPr wrap="square">
+            <a:spAutoFit/>
+          </a:bodyPr>
+          <a:lstStyle/>
+          <a:p>
+            <a:pPr algn="ctr">
+              <a:spcAft>
+                <a:spcPts val="400"/>
+              </a:spcAft>
+            </a:pPr>
+            <a:r>
+              <a:rPr sz="2000" b="1">
+                <a:solidFill>
+                  <a:srgbClr val="FFFFFF"/>
+                </a:solidFill>
+                <a:latin typeface="Calibri"/>
+              </a:rPr>
+              <a:t>Serializability is a correctness criterion, not a feature flag</a:t>
+            </a:r>
+          </a:p>
+        </p:txBody>
+      </p:sp>
+    </p:spTree>
+  </p:cSld>
+  <p:clrMapOvr>
+    <a:masterClrMapping/>
+  </p:clrMapOvr>
+</p:sld>
+</file>
+
+<file path=ppt/slides/slide22.xml><?xml version="1.0" encoding="utf-8"?>
+<p:sld xmlns:a="http://schemas.openxmlformats.org/drawingml/2006/main" xmlns:p="http://schemas.openxmlformats.org/presentationml/2006/main" xmlns:r="http://schemas.openxmlformats.org/officeDocument/2006/relationships">
+  <p:cSld>
+    <p:spTree>
+      <p:nvGrpSpPr>
+        <p:cNvPr id="1" name=""/>
+        <p:cNvGrpSpPr/>
+        <p:nvPr/>
+      </p:nvGrpSpPr>
+      <p:grpSpPr/>
+      <p:sp>
+        <p:nvSpPr>
+          <p:cNvPr id="2" name="Title"/>
+          <p:cNvSpPr txBox="1"/>
+          <p:nvPr/>
+        </p:nvSpPr>
+        <p:spPr>
+          <a:xfrm>
+            <a:off x="274320" y="128016"/>
+            <a:ext cx="8595360" cy="594360"/>
+          </a:xfrm>
+          <a:prstGeom prst="rect">
+            <a:avLst/>
+          </a:prstGeom>
+          <a:noFill/>
+        </p:spPr>
+        <p:txBody>
+          <a:bodyPr wrap="square">
+            <a:spAutoFit/>
+          </a:bodyPr>
+          <a:lstStyle/>
+          <a:p>
+            <a:pPr algn="l">
+              <a:spcAft>
+                <a:spcPts val="400"/>
+              </a:spcAft>
+            </a:pPr>
+            <a:r>
+              <a:rPr sz="2400" b="0">
+                <a:solidFill>
+                  <a:srgbClr val="2D2D2D"/>
+                </a:solidFill>
+                <a:latin typeface="Calibri"/>
+              </a:rPr>
+              <a:t>Isolation levels are an engineering choice</a:t>
+            </a:r>
+          </a:p>
+        </p:txBody>
+      </p:sp>
+      <p:sp>
+        <p:nvSpPr>
+          <p:cNvPr id="3" name="Card"/>
+          <p:cNvSpPr/>
+          <p:nvPr/>
+        </p:nvSpPr>
+        <p:spPr>
+          <a:xfrm>
+            <a:off x="411480" y="960120"/>
+            <a:ext cx="8321040" cy="1115568"/>
+          </a:xfrm>
+          <a:prstGeom prst="rect">
+            <a:avLst/>
+          </a:prstGeom>
+          <a:solidFill>
+            <a:srgbClr val="F5F1E8"/>
+          </a:solidFill>
+          <a:ln>
+            <a:noFill/>
+          </a:ln>
+          <a:effectLst/>
+        </p:spPr>
+        <p:style>
+          <a:lnRef idx="1">
+            <a:schemeClr val="accent1"/>
+          </a:lnRef>
+          <a:fillRef idx="3">
+            <a:schemeClr val="accent1"/>
+          </a:fillRef>
+          <a:effectRef idx="2">
+            <a:schemeClr val="accent1"/>
+          </a:effectRef>
+          <a:fontRef idx="minor">
+            <a:schemeClr val="lt1"/>
+          </a:fontRef>
+        </p:style>
+        <p:txBody>
+          <a:bodyPr rtlCol="0" anchor="ctr" wrap="square"/>
+          <a:lstStyle/>
+          <a:p>
+            <a:pPr algn="ctr"/>
+          </a:p>
+        </p:txBody>
+      </p:sp>
+      <p:sp>
+        <p:nvSpPr>
+          <p:cNvPr id="4" name="RowLabel"/>
+          <p:cNvSpPr txBox="1"/>
+          <p:nvPr/>
+        </p:nvSpPr>
+        <p:spPr>
+          <a:xfrm>
+            <a:off x="557784" y="1014984"/>
+            <a:ext cx="3017520" cy="1005840"/>
+          </a:xfrm>
+          <a:prstGeom prst="rect">
+            <a:avLst/>
+          </a:prstGeom>
+          <a:noFill/>
+        </p:spPr>
+        <p:txBody>
+          <a:bodyPr wrap="square" anchor="ctr">
+            <a:spAutoFit/>
+          </a:bodyPr>
+          <a:lstStyle/>
+          <a:p>
+            <a:pPr algn="l">
+              <a:spcAft>
+                <a:spcPts val="400"/>
+              </a:spcAft>
+            </a:pPr>
+            <a:r>
+              <a:rPr sz="2000" b="1">
+                <a:solidFill>
+                  <a:srgbClr val="8E6F3E"/>
+                </a:solidFill>
+                <a:latin typeface="Calibri"/>
+              </a:rPr>
+              <a:t>READ COMMITTED</a:t>
+            </a:r>
+          </a:p>
+        </p:txBody>
+      </p:sp>
+      <p:sp>
+        <p:nvSpPr>
+          <p:cNvPr id="5" name="RowBody"/>
+          <p:cNvSpPr txBox="1"/>
+          <p:nvPr/>
+        </p:nvSpPr>
+        <p:spPr>
+          <a:xfrm>
+            <a:off x="3703320" y="1014984"/>
+            <a:ext cx="4892040" cy="1005840"/>
+          </a:xfrm>
+          <a:prstGeom prst="rect">
+            <a:avLst/>
+          </a:prstGeom>
+          <a:noFill/>
+        </p:spPr>
+        <p:txBody>
+          <a:bodyPr wrap="square">
+            <a:spAutoFit/>
+          </a:bodyPr>
+          <a:lstStyle/>
+          <a:p>
+            <a:pPr algn="l">
+              <a:spcAft>
+                <a:spcPts val="200"/>
+              </a:spcAft>
+            </a:pPr>
+            <a:r>
+              <a:rPr sz="2000" b="1">
+                <a:solidFill>
+                  <a:srgbClr val="C01B1B"/>
+                </a:solidFill>
+                <a:latin typeface="Calibri"/>
+              </a:rPr>
+              <a:t>Our race is permitted</a:t>
+            </a:r>
+          </a:p>
+          <a:p>
+            <a:pPr algn="l">
+              <a:spcAft>
+                <a:spcPts val="400"/>
+              </a:spcAft>
+            </a:pPr>
+            <a:r>
+              <a:rPr sz="2000" b="0">
+                <a:solidFill>
+                  <a:srgbClr val="555960"/>
+                </a:solidFill>
+                <a:latin typeface="Calibri"/>
+              </a:rPr>
+              <a:t>A common default: no dirty reads, but checks still interleave</a:t>
+            </a:r>
+          </a:p>
+        </p:txBody>
+      </p:sp>
+      <p:sp>
+        <p:nvSpPr>
+          <p:cNvPr id="6" name="Card"/>
+          <p:cNvSpPr/>
+          <p:nvPr/>
+        </p:nvSpPr>
+        <p:spPr>
+          <a:xfrm>
+            <a:off x="411480" y="2212848"/>
+            <a:ext cx="8321040" cy="1115568"/>
+          </a:xfrm>
+          <a:prstGeom prst="rect">
+            <a:avLst/>
+          </a:prstGeom>
+          <a:solidFill>
+            <a:srgbClr val="F5F1E8"/>
+          </a:solidFill>
+          <a:ln>
+            <a:noFill/>
+          </a:ln>
+          <a:effectLst/>
+        </p:spPr>
+        <p:style>
+          <a:lnRef idx="1">
+            <a:schemeClr val="accent1"/>
+          </a:lnRef>
+          <a:fillRef idx="3">
+            <a:schemeClr val="accent1"/>
+          </a:fillRef>
+          <a:effectRef idx="2">
+            <a:schemeClr val="accent1"/>
+          </a:effectRef>
+          <a:fontRef idx="minor">
+            <a:schemeClr val="lt1"/>
+          </a:fontRef>
+        </p:style>
+        <p:txBody>
+          <a:bodyPr rtlCol="0" anchor="ctr" wrap="square"/>
+          <a:lstStyle/>
+          <a:p>
+            <a:pPr algn="ctr"/>
+          </a:p>
+        </p:txBody>
+      </p:sp>
+      <p:sp>
+        <p:nvSpPr>
+          <p:cNvPr id="7" name="RowLabel"/>
+          <p:cNvSpPr txBox="1"/>
+          <p:nvPr/>
+        </p:nvSpPr>
+        <p:spPr>
+          <a:xfrm>
+            <a:off x="557784" y="2267712"/>
+            <a:ext cx="3017520" cy="1005840"/>
+          </a:xfrm>
+          <a:prstGeom prst="rect">
+            <a:avLst/>
+          </a:prstGeom>
+          <a:noFill/>
+        </p:spPr>
+        <p:txBody>
+          <a:bodyPr wrap="square" anchor="ctr">
+            <a:spAutoFit/>
+          </a:bodyPr>
+          <a:lstStyle/>
+          <a:p>
+            <a:pPr algn="l">
+              <a:spcAft>
+                <a:spcPts val="400"/>
+              </a:spcAft>
+            </a:pPr>
+            <a:r>
+              <a:rPr sz="2000" b="1">
+                <a:solidFill>
+                  <a:srgbClr val="8E6F3E"/>
+                </a:solidFill>
+                <a:latin typeface="Calibri"/>
+              </a:rPr>
+              <a:t>SNAPSHOT / REPEATABLE READ</a:t>
+            </a:r>
+          </a:p>
+        </p:txBody>
+      </p:sp>
+      <p:sp>
+        <p:nvSpPr>
+          <p:cNvPr id="8" name="RowBody"/>
+          <p:cNvSpPr txBox="1"/>
+          <p:nvPr/>
+        </p:nvSpPr>
+        <p:spPr>
+          <a:xfrm>
+            <a:off x="3703320" y="2267712"/>
+            <a:ext cx="4892040" cy="1005840"/>
+          </a:xfrm>
+          <a:prstGeom prst="rect">
+            <a:avLst/>
+          </a:prstGeom>
+          <a:noFill/>
+        </p:spPr>
+        <p:txBody>
+          <a:bodyPr wrap="square">
+            <a:spAutoFit/>
+          </a:bodyPr>
+          <a:lstStyle/>
+          <a:p>
+            <a:pPr algn="l">
+              <a:spcAft>
+                <a:spcPts val="200"/>
+              </a:spcAft>
+            </a:pPr>
+            <a:r>
+              <a:rPr sz="2000" b="1">
+                <a:solidFill>
+                  <a:srgbClr val="C01B1B"/>
+                </a:solidFill>
+                <a:latin typeface="Calibri"/>
+              </a:rPr>
+              <a:t>Our race is STILL permitted</a:t>
+            </a:r>
+          </a:p>
+          <a:p>
+            <a:pPr algn="l">
+              <a:spcAft>
+                <a:spcPts val="400"/>
+              </a:spcAft>
+            </a:pPr>
+            <a:r>
+              <a:rPr sz="2000" b="0">
+                <a:solidFill>
+                  <a:srgbClr val="555960"/>
+                </a:solidFill>
+                <a:latin typeface="Calibri"/>
+              </a:rPr>
+              <a:t>Each reads a frozen view; both check, neither sees the other (write skew)</a:t>
+            </a:r>
+          </a:p>
+        </p:txBody>
+      </p:sp>
+      <p:sp>
+        <p:nvSpPr>
+          <p:cNvPr id="9" name="Card"/>
+          <p:cNvSpPr/>
+          <p:nvPr/>
+        </p:nvSpPr>
+        <p:spPr>
+          <a:xfrm>
+            <a:off x="411480" y="3465576"/>
+            <a:ext cx="8321040" cy="1115568"/>
+          </a:xfrm>
+          <a:prstGeom prst="rect">
+            <a:avLst/>
+          </a:prstGeom>
+          <a:solidFill>
+            <a:srgbClr val="FCFAF6"/>
+          </a:solidFill>
+          <a:ln>
+            <a:noFill/>
+          </a:ln>
+          <a:effectLst/>
+        </p:spPr>
+        <p:style>
+          <a:lnRef idx="1">
+            <a:schemeClr val="accent1"/>
+          </a:lnRef>
+          <a:fillRef idx="3">
+            <a:schemeClr val="accent1"/>
+          </a:fillRef>
+          <a:effectRef idx="2">
+            <a:schemeClr val="accent1"/>
+          </a:effectRef>
+          <a:fontRef idx="minor">
+            <a:schemeClr val="lt1"/>
+          </a:fontRef>
+        </p:style>
+        <p:txBody>
+          <a:bodyPr rtlCol="0" anchor="ctr" wrap="square"/>
+          <a:lstStyle/>
+          <a:p>
+            <a:pPr algn="ctr"/>
+          </a:p>
+        </p:txBody>
+      </p:sp>
+      <p:sp>
+        <p:nvSpPr>
+          <p:cNvPr id="10" name="RowLabel"/>
+          <p:cNvSpPr txBox="1"/>
+          <p:nvPr/>
+        </p:nvSpPr>
+        <p:spPr>
+          <a:xfrm>
+            <a:off x="557784" y="3520440"/>
+            <a:ext cx="3017520" cy="1005840"/>
+          </a:xfrm>
+          <a:prstGeom prst="rect">
+            <a:avLst/>
+          </a:prstGeom>
+          <a:noFill/>
+        </p:spPr>
+        <p:txBody>
+          <a:bodyPr wrap="square" anchor="ctr">
+            <a:spAutoFit/>
+          </a:bodyPr>
+          <a:lstStyle/>
+          <a:p>
+            <a:pPr algn="l">
+              <a:spcAft>
+                <a:spcPts val="400"/>
+              </a:spcAft>
+            </a:pPr>
+            <a:r>
+              <a:rPr sz="2000" b="1">
+                <a:solidFill>
+                  <a:srgbClr val="8E6F3E"/>
+                </a:solidFill>
+                <a:latin typeface="Calibri"/>
+              </a:rPr>
+              <a:t>SERIALIZABLE</a:t>
+            </a:r>
+          </a:p>
+        </p:txBody>
+      </p:sp>
+      <p:sp>
+        <p:nvSpPr>
+          <p:cNvPr id="11" name="RowBody"/>
+          <p:cNvSpPr txBox="1"/>
+          <p:nvPr/>
+        </p:nvSpPr>
+        <p:spPr>
+          <a:xfrm>
+            <a:off x="3703320" y="3520440"/>
+            <a:ext cx="4892040" cy="1005840"/>
+          </a:xfrm>
+          <a:prstGeom prst="rect">
+            <a:avLst/>
+          </a:prstGeom>
+          <a:noFill/>
+        </p:spPr>
+        <p:txBody>
+          <a:bodyPr wrap="square">
+            <a:spAutoFit/>
+          </a:bodyPr>
+          <a:lstStyle/>
+          <a:p>
+            <a:pPr algn="l">
+              <a:spcAft>
+                <a:spcPts val="200"/>
+              </a:spcAft>
+            </a:pPr>
+            <a:r>
+              <a:rPr sz="2000" b="1">
+                <a:solidFill>
+                  <a:srgbClr val="5C4826"/>
+                </a:solidFill>
+                <a:latin typeface="Calibri"/>
+              </a:rPr>
+              <a:t>Race excluded — one transaction aborts</a:t>
+            </a:r>
+          </a:p>
+          <a:p>
+            <a:pPr algn="l">
+              <a:spcAft>
+                <a:spcPts val="400"/>
+              </a:spcAft>
+            </a:pPr>
+            <a:r>
+              <a:rPr sz="2000" b="0">
+                <a:solidFill>
+                  <a:srgbClr val="555960"/>
+                </a:solidFill>
+                <a:latin typeface="Calibri"/>
+              </a:rPr>
+              <a:t>Your application must catch the abort and retry</a:t>
+            </a:r>
+          </a:p>
+        </p:txBody>
+      </p:sp>
+      <p:sp>
+        <p:nvSpPr>
+          <p:cNvPr id="12" name="Card"/>
+          <p:cNvSpPr/>
+          <p:nvPr/>
+        </p:nvSpPr>
+        <p:spPr>
+          <a:xfrm>
+            <a:off x="411480" y="4800600"/>
+            <a:ext cx="8321040" cy="868680"/>
+          </a:xfrm>
+          <a:prstGeom prst="rect">
+            <a:avLst/>
+          </a:prstGeom>
+          <a:solidFill>
+            <a:srgbClr val="FCFAF6"/>
+          </a:solidFill>
+          <a:ln>
+            <a:noFill/>
+          </a:ln>
+          <a:effectLst/>
+        </p:spPr>
+        <p:style>
+          <a:lnRef idx="1">
+            <a:schemeClr val="accent1"/>
+          </a:lnRef>
+          <a:fillRef idx="3">
+            <a:schemeClr val="accent1"/>
+          </a:fillRef>
+          <a:effectRef idx="2">
+            <a:schemeClr val="accent1"/>
+          </a:effectRef>
+          <a:fontRef idx="minor">
+            <a:schemeClr val="lt1"/>
+          </a:fontRef>
+        </p:style>
+        <p:txBody>
+          <a:bodyPr rtlCol="0" anchor="ctr" wrap="square"/>
+          <a:lstStyle/>
+          <a:p>
+            <a:pPr algn="ctr"/>
+          </a:p>
+        </p:txBody>
+      </p:sp>
+      <p:sp>
+        <p:nvSpPr>
+          <p:cNvPr id="13" name="CardBody"/>
+          <p:cNvSpPr txBox="1"/>
+          <p:nvPr/>
+        </p:nvSpPr>
+        <p:spPr>
+          <a:xfrm>
+            <a:off x="557784" y="4855464"/>
+            <a:ext cx="8046720" cy="768096"/>
+          </a:xfrm>
+          <a:prstGeom prst="rect">
+            <a:avLst/>
+          </a:prstGeom>
+          <a:noFill/>
+        </p:spPr>
+        <p:txBody>
+          <a:bodyPr wrap="square">
+            <a:spAutoFit/>
+          </a:bodyPr>
+          <a:lstStyle/>
+          <a:p>
+            <a:pPr algn="l">
+              <a:spcAft>
+                <a:spcPts val="100"/>
+              </a:spcAft>
+            </a:pPr>
+            <a:r>
+              <a:rPr sz="2000" b="1">
+                <a:solidFill>
+                  <a:srgbClr val="5C4826"/>
+                </a:solidFill>
+                <a:latin typeface="Calibri"/>
+              </a:rPr>
+              <a:t>The default is a choice someone else made for you</a:t>
+            </a:r>
+          </a:p>
+          <a:p>
+            <a:pPr algn="l">
+              <a:spcAft>
+                <a:spcPts val="400"/>
+              </a:spcAft>
+            </a:pPr>
+            <a:r>
+              <a:rPr sz="2000" b="0">
+                <a:solidFill>
+                  <a:srgbClr val="555960"/>
+                </a:solidFill>
+                <a:latin typeface="Calibri"/>
+              </a:rPr>
+              <a:t>Know your engine's default before trusting any check-then-act.</a:t>
+            </a:r>
+          </a:p>
+        </p:txBody>
+      </p:sp>
+      <p:sp>
+        <p:nvSpPr>
+          <p:cNvPr id="14" name="FooterBand"/>
+          <p:cNvSpPr/>
+          <p:nvPr/>
+        </p:nvSpPr>
+        <p:spPr>
+          <a:xfrm>
+            <a:off x="274320" y="5879592"/>
+            <a:ext cx="8595360" cy="502920"/>
+          </a:xfrm>
+          <a:prstGeom prst="rect">
+            <a:avLst/>
+          </a:prstGeom>
+          <a:solidFill>
+            <a:srgbClr val="8E6F3E"/>
+          </a:solidFill>
+          <a:ln>
+            <a:noFill/>
+          </a:ln>
+          <a:effectLst/>
+        </p:spPr>
+        <p:style>
+          <a:lnRef idx="1">
+            <a:schemeClr val="accent1"/>
+          </a:lnRef>
+          <a:fillRef idx="3">
+            <a:schemeClr val="accent1"/>
+          </a:fillRef>
+          <a:effectRef idx="2">
+            <a:schemeClr val="accent1"/>
+          </a:effectRef>
+          <a:fontRef idx="minor">
+            <a:schemeClr val="lt1"/>
+          </a:fontRef>
+        </p:style>
+        <p:txBody>
+          <a:bodyPr rtlCol="0" anchor="ctr" wrap="square"/>
+          <a:lstStyle/>
+          <a:p>
+            <a:pPr algn="ctr"/>
+          </a:p>
+        </p:txBody>
+      </p:sp>
+      <p:sp>
+        <p:nvSpPr>
+          <p:cNvPr id="15" name="FooterBandText"/>
+          <p:cNvSpPr txBox="1"/>
+          <p:nvPr/>
+        </p:nvSpPr>
+        <p:spPr>
+          <a:xfrm>
+            <a:off x="384048" y="5897880"/>
+            <a:ext cx="8375904" cy="457200"/>
+          </a:xfrm>
+          <a:prstGeom prst="rect">
+            <a:avLst/>
+          </a:prstGeom>
+          <a:noFill/>
+        </p:spPr>
+        <p:txBody>
+          <a:bodyPr wrap="square">
+            <a:spAutoFit/>
+          </a:bodyPr>
+          <a:lstStyle/>
+          <a:p>
+            <a:pPr algn="ctr">
+              <a:spcAft>
+                <a:spcPts val="400"/>
+              </a:spcAft>
+            </a:pPr>
+            <a:r>
+              <a:rPr sz="2000" b="1">
+                <a:solidFill>
+                  <a:srgbClr val="FFFFFF"/>
+                </a:solidFill>
+                <a:latin typeface="Calibri"/>
+              </a:rPr>
+              <a:t>Choosing an isolation level is choosing your failure modes</a:t>
+            </a:r>
+          </a:p>
+        </p:txBody>
+      </p:sp>
+    </p:spTree>
+  </p:cSld>
+  <p:clrMapOvr>
+    <a:masterClrMapping/>
+  </p:clrMapOvr>
+</p:sld>
+</file>
+
+<file path=ppt/slides/slide23.xml><?xml version="1.0" encoding="utf-8"?>
+<p:sld xmlns:a="http://schemas.openxmlformats.org/drawingml/2006/main" xmlns:p="http://schemas.openxmlformats.org/presentationml/2006/main" xmlns:r="http://schemas.openxmlformats.org/officeDocument/2006/relationships">
+  <p:cSld>
+    <p:spTree>
+      <p:nvGrpSpPr>
+        <p:cNvPr id="1" name=""/>
+        <p:cNvGrpSpPr/>
+        <p:nvPr/>
+      </p:nvGrpSpPr>
+      <p:grpSpPr/>
+      <p:sp>
+        <p:nvSpPr>
+          <p:cNvPr id="2" name="Title"/>
+          <p:cNvSpPr txBox="1"/>
+          <p:nvPr/>
+        </p:nvSpPr>
+        <p:spPr>
+          <a:xfrm>
+            <a:off x="274320" y="128016"/>
+            <a:ext cx="8595360" cy="594360"/>
+          </a:xfrm>
+          <a:prstGeom prst="rect">
+            <a:avLst/>
+          </a:prstGeom>
+          <a:noFill/>
+        </p:spPr>
+        <p:txBody>
+          <a:bodyPr wrap="square">
+            <a:spAutoFit/>
+          </a:bodyPr>
+          <a:lstStyle/>
+          <a:p>
+            <a:pPr algn="l">
+              <a:spcAft>
+                <a:spcPts val="400"/>
+              </a:spcAft>
+            </a:pPr>
+            <a:r>
+              <a:rPr sz="2400" b="0">
+                <a:solidFill>
+                  <a:srgbClr val="2D2D2D"/>
+                </a:solidFill>
+                <a:latin typeface="Calibri"/>
+              </a:rPr>
+              <a:t>Three ways to actually prevent double-booking</a:t>
+            </a:r>
+          </a:p>
+        </p:txBody>
+      </p:sp>
+      <p:sp>
+        <p:nvSpPr>
+          <p:cNvPr id="3" name="Card"/>
+          <p:cNvSpPr/>
+          <p:nvPr/>
+        </p:nvSpPr>
+        <p:spPr>
+          <a:xfrm>
+            <a:off x="411480" y="868680"/>
+            <a:ext cx="8321040" cy="1298448"/>
+          </a:xfrm>
+          <a:prstGeom prst="rect">
+            <a:avLst/>
+          </a:prstGeom>
+          <a:solidFill>
+            <a:srgbClr val="F5F1E8"/>
+          </a:solidFill>
+          <a:ln>
+            <a:noFill/>
+          </a:ln>
+          <a:effectLst/>
+        </p:spPr>
+        <p:style>
+          <a:lnRef idx="1">
+            <a:schemeClr val="accent1"/>
+          </a:lnRef>
+          <a:fillRef idx="3">
+            <a:schemeClr val="accent1"/>
+          </a:fillRef>
+          <a:effectRef idx="2">
+            <a:schemeClr val="accent1"/>
+          </a:effectRef>
+          <a:fontRef idx="minor">
+            <a:schemeClr val="lt1"/>
+          </a:fontRef>
+        </p:style>
+        <p:txBody>
+          <a:bodyPr rtlCol="0" anchor="ctr" wrap="square"/>
+          <a:lstStyle/>
+          <a:p>
+            <a:pPr algn="ctr"/>
+          </a:p>
+        </p:txBody>
+      </p:sp>
+      <p:sp>
+        <p:nvSpPr>
+          <p:cNvPr id="4" name="RowLabel"/>
+          <p:cNvSpPr txBox="1"/>
+          <p:nvPr/>
+        </p:nvSpPr>
+        <p:spPr>
+          <a:xfrm>
+            <a:off x="557784" y="923544"/>
+            <a:ext cx="2560320" cy="1188720"/>
+          </a:xfrm>
+          <a:prstGeom prst="rect">
+            <a:avLst/>
+          </a:prstGeom>
+          <a:noFill/>
+        </p:spPr>
+        <p:txBody>
+          <a:bodyPr wrap="square" anchor="ctr">
+            <a:spAutoFit/>
+          </a:bodyPr>
+          <a:lstStyle/>
+          <a:p>
+            <a:pPr algn="l">
+              <a:spcAft>
+                <a:spcPts val="400"/>
+              </a:spcAft>
+            </a:pPr>
+            <a:r>
+              <a:rPr sz="2000" b="1">
+                <a:solidFill>
+                  <a:srgbClr val="8E6F3E"/>
+                </a:solidFill>
+                <a:latin typeface="Calibri"/>
+              </a:rPr>
+              <a:t>EXCLUSION CONSTRAINT</a:t>
+            </a:r>
+          </a:p>
+        </p:txBody>
+      </p:sp>
+      <p:sp>
+        <p:nvSpPr>
+          <p:cNvPr id="5" name="RowBody"/>
+          <p:cNvSpPr txBox="1"/>
+          <p:nvPr/>
+        </p:nvSpPr>
+        <p:spPr>
+          <a:xfrm>
+            <a:off x="3246120" y="923544"/>
+            <a:ext cx="5349240" cy="1188720"/>
+          </a:xfrm>
+          <a:prstGeom prst="rect">
+            <a:avLst/>
+          </a:prstGeom>
+          <a:noFill/>
+        </p:spPr>
+        <p:txBody>
+          <a:bodyPr wrap="square">
+            <a:spAutoFit/>
+          </a:bodyPr>
+          <a:lstStyle/>
+          <a:p>
+            <a:pPr algn="l">
+              <a:spcAft>
+                <a:spcPts val="200"/>
+              </a:spcAft>
+            </a:pPr>
+            <a:r>
+              <a:rPr sz="2000" b="0">
+                <a:solidFill>
+                  <a:srgbClr val="5C4826"/>
+                </a:solidFill>
+                <a:latin typeface="Calibri"/>
+              </a:rPr>
+              <a:t>EXCLUDE (room =, time range &amp;&amp;): the SCHEMA states the invariant; the engine rejects the second insert</a:t>
+            </a:r>
+          </a:p>
+          <a:p>
+            <a:pPr algn="l">
+              <a:spcAft>
+                <a:spcPts val="400"/>
+              </a:spcAft>
+            </a:pPr>
+            <a:r>
+              <a:rPr sz="2000" b="0">
+                <a:solidFill>
+                  <a:srgbClr val="555960"/>
+                </a:solidFill>
+                <a:latin typeface="Calibri"/>
+              </a:rPr>
+              <a:t>engine-specific (e.g. Postgres GiST)</a:t>
+            </a:r>
+          </a:p>
+        </p:txBody>
+      </p:sp>
+      <p:sp>
+        <p:nvSpPr>
+          <p:cNvPr id="6" name="Card"/>
+          <p:cNvSpPr/>
+          <p:nvPr/>
+        </p:nvSpPr>
+        <p:spPr>
+          <a:xfrm>
+            <a:off x="411480" y="2258568"/>
+            <a:ext cx="8321040" cy="1298448"/>
+          </a:xfrm>
+          <a:prstGeom prst="rect">
+            <a:avLst/>
+          </a:prstGeom>
+          <a:solidFill>
+            <a:srgbClr val="FCFAF6"/>
+          </a:solidFill>
+          <a:ln>
+            <a:noFill/>
+          </a:ln>
+          <a:effectLst/>
+        </p:spPr>
+        <p:style>
+          <a:lnRef idx="1">
+            <a:schemeClr val="accent1"/>
+          </a:lnRef>
+          <a:fillRef idx="3">
+            <a:schemeClr val="accent1"/>
+          </a:fillRef>
+          <a:effectRef idx="2">
+            <a:schemeClr val="accent1"/>
+          </a:effectRef>
+          <a:fontRef idx="minor">
+            <a:schemeClr val="lt1"/>
+          </a:fontRef>
+        </p:style>
+        <p:txBody>
+          <a:bodyPr rtlCol="0" anchor="ctr" wrap="square"/>
+          <a:lstStyle/>
+          <a:p>
+            <a:pPr algn="ctr"/>
+          </a:p>
+        </p:txBody>
+      </p:sp>
+      <p:sp>
+        <p:nvSpPr>
+          <p:cNvPr id="7" name="RowLabel"/>
+          <p:cNvSpPr txBox="1"/>
+          <p:nvPr/>
+        </p:nvSpPr>
+        <p:spPr>
+          <a:xfrm>
+            <a:off x="557784" y="2313432"/>
+            <a:ext cx="2560320" cy="1188720"/>
+          </a:xfrm>
+          <a:prstGeom prst="rect">
+            <a:avLst/>
+          </a:prstGeom>
+          <a:noFill/>
+        </p:spPr>
+        <p:txBody>
+          <a:bodyPr wrap="square" anchor="ctr">
+            <a:spAutoFit/>
+          </a:bodyPr>
+          <a:lstStyle/>
+          <a:p>
+            <a:pPr algn="l">
+              <a:spcAft>
+                <a:spcPts val="400"/>
+              </a:spcAft>
+            </a:pPr>
+            <a:r>
+              <a:rPr sz="2000" b="1">
+                <a:solidFill>
+                  <a:srgbClr val="8E6F3E"/>
+                </a:solidFill>
+                <a:latin typeface="Calibri"/>
+              </a:rPr>
+              <a:t>SERIALIZABLE + RETRY</a:t>
+            </a:r>
+          </a:p>
+        </p:txBody>
+      </p:sp>
+      <p:sp>
+        <p:nvSpPr>
+          <p:cNvPr id="8" name="RowBody"/>
+          <p:cNvSpPr txBox="1"/>
+          <p:nvPr/>
+        </p:nvSpPr>
+        <p:spPr>
+          <a:xfrm>
+            <a:off x="3246120" y="2313432"/>
+            <a:ext cx="5349240" cy="1188720"/>
+          </a:xfrm>
+          <a:prstGeom prst="rect">
+            <a:avLst/>
+          </a:prstGeom>
+          <a:noFill/>
+        </p:spPr>
+        <p:txBody>
+          <a:bodyPr wrap="square">
+            <a:spAutoFit/>
+          </a:bodyPr>
+          <a:lstStyle/>
+          <a:p>
+            <a:pPr algn="l">
+              <a:spcAft>
+                <a:spcPts val="200"/>
+              </a:spcAft>
+            </a:pPr>
+            <a:r>
+              <a:rPr sz="2000" b="0">
+                <a:solidFill>
+                  <a:srgbClr val="5C4826"/>
+                </a:solidFill>
+                <a:latin typeface="Calibri"/>
+              </a:rPr>
+              <a:t>The ISOLATION CONTRACT excludes the bad history; one transaction aborts</a:t>
+            </a:r>
+          </a:p>
+          <a:p>
+            <a:pPr algn="l">
+              <a:spcAft>
+                <a:spcPts val="400"/>
+              </a:spcAft>
+            </a:pPr>
+            <a:r>
+              <a:rPr sz="2000" b="0">
+                <a:solidFill>
+                  <a:srgbClr val="555960"/>
+                </a:solidFill>
+                <a:latin typeface="Calibri"/>
+              </a:rPr>
+              <a:t>you must catch aborts and retry; contention costs throughput</a:t>
+            </a:r>
+          </a:p>
+        </p:txBody>
+      </p:sp>
+      <p:sp>
+        <p:nvSpPr>
+          <p:cNvPr id="9" name="Card"/>
+          <p:cNvSpPr/>
+          <p:nvPr/>
+        </p:nvSpPr>
+        <p:spPr>
+          <a:xfrm>
+            <a:off x="411480" y="3648456"/>
+            <a:ext cx="8321040" cy="1298448"/>
+          </a:xfrm>
+          <a:prstGeom prst="rect">
+            <a:avLst/>
+          </a:prstGeom>
+          <a:solidFill>
+            <a:srgbClr val="F5F1E8"/>
+          </a:solidFill>
+          <a:ln>
+            <a:noFill/>
+          </a:ln>
+          <a:effectLst/>
+        </p:spPr>
+        <p:style>
+          <a:lnRef idx="1">
+            <a:schemeClr val="accent1"/>
+          </a:lnRef>
+          <a:fillRef idx="3">
+            <a:schemeClr val="accent1"/>
+          </a:fillRef>
+          <a:effectRef idx="2">
+            <a:schemeClr val="accent1"/>
+          </a:effectRef>
+          <a:fontRef idx="minor">
+            <a:schemeClr val="lt1"/>
+          </a:fontRef>
+        </p:style>
+        <p:txBody>
+          <a:bodyPr rtlCol="0" anchor="ctr" wrap="square"/>
+          <a:lstStyle/>
+          <a:p>
+            <a:pPr algn="ctr"/>
+          </a:p>
+        </p:txBody>
+      </p:sp>
+      <p:sp>
+        <p:nvSpPr>
+          <p:cNvPr id="10" name="RowLabel"/>
+          <p:cNvSpPr txBox="1"/>
+          <p:nvPr/>
+        </p:nvSpPr>
+        <p:spPr>
+          <a:xfrm>
+            <a:off x="557784" y="3703320"/>
+            <a:ext cx="2560320" cy="1188720"/>
+          </a:xfrm>
+          <a:prstGeom prst="rect">
+            <a:avLst/>
+          </a:prstGeom>
+          <a:noFill/>
+        </p:spPr>
+        <p:txBody>
+          <a:bodyPr wrap="square" anchor="ctr">
+            <a:spAutoFit/>
+          </a:bodyPr>
+          <a:lstStyle/>
+          <a:p>
+            <a:pPr algn="l">
+              <a:spcAft>
+                <a:spcPts val="400"/>
+              </a:spcAft>
+            </a:pPr>
+            <a:r>
+              <a:rPr sz="2000" b="1">
+                <a:solidFill>
+                  <a:srgbClr val="8E6F3E"/>
+                </a:solidFill>
+                <a:latin typeface="Calibri"/>
+              </a:rPr>
+              <a:t>EXPLICIT LOCKING</a:t>
+            </a:r>
+          </a:p>
+        </p:txBody>
+      </p:sp>
+      <p:sp>
+        <p:nvSpPr>
+          <p:cNvPr id="11" name="RowBody"/>
+          <p:cNvSpPr txBox="1"/>
+          <p:nvPr/>
+        </p:nvSpPr>
+        <p:spPr>
+          <a:xfrm>
+            <a:off x="3246120" y="3703320"/>
+            <a:ext cx="5349240" cy="1188720"/>
+          </a:xfrm>
+          <a:prstGeom prst="rect">
+            <a:avLst/>
+          </a:prstGeom>
+          <a:noFill/>
+        </p:spPr>
+        <p:txBody>
+          <a:bodyPr wrap="square">
+            <a:spAutoFit/>
+          </a:bodyPr>
+          <a:lstStyle/>
+          <a:p>
+            <a:pPr algn="l">
+              <a:spcAft>
+                <a:spcPts val="200"/>
+              </a:spcAft>
+            </a:pPr>
+            <a:r>
+              <a:rPr sz="2000" b="0">
+                <a:solidFill>
+                  <a:srgbClr val="5C4826"/>
+                </a:solidFill>
+                <a:latin typeface="Calibri"/>
+              </a:rPr>
+              <a:t>SELECT … FOR UPDATE the room row before checking: your LOCKING DISCIPLINE serializes per room</a:t>
+            </a:r>
+          </a:p>
+          <a:p>
+            <a:pPr algn="l">
+              <a:spcAft>
+                <a:spcPts val="400"/>
+              </a:spcAft>
+            </a:pPr>
+            <a:r>
+              <a:rPr sz="2000" b="0">
+                <a:solidFill>
+                  <a:srgbClr val="555960"/>
+                </a:solidFill>
+                <a:latin typeface="Calibri"/>
+              </a:rPr>
+              <a:t>one code path that forgets the lock breaks it</a:t>
+            </a:r>
+          </a:p>
+        </p:txBody>
+      </p:sp>
+      <p:sp>
+        <p:nvSpPr>
+          <p:cNvPr id="12" name="Card"/>
+          <p:cNvSpPr/>
+          <p:nvPr/>
+        </p:nvSpPr>
+        <p:spPr>
+          <a:xfrm>
+            <a:off x="411480" y="5047488"/>
+            <a:ext cx="8321040" cy="749808"/>
+          </a:xfrm>
+          <a:prstGeom prst="rect">
+            <a:avLst/>
+          </a:prstGeom>
+          <a:solidFill>
+            <a:srgbClr val="F5F1E8"/>
+          </a:solidFill>
+          <a:ln>
+            <a:noFill/>
+          </a:ln>
+          <a:effectLst/>
+        </p:spPr>
+        <p:style>
+          <a:lnRef idx="1">
+            <a:schemeClr val="accent1"/>
+          </a:lnRef>
+          <a:fillRef idx="3">
+            <a:schemeClr val="accent1"/>
+          </a:fillRef>
+          <a:effectRef idx="2">
+            <a:schemeClr val="accent1"/>
+          </a:effectRef>
+          <a:fontRef idx="minor">
+            <a:schemeClr val="lt1"/>
+          </a:fontRef>
+        </p:style>
+        <p:txBody>
+          <a:bodyPr rtlCol="0" anchor="ctr" wrap="square"/>
+          <a:lstStyle/>
+          <a:p>
+            <a:pPr algn="ctr"/>
+          </a:p>
+        </p:txBody>
+      </p:sp>
+      <p:sp>
+        <p:nvSpPr>
+          <p:cNvPr id="13" name="NonClaim"/>
+          <p:cNvSpPr txBox="1"/>
+          <p:nvPr/>
+        </p:nvSpPr>
+        <p:spPr>
+          <a:xfrm>
+            <a:off x="557784" y="5084064"/>
+            <a:ext cx="8046720" cy="676656"/>
+          </a:xfrm>
+          <a:prstGeom prst="rect">
+            <a:avLst/>
+          </a:prstGeom>
+          <a:noFill/>
+        </p:spPr>
+        <p:txBody>
+          <a:bodyPr wrap="square">
+            <a:spAutoFit/>
+          </a:bodyPr>
+          <a:lstStyle/>
+          <a:p>
+            <a:pPr algn="l">
+              <a:spcAft>
+                <a:spcPts val="400"/>
+              </a:spcAft>
+            </a:pPr>
+            <a:r>
+              <a:rPr sz="2000" b="1">
+                <a:solidFill>
+                  <a:srgbClr val="C01B1B"/>
+                </a:solidFill>
+                <a:latin typeface="Calibri"/>
+              </a:rPr>
+              <a:t>A foreign key or CHECK cannot do this — they govern one row; overlap is a relation between rows.</a:t>
+            </a:r>
+          </a:p>
+        </p:txBody>
+      </p:sp>
+      <p:sp>
+        <p:nvSpPr>
+          <p:cNvPr id="14" name="FooterBand"/>
+          <p:cNvSpPr/>
+          <p:nvPr/>
+        </p:nvSpPr>
+        <p:spPr>
+          <a:xfrm>
+            <a:off x="274320" y="5879592"/>
+            <a:ext cx="8595360" cy="502920"/>
+          </a:xfrm>
+          <a:prstGeom prst="rect">
+            <a:avLst/>
+          </a:prstGeom>
+          <a:solidFill>
+            <a:srgbClr val="8E6F3E"/>
+          </a:solidFill>
+          <a:ln>
+            <a:noFill/>
+          </a:ln>
+          <a:effectLst/>
+        </p:spPr>
+        <p:style>
+          <a:lnRef idx="1">
+            <a:schemeClr val="accent1"/>
+          </a:lnRef>
+          <a:fillRef idx="3">
+            <a:schemeClr val="accent1"/>
+          </a:fillRef>
+          <a:effectRef idx="2">
+            <a:schemeClr val="accent1"/>
+          </a:effectRef>
+          <a:fontRef idx="minor">
+            <a:schemeClr val="lt1"/>
+          </a:fontRef>
+        </p:style>
+        <p:txBody>
+          <a:bodyPr rtlCol="0" anchor="ctr" wrap="square"/>
+          <a:lstStyle/>
+          <a:p>
+            <a:pPr algn="ctr"/>
+          </a:p>
+        </p:txBody>
+      </p:sp>
+      <p:sp>
+        <p:nvSpPr>
+          <p:cNvPr id="15" name="FooterBandText"/>
+          <p:cNvSpPr txBox="1"/>
+          <p:nvPr/>
+        </p:nvSpPr>
+        <p:spPr>
+          <a:xfrm>
+            <a:off x="384048" y="5897880"/>
+            <a:ext cx="8375904" cy="457200"/>
+          </a:xfrm>
+          <a:prstGeom prst="rect">
+            <a:avLst/>
+          </a:prstGeom>
+          <a:noFill/>
+        </p:spPr>
+        <p:txBody>
+          <a:bodyPr wrap="square">
+            <a:spAutoFit/>
+          </a:bodyPr>
+          <a:lstStyle/>
+          <a:p>
+            <a:pPr algn="ctr">
+              <a:spcAft>
+                <a:spcPts val="400"/>
+              </a:spcAft>
+            </a:pPr>
+            <a:r>
+              <a:rPr sz="2000" b="1">
+                <a:solidFill>
+                  <a:srgbClr val="FFFFFF"/>
+                </a:solidFill>
+                <a:latin typeface="Calibri"/>
+              </a:rPr>
+              <a:t>Decide where the invariant lives: schema, isolation, or discipline</a:t>
+            </a:r>
+          </a:p>
+        </p:txBody>
+      </p:sp>
+    </p:spTree>
+  </p:cSld>
+  <p:clrMapOvr>
+    <a:masterClrMapping/>
+  </p:clrMapOvr>
+</p:sld>
+</file>
+
+<file path=ppt/slides/slide24.xml><?xml version="1.0" encoding="utf-8"?>
+<p:sld xmlns:a="http://schemas.openxmlformats.org/drawingml/2006/main" xmlns:p="http://schemas.openxmlformats.org/presentationml/2006/main" xmlns:r="http://schemas.openxmlformats.org/officeDocument/2006/relationships">
+  <p:cSld>
+    <p:spTree>
+      <p:nvGrpSpPr>
+        <p:cNvPr id="1" name=""/>
+        <p:cNvGrpSpPr/>
+        <p:nvPr/>
+      </p:nvGrpSpPr>
+      <p:grpSpPr/>
+      <p:sp>
+        <p:nvSpPr>
+          <p:cNvPr id="2" name="Title"/>
+          <p:cNvSpPr txBox="1"/>
+          <p:nvPr/>
+        </p:nvSpPr>
+        <p:spPr>
+          <a:xfrm>
+            <a:off x="274320" y="128016"/>
+            <a:ext cx="8595360" cy="594360"/>
+          </a:xfrm>
+          <a:prstGeom prst="rect">
+            <a:avLst/>
+          </a:prstGeom>
+          <a:noFill/>
+        </p:spPr>
+        <p:txBody>
+          <a:bodyPr wrap="square">
+            <a:spAutoFit/>
+          </a:bodyPr>
+          <a:lstStyle/>
+          <a:p>
+            <a:pPr algn="l">
+              <a:spcAft>
+                <a:spcPts val="400"/>
+              </a:spcAft>
+            </a:pPr>
+            <a:r>
+              <a:rPr sz="2400" b="0">
+                <a:solidFill>
+                  <a:srgbClr val="2D2D2D"/>
+                </a:solidFill>
+                <a:latin typeface="Calibri"/>
+              </a:rPr>
+              <a:t>Concurrency control is not free</a:t>
+            </a:r>
+          </a:p>
+        </p:txBody>
+      </p:sp>
+      <p:sp>
+        <p:nvSpPr>
+          <p:cNvPr id="3" name="Card"/>
+          <p:cNvSpPr/>
+          <p:nvPr/>
+        </p:nvSpPr>
+        <p:spPr>
+          <a:xfrm>
+            <a:off x="411480" y="960120"/>
+            <a:ext cx="2651760" cy="2651760"/>
+          </a:xfrm>
+          <a:prstGeom prst="rect">
+            <a:avLst/>
+          </a:prstGeom>
+          <a:solidFill>
+            <a:srgbClr val="FCFAF6"/>
+          </a:solidFill>
+          <a:ln>
+            <a:noFill/>
+          </a:ln>
+          <a:effectLst/>
+        </p:spPr>
+        <p:style>
+          <a:lnRef idx="1">
+            <a:schemeClr val="accent1"/>
+          </a:lnRef>
+          <a:fillRef idx="3">
+            <a:schemeClr val="accent1"/>
+          </a:fillRef>
+          <a:effectRef idx="2">
+            <a:schemeClr val="accent1"/>
+          </a:effectRef>
+          <a:fontRef idx="minor">
+            <a:schemeClr val="lt1"/>
+          </a:fontRef>
+        </p:style>
+        <p:txBody>
+          <a:bodyPr rtlCol="0" anchor="ctr" wrap="square"/>
+          <a:lstStyle/>
+          <a:p>
+            <a:pPr algn="ctr"/>
+          </a:p>
+        </p:txBody>
+      </p:sp>
+      <p:sp>
+        <p:nvSpPr>
+          <p:cNvPr id="4" name="CardBody"/>
+          <p:cNvSpPr txBox="1"/>
+          <p:nvPr/>
+        </p:nvSpPr>
+        <p:spPr>
+          <a:xfrm>
+            <a:off x="557784" y="1051560"/>
+            <a:ext cx="2359152" cy="2468880"/>
+          </a:xfrm>
+          <a:prstGeom prst="rect">
+            <a:avLst/>
+          </a:prstGeom>
+          <a:noFill/>
+        </p:spPr>
+        <p:txBody>
+          <a:bodyPr wrap="square">
+            <a:spAutoFit/>
+          </a:bodyPr>
+          <a:lstStyle/>
+          <a:p>
+            <a:pPr algn="l">
+              <a:spcAft>
+                <a:spcPts val="500"/>
+              </a:spcAft>
+            </a:pPr>
+            <a:r>
+              <a:rPr sz="2000" b="1">
+                <a:solidFill>
+                  <a:srgbClr val="8E6F3E"/>
+                </a:solidFill>
+                <a:latin typeface="Calibri"/>
+              </a:rPr>
+              <a:t>CONTENTION</a:t>
+            </a:r>
+          </a:p>
+          <a:p>
+            <a:pPr algn="l">
+              <a:spcAft>
+                <a:spcPts val="400"/>
+              </a:spcAft>
+            </a:pPr>
+            <a:r>
+              <a:rPr sz="2000" b="0">
+                <a:solidFill>
+                  <a:srgbClr val="555960"/>
+                </a:solidFill>
+                <a:latin typeface="Calibri"/>
+              </a:rPr>
+              <a:t>Hot rooms serialize — the waiting IS the mechanism working</a:t>
+            </a:r>
+          </a:p>
+        </p:txBody>
+      </p:sp>
+      <p:sp>
+        <p:nvSpPr>
+          <p:cNvPr id="5" name="Card"/>
+          <p:cNvSpPr/>
+          <p:nvPr/>
+        </p:nvSpPr>
+        <p:spPr>
+          <a:xfrm>
+            <a:off x="3374136" y="960120"/>
+            <a:ext cx="2651760" cy="2651760"/>
+          </a:xfrm>
+          <a:prstGeom prst="rect">
+            <a:avLst/>
+          </a:prstGeom>
+          <a:solidFill>
+            <a:srgbClr val="FCFAF6"/>
+          </a:solidFill>
+          <a:ln>
+            <a:noFill/>
+          </a:ln>
+          <a:effectLst/>
+        </p:spPr>
+        <p:style>
+          <a:lnRef idx="1">
+            <a:schemeClr val="accent1"/>
+          </a:lnRef>
+          <a:fillRef idx="3">
+            <a:schemeClr val="accent1"/>
+          </a:fillRef>
+          <a:effectRef idx="2">
+            <a:schemeClr val="accent1"/>
+          </a:effectRef>
+          <a:fontRef idx="minor">
+            <a:schemeClr val="lt1"/>
+          </a:fontRef>
+        </p:style>
+        <p:txBody>
+          <a:bodyPr rtlCol="0" anchor="ctr" wrap="square"/>
+          <a:lstStyle/>
+          <a:p>
+            <a:pPr algn="ctr"/>
+          </a:p>
+        </p:txBody>
+      </p:sp>
+      <p:sp>
+        <p:nvSpPr>
+          <p:cNvPr id="6" name="CardBody"/>
+          <p:cNvSpPr txBox="1"/>
+          <p:nvPr/>
+        </p:nvSpPr>
+        <p:spPr>
+          <a:xfrm>
+            <a:off x="3520440" y="1051560"/>
+            <a:ext cx="2359152" cy="2468880"/>
+          </a:xfrm>
+          <a:prstGeom prst="rect">
+            <a:avLst/>
+          </a:prstGeom>
+          <a:noFill/>
+        </p:spPr>
+        <p:txBody>
+          <a:bodyPr wrap="square">
+            <a:spAutoFit/>
+          </a:bodyPr>
+          <a:lstStyle/>
+          <a:p>
+            <a:pPr algn="l">
+              <a:spcAft>
+                <a:spcPts val="500"/>
+              </a:spcAft>
+            </a:pPr>
+            <a:r>
+              <a:rPr sz="2000" b="1">
+                <a:solidFill>
+                  <a:srgbClr val="8E6F3E"/>
+                </a:solidFill>
+                <a:latin typeface="Calibri"/>
+              </a:rPr>
+              <a:t>RETRIES</a:t>
+            </a:r>
+          </a:p>
+          <a:p>
+            <a:pPr algn="l">
+              <a:spcAft>
+                <a:spcPts val="400"/>
+              </a:spcAft>
+            </a:pPr>
+            <a:r>
+              <a:rPr sz="2000" b="0">
+                <a:solidFill>
+                  <a:srgbClr val="555960"/>
+                </a:solidFill>
+                <a:latin typeface="Calibri"/>
+              </a:rPr>
+              <a:t>Serializable aborts are normal operation; wasted work grows with conflict rate</a:t>
+            </a:r>
+          </a:p>
+        </p:txBody>
+      </p:sp>
+      <p:sp>
+        <p:nvSpPr>
+          <p:cNvPr id="7" name="Card"/>
+          <p:cNvSpPr/>
+          <p:nvPr/>
+        </p:nvSpPr>
+        <p:spPr>
+          <a:xfrm>
+            <a:off x="6336792" y="960120"/>
+            <a:ext cx="2651760" cy="2651760"/>
+          </a:xfrm>
+          <a:prstGeom prst="rect">
+            <a:avLst/>
+          </a:prstGeom>
+          <a:solidFill>
+            <a:srgbClr val="FCFAF6"/>
+          </a:solidFill>
+          <a:ln>
+            <a:noFill/>
+          </a:ln>
+          <a:effectLst/>
+        </p:spPr>
+        <p:style>
+          <a:lnRef idx="1">
+            <a:schemeClr val="accent1"/>
+          </a:lnRef>
+          <a:fillRef idx="3">
+            <a:schemeClr val="accent1"/>
+          </a:fillRef>
+          <a:effectRef idx="2">
+            <a:schemeClr val="accent1"/>
+          </a:effectRef>
+          <a:fontRef idx="minor">
+            <a:schemeClr val="lt1"/>
+          </a:fontRef>
+        </p:style>
+        <p:txBody>
+          <a:bodyPr rtlCol="0" anchor="ctr" wrap="square"/>
+          <a:lstStyle/>
+          <a:p>
+            <a:pPr algn="ctr"/>
+          </a:p>
+        </p:txBody>
+      </p:sp>
+      <p:sp>
+        <p:nvSpPr>
+          <p:cNvPr id="8" name="CardBody"/>
+          <p:cNvSpPr txBox="1"/>
+          <p:nvPr/>
+        </p:nvSpPr>
+        <p:spPr>
+          <a:xfrm>
+            <a:off x="6483096" y="1051560"/>
+            <a:ext cx="2359152" cy="2468880"/>
+          </a:xfrm>
+          <a:prstGeom prst="rect">
+            <a:avLst/>
+          </a:prstGeom>
+          <a:noFill/>
+        </p:spPr>
+        <p:txBody>
+          <a:bodyPr wrap="square">
+            <a:spAutoFit/>
+          </a:bodyPr>
+          <a:lstStyle/>
+          <a:p>
+            <a:pPr algn="l">
+              <a:spcAft>
+                <a:spcPts val="500"/>
+              </a:spcAft>
+            </a:pPr>
+            <a:r>
+              <a:rPr sz="2000" b="1">
+                <a:solidFill>
+                  <a:srgbClr val="8E6F3E"/>
+                </a:solidFill>
+                <a:latin typeface="Calibri"/>
+              </a:rPr>
+              <a:t>THROUGHPUT</a:t>
+            </a:r>
+          </a:p>
+          <a:p>
+            <a:pPr algn="l">
+              <a:spcAft>
+                <a:spcPts val="400"/>
+              </a:spcAft>
+            </a:pPr>
+            <a:r>
+              <a:rPr sz="2000" b="0">
+                <a:solidFill>
+                  <a:srgbClr val="555960"/>
+                </a:solidFill>
+                <a:latin typeface="Calibri"/>
+              </a:rPr>
+              <a:t>Stronger isolation buys correctness with capacity</a:t>
+            </a:r>
+          </a:p>
+        </p:txBody>
+      </p:sp>
+      <p:sp>
+        <p:nvSpPr>
+          <p:cNvPr id="9" name="Card"/>
+          <p:cNvSpPr/>
+          <p:nvPr/>
+        </p:nvSpPr>
+        <p:spPr>
+          <a:xfrm>
+            <a:off x="411480" y="3840480"/>
+            <a:ext cx="8321040" cy="1463040"/>
+          </a:xfrm>
+          <a:prstGeom prst="rect">
+            <a:avLst/>
+          </a:prstGeom>
+          <a:solidFill>
+            <a:srgbClr val="F5F1E8"/>
+          </a:solidFill>
+          <a:ln>
+            <a:noFill/>
+          </a:ln>
+          <a:effectLst/>
+        </p:spPr>
+        <p:style>
+          <a:lnRef idx="1">
+            <a:schemeClr val="accent1"/>
+          </a:lnRef>
+          <a:fillRef idx="3">
+            <a:schemeClr val="accent1"/>
+          </a:fillRef>
+          <a:effectRef idx="2">
+            <a:schemeClr val="accent1"/>
+          </a:effectRef>
+          <a:fontRef idx="minor">
+            <a:schemeClr val="lt1"/>
+          </a:fontRef>
+        </p:style>
+        <p:txBody>
+          <a:bodyPr rtlCol="0" anchor="ctr" wrap="square"/>
+          <a:lstStyle/>
+          <a:p>
+            <a:pPr algn="ctr"/>
+          </a:p>
+        </p:txBody>
+      </p:sp>
+      <p:sp>
+        <p:nvSpPr>
+          <p:cNvPr id="10" name="CardBody"/>
+          <p:cNvSpPr txBox="1"/>
+          <p:nvPr/>
+        </p:nvSpPr>
+        <p:spPr>
+          <a:xfrm>
+            <a:off x="557784" y="3913632"/>
+            <a:ext cx="8046720" cy="1325880"/>
+          </a:xfrm>
+          <a:prstGeom prst="rect">
+            <a:avLst/>
+          </a:prstGeom>
+          <a:noFill/>
+        </p:spPr>
+        <p:txBody>
+          <a:bodyPr wrap="square">
+            <a:spAutoFit/>
+          </a:bodyPr>
+          <a:lstStyle/>
+          <a:p>
+            <a:pPr algn="l">
+              <a:spcAft>
+                <a:spcPts val="300"/>
+              </a:spcAft>
+            </a:pPr>
+            <a:r>
+              <a:rPr sz="2000" b="1">
+                <a:solidFill>
+                  <a:srgbClr val="5C4826"/>
+                </a:solidFill>
+                <a:latin typeface="Calibri"/>
+              </a:rPr>
+              <a:t>Pay for exactly the histories you must exclude</a:t>
+            </a:r>
+          </a:p>
+          <a:p>
+            <a:pPr algn="l">
+              <a:spcAft>
+                <a:spcPts val="400"/>
+              </a:spcAft>
+            </a:pPr>
+            <a:r>
+              <a:rPr sz="2000" b="0">
+                <a:solidFill>
+                  <a:srgbClr val="555960"/>
+                </a:solidFill>
+                <a:latin typeface="Calibri"/>
+              </a:rPr>
+              <a:t>Telemetry (slide 8) excludes none and flies; reservations exclude one class and pay for it. Measuring that price is the next unit: Performance &amp; Reliability.</a:t>
+            </a:r>
+          </a:p>
+        </p:txBody>
+      </p:sp>
+      <p:sp>
+        <p:nvSpPr>
+          <p:cNvPr id="11" name="FooterBand"/>
+          <p:cNvSpPr/>
+          <p:nvPr/>
+        </p:nvSpPr>
+        <p:spPr>
+          <a:xfrm>
+            <a:off x="274320" y="5879592"/>
+            <a:ext cx="8595360" cy="502920"/>
+          </a:xfrm>
+          <a:prstGeom prst="rect">
+            <a:avLst/>
+          </a:prstGeom>
+          <a:solidFill>
+            <a:srgbClr val="8E6F3E"/>
+          </a:solidFill>
+          <a:ln>
+            <a:noFill/>
+          </a:ln>
+          <a:effectLst/>
+        </p:spPr>
+        <p:style>
+          <a:lnRef idx="1">
+            <a:schemeClr val="accent1"/>
+          </a:lnRef>
+          <a:fillRef idx="3">
+            <a:schemeClr val="accent1"/>
+          </a:fillRef>
+          <a:effectRef idx="2">
+            <a:schemeClr val="accent1"/>
+          </a:effectRef>
+          <a:fontRef idx="minor">
+            <a:schemeClr val="lt1"/>
+          </a:fontRef>
+        </p:style>
+        <p:txBody>
+          <a:bodyPr rtlCol="0" anchor="ctr" wrap="square"/>
+          <a:lstStyle/>
+          <a:p>
+            <a:pPr algn="ctr"/>
+          </a:p>
+        </p:txBody>
+      </p:sp>
+      <p:sp>
+        <p:nvSpPr>
+          <p:cNvPr id="12" name="FooterBandText"/>
+          <p:cNvSpPr txBox="1"/>
+          <p:nvPr/>
+        </p:nvSpPr>
+        <p:spPr>
+          <a:xfrm>
+            <a:off x="384048" y="5897880"/>
+            <a:ext cx="8375904" cy="457200"/>
+          </a:xfrm>
+          <a:prstGeom prst="rect">
+            <a:avLst/>
+          </a:prstGeom>
+          <a:noFill/>
+        </p:spPr>
+        <p:txBody>
+          <a:bodyPr wrap="square">
+            <a:spAutoFit/>
+          </a:bodyPr>
+          <a:lstStyle/>
+          <a:p>
+            <a:pPr algn="ctr">
+              <a:spcAft>
+                <a:spcPts val="400"/>
+              </a:spcAft>
+            </a:pPr>
+            <a:r>
+              <a:rPr sz="2000" b="1">
+                <a:solidFill>
+                  <a:srgbClr val="FFFFFF"/>
+                </a:solidFill>
+                <a:latin typeface="Calibri"/>
+              </a:rPr>
+              <a:t>Concurrency control is a cost you choose on purpose</a:t>
             </a:r>
           </a:p>
         </p:txBody>

</xml_diff>

<commit_message>
deck 3-2: §6 evolution and synthesis (slides 25-27) — deck complete
Stage 6 of 6: schema evolution via the recurring-booking feature
(representation / existing records / availability, expand-migrate-
contract), today's decisions re-walked through the Act III method
flowchart (Problem→Model→Judgment→Realize→Evidence→Accept/reject with
ALIGNMENT drawn alongside, matching the 3-1 deck's motif pending a
reconciliation pass), and the handoff to Technical Debt, Architecture
& Supply Chains. 27 slides; TIMING notes total exactly 75 minutes;
pptx_validate 0 OPC / 0 schema; 20pt floor holds deck-wide.

Co-Authored-By: Claude Opus 5 <noreply@anthropic.com>
</commit_message>
<xml_diff>
--- a/course/lectures/act-3-software-in-the-world/02-compute-environments-and-data-management/3-2-Data-Management.pptx
+++ b/course/lectures/act-3-software-in-the-world/02-compute-environments-and-data-management/3-2-Data-Management.pptx
@@ -32,6 +32,9 @@
     <p:sldId id="277" r:id="rId28"/>
     <p:sldId id="278" r:id="rId29"/>
     <p:sldId id="279" r:id="rId6"/>
+    <p:sldId id="280" r:id="rId5"/>
+    <p:sldId id="281" r:id="rId4"/>
+    <p:sldId id="282" r:id="rId3"/>
   </p:sldIdLst>
   <p:sldSz cx="9144000" cy="6858000" type="screen4x3"/>
   <p:notesSz cx="6858000" cy="9144000"/>
@@ -2968,6 +2971,270 @@
           <a:p>
             <a:r>
               <a:t>Handoff: "how much does it cost under OUR workload?" is a measurement question — Performance &amp; Reliability, two lectures from now.</a:t>
+            </a:r>
+          </a:p>
+        </p:txBody>
+      </p:sp>
+      <p:sp>
+        <p:nvSpPr>
+          <p:cNvPr id="4" name="Slide Number Placeholder 3"/>
+          <p:cNvSpPr>
+            <a:spLocks noGrp="1"/>
+          </p:cNvSpPr>
+          <p:nvPr>
+            <p:ph type="sldNum" idx="12"/>
+          </p:nvPr>
+        </p:nvSpPr>
+        <p:spPr/>
+      </p:sp>
+    </p:spTree>
+  </p:cSld>
+  <p:clrMapOvr>
+    <a:masterClrMapping/>
+  </p:clrMapOvr>
+</p:notes>
+</file>
+
+<file path=ppt/notesSlides/notesSlide25.xml><?xml version="1.0" encoding="utf-8"?>
+<p:notes xmlns:a="http://schemas.openxmlformats.org/drawingml/2006/main" xmlns:p="http://schemas.openxmlformats.org/presentationml/2006/main" xmlns:r="http://schemas.openxmlformats.org/officeDocument/2006/relationships">
+  <p:cSld>
+    <p:spTree>
+      <p:nvGrpSpPr>
+        <p:cNvPr id="1" name=""/>
+        <p:cNvGrpSpPr/>
+        <p:nvPr/>
+      </p:nvGrpSpPr>
+      <p:grpSpPr>
+        <a:xfrm>
+          <a:off x="0" y="0"/>
+          <a:ext cx="0" cy="0"/>
+          <a:chOff x="0" y="0"/>
+          <a:chExt cx="0" cy="0"/>
+        </a:xfrm>
+      </p:grpSpPr>
+      <p:sp>
+        <p:nvSpPr>
+          <p:cNvPr id="2" name="Slide Image Placeholder 1"/>
+          <p:cNvSpPr>
+            <a:spLocks noGrp="1"/>
+          </p:cNvSpPr>
+          <p:nvPr>
+            <p:ph type="sldImg" idx="3"/>
+          </p:nvPr>
+        </p:nvSpPr>
+        <p:spPr/>
+      </p:sp>
+      <p:sp>
+        <p:nvSpPr>
+          <p:cNvPr id="3" name="Notes Placeholder 2"/>
+          <p:cNvSpPr>
+            <a:spLocks noGrp="1"/>
+          </p:cNvSpPr>
+          <p:nvPr>
+            <p:ph type="body" idx="1"/>
+          </p:nvPr>
+        </p:nvSpPr>
+        <p:spPr/>
+        <p:txBody>
+          <a:bodyPr/>
+          <a:lstStyle/>
+          <a:p>
+            <a:r>
+              <a:t>TIMING: 4 minutes.</a:t>
+            </a:r>
+          </a:p>
+          <a:p/>
+          <a:p>
+            <a:r>
+              <a:t>New requirement, same system: recurring bookings. The schema must change while the service runs and while two years of reservations sit in the table. Walk the three questions.</a:t>
+            </a:r>
+          </a:p>
+          <a:p/>
+          <a:p>
+            <a:r>
+              <a:t>Representation re-opens slide 5 honestly — a recurrence rule is compact but makes the overlap check computational; expanded rows keep the invariant machinery working but multiply data. There is no free choice; the invariant's HOME (slide 23) constrains which representations stay enforceable.</a:t>
+            </a:r>
+          </a:p>
+          <a:p/>
+          <a:p>
+            <a:r>
+              <a:t>The availability row ties directly to Tuesday: a rolling deploy means OLD and NEW code coexist for a window, so old and new DATA SHAPES must coexist too. Expand/migrate/contract is the discipline: add the new column or table (both versions tolerate it), migrate and dual-write, then contract once the old reader is gone. Migrations are numbered, reviewed, reversible artifacts — schema change is engineering, not a DBA favor.</a:t>
+            </a:r>
+          </a:p>
+          <a:p/>
+          <a:p>
+            <a:r>
+              <a:t>Rollback question for the class: code rolls back by redeploying the old image — what rolls back a migration that already rewrote rows?</a:t>
+            </a:r>
+          </a:p>
+        </p:txBody>
+      </p:sp>
+      <p:sp>
+        <p:nvSpPr>
+          <p:cNvPr id="4" name="Slide Number Placeholder 3"/>
+          <p:cNvSpPr>
+            <a:spLocks noGrp="1"/>
+          </p:cNvSpPr>
+          <p:nvPr>
+            <p:ph type="sldNum" idx="12"/>
+          </p:nvPr>
+        </p:nvSpPr>
+        <p:spPr/>
+      </p:sp>
+    </p:spTree>
+  </p:cSld>
+  <p:clrMapOvr>
+    <a:masterClrMapping/>
+  </p:clrMapOvr>
+</p:notes>
+</file>
+
+<file path=ppt/notesSlides/notesSlide26.xml><?xml version="1.0" encoding="utf-8"?>
+<p:notes xmlns:a="http://schemas.openxmlformats.org/drawingml/2006/main" xmlns:p="http://schemas.openxmlformats.org/presentationml/2006/main" xmlns:r="http://schemas.openxmlformats.org/officeDocument/2006/relationships">
+  <p:cSld>
+    <p:spTree>
+      <p:nvGrpSpPr>
+        <p:cNvPr id="1" name=""/>
+        <p:cNvGrpSpPr/>
+        <p:nvPr/>
+      </p:nvGrpSpPr>
+      <p:grpSpPr>
+        <a:xfrm>
+          <a:off x="0" y="0"/>
+          <a:ext cx="0" cy="0"/>
+          <a:chOff x="0" y="0"/>
+          <a:chExt cx="0" cy="0"/>
+        </a:xfrm>
+      </p:grpSpPr>
+      <p:sp>
+        <p:nvSpPr>
+          <p:cNvPr id="2" name="Slide Image Placeholder 1"/>
+          <p:cNvSpPr>
+            <a:spLocks noGrp="1"/>
+          </p:cNvSpPr>
+          <p:nvPr>
+            <p:ph type="sldImg" idx="3"/>
+          </p:nvPr>
+        </p:nvSpPr>
+        <p:spPr/>
+      </p:sp>
+      <p:sp>
+        <p:nvSpPr>
+          <p:cNvPr id="3" name="Notes Placeholder 2"/>
+          <p:cNvSpPr>
+            <a:spLocks noGrp="1"/>
+          </p:cNvSpPr>
+          <p:nvPr>
+            <p:ph type="body" idx="1"/>
+          </p:nvPr>
+        </p:nvSpPr>
+        <p:spPr/>
+        <p:txBody>
+          <a:bodyPr/>
+          <a:lstStyle/>
+          <a:p>
+            <a:r>
+              <a:t>TIMING: 4 minutes.</a:t>
+            </a:r>
+          </a:p>
+          <a:p/>
+          <a:p>
+            <a:r>
+              <a:t>This flowchart is Tuesday's slide-4 motif, reused verbatim as Act III's recurring frame — do not present it as new. Re-walk it with today's artifacts: the PROBLEM was slide 2's three requirements; the MODELS were the abstract five-dimension model, the ER diagram, and the schema; JUDGMENT was relational-vs-NoSQL and normalize-vs-denormalize; REALIZE was DDL, queries, ORM code; EVIDENCE was query plans, cost comparisons, and the double-booking interleaving; ACCEPT/REJECT chose the exclusion constraint and rejected check-then-act.</a:t>
+            </a:r>
+          </a:p>
+          <a:p/>
+          <a:p>
+            <a:r>
+              <a:t>Alignment runs ALONGSIDE, not after — that is why it is drawn as a parallel lane and not a seventh box. Today it was never a post-hoc review step: the schema constraints, the exclusion constraint, the serializable contract are alignment machinery embedded IN the realization. The database is the course's cleanest example of Modeling and Alignment fused in one component: the schema IS the model, with authority.</a:t>
+            </a:r>
+          </a:p>
+          <a:p/>
+          <a:p>
+            <a:r>
+              <a:t>(Deck-maintenance note, not for class: Tuesday's deck renders this same chart; the two renderings should be reconciled to one geometry after both decks land.)</a:t>
+            </a:r>
+          </a:p>
+        </p:txBody>
+      </p:sp>
+      <p:sp>
+        <p:nvSpPr>
+          <p:cNvPr id="4" name="Slide Number Placeholder 3"/>
+          <p:cNvSpPr>
+            <a:spLocks noGrp="1"/>
+          </p:cNvSpPr>
+          <p:nvPr>
+            <p:ph type="sldNum" idx="12"/>
+          </p:nvPr>
+        </p:nvSpPr>
+        <p:spPr/>
+      </p:sp>
+    </p:spTree>
+  </p:cSld>
+  <p:clrMapOvr>
+    <a:masterClrMapping/>
+  </p:clrMapOvr>
+</p:notes>
+</file>
+
+<file path=ppt/notesSlides/notesSlide27.xml><?xml version="1.0" encoding="utf-8"?>
+<p:notes xmlns:a="http://schemas.openxmlformats.org/drawingml/2006/main" xmlns:p="http://schemas.openxmlformats.org/presentationml/2006/main" xmlns:r="http://schemas.openxmlformats.org/officeDocument/2006/relationships">
+  <p:cSld>
+    <p:spTree>
+      <p:nvGrpSpPr>
+        <p:cNvPr id="1" name=""/>
+        <p:cNvGrpSpPr/>
+        <p:nvPr/>
+      </p:nvGrpSpPr>
+      <p:grpSpPr>
+        <a:xfrm>
+          <a:off x="0" y="0"/>
+          <a:ext cx="0" cy="0"/>
+          <a:chOff x="0" y="0"/>
+          <a:chExt cx="0" cy="0"/>
+        </a:xfrm>
+      </p:grpSpPr>
+      <p:sp>
+        <p:nvSpPr>
+          <p:cNvPr id="2" name="Slide Image Placeholder 1"/>
+          <p:cNvSpPr>
+            <a:spLocks noGrp="1"/>
+          </p:cNvSpPr>
+          <p:nvPr>
+            <p:ph type="sldImg" idx="3"/>
+          </p:nvPr>
+        </p:nvSpPr>
+        <p:spPr/>
+      </p:sp>
+      <p:sp>
+        <p:nvSpPr>
+          <p:cNvPr id="3" name="Notes Placeholder 2"/>
+          <p:cNvSpPr>
+            <a:spLocks noGrp="1"/>
+          </p:cNvSpPr>
+          <p:nvPr>
+            <p:ph type="body" idx="1"/>
+          </p:nvPr>
+        </p:nvSpPr>
+        <p:spPr/>
+        <p:txBody>
+          <a:bodyPr/>
+          <a:lstStyle/>
+          <a:p>
+            <a:r>
+              <a:t>TIMING: 2 minutes.</a:t>
+            </a:r>
+          </a:p>
+          <a:p/>
+          <a:p>
+            <a:r>
+              <a:t>Close on the governing question, answered dimension by dimension: we chose a representation (relational, normalized, indexed), demanded semantics (constraints, durability), picked interfaces (SQL under an ORM, with eyes open), governed concurrency (serializable-or-constraint, priced), and deferred scale until measured.</a:t>
+            </a:r>
+          </a:p>
+          <a:p/>
+          <a:p>
+            <a:r>
+              <a:t>Then hand off with the question on the title. A working system is the STARTING point of most engineering careers, not the end: next unit asks whether this system's structure — our code and everything we now depend on, engine features included (that exclusion constraint bound us to an engine) — can absorb its next ten changes economically.</a:t>
             </a:r>
           </a:p>
         </p:txBody>
@@ -20357,6 +20624,2005 @@
 </p:sld>
 </file>
 
+<file path=ppt/slides/slide25.xml><?xml version="1.0" encoding="utf-8"?>
+<p:sld xmlns:a="http://schemas.openxmlformats.org/drawingml/2006/main" xmlns:p="http://schemas.openxmlformats.org/presentationml/2006/main" xmlns:r="http://schemas.openxmlformats.org/officeDocument/2006/relationships">
+  <p:cSld>
+    <p:spTree>
+      <p:nvGrpSpPr>
+        <p:cNvPr id="1" name=""/>
+        <p:cNvGrpSpPr/>
+        <p:nvPr/>
+      </p:nvGrpSpPr>
+      <p:grpSpPr/>
+      <p:sp>
+        <p:nvSpPr>
+          <p:cNvPr id="2" name="Title"/>
+          <p:cNvSpPr txBox="1"/>
+          <p:nvPr/>
+        </p:nvSpPr>
+        <p:spPr>
+          <a:xfrm>
+            <a:off x="274320" y="128016"/>
+            <a:ext cx="8595360" cy="594360"/>
+          </a:xfrm>
+          <a:prstGeom prst="rect">
+            <a:avLst/>
+          </a:prstGeom>
+          <a:noFill/>
+        </p:spPr>
+        <p:txBody>
+          <a:bodyPr wrap="square">
+            <a:spAutoFit/>
+          </a:bodyPr>
+          <a:lstStyle/>
+          <a:p>
+            <a:pPr algn="l">
+              <a:spcAft>
+                <a:spcPts val="400"/>
+              </a:spcAft>
+            </a:pPr>
+            <a:r>
+              <a:rPr sz="2400" b="0">
+                <a:solidFill>
+                  <a:srgbClr val="2D2D2D"/>
+                </a:solidFill>
+                <a:latin typeface="Calibri"/>
+              </a:rPr>
+              <a:t>Schemas evolve: the recurring-booking feature arrives</a:t>
+            </a:r>
+          </a:p>
+        </p:txBody>
+      </p:sp>
+      <p:sp>
+        <p:nvSpPr>
+          <p:cNvPr id="3" name="Card"/>
+          <p:cNvSpPr/>
+          <p:nvPr/>
+        </p:nvSpPr>
+        <p:spPr>
+          <a:xfrm>
+            <a:off x="411480" y="896112"/>
+            <a:ext cx="8321040" cy="1325880"/>
+          </a:xfrm>
+          <a:prstGeom prst="rect">
+            <a:avLst/>
+          </a:prstGeom>
+          <a:solidFill>
+            <a:srgbClr val="F5F1E8"/>
+          </a:solidFill>
+          <a:ln>
+            <a:noFill/>
+          </a:ln>
+          <a:effectLst/>
+        </p:spPr>
+        <p:style>
+          <a:lnRef idx="1">
+            <a:schemeClr val="accent1"/>
+          </a:lnRef>
+          <a:fillRef idx="3">
+            <a:schemeClr val="accent1"/>
+          </a:fillRef>
+          <a:effectRef idx="2">
+            <a:schemeClr val="accent1"/>
+          </a:effectRef>
+          <a:fontRef idx="minor">
+            <a:schemeClr val="lt1"/>
+          </a:fontRef>
+        </p:style>
+        <p:txBody>
+          <a:bodyPr rtlCol="0" anchor="ctr" wrap="square"/>
+          <a:lstStyle/>
+          <a:p>
+            <a:pPr algn="ctr"/>
+          </a:p>
+        </p:txBody>
+      </p:sp>
+      <p:sp>
+        <p:nvSpPr>
+          <p:cNvPr id="4" name="RowLabel"/>
+          <p:cNvSpPr txBox="1"/>
+          <p:nvPr/>
+        </p:nvSpPr>
+        <p:spPr>
+          <a:xfrm>
+            <a:off x="557784" y="950976"/>
+            <a:ext cx="2560320" cy="1216152"/>
+          </a:xfrm>
+          <a:prstGeom prst="rect">
+            <a:avLst/>
+          </a:prstGeom>
+          <a:noFill/>
+        </p:spPr>
+        <p:txBody>
+          <a:bodyPr wrap="square" anchor="ctr">
+            <a:spAutoFit/>
+          </a:bodyPr>
+          <a:lstStyle/>
+          <a:p>
+            <a:pPr algn="l">
+              <a:spcAft>
+                <a:spcPts val="400"/>
+              </a:spcAft>
+            </a:pPr>
+            <a:r>
+              <a:rPr sz="2000" b="1">
+                <a:solidFill>
+                  <a:srgbClr val="8E6F3E"/>
+                </a:solidFill>
+                <a:latin typeface="Calibri"/>
+              </a:rPr>
+              <a:t>REPRESENTATION</a:t>
+            </a:r>
+          </a:p>
+        </p:txBody>
+      </p:sp>
+      <p:sp>
+        <p:nvSpPr>
+          <p:cNvPr id="5" name="RowBody"/>
+          <p:cNvSpPr txBox="1"/>
+          <p:nvPr/>
+        </p:nvSpPr>
+        <p:spPr>
+          <a:xfrm>
+            <a:off x="3246120" y="950976"/>
+            <a:ext cx="5349240" cy="1216152"/>
+          </a:xfrm>
+          <a:prstGeom prst="rect">
+            <a:avLst/>
+          </a:prstGeom>
+          <a:noFill/>
+        </p:spPr>
+        <p:txBody>
+          <a:bodyPr wrap="square">
+            <a:spAutoFit/>
+          </a:bodyPr>
+          <a:lstStyle/>
+          <a:p>
+            <a:pPr algn="l">
+              <a:spcAft>
+                <a:spcPts val="200"/>
+              </a:spcAft>
+            </a:pPr>
+            <a:r>
+              <a:rPr sz="2000" b="1">
+                <a:solidFill>
+                  <a:srgbClr val="5C4826"/>
+                </a:solidFill>
+                <a:latin typeface="Calibri"/>
+              </a:rPr>
+              <a:t>Weekly recitation, every Tuesday — a recurrence-rule column? a series table? expanded rows?</a:t>
+            </a:r>
+          </a:p>
+          <a:p>
+            <a:pPr algn="l">
+              <a:spcAft>
+                <a:spcPts val="400"/>
+              </a:spcAft>
+            </a:pPr>
+            <a:r>
+              <a:rPr sz="2000" b="0">
+                <a:solidFill>
+                  <a:srgbClr val="555960"/>
+                </a:solidFill>
+                <a:latin typeface="Calibri"/>
+              </a:rPr>
+              <a:t>Each choice re-runs the modeling tradeoffs</a:t>
+            </a:r>
+          </a:p>
+        </p:txBody>
+      </p:sp>
+      <p:sp>
+        <p:nvSpPr>
+          <p:cNvPr id="6" name="Card"/>
+          <p:cNvSpPr/>
+          <p:nvPr/>
+        </p:nvSpPr>
+        <p:spPr>
+          <a:xfrm>
+            <a:off x="411480" y="2340864"/>
+            <a:ext cx="8321040" cy="1325880"/>
+          </a:xfrm>
+          <a:prstGeom prst="rect">
+            <a:avLst/>
+          </a:prstGeom>
+          <a:solidFill>
+            <a:srgbClr val="FCFAF6"/>
+          </a:solidFill>
+          <a:ln>
+            <a:noFill/>
+          </a:ln>
+          <a:effectLst/>
+        </p:spPr>
+        <p:style>
+          <a:lnRef idx="1">
+            <a:schemeClr val="accent1"/>
+          </a:lnRef>
+          <a:fillRef idx="3">
+            <a:schemeClr val="accent1"/>
+          </a:fillRef>
+          <a:effectRef idx="2">
+            <a:schemeClr val="accent1"/>
+          </a:effectRef>
+          <a:fontRef idx="minor">
+            <a:schemeClr val="lt1"/>
+          </a:fontRef>
+        </p:style>
+        <p:txBody>
+          <a:bodyPr rtlCol="0" anchor="ctr" wrap="square"/>
+          <a:lstStyle/>
+          <a:p>
+            <a:pPr algn="ctr"/>
+          </a:p>
+        </p:txBody>
+      </p:sp>
+      <p:sp>
+        <p:nvSpPr>
+          <p:cNvPr id="7" name="RowLabel"/>
+          <p:cNvSpPr txBox="1"/>
+          <p:nvPr/>
+        </p:nvSpPr>
+        <p:spPr>
+          <a:xfrm>
+            <a:off x="557784" y="2395728"/>
+            <a:ext cx="2560320" cy="1216152"/>
+          </a:xfrm>
+          <a:prstGeom prst="rect">
+            <a:avLst/>
+          </a:prstGeom>
+          <a:noFill/>
+        </p:spPr>
+        <p:txBody>
+          <a:bodyPr wrap="square" anchor="ctr">
+            <a:spAutoFit/>
+          </a:bodyPr>
+          <a:lstStyle/>
+          <a:p>
+            <a:pPr algn="l">
+              <a:spcAft>
+                <a:spcPts val="400"/>
+              </a:spcAft>
+            </a:pPr>
+            <a:r>
+              <a:rPr sz="2000" b="1">
+                <a:solidFill>
+                  <a:srgbClr val="8E6F3E"/>
+                </a:solidFill>
+                <a:latin typeface="Calibri"/>
+              </a:rPr>
+              <a:t>EXISTING RECORDS</a:t>
+            </a:r>
+          </a:p>
+        </p:txBody>
+      </p:sp>
+      <p:sp>
+        <p:nvSpPr>
+          <p:cNvPr id="8" name="RowBody"/>
+          <p:cNvSpPr txBox="1"/>
+          <p:nvPr/>
+        </p:nvSpPr>
+        <p:spPr>
+          <a:xfrm>
+            <a:off x="3246120" y="2395728"/>
+            <a:ext cx="5349240" cy="1216152"/>
+          </a:xfrm>
+          <a:prstGeom prst="rect">
+            <a:avLst/>
+          </a:prstGeom>
+          <a:noFill/>
+        </p:spPr>
+        <p:txBody>
+          <a:bodyPr wrap="square">
+            <a:spAutoFit/>
+          </a:bodyPr>
+          <a:lstStyle/>
+          <a:p>
+            <a:pPr algn="l">
+              <a:spcAft>
+                <a:spcPts val="200"/>
+              </a:spcAft>
+            </a:pPr>
+            <a:r>
+              <a:rPr sz="2000" b="1">
+                <a:solidFill>
+                  <a:srgbClr val="5C4826"/>
+                </a:solidFill>
+                <a:latin typeface="Calibri"/>
+              </a:rPr>
+              <a:t>What happens to the rows already there — backfill, defaults, or dual reads?</a:t>
+            </a:r>
+          </a:p>
+          <a:p>
+            <a:pPr algn="l">
+              <a:spcAft>
+                <a:spcPts val="400"/>
+              </a:spcAft>
+            </a:pPr>
+            <a:r>
+              <a:rPr sz="2000" b="0">
+                <a:solidFill>
+                  <a:srgbClr val="555960"/>
+                </a:solidFill>
+                <a:latin typeface="Calibri"/>
+              </a:rPr>
+              <a:t>Data outlives the code that wrote it</a:t>
+            </a:r>
+          </a:p>
+        </p:txBody>
+      </p:sp>
+      <p:sp>
+        <p:nvSpPr>
+          <p:cNvPr id="9" name="Card"/>
+          <p:cNvSpPr/>
+          <p:nvPr/>
+        </p:nvSpPr>
+        <p:spPr>
+          <a:xfrm>
+            <a:off x="411480" y="3785616"/>
+            <a:ext cx="8321040" cy="1325880"/>
+          </a:xfrm>
+          <a:prstGeom prst="rect">
+            <a:avLst/>
+          </a:prstGeom>
+          <a:solidFill>
+            <a:srgbClr val="F5F1E8"/>
+          </a:solidFill>
+          <a:ln>
+            <a:noFill/>
+          </a:ln>
+          <a:effectLst/>
+        </p:spPr>
+        <p:style>
+          <a:lnRef idx="1">
+            <a:schemeClr val="accent1"/>
+          </a:lnRef>
+          <a:fillRef idx="3">
+            <a:schemeClr val="accent1"/>
+          </a:fillRef>
+          <a:effectRef idx="2">
+            <a:schemeClr val="accent1"/>
+          </a:effectRef>
+          <a:fontRef idx="minor">
+            <a:schemeClr val="lt1"/>
+          </a:fontRef>
+        </p:style>
+        <p:txBody>
+          <a:bodyPr rtlCol="0" anchor="ctr" wrap="square"/>
+          <a:lstStyle/>
+          <a:p>
+            <a:pPr algn="ctr"/>
+          </a:p>
+        </p:txBody>
+      </p:sp>
+      <p:sp>
+        <p:nvSpPr>
+          <p:cNvPr id="10" name="RowLabel"/>
+          <p:cNvSpPr txBox="1"/>
+          <p:nvPr/>
+        </p:nvSpPr>
+        <p:spPr>
+          <a:xfrm>
+            <a:off x="557784" y="3840480"/>
+            <a:ext cx="2560320" cy="1216152"/>
+          </a:xfrm>
+          <a:prstGeom prst="rect">
+            <a:avLst/>
+          </a:prstGeom>
+          <a:noFill/>
+        </p:spPr>
+        <p:txBody>
+          <a:bodyPr wrap="square" anchor="ctr">
+            <a:spAutoFit/>
+          </a:bodyPr>
+          <a:lstStyle/>
+          <a:p>
+            <a:pPr algn="l">
+              <a:spcAft>
+                <a:spcPts val="400"/>
+              </a:spcAft>
+            </a:pPr>
+            <a:r>
+              <a:rPr sz="2000" b="1">
+                <a:solidFill>
+                  <a:srgbClr val="8E6F3E"/>
+                </a:solidFill>
+                <a:latin typeface="Calibri"/>
+              </a:rPr>
+              <a:t>AVAILABILITY DURING CHANGE</a:t>
+            </a:r>
+          </a:p>
+        </p:txBody>
+      </p:sp>
+      <p:sp>
+        <p:nvSpPr>
+          <p:cNvPr id="11" name="RowBody"/>
+          <p:cNvSpPr txBox="1"/>
+          <p:nvPr/>
+        </p:nvSpPr>
+        <p:spPr>
+          <a:xfrm>
+            <a:off x="3246120" y="3840480"/>
+            <a:ext cx="5349240" cy="1216152"/>
+          </a:xfrm>
+          <a:prstGeom prst="rect">
+            <a:avLst/>
+          </a:prstGeom>
+          <a:noFill/>
+        </p:spPr>
+        <p:txBody>
+          <a:bodyPr wrap="square">
+            <a:spAutoFit/>
+          </a:bodyPr>
+          <a:lstStyle/>
+          <a:p>
+            <a:pPr algn="l">
+              <a:spcAft>
+                <a:spcPts val="200"/>
+              </a:spcAft>
+            </a:pPr>
+            <a:r>
+              <a:rPr sz="2000" b="1">
+                <a:solidFill>
+                  <a:srgbClr val="5C4826"/>
+                </a:solidFill>
+                <a:latin typeface="Calibri"/>
+              </a:rPr>
+              <a:t>Can the old version keep operating mid-migration?</a:t>
+            </a:r>
+          </a:p>
+          <a:p>
+            <a:pPr algn="l">
+              <a:spcAft>
+                <a:spcPts val="400"/>
+              </a:spcAft>
+            </a:pPr>
+            <a:r>
+              <a:rPr sz="2000" b="0">
+                <a:solidFill>
+                  <a:srgbClr val="555960"/>
+                </a:solidFill>
+                <a:latin typeface="Calibri"/>
+              </a:rPr>
+              <a:t>Expand → migrate → contract: add the new shape, move, then retire the old</a:t>
+            </a:r>
+          </a:p>
+        </p:txBody>
+      </p:sp>
+      <p:sp>
+        <p:nvSpPr>
+          <p:cNvPr id="12" name="FooterBand"/>
+          <p:cNvSpPr/>
+          <p:nvPr/>
+        </p:nvSpPr>
+        <p:spPr>
+          <a:xfrm>
+            <a:off x="274320" y="5879592"/>
+            <a:ext cx="8595360" cy="502920"/>
+          </a:xfrm>
+          <a:prstGeom prst="rect">
+            <a:avLst/>
+          </a:prstGeom>
+          <a:solidFill>
+            <a:srgbClr val="8E6F3E"/>
+          </a:solidFill>
+          <a:ln>
+            <a:noFill/>
+          </a:ln>
+          <a:effectLst/>
+        </p:spPr>
+        <p:style>
+          <a:lnRef idx="1">
+            <a:schemeClr val="accent1"/>
+          </a:lnRef>
+          <a:fillRef idx="3">
+            <a:schemeClr val="accent1"/>
+          </a:fillRef>
+          <a:effectRef idx="2">
+            <a:schemeClr val="accent1"/>
+          </a:effectRef>
+          <a:fontRef idx="minor">
+            <a:schemeClr val="lt1"/>
+          </a:fontRef>
+        </p:style>
+        <p:txBody>
+          <a:bodyPr rtlCol="0" anchor="ctr" wrap="square"/>
+          <a:lstStyle/>
+          <a:p>
+            <a:pPr algn="ctr"/>
+          </a:p>
+        </p:txBody>
+      </p:sp>
+      <p:sp>
+        <p:nvSpPr>
+          <p:cNvPr id="13" name="FooterBandText"/>
+          <p:cNvSpPr txBox="1"/>
+          <p:nvPr/>
+        </p:nvSpPr>
+        <p:spPr>
+          <a:xfrm>
+            <a:off x="384048" y="5897880"/>
+            <a:ext cx="8375904" cy="457200"/>
+          </a:xfrm>
+          <a:prstGeom prst="rect">
+            <a:avLst/>
+          </a:prstGeom>
+          <a:noFill/>
+        </p:spPr>
+        <p:txBody>
+          <a:bodyPr wrap="square">
+            <a:spAutoFit/>
+          </a:bodyPr>
+          <a:lstStyle/>
+          <a:p>
+            <a:pPr algn="ctr">
+              <a:spcAft>
+                <a:spcPts val="400"/>
+              </a:spcAft>
+            </a:pPr>
+            <a:r>
+              <a:rPr sz="2000" b="1">
+                <a:solidFill>
+                  <a:srgbClr val="FFFFFF"/>
+                </a:solidFill>
+                <a:latin typeface="Calibri"/>
+              </a:rPr>
+              <a:t>A migration is a deployment of the data model — not a flag day</a:t>
+            </a:r>
+          </a:p>
+        </p:txBody>
+      </p:sp>
+    </p:spTree>
+  </p:cSld>
+  <p:clrMapOvr>
+    <a:masterClrMapping/>
+  </p:clrMapOvr>
+</p:sld>
+</file>
+
+<file path=ppt/slides/slide26.xml><?xml version="1.0" encoding="utf-8"?>
+<p:sld xmlns:a="http://schemas.openxmlformats.org/drawingml/2006/main" xmlns:p="http://schemas.openxmlformats.org/presentationml/2006/main" xmlns:r="http://schemas.openxmlformats.org/officeDocument/2006/relationships">
+  <p:cSld>
+    <p:spTree>
+      <p:nvGrpSpPr>
+        <p:cNvPr id="1" name=""/>
+        <p:cNvGrpSpPr/>
+        <p:nvPr/>
+      </p:nvGrpSpPr>
+      <p:grpSpPr/>
+      <p:sp>
+        <p:nvSpPr>
+          <p:cNvPr id="2" name="Title"/>
+          <p:cNvSpPr txBox="1"/>
+          <p:nvPr/>
+        </p:nvSpPr>
+        <p:spPr>
+          <a:xfrm>
+            <a:off x="274320" y="128016"/>
+            <a:ext cx="8595360" cy="594360"/>
+          </a:xfrm>
+          <a:prstGeom prst="rect">
+            <a:avLst/>
+          </a:prstGeom>
+          <a:noFill/>
+        </p:spPr>
+        <p:txBody>
+          <a:bodyPr wrap="square">
+            <a:spAutoFit/>
+          </a:bodyPr>
+          <a:lstStyle/>
+          <a:p>
+            <a:pPr algn="l">
+              <a:spcAft>
+                <a:spcPts val="400"/>
+              </a:spcAft>
+            </a:pPr>
+            <a:r>
+              <a:rPr sz="2400" b="0">
+                <a:solidFill>
+                  <a:srgbClr val="2D2D2D"/>
+                </a:solidFill>
+                <a:latin typeface="Calibri"/>
+              </a:rPr>
+              <a:t>Today's decisions through the Act III engineering method</a:t>
+            </a:r>
+          </a:p>
+        </p:txBody>
+      </p:sp>
+      <p:sp>
+        <p:nvSpPr>
+          <p:cNvPr id="3" name="Block"/>
+          <p:cNvSpPr/>
+          <p:nvPr/>
+        </p:nvSpPr>
+        <p:spPr>
+          <a:xfrm>
+            <a:off x="411480" y="1005840"/>
+            <a:ext cx="2468880" cy="640080"/>
+          </a:xfrm>
+          <a:prstGeom prst="rect">
+            <a:avLst/>
+          </a:prstGeom>
+          <a:solidFill>
+            <a:srgbClr val="8E6F3E"/>
+          </a:solidFill>
+          <a:ln>
+            <a:noFill/>
+          </a:ln>
+          <a:effectLst/>
+        </p:spPr>
+        <p:style>
+          <a:lnRef idx="1">
+            <a:schemeClr val="accent1"/>
+          </a:lnRef>
+          <a:fillRef idx="3">
+            <a:schemeClr val="accent1"/>
+          </a:fillRef>
+          <a:effectRef idx="2">
+            <a:schemeClr val="accent1"/>
+          </a:effectRef>
+          <a:fontRef idx="minor">
+            <a:schemeClr val="lt1"/>
+          </a:fontRef>
+        </p:style>
+        <p:txBody>
+          <a:bodyPr rtlCol="0" anchor="ctr" wrap="square"/>
+          <a:lstStyle/>
+          <a:p>
+            <a:pPr algn="ctr">
+              <a:spcAft>
+                <a:spcPts val="0"/>
+              </a:spcAft>
+            </a:pPr>
+            <a:r>
+              <a:rPr sz="2000" b="1">
+                <a:solidFill>
+                  <a:srgbClr val="FFFFFF"/>
+                </a:solidFill>
+                <a:latin typeface="Calibri"/>
+              </a:rPr>
+              <a:t>Problem</a:t>
+            </a:r>
+          </a:p>
+        </p:txBody>
+      </p:sp>
+      <p:sp>
+        <p:nvSpPr>
+          <p:cNvPr id="4" name="Block"/>
+          <p:cNvSpPr/>
+          <p:nvPr/>
+        </p:nvSpPr>
+        <p:spPr>
+          <a:xfrm>
+            <a:off x="3337560" y="1005840"/>
+            <a:ext cx="2468880" cy="640080"/>
+          </a:xfrm>
+          <a:prstGeom prst="rect">
+            <a:avLst/>
+          </a:prstGeom>
+          <a:solidFill>
+            <a:srgbClr val="8E6F3E"/>
+          </a:solidFill>
+          <a:ln>
+            <a:noFill/>
+          </a:ln>
+          <a:effectLst/>
+        </p:spPr>
+        <p:style>
+          <a:lnRef idx="1">
+            <a:schemeClr val="accent1"/>
+          </a:lnRef>
+          <a:fillRef idx="3">
+            <a:schemeClr val="accent1"/>
+          </a:fillRef>
+          <a:effectRef idx="2">
+            <a:schemeClr val="accent1"/>
+          </a:effectRef>
+          <a:fontRef idx="minor">
+            <a:schemeClr val="lt1"/>
+          </a:fontRef>
+        </p:style>
+        <p:txBody>
+          <a:bodyPr rtlCol="0" anchor="ctr" wrap="square"/>
+          <a:lstStyle/>
+          <a:p>
+            <a:pPr algn="ctr">
+              <a:spcAft>
+                <a:spcPts val="0"/>
+              </a:spcAft>
+            </a:pPr>
+            <a:r>
+              <a:rPr sz="2000" b="1">
+                <a:solidFill>
+                  <a:srgbClr val="FFFFFF"/>
+                </a:solidFill>
+                <a:latin typeface="Calibri"/>
+              </a:rPr>
+              <a:t>Model</a:t>
+            </a:r>
+          </a:p>
+        </p:txBody>
+      </p:sp>
+      <p:sp>
+        <p:nvSpPr>
+          <p:cNvPr id="5" name="Block"/>
+          <p:cNvSpPr/>
+          <p:nvPr/>
+        </p:nvSpPr>
+        <p:spPr>
+          <a:xfrm>
+            <a:off x="6263640" y="1005840"/>
+            <a:ext cx="2468880" cy="640080"/>
+          </a:xfrm>
+          <a:prstGeom prst="rect">
+            <a:avLst/>
+          </a:prstGeom>
+          <a:solidFill>
+            <a:srgbClr val="8E6F3E"/>
+          </a:solidFill>
+          <a:ln>
+            <a:noFill/>
+          </a:ln>
+          <a:effectLst/>
+        </p:spPr>
+        <p:style>
+          <a:lnRef idx="1">
+            <a:schemeClr val="accent1"/>
+          </a:lnRef>
+          <a:fillRef idx="3">
+            <a:schemeClr val="accent1"/>
+          </a:fillRef>
+          <a:effectRef idx="2">
+            <a:schemeClr val="accent1"/>
+          </a:effectRef>
+          <a:fontRef idx="minor">
+            <a:schemeClr val="lt1"/>
+          </a:fontRef>
+        </p:style>
+        <p:txBody>
+          <a:bodyPr rtlCol="0" anchor="ctr" wrap="square"/>
+          <a:lstStyle/>
+          <a:p>
+            <a:pPr algn="ctr">
+              <a:spcAft>
+                <a:spcPts val="0"/>
+              </a:spcAft>
+            </a:pPr>
+            <a:r>
+              <a:rPr sz="2000" b="1">
+                <a:solidFill>
+                  <a:srgbClr val="FFFFFF"/>
+                </a:solidFill>
+                <a:latin typeface="Calibri"/>
+              </a:rPr>
+              <a:t>Judgment</a:t>
+            </a:r>
+          </a:p>
+        </p:txBody>
+      </p:sp>
+      <p:sp>
+        <p:nvSpPr>
+          <p:cNvPr id="6" name="Arrow"/>
+          <p:cNvSpPr/>
+          <p:nvPr/>
+        </p:nvSpPr>
+        <p:spPr>
+          <a:xfrm>
+            <a:off x="2907792" y="1225296"/>
+            <a:ext cx="402336" cy="201168"/>
+          </a:xfrm>
+          <a:prstGeom prst="rightArrow">
+            <a:avLst/>
+          </a:prstGeom>
+          <a:solidFill>
+            <a:srgbClr val="8E6F3E"/>
+          </a:solidFill>
+          <a:ln>
+            <a:noFill/>
+          </a:ln>
+          <a:effectLst/>
+        </p:spPr>
+        <p:style>
+          <a:lnRef idx="1">
+            <a:schemeClr val="accent1"/>
+          </a:lnRef>
+          <a:fillRef idx="3">
+            <a:schemeClr val="accent1"/>
+          </a:fillRef>
+          <a:effectRef idx="2">
+            <a:schemeClr val="accent1"/>
+          </a:effectRef>
+          <a:fontRef idx="minor">
+            <a:schemeClr val="lt1"/>
+          </a:fontRef>
+        </p:style>
+        <p:txBody>
+          <a:bodyPr rtlCol="0" anchor="ctr" wrap="square"/>
+          <a:lstStyle/>
+          <a:p>
+            <a:pPr algn="ctr"/>
+          </a:p>
+        </p:txBody>
+      </p:sp>
+      <p:sp>
+        <p:nvSpPr>
+          <p:cNvPr id="7" name="Arrow"/>
+          <p:cNvSpPr/>
+          <p:nvPr/>
+        </p:nvSpPr>
+        <p:spPr>
+          <a:xfrm>
+            <a:off x="5833872" y="1225296"/>
+            <a:ext cx="402336" cy="201168"/>
+          </a:xfrm>
+          <a:prstGeom prst="rightArrow">
+            <a:avLst/>
+          </a:prstGeom>
+          <a:solidFill>
+            <a:srgbClr val="8E6F3E"/>
+          </a:solidFill>
+          <a:ln>
+            <a:noFill/>
+          </a:ln>
+          <a:effectLst/>
+        </p:spPr>
+        <p:style>
+          <a:lnRef idx="1">
+            <a:schemeClr val="accent1"/>
+          </a:lnRef>
+          <a:fillRef idx="3">
+            <a:schemeClr val="accent1"/>
+          </a:fillRef>
+          <a:effectRef idx="2">
+            <a:schemeClr val="accent1"/>
+          </a:effectRef>
+          <a:fontRef idx="minor">
+            <a:schemeClr val="lt1"/>
+          </a:fontRef>
+        </p:style>
+        <p:txBody>
+          <a:bodyPr rtlCol="0" anchor="ctr" wrap="square"/>
+          <a:lstStyle/>
+          <a:p>
+            <a:pPr algn="ctr"/>
+          </a:p>
+        </p:txBody>
+      </p:sp>
+      <p:sp>
+        <p:nvSpPr>
+          <p:cNvPr id="8" name="Arrow"/>
+          <p:cNvSpPr/>
+          <p:nvPr/>
+        </p:nvSpPr>
+        <p:spPr>
+          <a:xfrm>
+            <a:off x="7315200" y="1700784"/>
+            <a:ext cx="365760" cy="530352"/>
+          </a:xfrm>
+          <a:prstGeom prst="downArrow">
+            <a:avLst/>
+          </a:prstGeom>
+          <a:solidFill>
+            <a:srgbClr val="8E6F3E"/>
+          </a:solidFill>
+          <a:ln>
+            <a:noFill/>
+          </a:ln>
+          <a:effectLst/>
+        </p:spPr>
+        <p:style>
+          <a:lnRef idx="1">
+            <a:schemeClr val="accent1"/>
+          </a:lnRef>
+          <a:fillRef idx="3">
+            <a:schemeClr val="accent1"/>
+          </a:fillRef>
+          <a:effectRef idx="2">
+            <a:schemeClr val="accent1"/>
+          </a:effectRef>
+          <a:fontRef idx="minor">
+            <a:schemeClr val="lt1"/>
+          </a:fontRef>
+        </p:style>
+        <p:txBody>
+          <a:bodyPr rtlCol="0" anchor="ctr" wrap="square"/>
+          <a:lstStyle/>
+          <a:p>
+            <a:pPr algn="ctr"/>
+          </a:p>
+        </p:txBody>
+      </p:sp>
+      <p:sp>
+        <p:nvSpPr>
+          <p:cNvPr id="9" name="Block"/>
+          <p:cNvSpPr/>
+          <p:nvPr/>
+        </p:nvSpPr>
+        <p:spPr>
+          <a:xfrm>
+            <a:off x="6263640" y="2286000"/>
+            <a:ext cx="2468880" cy="640080"/>
+          </a:xfrm>
+          <a:prstGeom prst="rect">
+            <a:avLst/>
+          </a:prstGeom>
+          <a:solidFill>
+            <a:srgbClr val="8E6F3E"/>
+          </a:solidFill>
+          <a:ln>
+            <a:noFill/>
+          </a:ln>
+          <a:effectLst/>
+        </p:spPr>
+        <p:style>
+          <a:lnRef idx="1">
+            <a:schemeClr val="accent1"/>
+          </a:lnRef>
+          <a:fillRef idx="3">
+            <a:schemeClr val="accent1"/>
+          </a:fillRef>
+          <a:effectRef idx="2">
+            <a:schemeClr val="accent1"/>
+          </a:effectRef>
+          <a:fontRef idx="minor">
+            <a:schemeClr val="lt1"/>
+          </a:fontRef>
+        </p:style>
+        <p:txBody>
+          <a:bodyPr rtlCol="0" anchor="ctr" wrap="square"/>
+          <a:lstStyle/>
+          <a:p>
+            <a:pPr algn="ctr">
+              <a:spcAft>
+                <a:spcPts val="0"/>
+              </a:spcAft>
+            </a:pPr>
+            <a:r>
+              <a:rPr sz="2000" b="1">
+                <a:solidFill>
+                  <a:srgbClr val="FFFFFF"/>
+                </a:solidFill>
+                <a:latin typeface="Calibri"/>
+              </a:rPr>
+              <a:t>Realize</a:t>
+            </a:r>
+          </a:p>
+        </p:txBody>
+      </p:sp>
+      <p:sp>
+        <p:nvSpPr>
+          <p:cNvPr id="10" name="Block"/>
+          <p:cNvSpPr/>
+          <p:nvPr/>
+        </p:nvSpPr>
+        <p:spPr>
+          <a:xfrm>
+            <a:off x="3337560" y="2286000"/>
+            <a:ext cx="2468880" cy="640080"/>
+          </a:xfrm>
+          <a:prstGeom prst="rect">
+            <a:avLst/>
+          </a:prstGeom>
+          <a:solidFill>
+            <a:srgbClr val="8E6F3E"/>
+          </a:solidFill>
+          <a:ln>
+            <a:noFill/>
+          </a:ln>
+          <a:effectLst/>
+        </p:spPr>
+        <p:style>
+          <a:lnRef idx="1">
+            <a:schemeClr val="accent1"/>
+          </a:lnRef>
+          <a:fillRef idx="3">
+            <a:schemeClr val="accent1"/>
+          </a:fillRef>
+          <a:effectRef idx="2">
+            <a:schemeClr val="accent1"/>
+          </a:effectRef>
+          <a:fontRef idx="minor">
+            <a:schemeClr val="lt1"/>
+          </a:fontRef>
+        </p:style>
+        <p:txBody>
+          <a:bodyPr rtlCol="0" anchor="ctr" wrap="square"/>
+          <a:lstStyle/>
+          <a:p>
+            <a:pPr algn="ctr">
+              <a:spcAft>
+                <a:spcPts val="0"/>
+              </a:spcAft>
+            </a:pPr>
+            <a:r>
+              <a:rPr sz="2000" b="1">
+                <a:solidFill>
+                  <a:srgbClr val="FFFFFF"/>
+                </a:solidFill>
+                <a:latin typeface="Calibri"/>
+              </a:rPr>
+              <a:t>Evidence</a:t>
+            </a:r>
+          </a:p>
+        </p:txBody>
+      </p:sp>
+      <p:sp>
+        <p:nvSpPr>
+          <p:cNvPr id="11" name="Block"/>
+          <p:cNvSpPr/>
+          <p:nvPr/>
+        </p:nvSpPr>
+        <p:spPr>
+          <a:xfrm>
+            <a:off x="411480" y="2286000"/>
+            <a:ext cx="2468880" cy="640080"/>
+          </a:xfrm>
+          <a:prstGeom prst="rect">
+            <a:avLst/>
+          </a:prstGeom>
+          <a:solidFill>
+            <a:srgbClr val="8E6F3E"/>
+          </a:solidFill>
+          <a:ln>
+            <a:noFill/>
+          </a:ln>
+          <a:effectLst/>
+        </p:spPr>
+        <p:style>
+          <a:lnRef idx="1">
+            <a:schemeClr val="accent1"/>
+          </a:lnRef>
+          <a:fillRef idx="3">
+            <a:schemeClr val="accent1"/>
+          </a:fillRef>
+          <a:effectRef idx="2">
+            <a:schemeClr val="accent1"/>
+          </a:effectRef>
+          <a:fontRef idx="minor">
+            <a:schemeClr val="lt1"/>
+          </a:fontRef>
+        </p:style>
+        <p:txBody>
+          <a:bodyPr rtlCol="0" anchor="ctr" wrap="square"/>
+          <a:lstStyle/>
+          <a:p>
+            <a:pPr algn="ctr">
+              <a:spcAft>
+                <a:spcPts val="0"/>
+              </a:spcAft>
+            </a:pPr>
+            <a:r>
+              <a:rPr sz="2000" b="1">
+                <a:solidFill>
+                  <a:srgbClr val="FFFFFF"/>
+                </a:solidFill>
+                <a:latin typeface="Calibri"/>
+              </a:rPr>
+              <a:t>Accept / reject</a:t>
+            </a:r>
+          </a:p>
+        </p:txBody>
+      </p:sp>
+      <p:sp>
+        <p:nvSpPr>
+          <p:cNvPr id="12" name="Arrow"/>
+          <p:cNvSpPr/>
+          <p:nvPr/>
+        </p:nvSpPr>
+        <p:spPr>
+          <a:xfrm>
+            <a:off x="5833872" y="2505456"/>
+            <a:ext cx="402336" cy="201168"/>
+          </a:xfrm>
+          <a:prstGeom prst="leftArrow">
+            <a:avLst/>
+          </a:prstGeom>
+          <a:solidFill>
+            <a:srgbClr val="8E6F3E"/>
+          </a:solidFill>
+          <a:ln>
+            <a:noFill/>
+          </a:ln>
+          <a:effectLst/>
+        </p:spPr>
+        <p:style>
+          <a:lnRef idx="1">
+            <a:schemeClr val="accent1"/>
+          </a:lnRef>
+          <a:fillRef idx="3">
+            <a:schemeClr val="accent1"/>
+          </a:fillRef>
+          <a:effectRef idx="2">
+            <a:schemeClr val="accent1"/>
+          </a:effectRef>
+          <a:fontRef idx="minor">
+            <a:schemeClr val="lt1"/>
+          </a:fontRef>
+        </p:style>
+        <p:txBody>
+          <a:bodyPr rtlCol="0" anchor="ctr" wrap="square"/>
+          <a:lstStyle/>
+          <a:p>
+            <a:pPr algn="ctr"/>
+          </a:p>
+        </p:txBody>
+      </p:sp>
+      <p:sp>
+        <p:nvSpPr>
+          <p:cNvPr id="13" name="Arrow"/>
+          <p:cNvSpPr/>
+          <p:nvPr/>
+        </p:nvSpPr>
+        <p:spPr>
+          <a:xfrm>
+            <a:off x="2907792" y="2505456"/>
+            <a:ext cx="402336" cy="201168"/>
+          </a:xfrm>
+          <a:prstGeom prst="leftArrow">
+            <a:avLst/>
+          </a:prstGeom>
+          <a:solidFill>
+            <a:srgbClr val="8E6F3E"/>
+          </a:solidFill>
+          <a:ln>
+            <a:noFill/>
+          </a:ln>
+          <a:effectLst/>
+        </p:spPr>
+        <p:style>
+          <a:lnRef idx="1">
+            <a:schemeClr val="accent1"/>
+          </a:lnRef>
+          <a:fillRef idx="3">
+            <a:schemeClr val="accent1"/>
+          </a:fillRef>
+          <a:effectRef idx="2">
+            <a:schemeClr val="accent1"/>
+          </a:effectRef>
+          <a:fontRef idx="minor">
+            <a:schemeClr val="lt1"/>
+          </a:fontRef>
+        </p:style>
+        <p:txBody>
+          <a:bodyPr rtlCol="0" anchor="ctr" wrap="square"/>
+          <a:lstStyle/>
+          <a:p>
+            <a:pPr algn="ctr"/>
+          </a:p>
+        </p:txBody>
+      </p:sp>
+      <p:sp>
+        <p:nvSpPr>
+          <p:cNvPr id="14" name="Block"/>
+          <p:cNvSpPr/>
+          <p:nvPr/>
+        </p:nvSpPr>
+        <p:spPr>
+          <a:xfrm>
+            <a:off x="411480" y="3383280"/>
+            <a:ext cx="8321040" cy="566928"/>
+          </a:xfrm>
+          <a:prstGeom prst="rect">
+            <a:avLst/>
+          </a:prstGeom>
+          <a:solidFill>
+            <a:srgbClr val="FCFAF6"/>
+          </a:solidFill>
+          <a:ln>
+            <a:noFill/>
+          </a:ln>
+          <a:effectLst/>
+        </p:spPr>
+        <p:style>
+          <a:lnRef idx="1">
+            <a:schemeClr val="accent1"/>
+          </a:lnRef>
+          <a:fillRef idx="3">
+            <a:schemeClr val="accent1"/>
+          </a:fillRef>
+          <a:effectRef idx="2">
+            <a:schemeClr val="accent1"/>
+          </a:effectRef>
+          <a:fontRef idx="minor">
+            <a:schemeClr val="lt1"/>
+          </a:fontRef>
+        </p:style>
+        <p:txBody>
+          <a:bodyPr rtlCol="0" anchor="ctr" wrap="square"/>
+          <a:lstStyle/>
+          <a:p>
+            <a:pPr algn="ctr">
+              <a:spcAft>
+                <a:spcPts val="0"/>
+              </a:spcAft>
+            </a:pPr>
+            <a:r>
+              <a:rPr sz="2000" b="1">
+                <a:solidFill>
+                  <a:srgbClr val="8E6F3E"/>
+                </a:solidFill>
+                <a:latin typeface="Calibri"/>
+              </a:rPr>
+              <a:t>ALIGNMENT — alongside every step: constraints, checks, admission decisions</a:t>
+            </a:r>
+          </a:p>
+        </p:txBody>
+      </p:sp>
+      <p:cxnSp>
+        <p:nvCxnSpPr>
+          <p:cNvPr id="15" name="AlignLink"/>
+          <p:cNvCxnSpPr/>
+          <p:nvPr/>
+        </p:nvCxnSpPr>
+        <p:spPr>
+          <a:xfrm>
+            <a:off x="1645920" y="2926080"/>
+            <a:ext cx="0" cy="457200"/>
+          </a:xfrm>
+          <a:prstGeom prst="line">
+            <a:avLst/>
+          </a:prstGeom>
+          <a:ln w="31750">
+            <a:solidFill>
+              <a:srgbClr val="8E6F3E"/>
+            </a:solidFill>
+          </a:ln>
+        </p:spPr>
+        <p:style>
+          <a:lnRef idx="2">
+            <a:schemeClr val="accent1"/>
+          </a:lnRef>
+          <a:fillRef idx="0">
+            <a:schemeClr val="accent1"/>
+          </a:fillRef>
+          <a:effectRef idx="1">
+            <a:schemeClr val="accent1"/>
+          </a:effectRef>
+          <a:fontRef idx="minor">
+            <a:schemeClr val="tx1"/>
+          </a:fontRef>
+        </p:style>
+      </p:cxnSp>
+      <p:cxnSp>
+        <p:nvCxnSpPr>
+          <p:cNvPr id="16" name="AlignLink"/>
+          <p:cNvCxnSpPr/>
+          <p:nvPr/>
+        </p:nvCxnSpPr>
+        <p:spPr>
+          <a:xfrm>
+            <a:off x="7498079" y="2926080"/>
+            <a:ext cx="0" cy="457200"/>
+          </a:xfrm>
+          <a:prstGeom prst="line">
+            <a:avLst/>
+          </a:prstGeom>
+          <a:ln w="31750">
+            <a:solidFill>
+              <a:srgbClr val="8E6F3E"/>
+            </a:solidFill>
+          </a:ln>
+        </p:spPr>
+        <p:style>
+          <a:lnRef idx="2">
+            <a:schemeClr val="accent1"/>
+          </a:lnRef>
+          <a:fillRef idx="0">
+            <a:schemeClr val="accent1"/>
+          </a:fillRef>
+          <a:effectRef idx="1">
+            <a:schemeClr val="accent1"/>
+          </a:effectRef>
+          <a:fontRef idx="minor">
+            <a:schemeClr val="tx1"/>
+          </a:fontRef>
+        </p:style>
+      </p:cxnSp>
+      <p:sp>
+        <p:nvSpPr>
+          <p:cNvPr id="17" name="Card"/>
+          <p:cNvSpPr/>
+          <p:nvPr/>
+        </p:nvSpPr>
+        <p:spPr>
+          <a:xfrm>
+            <a:off x="411480" y="4224528"/>
+            <a:ext cx="8321040" cy="1444752"/>
+          </a:xfrm>
+          <a:prstGeom prst="rect">
+            <a:avLst/>
+          </a:prstGeom>
+          <a:solidFill>
+            <a:srgbClr val="F5F1E8"/>
+          </a:solidFill>
+          <a:ln>
+            <a:noFill/>
+          </a:ln>
+          <a:effectLst/>
+        </p:spPr>
+        <p:style>
+          <a:lnRef idx="1">
+            <a:schemeClr val="accent1"/>
+          </a:lnRef>
+          <a:fillRef idx="3">
+            <a:schemeClr val="accent1"/>
+          </a:fillRef>
+          <a:effectRef idx="2">
+            <a:schemeClr val="accent1"/>
+          </a:effectRef>
+          <a:fontRef idx="minor">
+            <a:schemeClr val="lt1"/>
+          </a:fontRef>
+        </p:style>
+        <p:txBody>
+          <a:bodyPr rtlCol="0" anchor="ctr" wrap="square"/>
+          <a:lstStyle/>
+          <a:p>
+            <a:pPr algn="ctr"/>
+          </a:p>
+        </p:txBody>
+      </p:sp>
+      <p:sp>
+        <p:nvSpPr>
+          <p:cNvPr id="18" name="CardBody"/>
+          <p:cNvSpPr txBox="1"/>
+          <p:nvPr/>
+        </p:nvSpPr>
+        <p:spPr>
+          <a:xfrm>
+            <a:off x="557784" y="4297680"/>
+            <a:ext cx="8046720" cy="1298448"/>
+          </a:xfrm>
+          <a:prstGeom prst="rect">
+            <a:avLst/>
+          </a:prstGeom>
+          <a:noFill/>
+        </p:spPr>
+        <p:txBody>
+          <a:bodyPr wrap="square">
+            <a:spAutoFit/>
+          </a:bodyPr>
+          <a:lstStyle/>
+          <a:p>
+            <a:pPr algn="l">
+              <a:spcAft>
+                <a:spcPts val="200"/>
+              </a:spcAft>
+            </a:pPr>
+            <a:r>
+              <a:rPr sz="2000" b="1">
+                <a:solidFill>
+                  <a:srgbClr val="5C4826"/>
+                </a:solidFill>
+                <a:latin typeface="Calibri"/>
+              </a:rPr>
+              <a:t>Today's pass</a:t>
+            </a:r>
+          </a:p>
+          <a:p>
+            <a:pPr algn="l">
+              <a:spcAft>
+                <a:spcPts val="400"/>
+              </a:spcAft>
+            </a:pPr>
+            <a:r>
+              <a:rPr sz="2000" b="0">
+                <a:solidFill>
+                  <a:srgbClr val="555960"/>
+                </a:solidFill>
+                <a:latin typeface="Calibri"/>
+              </a:rPr>
+              <a:t>Preserve reservations → ER + schema → relational, normalized → DDL and queries → plans and the race → accept the exclusion constraint. Alignment: the constraint itself.</a:t>
+            </a:r>
+          </a:p>
+        </p:txBody>
+      </p:sp>
+      <p:sp>
+        <p:nvSpPr>
+          <p:cNvPr id="19" name="FooterBand"/>
+          <p:cNvSpPr/>
+          <p:nvPr/>
+        </p:nvSpPr>
+        <p:spPr>
+          <a:xfrm>
+            <a:off x="274320" y="5879592"/>
+            <a:ext cx="8595360" cy="502920"/>
+          </a:xfrm>
+          <a:prstGeom prst="rect">
+            <a:avLst/>
+          </a:prstGeom>
+          <a:solidFill>
+            <a:srgbClr val="8E6F3E"/>
+          </a:solidFill>
+          <a:ln>
+            <a:noFill/>
+          </a:ln>
+          <a:effectLst/>
+        </p:spPr>
+        <p:style>
+          <a:lnRef idx="1">
+            <a:schemeClr val="accent1"/>
+          </a:lnRef>
+          <a:fillRef idx="3">
+            <a:schemeClr val="accent1"/>
+          </a:fillRef>
+          <a:effectRef idx="2">
+            <a:schemeClr val="accent1"/>
+          </a:effectRef>
+          <a:fontRef idx="minor">
+            <a:schemeClr val="lt1"/>
+          </a:fontRef>
+        </p:style>
+        <p:txBody>
+          <a:bodyPr rtlCol="0" anchor="ctr" wrap="square"/>
+          <a:lstStyle/>
+          <a:p>
+            <a:pPr algn="ctr"/>
+          </a:p>
+        </p:txBody>
+      </p:sp>
+      <p:sp>
+        <p:nvSpPr>
+          <p:cNvPr id="20" name="FooterBandText"/>
+          <p:cNvSpPr txBox="1"/>
+          <p:nvPr/>
+        </p:nvSpPr>
+        <p:spPr>
+          <a:xfrm>
+            <a:off x="384048" y="5897880"/>
+            <a:ext cx="8375904" cy="457200"/>
+          </a:xfrm>
+          <a:prstGeom prst="rect">
+            <a:avLst/>
+          </a:prstGeom>
+          <a:noFill/>
+        </p:spPr>
+        <p:txBody>
+          <a:bodyPr wrap="square">
+            <a:spAutoFit/>
+          </a:bodyPr>
+          <a:lstStyle/>
+          <a:p>
+            <a:pPr algn="ctr">
+              <a:spcAft>
+                <a:spcPts val="400"/>
+              </a:spcAft>
+            </a:pPr>
+            <a:r>
+              <a:rPr sz="2000" b="1">
+                <a:solidFill>
+                  <a:srgbClr val="FFFFFF"/>
+                </a:solidFill>
+                <a:latin typeface="Calibri"/>
+              </a:rPr>
+              <a:t>The same method as Tuesday — different models, same discipline</a:t>
+            </a:r>
+          </a:p>
+        </p:txBody>
+      </p:sp>
+    </p:spTree>
+  </p:cSld>
+  <p:clrMapOvr>
+    <a:masterClrMapping/>
+  </p:clrMapOvr>
+</p:sld>
+</file>
+
+<file path=ppt/slides/slide27.xml><?xml version="1.0" encoding="utf-8"?>
+<p:sld xmlns:a="http://schemas.openxmlformats.org/drawingml/2006/main" xmlns:p="http://schemas.openxmlformats.org/presentationml/2006/main" xmlns:r="http://schemas.openxmlformats.org/officeDocument/2006/relationships">
+  <p:cSld>
+    <p:spTree>
+      <p:nvGrpSpPr>
+        <p:cNvPr id="1" name=""/>
+        <p:cNvGrpSpPr/>
+        <p:nvPr/>
+      </p:nvGrpSpPr>
+      <p:grpSpPr/>
+      <p:sp>
+        <p:nvSpPr>
+          <p:cNvPr id="2" name="Title"/>
+          <p:cNvSpPr txBox="1"/>
+          <p:nvPr/>
+        </p:nvSpPr>
+        <p:spPr>
+          <a:xfrm>
+            <a:off x="274320" y="128016"/>
+            <a:ext cx="8595360" cy="594360"/>
+          </a:xfrm>
+          <a:prstGeom prst="rect">
+            <a:avLst/>
+          </a:prstGeom>
+          <a:noFill/>
+        </p:spPr>
+        <p:txBody>
+          <a:bodyPr wrap="square">
+            <a:spAutoFit/>
+          </a:bodyPr>
+          <a:lstStyle/>
+          <a:p>
+            <a:pPr algn="l">
+              <a:spcAft>
+                <a:spcPts val="400"/>
+              </a:spcAft>
+            </a:pPr>
+            <a:r>
+              <a:rPr sz="2400" b="0">
+                <a:solidFill>
+                  <a:srgbClr val="2D2D2D"/>
+                </a:solidFill>
+                <a:latin typeface="Calibri"/>
+              </a:rPr>
+              <a:t>We have a working system — how easily can we change it?</a:t>
+            </a:r>
+          </a:p>
+        </p:txBody>
+      </p:sp>
+      <p:sp>
+        <p:nvSpPr>
+          <p:cNvPr id="3" name="Card"/>
+          <p:cNvSpPr/>
+          <p:nvPr/>
+        </p:nvSpPr>
+        <p:spPr>
+          <a:xfrm>
+            <a:off x="411480" y="960120"/>
+            <a:ext cx="4069080" cy="2788920"/>
+          </a:xfrm>
+          <a:prstGeom prst="rect">
+            <a:avLst/>
+          </a:prstGeom>
+          <a:solidFill>
+            <a:srgbClr val="F5F1E8"/>
+          </a:solidFill>
+          <a:ln>
+            <a:noFill/>
+          </a:ln>
+          <a:effectLst/>
+        </p:spPr>
+        <p:style>
+          <a:lnRef idx="1">
+            <a:schemeClr val="accent1"/>
+          </a:lnRef>
+          <a:fillRef idx="3">
+            <a:schemeClr val="accent1"/>
+          </a:fillRef>
+          <a:effectRef idx="2">
+            <a:schemeClr val="accent1"/>
+          </a:effectRef>
+          <a:fontRef idx="minor">
+            <a:schemeClr val="lt1"/>
+          </a:fontRef>
+        </p:style>
+        <p:txBody>
+          <a:bodyPr rtlCol="0" anchor="ctr" wrap="square"/>
+          <a:lstStyle/>
+          <a:p>
+            <a:pPr algn="ctr"/>
+          </a:p>
+        </p:txBody>
+      </p:sp>
+      <p:sp>
+        <p:nvSpPr>
+          <p:cNvPr id="4" name="CardBody"/>
+          <p:cNvSpPr txBox="1"/>
+          <p:nvPr/>
+        </p:nvSpPr>
+        <p:spPr>
+          <a:xfrm>
+            <a:off x="557784" y="1051560"/>
+            <a:ext cx="3776472" cy="2606040"/>
+          </a:xfrm>
+          <a:prstGeom prst="rect">
+            <a:avLst/>
+          </a:prstGeom>
+          <a:noFill/>
+        </p:spPr>
+        <p:txBody>
+          <a:bodyPr wrap="square">
+            <a:spAutoFit/>
+          </a:bodyPr>
+          <a:lstStyle/>
+          <a:p>
+            <a:pPr algn="l">
+              <a:spcAft>
+                <a:spcPts val="500"/>
+              </a:spcAft>
+            </a:pPr>
+            <a:r>
+              <a:rPr sz="2000" b="1">
+                <a:solidFill>
+                  <a:srgbClr val="8E6F3E"/>
+                </a:solidFill>
+                <a:latin typeface="Calibri"/>
+              </a:rPr>
+              <a:t>WHAT WE NOW HOLD</a:t>
+            </a:r>
+          </a:p>
+          <a:p>
+            <a:pPr algn="l">
+              <a:spcAft>
+                <a:spcPts val="400"/>
+              </a:spcAft>
+            </a:pPr>
+            <a:r>
+              <a:rPr sz="2000" b="0">
+                <a:solidFill>
+                  <a:srgbClr val="5C4826"/>
+                </a:solidFill>
+                <a:latin typeface="Calibri"/>
+              </a:rPr>
+              <a:t>Reservations survive restarts</a:t>
+            </a:r>
+          </a:p>
+          <a:p>
+            <a:pPr algn="l">
+              <a:spcAft>
+                <a:spcPts val="400"/>
+              </a:spcAft>
+            </a:pPr>
+            <a:r>
+              <a:rPr sz="2000" b="0">
+                <a:solidFill>
+                  <a:srgbClr val="5C4826"/>
+                </a:solidFill>
+                <a:latin typeface="Calibri"/>
+              </a:rPr>
+              <a:t>One authoritative, shared copy</a:t>
+            </a:r>
+          </a:p>
+          <a:p>
+            <a:pPr algn="l">
+              <a:spcAft>
+                <a:spcPts val="400"/>
+              </a:spcAft>
+            </a:pPr>
+            <a:r>
+              <a:rPr sz="2000" b="0">
+                <a:solidFill>
+                  <a:srgbClr val="5C4826"/>
+                </a:solidFill>
+                <a:latin typeface="Calibri"/>
+              </a:rPr>
+              <a:t>The invariant has an enforced home</a:t>
+            </a:r>
+          </a:p>
+          <a:p>
+            <a:pPr algn="l">
+              <a:spcAft>
+                <a:spcPts val="400"/>
+              </a:spcAft>
+            </a:pPr>
+            <a:r>
+              <a:rPr sz="2000" b="0">
+                <a:solidFill>
+                  <a:srgbClr val="5C4826"/>
+                </a:solidFill>
+                <a:latin typeface="Calibri"/>
+              </a:rPr>
+              <a:t>Known, chosen costs</a:t>
+            </a:r>
+          </a:p>
+        </p:txBody>
+      </p:sp>
+      <p:sp>
+        <p:nvSpPr>
+          <p:cNvPr id="5" name="Card"/>
+          <p:cNvSpPr/>
+          <p:nvPr/>
+        </p:nvSpPr>
+        <p:spPr>
+          <a:xfrm>
+            <a:off x="4663440" y="960120"/>
+            <a:ext cx="4069080" cy="2788920"/>
+          </a:xfrm>
+          <a:prstGeom prst="rect">
+            <a:avLst/>
+          </a:prstGeom>
+          <a:solidFill>
+            <a:srgbClr val="FCFAF6"/>
+          </a:solidFill>
+          <a:ln>
+            <a:noFill/>
+          </a:ln>
+          <a:effectLst/>
+        </p:spPr>
+        <p:style>
+          <a:lnRef idx="1">
+            <a:schemeClr val="accent1"/>
+          </a:lnRef>
+          <a:fillRef idx="3">
+            <a:schemeClr val="accent1"/>
+          </a:fillRef>
+          <a:effectRef idx="2">
+            <a:schemeClr val="accent1"/>
+          </a:effectRef>
+          <a:fontRef idx="minor">
+            <a:schemeClr val="lt1"/>
+          </a:fontRef>
+        </p:style>
+        <p:txBody>
+          <a:bodyPr rtlCol="0" anchor="ctr" wrap="square"/>
+          <a:lstStyle/>
+          <a:p>
+            <a:pPr algn="ctr"/>
+          </a:p>
+        </p:txBody>
+      </p:sp>
+      <p:sp>
+        <p:nvSpPr>
+          <p:cNvPr id="6" name="CardBody"/>
+          <p:cNvSpPr txBox="1"/>
+          <p:nvPr/>
+        </p:nvSpPr>
+        <p:spPr>
+          <a:xfrm>
+            <a:off x="4809744" y="1051560"/>
+            <a:ext cx="3776472" cy="2606040"/>
+          </a:xfrm>
+          <a:prstGeom prst="rect">
+            <a:avLst/>
+          </a:prstGeom>
+          <a:noFill/>
+        </p:spPr>
+        <p:txBody>
+          <a:bodyPr wrap="square">
+            <a:spAutoFit/>
+          </a:bodyPr>
+          <a:lstStyle/>
+          <a:p>
+            <a:pPr algn="l">
+              <a:spcAft>
+                <a:spcPts val="500"/>
+              </a:spcAft>
+            </a:pPr>
+            <a:r>
+              <a:rPr sz="2000" b="1">
+                <a:solidFill>
+                  <a:srgbClr val="8E6F3E"/>
+                </a:solidFill>
+                <a:latin typeface="Calibri"/>
+              </a:rPr>
+              <a:t>WHAT WE DO NOT YET KNOW</a:t>
+            </a:r>
+          </a:p>
+          <a:p>
+            <a:pPr algn="l">
+              <a:spcAft>
+                <a:spcPts val="400"/>
+              </a:spcAft>
+            </a:pPr>
+            <a:r>
+              <a:rPr sz="2000" b="0">
+                <a:solidFill>
+                  <a:srgbClr val="5C4826"/>
+                </a:solidFill>
+                <a:latin typeface="Calibri"/>
+              </a:rPr>
+              <a:t>Can the structure absorb change?</a:t>
+            </a:r>
+          </a:p>
+          <a:p>
+            <a:pPr algn="l">
+              <a:spcAft>
+                <a:spcPts val="400"/>
+              </a:spcAft>
+            </a:pPr>
+            <a:r>
+              <a:rPr sz="2000" b="0">
+                <a:solidFill>
+                  <a:srgbClr val="5C4826"/>
+                </a:solidFill>
+                <a:latin typeface="Calibri"/>
+              </a:rPr>
+              <a:t>What did dependencies commit us to?</a:t>
+            </a:r>
+          </a:p>
+          <a:p>
+            <a:pPr algn="l">
+              <a:spcAft>
+                <a:spcPts val="400"/>
+              </a:spcAft>
+            </a:pPr>
+            <a:r>
+              <a:rPr sz="2000" b="0">
+                <a:solidFill>
+                  <a:srgbClr val="5C4826"/>
+                </a:solidFill>
+                <a:latin typeface="Calibri"/>
+              </a:rPr>
+              <a:t>How does it behave under load?</a:t>
+            </a:r>
+          </a:p>
+        </p:txBody>
+      </p:sp>
+      <p:sp>
+        <p:nvSpPr>
+          <p:cNvPr id="7" name="Card"/>
+          <p:cNvSpPr/>
+          <p:nvPr/>
+        </p:nvSpPr>
+        <p:spPr>
+          <a:xfrm>
+            <a:off x="411480" y="3977639"/>
+            <a:ext cx="8321040" cy="1234440"/>
+          </a:xfrm>
+          <a:prstGeom prst="rect">
+            <a:avLst/>
+          </a:prstGeom>
+          <a:solidFill>
+            <a:srgbClr val="F5F1E8"/>
+          </a:solidFill>
+          <a:ln>
+            <a:noFill/>
+          </a:ln>
+          <a:effectLst/>
+        </p:spPr>
+        <p:style>
+          <a:lnRef idx="1">
+            <a:schemeClr val="accent1"/>
+          </a:lnRef>
+          <a:fillRef idx="3">
+            <a:schemeClr val="accent1"/>
+          </a:fillRef>
+          <a:effectRef idx="2">
+            <a:schemeClr val="accent1"/>
+          </a:effectRef>
+          <a:fontRef idx="minor">
+            <a:schemeClr val="lt1"/>
+          </a:fontRef>
+        </p:style>
+        <p:txBody>
+          <a:bodyPr rtlCol="0" anchor="ctr" wrap="square"/>
+          <a:lstStyle/>
+          <a:p>
+            <a:pPr algn="ctr"/>
+          </a:p>
+        </p:txBody>
+      </p:sp>
+      <p:sp>
+        <p:nvSpPr>
+          <p:cNvPr id="8" name="CardBody"/>
+          <p:cNvSpPr txBox="1"/>
+          <p:nvPr/>
+        </p:nvSpPr>
+        <p:spPr>
+          <a:xfrm>
+            <a:off x="557784" y="4050791"/>
+            <a:ext cx="8046720" cy="1097280"/>
+          </a:xfrm>
+          <a:prstGeom prst="rect">
+            <a:avLst/>
+          </a:prstGeom>
+          <a:noFill/>
+        </p:spPr>
+        <p:txBody>
+          <a:bodyPr wrap="square">
+            <a:spAutoFit/>
+          </a:bodyPr>
+          <a:lstStyle/>
+          <a:p>
+            <a:pPr algn="l">
+              <a:spcAft>
+                <a:spcPts val="300"/>
+              </a:spcAft>
+            </a:pPr>
+            <a:r>
+              <a:rPr sz="2000" b="1">
+                <a:solidFill>
+                  <a:srgbClr val="5C4826"/>
+                </a:solidFill>
+                <a:latin typeface="Calibri"/>
+              </a:rPr>
+              <a:t>Next: Technical Debt, Architecture &amp; Supply Chains</a:t>
+            </a:r>
+          </a:p>
+          <a:p>
+            <a:pPr algn="l">
+              <a:spcAft>
+                <a:spcPts val="400"/>
+              </a:spcAft>
+            </a:pPr>
+            <a:r>
+              <a:rPr sz="2000" b="0">
+                <a:solidFill>
+                  <a:srgbClr val="555960"/>
+                </a:solidFill>
+                <a:latin typeface="Calibri"/>
+              </a:rPr>
+              <a:t>The system's own shape — and everything it inherited — become the object of engineering.</a:t>
+            </a:r>
+          </a:p>
+        </p:txBody>
+      </p:sp>
+      <p:sp>
+        <p:nvSpPr>
+          <p:cNvPr id="9" name="FooterBand"/>
+          <p:cNvSpPr/>
+          <p:nvPr/>
+        </p:nvSpPr>
+        <p:spPr>
+          <a:xfrm>
+            <a:off x="274320" y="5879592"/>
+            <a:ext cx="8595360" cy="502920"/>
+          </a:xfrm>
+          <a:prstGeom prst="rect">
+            <a:avLst/>
+          </a:prstGeom>
+          <a:solidFill>
+            <a:srgbClr val="8E6F3E"/>
+          </a:solidFill>
+          <a:ln>
+            <a:noFill/>
+          </a:ln>
+          <a:effectLst/>
+        </p:spPr>
+        <p:style>
+          <a:lnRef idx="1">
+            <a:schemeClr val="accent1"/>
+          </a:lnRef>
+          <a:fillRef idx="3">
+            <a:schemeClr val="accent1"/>
+          </a:fillRef>
+          <a:effectRef idx="2">
+            <a:schemeClr val="accent1"/>
+          </a:effectRef>
+          <a:fontRef idx="minor">
+            <a:schemeClr val="lt1"/>
+          </a:fontRef>
+        </p:style>
+        <p:txBody>
+          <a:bodyPr rtlCol="0" anchor="ctr" wrap="square"/>
+          <a:lstStyle/>
+          <a:p>
+            <a:pPr algn="ctr"/>
+          </a:p>
+        </p:txBody>
+      </p:sp>
+      <p:sp>
+        <p:nvSpPr>
+          <p:cNvPr id="10" name="FooterBandText"/>
+          <p:cNvSpPr txBox="1"/>
+          <p:nvPr/>
+        </p:nvSpPr>
+        <p:spPr>
+          <a:xfrm>
+            <a:off x="384048" y="5897880"/>
+            <a:ext cx="8375904" cy="457200"/>
+          </a:xfrm>
+          <a:prstGeom prst="rect">
+            <a:avLst/>
+          </a:prstGeom>
+          <a:noFill/>
+        </p:spPr>
+        <p:txBody>
+          <a:bodyPr wrap="square">
+            <a:spAutoFit/>
+          </a:bodyPr>
+          <a:lstStyle/>
+          <a:p>
+            <a:pPr algn="ctr">
+              <a:spcAft>
+                <a:spcPts val="400"/>
+              </a:spcAft>
+            </a:pPr>
+            <a:r>
+              <a:rPr sz="2000" b="1">
+                <a:solidFill>
+                  <a:srgbClr val="FFFFFF"/>
+                </a:solidFill>
+                <a:latin typeface="Calibri"/>
+              </a:rPr>
+              <a:t>From preserving information to changing the system that holds it</a:t>
+            </a:r>
+          </a:p>
+        </p:txBody>
+      </p:sp>
+    </p:spTree>
+  </p:cSld>
+  <p:clrMapOvr>
+    <a:masterClrMapping/>
+  </p:clrMapOvr>
+</p:sld>
+</file>
+
 <file path=ppt/slides/slide3.xml><?xml version="1.0" encoding="utf-8"?>
 <p:sld xmlns:a="http://schemas.openxmlformats.org/drawingml/2006/main" xmlns:p="http://schemas.openxmlformats.org/presentationml/2006/main" xmlns:r="http://schemas.openxmlformats.org/officeDocument/2006/relationships">
   <p:cSld>

</xml_diff>

<commit_message>
deck 3-2: bank post-commit terseness pass found in working tree
Working tree held an uncommitted fit/terseness save (shorter SQL, labels,
annotations on slides 9,10,12,14,18,19,23,26) dated 5 min after the final
authoring commit. Banked verbatim before the review-driven revision so the
pre-existing state survives; revisions land on top in separate commits.

Co-Authored-By: Claude Opus 5 <noreply@anthropic.com>
</commit_message>
<xml_diff>
--- a/course/lectures/act-3-software-in-the-world/02-compute-environments-and-data-management/3-2-Data-Management.pptx
+++ b/course/lectures/act-3-software-in-the-world/02-compute-environments-and-data-management/3-2-Data-Management.pptx
@@ -11380,7 +11380,7 @@
                 </a:solidFill>
                 <a:latin typeface="Consolas"/>
               </a:rPr>
-              <a:t>  room_id    INT REFERENCES rooms(id),</a:t>
+              <a:t>  room_id  INT REFERENCES rooms,</a:t>
             </a:r>
           </a:p>
           <a:p>
@@ -11396,7 +11396,7 @@
                 </a:solidFill>
                 <a:latin typeface="Consolas"/>
               </a:rPr>
-              <a:t>  user_id    INT REFERENCES users(id),</a:t>
+              <a:t>  user_id  INT REFERENCES users,</a:t>
             </a:r>
           </a:p>
           <a:p>
@@ -11412,7 +11412,7 @@
                 </a:solidFill>
                 <a:latin typeface="Consolas"/>
               </a:rPr>
-              <a:t>  starts_at  TIMESTAMP NOT NULL,</a:t>
+              <a:t>  starts_at TIMESTAMP NOT NULL,</a:t>
             </a:r>
           </a:p>
           <a:p>
@@ -11428,7 +11428,7 @@
                 </a:solidFill>
                 <a:latin typeface="Consolas"/>
               </a:rPr>
-              <a:t>  ends_at    TIMESTAMP NOT NULL,</a:t>
+              <a:t>  ends_at   TIMESTAMP NOT NULL,</a:t>
             </a:r>
           </a:p>
           <a:p>
@@ -11444,7 +11444,7 @@
                 </a:solidFill>
                 <a:latin typeface="Consolas"/>
               </a:rPr>
-              <a:t>  status     TEXT NOT NULL,</a:t>
+              <a:t>  status    TEXT NOT NULL,</a:t>
             </a:r>
           </a:p>
           <a:p>
@@ -11871,7 +11871,7 @@
         <p:spPr>
           <a:xfrm>
             <a:off x="411480" y="960120"/>
-            <a:ext cx="4069080" cy="2377440"/>
+            <a:ext cx="4069080" cy="2514600"/>
           </a:xfrm>
           <a:prstGeom prst="rect">
             <a:avLst/>
@@ -12018,7 +12018,7 @@
         <p:spPr>
           <a:xfrm>
             <a:off x="4663440" y="960120"/>
-            <a:ext cx="4069080" cy="2377440"/>
+            <a:ext cx="4069080" cy="2514600"/>
           </a:xfrm>
           <a:prstGeom prst="rect">
             <a:avLst/>
@@ -12489,7 +12489,7 @@
                 </a:solidFill>
                 <a:latin typeface="Consolas"/>
               </a:rPr>
-              <a:t>117 · 10:00–11:00 · CONFIRMED</a:t>
+              <a:t>117 10:00–11:00 CONFIRMED</a:t>
             </a:r>
           </a:p>
           <a:p>
@@ -12505,7 +12505,7 @@
                 </a:solidFill>
                 <a:latin typeface="Consolas"/>
               </a:rPr>
-              <a:t>117 · 10:30–11:30 · CONFIRMED</a:t>
+              <a:t>117 10:30–11:30 CONFIRMED</a:t>
             </a:r>
           </a:p>
           <a:p>
@@ -12521,7 +12521,7 @@
                 </a:solidFill>
                 <a:latin typeface="Calibri"/>
               </a:rPr>
-              <a:t>Every constraint from the schema passes, row by row</a:t>
+              <a:t>Every schema constraint passes, row by row</a:t>
             </a:r>
           </a:p>
         </p:txBody>
@@ -13514,7 +13514,7 @@
                 </a:solidFill>
                 <a:latin typeface="Consolas"/>
               </a:rPr>
-              <a:t>conflict = (Reservation.query</a:t>
+              <a:t>conflict = (Resv.query</a:t>
             </a:r>
           </a:p>
           <a:p>
@@ -13530,7 +13530,7 @@
                 </a:solidFill>
                 <a:latin typeface="Consolas"/>
               </a:rPr>
-              <a:t>  .filter_by(room_id=room,</a:t>
+              <a:t>  .filter_by(room=room,</a:t>
             </a:r>
           </a:p>
           <a:p>
@@ -13546,7 +13546,7 @@
                 </a:solidFill>
                 <a:latin typeface="Consolas"/>
               </a:rPr>
-              <a:t>             status='CONFIRMED')</a:t>
+              <a:t>    status='CONFIRMED')</a:t>
             </a:r>
           </a:p>
           <a:p>
@@ -13562,23 +13562,7 @@
                 </a:solidFill>
                 <a:latin typeface="Consolas"/>
               </a:rPr>
-              <a:t>  .filter(R.starts_at &lt; ends,</a:t>
-            </a:r>
-          </a:p>
-          <a:p>
-            <a:pPr algn="l">
-              <a:spcAft>
-                <a:spcPts val="200"/>
-              </a:spcAft>
-            </a:pPr>
-            <a:r>
-              <a:rPr sz="2000" b="0">
-                <a:solidFill>
-                  <a:srgbClr val="2D2D2D"/>
-                </a:solidFill>
-                <a:latin typeface="Consolas"/>
-              </a:rPr>
-              <a:t>          R.ends_at   &gt; starts)</a:t>
+              <a:t>  .filter(overlaps(s, e))</a:t>
             </a:r>
           </a:p>
           <a:p>
@@ -14471,7 +14455,7 @@
         <p:spPr>
           <a:xfrm>
             <a:off x="5486400" y="1280160"/>
-            <a:ext cx="3246120" cy="3566160"/>
+            <a:ext cx="3246120" cy="4069080"/>
           </a:xfrm>
           <a:prstGeom prst="rect">
             <a:avLst/>
@@ -14515,7 +14499,7 @@
         <p:spPr>
           <a:xfrm>
             <a:off x="5632704" y="1371600"/>
-            <a:ext cx="2953512" cy="3383280"/>
+            <a:ext cx="2953512" cy="3886200"/>
           </a:xfrm>
           <a:prstGeom prst="rect">
             <a:avLst/>
@@ -16097,7 +16081,7 @@
                 </a:solidFill>
                 <a:latin typeface="Consolas"/>
               </a:rPr>
-              <a:t>for r in reservations:   # 1 query</a:t>
+              <a:t>for r in reservations:</a:t>
             </a:r>
           </a:p>
           <a:p>
@@ -16113,7 +16097,7 @@
                 </a:solidFill>
                 <a:latin typeface="Consolas"/>
               </a:rPr>
-              <a:t>    print(r.room.name)   # +1 each</a:t>
+              <a:t>    print(r.room.name)</a:t>
             </a:r>
           </a:p>
           <a:p>
@@ -16129,7 +16113,7 @@
                 </a:solidFill>
                 <a:latin typeface="Consolas"/>
               </a:rPr>
-              <a:t># 200 reservations -&gt; 201 queries</a:t>
+              <a:t># 200 rows -&gt; 201 queries</a:t>
             </a:r>
           </a:p>
         </p:txBody>
@@ -16530,7 +16514,7 @@
           <a:p>
             <a:pPr algn="ctr">
               <a:spcAft>
-                <a:spcPts val="0"/>
+                <a:spcPts val="400"/>
               </a:spcAft>
             </a:pPr>
             <a:r>
@@ -16540,7 +16524,7 @@
                 </a:solidFill>
                 <a:latin typeface="Calibri"/>
               </a:rPr>
-              <a:t>REQUEST A — room 117, 10:00–11:00</a:t>
+              <a:t>REQUEST A — 117, 10:00–11:00</a:t>
             </a:r>
           </a:p>
         </p:txBody>
@@ -16587,7 +16571,7 @@
           <a:p>
             <a:pPr algn="ctr">
               <a:spcAft>
-                <a:spcPts val="0"/>
+                <a:spcPts val="400"/>
               </a:spcAft>
             </a:pPr>
             <a:r>
@@ -16597,7 +16581,7 @@
                 </a:solidFill>
                 <a:latin typeface="Calibri"/>
               </a:rPr>
-              <a:t>REQUEST B — room 117, 10:30–11:30</a:t>
+              <a:t>REQUEST B — 117, 10:30–11:30</a:t>
             </a:r>
           </a:p>
         </p:txBody>
@@ -16758,7 +16742,7 @@
           <a:p>
             <a:pPr algn="l">
               <a:spcAft>
-                <a:spcPts val="0"/>
+                <a:spcPts val="400"/>
               </a:spcAft>
             </a:pPr>
             <a:r>
@@ -16768,7 +16752,7 @@
                 </a:solidFill>
                 <a:latin typeface="Calibri"/>
               </a:rPr>
-              <a:t>t3 · INSERT CONFIRMED — commit ✓</a:t>
+              <a:t>t3 · INSERT CONFIRMED ✓</a:t>
             </a:r>
           </a:p>
         </p:txBody>
@@ -16815,7 +16799,7 @@
           <a:p>
             <a:pPr algn="l">
               <a:spcAft>
-                <a:spcPts val="0"/>
+                <a:spcPts val="400"/>
               </a:spcAft>
             </a:pPr>
             <a:r>
@@ -16825,7 +16809,7 @@
                 </a:solidFill>
                 <a:latin typeface="Calibri"/>
               </a:rPr>
-              <a:t>t4 · INSERT CONFIRMED — commit ✓</a:t>
+              <a:t>t4 · INSERT CONFIRMED ✓</a:t>
             </a:r>
           </a:p>
         </p:txBody>
@@ -19617,7 +19601,7 @@
                 </a:solidFill>
                 <a:latin typeface="Calibri"/>
               </a:rPr>
-              <a:t>EXCLUDE (room =, time range &amp;&amp;): the SCHEMA states the invariant; the engine rejects the second insert</a:t>
+              <a:t>EXCLUDE (room =, time &amp;&amp;): the SCHEMA states it; the engine rejects the insert</a:t>
             </a:r>
           </a:p>
           <a:p>
@@ -19755,7 +19739,7 @@
                 </a:solidFill>
                 <a:latin typeface="Calibri"/>
               </a:rPr>
-              <a:t>The ISOLATION CONTRACT excludes the bad history; one transaction aborts</a:t>
+              <a:t>The ISOLATION CONTRACT excludes the bad history</a:t>
             </a:r>
           </a:p>
           <a:p>
@@ -19771,7 +19755,7 @@
                 </a:solidFill>
                 <a:latin typeface="Calibri"/>
               </a:rPr>
-              <a:t>you must catch aborts and retry; contention costs throughput</a:t>
+              <a:t>catch aborts and retry; contention costs throughput</a:t>
             </a:r>
           </a:p>
         </p:txBody>
@@ -19893,7 +19877,7 @@
                 </a:solidFill>
                 <a:latin typeface="Calibri"/>
               </a:rPr>
-              <a:t>SELECT … FOR UPDATE the room row before checking: your LOCKING DISCIPLINE serializes per room</a:t>
+              <a:t>SELECT … FOR UPDATE the room row first — your LOCKING DISCIPLINE, per room</a:t>
             </a:r>
           </a:p>
           <a:p>
@@ -21831,7 +21815,7 @@
           <a:p>
             <a:pPr algn="ctr">
               <a:spcAft>
-                <a:spcPts val="0"/>
+                <a:spcPts val="400"/>
               </a:spcAft>
             </a:pPr>
             <a:r>
@@ -21841,7 +21825,7 @@
                 </a:solidFill>
                 <a:latin typeface="Calibri"/>
               </a:rPr>
-              <a:t>ALIGNMENT — alongside every step: constraints, checks, admission decisions</a:t>
+              <a:t>ALIGNMENT — alongside every step: constraints, checks, gates</a:t>
             </a:r>
           </a:p>
         </p:txBody>
@@ -24699,7 +24683,7 @@
         <p:spPr>
           <a:xfrm>
             <a:off x="411480" y="960120"/>
-            <a:ext cx="4069080" cy="2057400"/>
+            <a:ext cx="4069080" cy="2240280"/>
           </a:xfrm>
           <a:prstGeom prst="rect">
             <a:avLst/>
@@ -24743,7 +24727,7 @@
         <p:spPr>
           <a:xfrm>
             <a:off x="557784" y="1051560"/>
-            <a:ext cx="3776472" cy="1874519"/>
+            <a:ext cx="3776472" cy="2057400"/>
           </a:xfrm>
           <a:prstGeom prst="rect">
             <a:avLst/>
@@ -24830,7 +24814,7 @@
         <p:spPr>
           <a:xfrm>
             <a:off x="4663440" y="960120"/>
-            <a:ext cx="4069080" cy="2057400"/>
+            <a:ext cx="4069080" cy="2240280"/>
           </a:xfrm>
           <a:prstGeom prst="rect">
             <a:avLst/>
@@ -24874,7 +24858,7 @@
         <p:spPr>
           <a:xfrm>
             <a:off x="4809744" y="1051560"/>
-            <a:ext cx="3776472" cy="1874519"/>
+            <a:ext cx="3776472" cy="2057400"/>
           </a:xfrm>
           <a:prstGeom prst="rect">
             <a:avLst/>
@@ -24960,7 +24944,7 @@
         </p:nvSpPr>
         <p:spPr>
           <a:xfrm>
-            <a:off x="411480" y="3246120"/>
+            <a:off x="411480" y="3383280"/>
             <a:ext cx="8321040" cy="1417320"/>
           </a:xfrm>
           <a:prstGeom prst="rect">
@@ -25004,7 +24988,7 @@
         </p:nvSpPr>
         <p:spPr>
           <a:xfrm>
-            <a:off x="557784" y="3319272"/>
+            <a:off x="557784" y="3456432"/>
             <a:ext cx="8046720" cy="1280160"/>
           </a:xfrm>
           <a:prstGeom prst="rect">
@@ -26675,7 +26659,7 @@
         <p:spPr>
           <a:xfrm>
             <a:off x="3383280" y="2377440"/>
-            <a:ext cx="2651760" cy="2148840"/>
+            <a:ext cx="2651760" cy="2286000"/>
           </a:xfrm>
           <a:prstGeom prst="rect">
             <a:avLst/>
@@ -27022,7 +27006,7 @@
                 </a:solidFill>
                 <a:latin typeface="Calibri"/>
               </a:rPr>
-              <a:t>INVARIANT — a room must not have overlapping CONFIRMED reservations</a:t>
+              <a:t>INVARIANT — no overlapping CONFIRMED reservations per room</a:t>
             </a:r>
           </a:p>
           <a:p>

</xml_diff>

<commit_message>
deck 3-2: P1 structure — outline, structural titles, sections, no internal refs
- New slide 2: module outline, five movements named by their engineering
  questions (same vocabulary as the native sections)
- Every slide's title converted from a text box to a structural title
  placeholder (2-4 pattern: ph type=title, geometry kept explicit; cover
  gets ctrTitle/subTitle)
- Six native PowerPoint sections: Opening / Database design choices /
  Representing obligations / Queries and execution / Concurrency and
  transactions / Evolution and synthesis
- Section-opener question titles per review: slides 10, 14, 20, 26; plus
  pose-form titles for 13 and 24, assertion title for 17, em-dash-free 28
- Internal slide/section/unit references removed from audience-facing
  text (Unit 6 -> Operations & SRE; slide 16/18/19/23 and §5 cites gone)

Co-Authored-By: Claude Opus 5 <noreply@anthropic.com>
</commit_message>
<xml_diff>
--- a/course/lectures/act-3-software-in-the-world/02-compute-environments-and-data-management/3-2-Data-Management.pptx
+++ b/course/lectures/act-3-software-in-the-world/02-compute-environments-and-data-management/3-2-Data-Management.pptx
@@ -9,6 +9,7 @@
   </p:notesMasterIdLst>
   <p:sldIdLst>
     <p:sldId id="256" r:id="rId7"/>
+    <p:sldId id="283" r:id="rId2"/>
     <p:sldId id="257" r:id="rId8"/>
     <p:sldId id="258" r:id="rId9"/>
     <p:sldId id="259" r:id="rId10"/>
@@ -271,6 +272,62 @@
     <p:ext uri="{EFAFB233-063F-42B5-8137-9DF3F51BA10A}">
       <p15:sldGuideLst xmlns:p15="http://schemas.microsoft.com/office/powerpoint/2012/main"/>
     </p:ext>
+    <p:ext uri="{521415D9-36F7-43E2-AB2F-B90AF26B5E84}">
+      <ns0:sectionLst xmlns:ns0="http://schemas.microsoft.com/office/powerpoint/2010/main">
+        <ns0:section name="Opening" id="{6AFD6B58-CD2F-4A0E-A4B8-C5B124201245}">
+          <ns0:sldIdLst>
+            <ns0:sldId id="256"/>
+            <ns0:sldId id="283"/>
+          </ns0:sldIdLst>
+        </ns0:section>
+        <ns0:section name="Database design choices" id="{008FA20D-FAED-478C-916F-C8893B876F82}">
+          <ns0:sldIdLst>
+            <ns0:sldId id="257"/>
+            <ns0:sldId id="258"/>
+            <ns0:sldId id="259"/>
+            <ns0:sldId id="260"/>
+            <ns0:sldId id="261"/>
+            <ns0:sldId id="262"/>
+            <ns0:sldId id="263"/>
+          </ns0:sldIdLst>
+        </ns0:section>
+        <ns0:section name="Representing obligations" id="{F7197E19-83B0-4640-9211-26488498E845}">
+          <ns0:sldIdLst>
+            <ns0:sldId id="264"/>
+            <ns0:sldId id="265"/>
+            <ns0:sldId id="266"/>
+            <ns0:sldId id="267"/>
+          </ns0:sldIdLst>
+        </ns0:section>
+        <ns0:section name="Queries and execution" id="{755BBA9C-3422-4617-93F4-0AF7FD88E784}">
+          <ns0:sldIdLst>
+            <ns0:sldId id="268"/>
+            <ns0:sldId id="269"/>
+            <ns0:sldId id="270"/>
+            <ns0:sldId id="271"/>
+            <ns0:sldId id="272"/>
+            <ns0:sldId id="273"/>
+          </ns0:sldIdLst>
+        </ns0:section>
+        <ns0:section name="Concurrency and transactions" id="{DB0BF643-3A40-40F9-9DC0-27E39851FDD0}">
+          <ns0:sldIdLst>
+            <ns0:sldId id="274"/>
+            <ns0:sldId id="275"/>
+            <ns0:sldId id="276"/>
+            <ns0:sldId id="277"/>
+            <ns0:sldId id="278"/>
+            <ns0:sldId id="279"/>
+          </ns0:sldIdLst>
+        </ns0:section>
+        <ns0:section name="Evolution and synthesis" id="{155B7408-0F63-4329-B77A-A5C1141AE690}">
+          <ns0:sldIdLst>
+            <ns0:sldId id="280"/>
+            <ns0:sldId id="281"/>
+            <ns0:sldId id="282"/>
+          </ns0:sldIdLst>
+        </ns0:section>
+      </ns0:sectionLst>
+    </p:ext>
   </p:extLst>
 </p:presentation>
 </file>
@@ -3235,6 +3292,82 @@
           <a:p>
             <a:r>
               <a:t>Then hand off with the question on the title. A working system is the STARTING point of most engineering careers, not the end: next unit asks whether this system's structure — our code and everything we now depend on, engine features included (that exclusion constraint bound us to an engine) — can absorb its next ten changes economically.</a:t>
+            </a:r>
+          </a:p>
+        </p:txBody>
+      </p:sp>
+      <p:sp>
+        <p:nvSpPr>
+          <p:cNvPr id="4" name="Slide Number Placeholder 3"/>
+          <p:cNvSpPr>
+            <a:spLocks noGrp="1"/>
+          </p:cNvSpPr>
+          <p:nvPr>
+            <p:ph type="sldNum" idx="12"/>
+          </p:nvPr>
+        </p:nvSpPr>
+        <p:spPr/>
+      </p:sp>
+    </p:spTree>
+  </p:cSld>
+  <p:clrMapOvr>
+    <a:masterClrMapping/>
+  </p:clrMapOvr>
+</p:notes>
+</file>
+
+<file path=ppt/notesSlides/notesSlide28.xml><?xml version="1.0" encoding="utf-8"?>
+<p:notes xmlns:a="http://schemas.openxmlformats.org/drawingml/2006/main" xmlns:p="http://schemas.openxmlformats.org/presentationml/2006/main" xmlns:r="http://schemas.openxmlformats.org/officeDocument/2006/relationships">
+  <p:cSld>
+    <p:spTree>
+      <p:nvGrpSpPr>
+        <p:cNvPr id="1" name=""/>
+        <p:cNvGrpSpPr/>
+        <p:nvPr/>
+      </p:nvGrpSpPr>
+      <p:grpSpPr>
+        <a:xfrm>
+          <a:off x="0" y="0"/>
+          <a:ext cx="0" cy="0"/>
+          <a:chOff x="0" y="0"/>
+          <a:chExt cx="0" cy="0"/>
+        </a:xfrm>
+      </p:grpSpPr>
+      <p:sp>
+        <p:nvSpPr>
+          <p:cNvPr id="2" name="Slide Image Placeholder 1"/>
+          <p:cNvSpPr>
+            <a:spLocks noGrp="1"/>
+          </p:cNvSpPr>
+          <p:nvPr>
+            <p:ph type="sldImg" idx="3"/>
+          </p:nvPr>
+        </p:nvSpPr>
+        <p:spPr/>
+      </p:sp>
+      <p:sp>
+        <p:nvSpPr>
+          <p:cNvPr id="3" name="Notes Placeholder 2"/>
+          <p:cNvSpPr>
+            <a:spLocks noGrp="1"/>
+          </p:cNvSpPr>
+          <p:nvPr>
+            <p:ph type="body" idx="1"/>
+          </p:nvPr>
+        </p:nvSpPr>
+        <p:spPr/>
+        <p:txBody>
+          <a:bodyPr/>
+          <a:lstStyle/>
+          <a:p>
+            <a:r>
+              <a:t>TIMING: 1 minute.</a:t>
+            </a:r>
+          </a:p>
+          <a:p/>
+          <a:p>
+            <a:r>
+              <a:t>The five movements, each named by the engineering question it answers. This vocabulary recurs: the deck's sections carry the same names. Point at row four: the lecture's destination is the concurrency question — everything before it builds the vocabulary to ask it precisely.</a:t>
             </a:r>
           </a:p>
         </p:txBody>
@@ -11021,8 +11154,12 @@
       <p:sp>
         <p:nvSpPr>
           <p:cNvPr id="4" name="Title"/>
-          <p:cNvSpPr txBox="1"/>
-          <p:nvPr/>
+          <p:cNvSpPr txBox="1">
+            <a:spLocks noGrp="1"/>
+          </p:cNvSpPr>
+          <p:nvPr>
+            <p:ph type="ctrTitle"/>
+          </p:nvPr>
         </p:nvSpPr>
         <p:spPr>
           <a:xfrm>
@@ -11060,8 +11197,12 @@
       <p:sp>
         <p:nvSpPr>
           <p:cNvPr id="5" name="Subtitle"/>
-          <p:cNvSpPr txBox="1"/>
-          <p:nvPr/>
+          <p:cNvSpPr txBox="1">
+            <a:spLocks noGrp="1"/>
+          </p:cNvSpPr>
+          <p:nvPr>
+            <p:ph type="subTitle" idx="1"/>
+          </p:nvPr>
         </p:nvSpPr>
         <p:spPr>
           <a:xfrm>
@@ -11250,8 +11391,12 @@
       <p:sp>
         <p:nvSpPr>
           <p:cNvPr id="2" name="Title"/>
-          <p:cNvSpPr txBox="1"/>
-          <p:nvPr/>
+          <p:cNvSpPr txBox="1">
+            <a:spLocks noGrp="1"/>
+          </p:cNvSpPr>
+          <p:nvPr>
+            <p:ph type="title"/>
+          </p:nvPr>
         </p:nvSpPr>
         <p:spPr>
           <a:xfrm>
@@ -11826,8 +11971,12 @@
       <p:sp>
         <p:nvSpPr>
           <p:cNvPr id="2" name="Title"/>
-          <p:cNvSpPr txBox="1"/>
-          <p:nvPr/>
+          <p:cNvSpPr txBox="1">
+            <a:spLocks noGrp="1"/>
+          </p:cNvSpPr>
+          <p:nvPr>
+            <p:ph type="title"/>
+          </p:nvPr>
         </p:nvSpPr>
         <p:spPr>
           <a:xfrm>
@@ -12359,8 +12508,12 @@
       <p:sp>
         <p:nvSpPr>
           <p:cNvPr id="2" name="Title"/>
-          <p:cNvSpPr txBox="1"/>
-          <p:nvPr/>
+          <p:cNvSpPr txBox="1">
+            <a:spLocks noGrp="1"/>
+          </p:cNvSpPr>
+          <p:nvPr>
+            <p:ph type="title"/>
+          </p:nvPr>
         </p:nvSpPr>
         <p:spPr>
           <a:xfrm>
@@ -12390,7 +12543,7 @@
                 </a:solidFill>
                 <a:latin typeface="Calibri"/>
               </a:rPr>
-              <a:t>A valid data model is not a correct application</a:t>
+              <a:t>Two valid rows: is the application correct?</a:t>
             </a:r>
           </a:p>
         </p:txBody>
@@ -12719,7 +12872,7 @@
                 </a:solidFill>
                 <a:latin typeface="Calibri"/>
               </a:rPr>
-              <a:t>…and, once requests overlap in time, relations between operations. That is §5.</a:t>
+              <a:t>…and, once requests overlap in time, relations between operations: the concurrency section.</a:t>
             </a:r>
           </a:p>
         </p:txBody>
@@ -12828,8 +12981,12 @@
       <p:sp>
         <p:nvSpPr>
           <p:cNvPr id="2" name="Title"/>
-          <p:cNvSpPr txBox="1"/>
-          <p:nvPr/>
+          <p:cNvSpPr txBox="1">
+            <a:spLocks noGrp="1"/>
+          </p:cNvSpPr>
+          <p:nvPr>
+            <p:ph type="title"/>
+          </p:nvPr>
         </p:nvSpPr>
         <p:spPr>
           <a:xfrm>
@@ -12859,7 +13016,7 @@
                 </a:solidFill>
                 <a:latin typeface="Calibri"/>
               </a:rPr>
-              <a:t>SQL states WHAT you want, not HOW to get it</a:t>
+              <a:t>How does an application ask for stored information?</a:t>
             </a:r>
           </a:p>
         </p:txBody>
@@ -13153,7 +13310,7 @@
                 </a:solidFill>
                 <a:latin typeface="Calibri"/>
               </a:rPr>
-              <a:t>The engine chooses HOW — slide 16</a:t>
+              <a:t>The engine chooses HOW</a:t>
             </a:r>
           </a:p>
         </p:txBody>
@@ -13252,7 +13409,7 @@
                 </a:solidFill>
                 <a:latin typeface="Calibri"/>
               </a:rPr>
-              <a:t>This predicate is the invariant in query form — it returns on slides 19 and 23.</a:t>
+              <a:t>This predicate is the invariant in query form. It returns when requests overlap.</a:t>
             </a:r>
           </a:p>
         </p:txBody>
@@ -13361,8 +13518,12 @@
       <p:sp>
         <p:nvSpPr>
           <p:cNvPr id="2" name="Title"/>
-          <p:cNvSpPr txBox="1"/>
-          <p:nvPr/>
+          <p:cNvSpPr txBox="1">
+            <a:spLocks noGrp="1"/>
+          </p:cNvSpPr>
+          <p:nvPr>
+            <p:ph type="title"/>
+          </p:nvPr>
         </p:nvSpPr>
         <p:spPr>
           <a:xfrm>
@@ -13824,7 +13985,7 @@
                 </a:solidFill>
                 <a:latin typeface="Calibri"/>
               </a:rPr>
-              <a:t>Generated queries can be inefficient — the N+1 trap, slide 18</a:t>
+              <a:t>Generated queries can be inefficient: the N+1 trap</a:t>
             </a:r>
           </a:p>
           <a:p>
@@ -13949,8 +14110,12 @@
       <p:sp>
         <p:nvSpPr>
           <p:cNvPr id="2" name="Title"/>
-          <p:cNvSpPr txBox="1"/>
-          <p:nvPr/>
+          <p:cNvSpPr txBox="1">
+            <a:spLocks noGrp="1"/>
+          </p:cNvSpPr>
+          <p:nvPr>
+            <p:ph type="title"/>
+          </p:nvPr>
         </p:nvSpPr>
         <p:spPr>
           <a:xfrm>
@@ -14665,8 +14830,12 @@
       <p:sp>
         <p:nvSpPr>
           <p:cNvPr id="2" name="Title"/>
-          <p:cNvSpPr txBox="1"/>
-          <p:nvPr/>
+          <p:cNvSpPr txBox="1">
+            <a:spLocks noGrp="1"/>
+          </p:cNvSpPr>
+          <p:nvPr>
+            <p:ph type="title"/>
+          </p:nvPr>
         </p:nvSpPr>
         <p:spPr>
           <a:xfrm>
@@ -14696,7 +14865,7 @@
                 </a:solidFill>
                 <a:latin typeface="Calibri"/>
               </a:rPr>
-              <a:t>How the engine executes your query</a:t>
+              <a:t>The optimizer chooses how your query runs</a:t>
             </a:r>
           </a:p>
         </p:txBody>
@@ -15466,8 +15635,12 @@
       <p:sp>
         <p:nvSpPr>
           <p:cNvPr id="2" name="Title"/>
-          <p:cNvSpPr txBox="1"/>
-          <p:nvPr/>
+          <p:cNvSpPr txBox="1">
+            <a:spLocks noGrp="1"/>
+          </p:cNvSpPr>
+          <p:nvPr>
+            <p:ph type="title"/>
+          </p:nvPr>
         </p:nvSpPr>
         <p:spPr>
           <a:xfrm>
@@ -15980,8 +16153,12 @@
       <p:sp>
         <p:nvSpPr>
           <p:cNvPr id="2" name="Title"/>
-          <p:cNvSpPr txBox="1"/>
-          <p:nvPr/>
+          <p:cNvSpPr txBox="1">
+            <a:spLocks noGrp="1"/>
+          </p:cNvSpPr>
+          <p:nvPr>
+            <p:ph type="title"/>
+          </p:nvPr>
         </p:nvSpPr>
         <p:spPr>
           <a:xfrm>
@@ -16449,8 +16626,12 @@
       <p:sp>
         <p:nvSpPr>
           <p:cNvPr id="2" name="Title"/>
-          <p:cNvSpPr txBox="1"/>
-          <p:nvPr/>
+          <p:cNvSpPr txBox="1">
+            <a:spLocks noGrp="1"/>
+          </p:cNvSpPr>
+          <p:nvPr>
+            <p:ph type="title"/>
+          </p:nvPr>
         </p:nvSpPr>
         <p:spPr>
           <a:xfrm>
@@ -16480,7 +16661,7 @@
                 </a:solidFill>
                 <a:latin typeface="Calibri"/>
               </a:rPr>
-              <a:t>Double-booking: two correct requests, one broken invariant</a:t>
+              <a:t>Can individually correct requests violate an invariant?</a:t>
             </a:r>
           </a:p>
         </p:txBody>
@@ -17030,8 +17211,12 @@
       <p:sp>
         <p:nvSpPr>
           <p:cNvPr id="2" name="Title"/>
-          <p:cNvSpPr txBox="1"/>
-          <p:nvPr/>
+          <p:cNvSpPr txBox="1">
+            <a:spLocks noGrp="1"/>
+          </p:cNvSpPr>
+          <p:nvPr>
+            <p:ph type="title"/>
+          </p:nvPr>
         </p:nvSpPr>
         <p:spPr>
           <a:xfrm>
@@ -17671,8 +17856,12 @@
       <p:sp>
         <p:nvSpPr>
           <p:cNvPr id="2" name="Title"/>
-          <p:cNvSpPr txBox="1"/>
-          <p:nvPr/>
+          <p:cNvSpPr txBox="1">
+            <a:spLocks noGrp="1"/>
+          </p:cNvSpPr>
+          <p:nvPr>
+            <p:ph type="title"/>
+          </p:nvPr>
         </p:nvSpPr>
         <p:spPr>
           <a:xfrm>
@@ -18398,8 +18587,12 @@
       <p:sp>
         <p:nvSpPr>
           <p:cNvPr id="2" name="Title"/>
-          <p:cNvSpPr txBox="1"/>
-          <p:nvPr/>
+          <p:cNvSpPr txBox="1">
+            <a:spLocks noGrp="1"/>
+          </p:cNvSpPr>
+          <p:nvPr>
+            <p:ph type="title"/>
+          </p:nvPr>
         </p:nvSpPr>
         <p:spPr>
           <a:xfrm>
@@ -18808,8 +19001,12 @@
       <p:sp>
         <p:nvSpPr>
           <p:cNvPr id="2" name="Title"/>
-          <p:cNvSpPr txBox="1"/>
-          <p:nvPr/>
+          <p:cNvSpPr txBox="1">
+            <a:spLocks noGrp="1"/>
+          </p:cNvSpPr>
+          <p:nvPr>
+            <p:ph type="title"/>
+          </p:nvPr>
         </p:nvSpPr>
         <p:spPr>
           <a:xfrm>
@@ -19477,8 +19674,12 @@
       <p:sp>
         <p:nvSpPr>
           <p:cNvPr id="2" name="Title"/>
-          <p:cNvSpPr txBox="1"/>
-          <p:nvPr/>
+          <p:cNvSpPr txBox="1">
+            <a:spLocks noGrp="1"/>
+          </p:cNvSpPr>
+          <p:nvPr>
+            <p:ph type="title"/>
+          </p:nvPr>
         </p:nvSpPr>
         <p:spPr>
           <a:xfrm>
@@ -19508,7 +19709,7 @@
                 </a:solidFill>
                 <a:latin typeface="Calibri"/>
               </a:rPr>
-              <a:t>Three ways to actually prevent double-booking</a:t>
+              <a:t>Where can the no-overlap invariant be enforced?</a:t>
             </a:r>
           </a:p>
         </p:txBody>
@@ -20114,8 +20315,12 @@
       <p:sp>
         <p:nvSpPr>
           <p:cNvPr id="2" name="Title"/>
-          <p:cNvSpPr txBox="1"/>
-          <p:nvPr/>
+          <p:cNvSpPr txBox="1">
+            <a:spLocks noGrp="1"/>
+          </p:cNvSpPr>
+          <p:nvPr>
+            <p:ph type="title"/>
+          </p:nvPr>
         </p:nvSpPr>
         <p:spPr>
           <a:xfrm>
@@ -20650,8 +20855,12 @@
       <p:sp>
         <p:nvSpPr>
           <p:cNvPr id="2" name="Title"/>
-          <p:cNvSpPr txBox="1"/>
-          <p:nvPr/>
+          <p:cNvSpPr txBox="1">
+            <a:spLocks noGrp="1"/>
+          </p:cNvSpPr>
+          <p:nvPr>
+            <p:ph type="title"/>
+          </p:nvPr>
         </p:nvSpPr>
         <p:spPr>
           <a:xfrm>
@@ -20681,7 +20890,7 @@
                 </a:solidFill>
                 <a:latin typeface="Calibri"/>
               </a:rPr>
-              <a:t>Schemas evolve: the recurring-booking feature arrives</a:t>
+              <a:t>What happens when the data model must change?</a:t>
             </a:r>
           </a:p>
         </p:txBody>
@@ -21204,8 +21413,12 @@
       <p:sp>
         <p:nvSpPr>
           <p:cNvPr id="2" name="Title"/>
-          <p:cNvSpPr txBox="1"/>
-          <p:nvPr/>
+          <p:cNvSpPr txBox="1">
+            <a:spLocks noGrp="1"/>
+          </p:cNvSpPr>
+          <p:nvPr>
+            <p:ph type="title"/>
+          </p:nvPr>
         </p:nvSpPr>
         <p:spPr>
           <a:xfrm>
@@ -22132,8 +22345,12 @@
       <p:sp>
         <p:nvSpPr>
           <p:cNvPr id="2" name="Title"/>
-          <p:cNvSpPr txBox="1"/>
-          <p:nvPr/>
+          <p:cNvSpPr txBox="1">
+            <a:spLocks noGrp="1"/>
+          </p:cNvSpPr>
+          <p:nvPr>
+            <p:ph type="title"/>
+          </p:nvPr>
         </p:nvSpPr>
         <p:spPr>
           <a:xfrm>
@@ -22163,7 +22380,7 @@
                 </a:solidFill>
                 <a:latin typeface="Calibri"/>
               </a:rPr>
-              <a:t>We have a working system — how easily can we change it?</a:t>
+              <a:t>A working system: how easily can we change it?</a:t>
             </a:r>
           </a:p>
         </p:txBody>
@@ -22624,6 +22841,561 @@
                 <a:latin typeface="Calibri"/>
               </a:rPr>
               <a:t>From preserving information to changing the system that holds it</a:t>
+            </a:r>
+          </a:p>
+        </p:txBody>
+      </p:sp>
+    </p:spTree>
+  </p:cSld>
+  <p:clrMapOvr>
+    <a:masterClrMapping/>
+  </p:clrMapOvr>
+</p:sld>
+</file>
+
+<file path=ppt/slides/slide28.xml><?xml version="1.0" encoding="utf-8"?>
+<p:sld xmlns:a="http://schemas.openxmlformats.org/drawingml/2006/main" xmlns:p="http://schemas.openxmlformats.org/presentationml/2006/main" xmlns:r="http://schemas.openxmlformats.org/officeDocument/2006/relationships">
+  <p:cSld>
+    <p:spTree>
+      <p:nvGrpSpPr>
+        <p:cNvPr id="1" name=""/>
+        <p:cNvGrpSpPr/>
+        <p:nvPr/>
+      </p:nvGrpSpPr>
+      <p:grpSpPr/>
+      <p:sp>
+        <p:nvSpPr>
+          <p:cNvPr id="3" name="Title"/>
+          <p:cNvSpPr>
+            <a:spLocks noGrp="1"/>
+          </p:cNvSpPr>
+          <p:nvPr>
+            <p:ph type="title"/>
+          </p:nvPr>
+        </p:nvSpPr>
+        <p:spPr>
+          <a:xfrm>
+            <a:off x="274320" y="128016"/>
+            <a:ext cx="8595360" cy="594360"/>
+          </a:xfrm>
+        </p:spPr>
+        <p:txBody>
+          <a:bodyPr/>
+          <a:lstStyle/>
+          <a:p>
+            <a:r>
+              <a:rPr sz="2400" b="0"/>
+              <a:t>Today: five engineering questions</a:t>
+            </a:r>
+          </a:p>
+        </p:txBody>
+      </p:sp>
+      <p:sp>
+        <p:nvSpPr>
+          <p:cNvPr id="4" name="Card"/>
+          <p:cNvSpPr/>
+          <p:nvPr/>
+        </p:nvSpPr>
+        <p:spPr>
+          <a:xfrm>
+            <a:off x="411480" y="1051560"/>
+            <a:ext cx="8321040" cy="841248"/>
+          </a:xfrm>
+          <a:prstGeom prst="rect">
+            <a:avLst/>
+          </a:prstGeom>
+          <a:solidFill>
+            <a:srgbClr val="F5F1E8"/>
+          </a:solidFill>
+          <a:ln>
+            <a:noFill/>
+          </a:ln>
+          <a:effectLst/>
+        </p:spPr>
+        <p:style>
+          <a:lnRef idx="1">
+            <a:schemeClr val="accent1"/>
+          </a:lnRef>
+          <a:fillRef idx="3">
+            <a:schemeClr val="accent1"/>
+          </a:fillRef>
+          <a:effectRef idx="2">
+            <a:schemeClr val="accent1"/>
+          </a:effectRef>
+          <a:fontRef idx="minor">
+            <a:schemeClr val="lt1"/>
+          </a:fontRef>
+        </p:style>
+        <p:txBody>
+          <a:bodyPr rtlCol="0" anchor="ctr"/>
+          <a:lstStyle/>
+          <a:p>
+            <a:pPr algn="ctr"/>
+          </a:p>
+        </p:txBody>
+      </p:sp>
+      <p:sp>
+        <p:nvSpPr>
+          <p:cNvPr id="5" name="RowLabel"/>
+          <p:cNvSpPr txBox="1"/>
+          <p:nvPr/>
+        </p:nvSpPr>
+        <p:spPr>
+          <a:xfrm>
+            <a:off x="557784" y="1088136"/>
+            <a:ext cx="2788920" cy="768096"/>
+          </a:xfrm>
+          <a:prstGeom prst="rect">
+            <a:avLst/>
+          </a:prstGeom>
+          <a:noFill/>
+        </p:spPr>
+        <p:txBody>
+          <a:bodyPr wrap="square">
+            <a:spAutoFit/>
+          </a:bodyPr>
+          <a:lstStyle/>
+          <a:p>
+            <a:r>
+              <a:rPr sz="2000" b="1"/>
+              <a:t>Database design choices</a:t>
+            </a:r>
+          </a:p>
+        </p:txBody>
+      </p:sp>
+      <p:sp>
+        <p:nvSpPr>
+          <p:cNvPr id="6" name="RowBody"/>
+          <p:cNvSpPr txBox="1"/>
+          <p:nvPr/>
+        </p:nvSpPr>
+        <p:spPr>
+          <a:xfrm>
+            <a:off x="3438144" y="1088136"/>
+            <a:ext cx="5166360" cy="768096"/>
+          </a:xfrm>
+          <a:prstGeom prst="rect">
+            <a:avLst/>
+          </a:prstGeom>
+          <a:noFill/>
+        </p:spPr>
+        <p:txBody>
+          <a:bodyPr wrap="square">
+            <a:spAutoFit/>
+          </a:bodyPr>
+          <a:lstStyle/>
+          <a:p>
+            <a:r>
+              <a:rPr sz="2000" b="0"/>
+              <a:t>What guarantees do we need, and which representations provide them?</a:t>
+            </a:r>
+          </a:p>
+        </p:txBody>
+      </p:sp>
+      <p:sp>
+        <p:nvSpPr>
+          <p:cNvPr id="7" name="Card"/>
+          <p:cNvSpPr/>
+          <p:nvPr/>
+        </p:nvSpPr>
+        <p:spPr>
+          <a:xfrm>
+            <a:off x="411480" y="2002536"/>
+            <a:ext cx="8321040" cy="841248"/>
+          </a:xfrm>
+          <a:prstGeom prst="rect">
+            <a:avLst/>
+          </a:prstGeom>
+          <a:solidFill>
+            <a:srgbClr val="FCFAF6"/>
+          </a:solidFill>
+          <a:ln>
+            <a:noFill/>
+          </a:ln>
+          <a:effectLst/>
+        </p:spPr>
+        <p:style>
+          <a:lnRef idx="1">
+            <a:schemeClr val="accent1"/>
+          </a:lnRef>
+          <a:fillRef idx="3">
+            <a:schemeClr val="accent1"/>
+          </a:fillRef>
+          <a:effectRef idx="2">
+            <a:schemeClr val="accent1"/>
+          </a:effectRef>
+          <a:fontRef idx="minor">
+            <a:schemeClr val="lt1"/>
+          </a:fontRef>
+        </p:style>
+        <p:txBody>
+          <a:bodyPr rtlCol="0" anchor="ctr"/>
+          <a:lstStyle/>
+          <a:p>
+            <a:pPr algn="ctr"/>
+          </a:p>
+        </p:txBody>
+      </p:sp>
+      <p:sp>
+        <p:nvSpPr>
+          <p:cNvPr id="8" name="RowLabel"/>
+          <p:cNvSpPr txBox="1"/>
+          <p:nvPr/>
+        </p:nvSpPr>
+        <p:spPr>
+          <a:xfrm>
+            <a:off x="557784" y="2039112"/>
+            <a:ext cx="2788920" cy="768096"/>
+          </a:xfrm>
+          <a:prstGeom prst="rect">
+            <a:avLst/>
+          </a:prstGeom>
+          <a:noFill/>
+        </p:spPr>
+        <p:txBody>
+          <a:bodyPr wrap="square">
+            <a:spAutoFit/>
+          </a:bodyPr>
+          <a:lstStyle/>
+          <a:p>
+            <a:r>
+              <a:rPr sz="2000" b="1"/>
+              <a:t>Representing obligations</a:t>
+            </a:r>
+          </a:p>
+        </p:txBody>
+      </p:sp>
+      <p:sp>
+        <p:nvSpPr>
+          <p:cNvPr id="9" name="RowBody"/>
+          <p:cNvSpPr txBox="1"/>
+          <p:nvPr/>
+        </p:nvSpPr>
+        <p:spPr>
+          <a:xfrm>
+            <a:off x="3438144" y="2039112"/>
+            <a:ext cx="5166360" cy="768096"/>
+          </a:xfrm>
+          <a:prstGeom prst="rect">
+            <a:avLst/>
+          </a:prstGeom>
+          <a:noFill/>
+        </p:spPr>
+        <p:txBody>
+          <a:bodyPr wrap="square">
+            <a:spAutoFit/>
+          </a:bodyPr>
+          <a:lstStyle/>
+          <a:p>
+            <a:r>
+              <a:rPr sz="2000" b="0"/>
+              <a:t>How do schemas express and enforce properties of stored data?</a:t>
+            </a:r>
+          </a:p>
+        </p:txBody>
+      </p:sp>
+      <p:sp>
+        <p:nvSpPr>
+          <p:cNvPr id="10" name="Card"/>
+          <p:cNvSpPr/>
+          <p:nvPr/>
+        </p:nvSpPr>
+        <p:spPr>
+          <a:xfrm>
+            <a:off x="411480" y="2953512"/>
+            <a:ext cx="8321040" cy="841248"/>
+          </a:xfrm>
+          <a:prstGeom prst="rect">
+            <a:avLst/>
+          </a:prstGeom>
+          <a:solidFill>
+            <a:srgbClr val="F5F1E8"/>
+          </a:solidFill>
+          <a:ln>
+            <a:noFill/>
+          </a:ln>
+          <a:effectLst/>
+        </p:spPr>
+        <p:style>
+          <a:lnRef idx="1">
+            <a:schemeClr val="accent1"/>
+          </a:lnRef>
+          <a:fillRef idx="3">
+            <a:schemeClr val="accent1"/>
+          </a:fillRef>
+          <a:effectRef idx="2">
+            <a:schemeClr val="accent1"/>
+          </a:effectRef>
+          <a:fontRef idx="minor">
+            <a:schemeClr val="lt1"/>
+          </a:fontRef>
+        </p:style>
+        <p:txBody>
+          <a:bodyPr rtlCol="0" anchor="ctr"/>
+          <a:lstStyle/>
+          <a:p>
+            <a:pPr algn="ctr"/>
+          </a:p>
+        </p:txBody>
+      </p:sp>
+      <p:sp>
+        <p:nvSpPr>
+          <p:cNvPr id="11" name="RowLabel"/>
+          <p:cNvSpPr txBox="1"/>
+          <p:nvPr/>
+        </p:nvSpPr>
+        <p:spPr>
+          <a:xfrm>
+            <a:off x="557784" y="2990088"/>
+            <a:ext cx="2788920" cy="768096"/>
+          </a:xfrm>
+          <a:prstGeom prst="rect">
+            <a:avLst/>
+          </a:prstGeom>
+          <a:noFill/>
+        </p:spPr>
+        <p:txBody>
+          <a:bodyPr wrap="square">
+            <a:spAutoFit/>
+          </a:bodyPr>
+          <a:lstStyle/>
+          <a:p>
+            <a:r>
+              <a:rPr sz="2000" b="1"/>
+              <a:t>Queries and execution</a:t>
+            </a:r>
+          </a:p>
+        </p:txBody>
+      </p:sp>
+      <p:sp>
+        <p:nvSpPr>
+          <p:cNvPr id="12" name="RowBody"/>
+          <p:cNvSpPr txBox="1"/>
+          <p:nvPr/>
+        </p:nvSpPr>
+        <p:spPr>
+          <a:xfrm>
+            <a:off x="3438144" y="2990088"/>
+            <a:ext cx="5166360" cy="768096"/>
+          </a:xfrm>
+          <a:prstGeom prst="rect">
+            <a:avLst/>
+          </a:prstGeom>
+          <a:noFill/>
+        </p:spPr>
+        <p:txBody>
+          <a:bodyPr wrap="square">
+            <a:spAutoFit/>
+          </a:bodyPr>
+          <a:lstStyle/>
+          <a:p>
+            <a:r>
+              <a:rPr sz="2000" b="0"/>
+              <a:t>How does the database realize our requests, and at what cost?</a:t>
+            </a:r>
+          </a:p>
+        </p:txBody>
+      </p:sp>
+      <p:sp>
+        <p:nvSpPr>
+          <p:cNvPr id="13" name="Card"/>
+          <p:cNvSpPr/>
+          <p:nvPr/>
+        </p:nvSpPr>
+        <p:spPr>
+          <a:xfrm>
+            <a:off x="411480" y="3904487"/>
+            <a:ext cx="8321040" cy="841248"/>
+          </a:xfrm>
+          <a:prstGeom prst="rect">
+            <a:avLst/>
+          </a:prstGeom>
+          <a:solidFill>
+            <a:srgbClr val="FCFAF6"/>
+          </a:solidFill>
+          <a:ln>
+            <a:noFill/>
+          </a:ln>
+          <a:effectLst/>
+        </p:spPr>
+        <p:style>
+          <a:lnRef idx="1">
+            <a:schemeClr val="accent1"/>
+          </a:lnRef>
+          <a:fillRef idx="3">
+            <a:schemeClr val="accent1"/>
+          </a:fillRef>
+          <a:effectRef idx="2">
+            <a:schemeClr val="accent1"/>
+          </a:effectRef>
+          <a:fontRef idx="minor">
+            <a:schemeClr val="lt1"/>
+          </a:fontRef>
+        </p:style>
+        <p:txBody>
+          <a:bodyPr rtlCol="0" anchor="ctr"/>
+          <a:lstStyle/>
+          <a:p>
+            <a:pPr algn="ctr"/>
+          </a:p>
+        </p:txBody>
+      </p:sp>
+      <p:sp>
+        <p:nvSpPr>
+          <p:cNvPr id="14" name="RowLabel"/>
+          <p:cNvSpPr txBox="1"/>
+          <p:nvPr/>
+        </p:nvSpPr>
+        <p:spPr>
+          <a:xfrm>
+            <a:off x="557784" y="3941063"/>
+            <a:ext cx="2788920" cy="768096"/>
+          </a:xfrm>
+          <a:prstGeom prst="rect">
+            <a:avLst/>
+          </a:prstGeom>
+          <a:noFill/>
+        </p:spPr>
+        <p:txBody>
+          <a:bodyPr wrap="square">
+            <a:spAutoFit/>
+          </a:bodyPr>
+          <a:lstStyle/>
+          <a:p>
+            <a:r>
+              <a:rPr sz="2000" b="1"/>
+              <a:t>Concurrency and transactions</a:t>
+            </a:r>
+          </a:p>
+        </p:txBody>
+      </p:sp>
+      <p:sp>
+        <p:nvSpPr>
+          <p:cNvPr id="15" name="RowBody"/>
+          <p:cNvSpPr txBox="1"/>
+          <p:nvPr/>
+        </p:nvSpPr>
+        <p:spPr>
+          <a:xfrm>
+            <a:off x="3438144" y="3941063"/>
+            <a:ext cx="5166360" cy="768096"/>
+          </a:xfrm>
+          <a:prstGeom prst="rect">
+            <a:avLst/>
+          </a:prstGeom>
+          <a:noFill/>
+        </p:spPr>
+        <p:txBody>
+          <a:bodyPr wrap="square">
+            <a:spAutoFit/>
+          </a:bodyPr>
+          <a:lstStyle/>
+          <a:p>
+            <a:r>
+              <a:rPr sz="2000" b="0"/>
+              <a:t>How do we preserve invariants across overlapping operations?</a:t>
+            </a:r>
+          </a:p>
+        </p:txBody>
+      </p:sp>
+      <p:sp>
+        <p:nvSpPr>
+          <p:cNvPr id="16" name="Card"/>
+          <p:cNvSpPr/>
+          <p:nvPr/>
+        </p:nvSpPr>
+        <p:spPr>
+          <a:xfrm>
+            <a:off x="411480" y="4855464"/>
+            <a:ext cx="8321040" cy="841248"/>
+          </a:xfrm>
+          <a:prstGeom prst="rect">
+            <a:avLst/>
+          </a:prstGeom>
+          <a:solidFill>
+            <a:srgbClr val="F5F1E8"/>
+          </a:solidFill>
+          <a:ln>
+            <a:noFill/>
+          </a:ln>
+          <a:effectLst/>
+        </p:spPr>
+        <p:style>
+          <a:lnRef idx="1">
+            <a:schemeClr val="accent1"/>
+          </a:lnRef>
+          <a:fillRef idx="3">
+            <a:schemeClr val="accent1"/>
+          </a:fillRef>
+          <a:effectRef idx="2">
+            <a:schemeClr val="accent1"/>
+          </a:effectRef>
+          <a:fontRef idx="minor">
+            <a:schemeClr val="lt1"/>
+          </a:fontRef>
+        </p:style>
+        <p:txBody>
+          <a:bodyPr rtlCol="0" anchor="ctr"/>
+          <a:lstStyle/>
+          <a:p>
+            <a:pPr algn="ctr"/>
+          </a:p>
+        </p:txBody>
+      </p:sp>
+      <p:sp>
+        <p:nvSpPr>
+          <p:cNvPr id="17" name="RowLabel"/>
+          <p:cNvSpPr txBox="1"/>
+          <p:nvPr/>
+        </p:nvSpPr>
+        <p:spPr>
+          <a:xfrm>
+            <a:off x="557784" y="4892040"/>
+            <a:ext cx="2788920" cy="768096"/>
+          </a:xfrm>
+          <a:prstGeom prst="rect">
+            <a:avLst/>
+          </a:prstGeom>
+          <a:noFill/>
+        </p:spPr>
+        <p:txBody>
+          <a:bodyPr wrap="square">
+            <a:spAutoFit/>
+          </a:bodyPr>
+          <a:lstStyle/>
+          <a:p>
+            <a:r>
+              <a:rPr sz="2000" b="1"/>
+              <a:t>Evolution and synthesis</a:t>
+            </a:r>
+          </a:p>
+        </p:txBody>
+      </p:sp>
+      <p:sp>
+        <p:nvSpPr>
+          <p:cNvPr id="18" name="RowBody"/>
+          <p:cNvSpPr txBox="1"/>
+          <p:nvPr/>
+        </p:nvSpPr>
+        <p:spPr>
+          <a:xfrm>
+            <a:off x="3438144" y="4892040"/>
+            <a:ext cx="5166360" cy="768096"/>
+          </a:xfrm>
+          <a:prstGeom prst="rect">
+            <a:avLst/>
+          </a:prstGeom>
+          <a:noFill/>
+        </p:spPr>
+        <p:txBody>
+          <a:bodyPr wrap="square">
+            <a:spAutoFit/>
+          </a:bodyPr>
+          <a:lstStyle/>
+          <a:p>
+            <a:r>
+              <a:rPr sz="2000" b="0"/>
+              <a:t>How do data models change, and what have we decided?</a:t>
             </a:r>
           </a:p>
         </p:txBody>
@@ -22649,8 +23421,12 @@
       <p:sp>
         <p:nvSpPr>
           <p:cNvPr id="2" name="Title"/>
-          <p:cNvSpPr txBox="1"/>
-          <p:nvPr/>
+          <p:cNvSpPr txBox="1">
+            <a:spLocks noGrp="1"/>
+          </p:cNvSpPr>
+          <p:nvPr>
+            <p:ph type="title"/>
+          </p:nvPr>
         </p:nvSpPr>
         <p:spPr>
           <a:xfrm>
@@ -23198,8 +23974,12 @@
       <p:sp>
         <p:nvSpPr>
           <p:cNvPr id="2" name="Title"/>
-          <p:cNvSpPr txBox="1"/>
-          <p:nvPr/>
+          <p:cNvSpPr txBox="1">
+            <a:spLocks noGrp="1"/>
+          </p:cNvSpPr>
+          <p:nvPr>
+            <p:ph type="title"/>
+          </p:nvPr>
         </p:nvSpPr>
         <p:spPr>
           <a:xfrm>
@@ -23958,7 +24738,7 @@
                 </a:solidFill>
                 <a:latin typeface="Calibri"/>
               </a:rPr>
-              <a:t>Sixth, Operations — backup, recovery, migration — deferred to Unit 6</a:t>
+              <a:t>A sixth, Operations (backup, recovery, migration), waits for Operations &amp; SRE</a:t>
             </a:r>
           </a:p>
         </p:txBody>
@@ -24067,8 +24847,12 @@
       <p:sp>
         <p:nvSpPr>
           <p:cNvPr id="2" name="Title"/>
-          <p:cNvSpPr txBox="1"/>
-          <p:nvPr/>
+          <p:cNvSpPr txBox="1">
+            <a:spLocks noGrp="1"/>
+          </p:cNvSpPr>
+          <p:nvPr>
+            <p:ph type="title"/>
+          </p:nvPr>
         </p:nvSpPr>
         <p:spPr>
           <a:xfrm>
@@ -24667,8 +25451,12 @@
       <p:sp>
         <p:nvSpPr>
           <p:cNvPr id="2" name="Title"/>
-          <p:cNvSpPr txBox="1"/>
-          <p:nvPr/>
+          <p:cNvSpPr txBox="1">
+            <a:spLocks noGrp="1"/>
+          </p:cNvSpPr>
+          <p:nvPr>
+            <p:ph type="title"/>
+          </p:nvPr>
         </p:nvSpPr>
         <p:spPr>
           <a:xfrm>
@@ -25168,8 +25956,12 @@
       <p:sp>
         <p:nvSpPr>
           <p:cNvPr id="2" name="Title"/>
-          <p:cNvSpPr txBox="1"/>
-          <p:nvPr/>
+          <p:cNvSpPr txBox="1">
+            <a:spLocks noGrp="1"/>
+          </p:cNvSpPr>
+          <p:nvPr>
+            <p:ph type="title"/>
+          </p:nvPr>
         </p:nvSpPr>
         <p:spPr>
           <a:xfrm>
@@ -25743,8 +26535,12 @@
       <p:sp>
         <p:nvSpPr>
           <p:cNvPr id="2" name="Title"/>
-          <p:cNvSpPr txBox="1"/>
-          <p:nvPr/>
+          <p:cNvSpPr txBox="1">
+            <a:spLocks noGrp="1"/>
+          </p:cNvSpPr>
+          <p:nvPr>
+            <p:ph type="title"/>
+          </p:nvPr>
         </p:nvSpPr>
         <p:spPr>
           <a:xfrm>
@@ -26209,8 +27005,12 @@
       <p:sp>
         <p:nvSpPr>
           <p:cNvPr id="2" name="Title"/>
-          <p:cNvSpPr txBox="1"/>
-          <p:nvPr/>
+          <p:cNvSpPr txBox="1">
+            <a:spLocks noGrp="1"/>
+          </p:cNvSpPr>
+          <p:nvPr>
+            <p:ph type="title"/>
+          </p:nvPr>
         </p:nvSpPr>
         <p:spPr>
           <a:xfrm>
@@ -26240,7 +27040,7 @@
                 </a:solidFill>
                 <a:latin typeface="Calibri"/>
               </a:rPr>
-              <a:t>Modeling the domain: entities and relationships</a:t>
+              <a:t>How should we represent the reservation domain?</a:t>
             </a:r>
           </a:p>
         </p:txBody>

</xml_diff>

<commit_message>
deck 3-2: pose-before-answer builds on slides 13, 20, 24
Review pattern B: students reason before the answer appears.
- Slide 13 (two valid rows): the violation card, relation card, and gold
  banner appear on one click after students judge the rows
- Slide 20 (race): availability checks visible; click 1 reveals both
  INSERTs, click 2 the verdict
- Slide 24 (invariant home): the three mechanism rows appear on three
  clicks after students propose enforcement homes
Appear entrances via canonical set-visibility timing trees; validator
clean. ANIMATE markers land with the notes-format pass next.

Co-Authored-By: Claude Opus 5 <noreply@anthropic.com>
</commit_message>
<xml_diff>
--- a/course/lectures/act-3-software-in-the-world/02-compute-environments-and-data-management/3-2-Data-Management.pptx
+++ b/course/lectures/act-3-software-in-the-world/02-compute-environments-and-data-management/3-2-Data-Management.pptx
@@ -13693,6 +13693,216 @@
   <p:clrMapOvr>
     <a:masterClrMapping/>
   </p:clrMapOvr>
+  <p:timing>
+    <p:tnLst>
+      <p:par>
+        <p:cTn id="1" dur="indefinite" restart="never" nodeType="tmRoot">
+          <p:childTnLst>
+            <p:seq concurrent="1" nextAc="seek">
+              <p:cTn id="2" dur="indefinite" nodeType="mainSeq">
+                <p:childTnLst>
+                  <p:par>
+                    <p:cTn id="3" fill="hold">
+                      <p:stCondLst>
+                        <p:cond delay="indefinite"/>
+                      </p:stCondLst>
+                      <p:childTnLst>
+                        <p:par>
+                          <p:cTn id="4" fill="hold">
+                            <p:stCondLst>
+                              <p:cond delay="0"/>
+                            </p:stCondLst>
+                            <p:childTnLst>
+                              <p:par>
+                                <p:cTn id="5" presetID="1" presetClass="entr" presetSubtype="0" fill="hold" nodeType="clickEffect">
+                                  <p:stCondLst>
+                                    <p:cond delay="0"/>
+                                  </p:stCondLst>
+                                  <p:childTnLst>
+                                    <p:set>
+                                      <p:cBhvr>
+                                        <p:cTn id="6" dur="1" fill="hold">
+                                          <p:stCondLst>
+                                            <p:cond delay="0"/>
+                                          </p:stCondLst>
+                                        </p:cTn>
+                                        <p:tgtEl>
+                                          <p:spTgt spid="5"/>
+                                        </p:tgtEl>
+                                        <p:attrNameLst>
+                                          <p:attrName>style.visibility</p:attrName>
+                                        </p:attrNameLst>
+                                      </p:cBhvr>
+                                      <p:to>
+                                        <p:strVal val="visible"/>
+                                      </p:to>
+                                    </p:set>
+                                  </p:childTnLst>
+                                </p:cTn>
+                              </p:par>
+                              <p:par>
+                                <p:cTn id="7" presetID="1" presetClass="entr" presetSubtype="0" fill="hold" nodeType="withEffect">
+                                  <p:stCondLst>
+                                    <p:cond delay="0"/>
+                                  </p:stCondLst>
+                                  <p:childTnLst>
+                                    <p:set>
+                                      <p:cBhvr>
+                                        <p:cTn id="8" dur="1" fill="hold">
+                                          <p:stCondLst>
+                                            <p:cond delay="0"/>
+                                          </p:stCondLst>
+                                        </p:cTn>
+                                        <p:tgtEl>
+                                          <p:spTgt spid="6"/>
+                                        </p:tgtEl>
+                                        <p:attrNameLst>
+                                          <p:attrName>style.visibility</p:attrName>
+                                        </p:attrNameLst>
+                                      </p:cBhvr>
+                                      <p:to>
+                                        <p:strVal val="visible"/>
+                                      </p:to>
+                                    </p:set>
+                                  </p:childTnLst>
+                                </p:cTn>
+                              </p:par>
+                              <p:par>
+                                <p:cTn id="9" presetID="1" presetClass="entr" presetSubtype="0" fill="hold" nodeType="withEffect">
+                                  <p:stCondLst>
+                                    <p:cond delay="0"/>
+                                  </p:stCondLst>
+                                  <p:childTnLst>
+                                    <p:set>
+                                      <p:cBhvr>
+                                        <p:cTn id="10" dur="1" fill="hold">
+                                          <p:stCondLst>
+                                            <p:cond delay="0"/>
+                                          </p:stCondLst>
+                                        </p:cTn>
+                                        <p:tgtEl>
+                                          <p:spTgt spid="7"/>
+                                        </p:tgtEl>
+                                        <p:attrNameLst>
+                                          <p:attrName>style.visibility</p:attrName>
+                                        </p:attrNameLst>
+                                      </p:cBhvr>
+                                      <p:to>
+                                        <p:strVal val="visible"/>
+                                      </p:to>
+                                    </p:set>
+                                  </p:childTnLst>
+                                </p:cTn>
+                              </p:par>
+                              <p:par>
+                                <p:cTn id="11" presetID="1" presetClass="entr" presetSubtype="0" fill="hold" nodeType="withEffect">
+                                  <p:stCondLst>
+                                    <p:cond delay="0"/>
+                                  </p:stCondLst>
+                                  <p:childTnLst>
+                                    <p:set>
+                                      <p:cBhvr>
+                                        <p:cTn id="12" dur="1" fill="hold">
+                                          <p:stCondLst>
+                                            <p:cond delay="0"/>
+                                          </p:stCondLst>
+                                        </p:cTn>
+                                        <p:tgtEl>
+                                          <p:spTgt spid="8"/>
+                                        </p:tgtEl>
+                                        <p:attrNameLst>
+                                          <p:attrName>style.visibility</p:attrName>
+                                        </p:attrNameLst>
+                                      </p:cBhvr>
+                                      <p:to>
+                                        <p:strVal val="visible"/>
+                                      </p:to>
+                                    </p:set>
+                                  </p:childTnLst>
+                                </p:cTn>
+                              </p:par>
+                              <p:par>
+                                <p:cTn id="13" presetID="1" presetClass="entr" presetSubtype="0" fill="hold" nodeType="withEffect">
+                                  <p:stCondLst>
+                                    <p:cond delay="0"/>
+                                  </p:stCondLst>
+                                  <p:childTnLst>
+                                    <p:set>
+                                      <p:cBhvr>
+                                        <p:cTn id="14" dur="1" fill="hold">
+                                          <p:stCondLst>
+                                            <p:cond delay="0"/>
+                                          </p:stCondLst>
+                                        </p:cTn>
+                                        <p:tgtEl>
+                                          <p:spTgt spid="9"/>
+                                        </p:tgtEl>
+                                        <p:attrNameLst>
+                                          <p:attrName>style.visibility</p:attrName>
+                                        </p:attrNameLst>
+                                      </p:cBhvr>
+                                      <p:to>
+                                        <p:strVal val="visible"/>
+                                      </p:to>
+                                    </p:set>
+                                  </p:childTnLst>
+                                </p:cTn>
+                              </p:par>
+                              <p:par>
+                                <p:cTn id="15" presetID="1" presetClass="entr" presetSubtype="0" fill="hold" nodeType="withEffect">
+                                  <p:stCondLst>
+                                    <p:cond delay="0"/>
+                                  </p:stCondLst>
+                                  <p:childTnLst>
+                                    <p:set>
+                                      <p:cBhvr>
+                                        <p:cTn id="16" dur="1" fill="hold">
+                                          <p:stCondLst>
+                                            <p:cond delay="0"/>
+                                          </p:stCondLst>
+                                        </p:cTn>
+                                        <p:tgtEl>
+                                          <p:spTgt spid="10"/>
+                                        </p:tgtEl>
+                                        <p:attrNameLst>
+                                          <p:attrName>style.visibility</p:attrName>
+                                        </p:attrNameLst>
+                                      </p:cBhvr>
+                                      <p:to>
+                                        <p:strVal val="visible"/>
+                                      </p:to>
+                                    </p:set>
+                                  </p:childTnLst>
+                                </p:cTn>
+                              </p:par>
+                            </p:childTnLst>
+                          </p:cTn>
+                        </p:par>
+                      </p:childTnLst>
+                    </p:cTn>
+                  </p:par>
+                </p:childTnLst>
+              </p:cTn>
+              <p:prevCondLst>
+                <p:cond evt="onPrev" delay="0">
+                  <p:tgtEl>
+                    <p:sldTgt/>
+                  </p:tgtEl>
+                </p:cond>
+              </p:prevCondLst>
+              <p:nextCondLst>
+                <p:cond evt="onNext" delay="0">
+                  <p:tgtEl>
+                    <p:sldTgt/>
+                  </p:tgtEl>
+                </p:cond>
+              </p:nextCondLst>
+            </p:seq>
+          </p:childTnLst>
+        </p:cTn>
+      </p:par>
+    </p:tnLst>
+  </p:timing>
 </p:sld>
 </file>
 
@@ -18187,6 +18397,180 @@
   <p:clrMapOvr>
     <a:masterClrMapping/>
   </p:clrMapOvr>
+  <p:timing>
+    <p:tnLst>
+      <p:par>
+        <p:cTn id="1" dur="indefinite" restart="never" nodeType="tmRoot">
+          <p:childTnLst>
+            <p:seq concurrent="1" nextAc="seek">
+              <p:cTn id="2" dur="indefinite" nodeType="mainSeq">
+                <p:childTnLst>
+                  <p:par>
+                    <p:cTn id="3" fill="hold">
+                      <p:stCondLst>
+                        <p:cond delay="indefinite"/>
+                      </p:stCondLst>
+                      <p:childTnLst>
+                        <p:par>
+                          <p:cTn id="4" fill="hold">
+                            <p:stCondLst>
+                              <p:cond delay="0"/>
+                            </p:stCondLst>
+                            <p:childTnLst>
+                              <p:par>
+                                <p:cTn id="5" presetID="1" presetClass="entr" presetSubtype="0" fill="hold" nodeType="clickEffect">
+                                  <p:stCondLst>
+                                    <p:cond delay="0"/>
+                                  </p:stCondLst>
+                                  <p:childTnLst>
+                                    <p:set>
+                                      <p:cBhvr>
+                                        <p:cTn id="6" dur="1" fill="hold">
+                                          <p:stCondLst>
+                                            <p:cond delay="0"/>
+                                          </p:stCondLst>
+                                        </p:cTn>
+                                        <p:tgtEl>
+                                          <p:spTgt spid="7"/>
+                                        </p:tgtEl>
+                                        <p:attrNameLst>
+                                          <p:attrName>style.visibility</p:attrName>
+                                        </p:attrNameLst>
+                                      </p:cBhvr>
+                                      <p:to>
+                                        <p:strVal val="visible"/>
+                                      </p:to>
+                                    </p:set>
+                                  </p:childTnLst>
+                                </p:cTn>
+                              </p:par>
+                              <p:par>
+                                <p:cTn id="7" presetID="1" presetClass="entr" presetSubtype="0" fill="hold" nodeType="withEffect">
+                                  <p:stCondLst>
+                                    <p:cond delay="0"/>
+                                  </p:stCondLst>
+                                  <p:childTnLst>
+                                    <p:set>
+                                      <p:cBhvr>
+                                        <p:cTn id="8" dur="1" fill="hold">
+                                          <p:stCondLst>
+                                            <p:cond delay="0"/>
+                                          </p:stCondLst>
+                                        </p:cTn>
+                                        <p:tgtEl>
+                                          <p:spTgt spid="8"/>
+                                        </p:tgtEl>
+                                        <p:attrNameLst>
+                                          <p:attrName>style.visibility</p:attrName>
+                                        </p:attrNameLst>
+                                      </p:cBhvr>
+                                      <p:to>
+                                        <p:strVal val="visible"/>
+                                      </p:to>
+                                    </p:set>
+                                  </p:childTnLst>
+                                </p:cTn>
+                              </p:par>
+                            </p:childTnLst>
+                          </p:cTn>
+                        </p:par>
+                      </p:childTnLst>
+                    </p:cTn>
+                  </p:par>
+                  <p:par>
+                    <p:cTn id="9" fill="hold">
+                      <p:stCondLst>
+                        <p:cond delay="indefinite"/>
+                      </p:stCondLst>
+                      <p:childTnLst>
+                        <p:par>
+                          <p:cTn id="10" fill="hold">
+                            <p:stCondLst>
+                              <p:cond delay="0"/>
+                            </p:stCondLst>
+                            <p:childTnLst>
+                              <p:par>
+                                <p:cTn id="11" presetID="1" presetClass="entr" presetSubtype="0" fill="hold" nodeType="clickEffect">
+                                  <p:stCondLst>
+                                    <p:cond delay="0"/>
+                                  </p:stCondLst>
+                                  <p:childTnLst>
+                                    <p:set>
+                                      <p:cBhvr>
+                                        <p:cTn id="12" dur="1" fill="hold">
+                                          <p:stCondLst>
+                                            <p:cond delay="0"/>
+                                          </p:stCondLst>
+                                        </p:cTn>
+                                        <p:tgtEl>
+                                          <p:spTgt spid="9"/>
+                                        </p:tgtEl>
+                                        <p:attrNameLst>
+                                          <p:attrName>style.visibility</p:attrName>
+                                        </p:attrNameLst>
+                                      </p:cBhvr>
+                                      <p:to>
+                                        <p:strVal val="visible"/>
+                                      </p:to>
+                                    </p:set>
+                                  </p:childTnLst>
+                                </p:cTn>
+                              </p:par>
+                              <p:par>
+                                <p:cTn id="13" presetID="1" presetClass="entr" presetSubtype="0" fill="hold" nodeType="withEffect">
+                                  <p:stCondLst>
+                                    <p:cond delay="0"/>
+                                  </p:stCondLst>
+                                  <p:childTnLst>
+                                    <p:set>
+                                      <p:cBhvr>
+                                        <p:cTn id="14" dur="1" fill="hold">
+                                          <p:stCondLst>
+                                            <p:cond delay="0"/>
+                                          </p:stCondLst>
+                                        </p:cTn>
+                                        <p:tgtEl>
+                                          <p:spTgt spid="10"/>
+                                        </p:tgtEl>
+                                        <p:attrNameLst>
+                                          <p:attrName>style.visibility</p:attrName>
+                                        </p:attrNameLst>
+                                      </p:cBhvr>
+                                      <p:to>
+                                        <p:strVal val="visible"/>
+                                      </p:to>
+                                    </p:set>
+                                  </p:childTnLst>
+                                </p:cTn>
+                              </p:par>
+                            </p:childTnLst>
+                          </p:cTn>
+                        </p:par>
+                      </p:childTnLst>
+                    </p:cTn>
+                  </p:par>
+                </p:childTnLst>
+              </p:cTn>
+              <p:prevCondLst>
+                <p:cond evt="onPrev" delay="0">
+                  <p:tgtEl>
+                    <p:sldTgt/>
+                  </p:tgtEl>
+                </p:cond>
+              </p:prevCondLst>
+              <p:nextCondLst>
+                <p:cond evt="onNext" delay="0">
+                  <p:tgtEl>
+                    <p:sldTgt/>
+                  </p:tgtEl>
+                </p:cond>
+              </p:nextCondLst>
+            </p:seq>
+          </p:childTnLst>
+        </p:cTn>
+      </p:par>
+    </p:tnLst>
+  </p:timing>
 </p:sld>
 </file>
 
@@ -20496,6 +20880,333 @@
   <p:clrMapOvr>
     <a:masterClrMapping/>
   </p:clrMapOvr>
+  <p:timing>
+    <p:tnLst>
+      <p:par>
+        <p:cTn id="1" dur="indefinite" restart="never" nodeType="tmRoot">
+          <p:childTnLst>
+            <p:seq concurrent="1" nextAc="seek">
+              <p:cTn id="2" dur="indefinite" nodeType="mainSeq">
+                <p:childTnLst>
+                  <p:par>
+                    <p:cTn id="3" fill="hold">
+                      <p:stCondLst>
+                        <p:cond delay="indefinite"/>
+                      </p:stCondLst>
+                      <p:childTnLst>
+                        <p:par>
+                          <p:cTn id="4" fill="hold">
+                            <p:stCondLst>
+                              <p:cond delay="0"/>
+                            </p:stCondLst>
+                            <p:childTnLst>
+                              <p:par>
+                                <p:cTn id="5" presetID="1" presetClass="entr" presetSubtype="0" fill="hold" nodeType="clickEffect">
+                                  <p:stCondLst>
+                                    <p:cond delay="0"/>
+                                  </p:stCondLst>
+                                  <p:childTnLst>
+                                    <p:set>
+                                      <p:cBhvr>
+                                        <p:cTn id="6" dur="1" fill="hold">
+                                          <p:stCondLst>
+                                            <p:cond delay="0"/>
+                                          </p:stCondLst>
+                                        </p:cTn>
+                                        <p:tgtEl>
+                                          <p:spTgt spid="3"/>
+                                        </p:tgtEl>
+                                        <p:attrNameLst>
+                                          <p:attrName>style.visibility</p:attrName>
+                                        </p:attrNameLst>
+                                      </p:cBhvr>
+                                      <p:to>
+                                        <p:strVal val="visible"/>
+                                      </p:to>
+                                    </p:set>
+                                  </p:childTnLst>
+                                </p:cTn>
+                              </p:par>
+                              <p:par>
+                                <p:cTn id="7" presetID="1" presetClass="entr" presetSubtype="0" fill="hold" nodeType="withEffect">
+                                  <p:stCondLst>
+                                    <p:cond delay="0"/>
+                                  </p:stCondLst>
+                                  <p:childTnLst>
+                                    <p:set>
+                                      <p:cBhvr>
+                                        <p:cTn id="8" dur="1" fill="hold">
+                                          <p:stCondLst>
+                                            <p:cond delay="0"/>
+                                          </p:stCondLst>
+                                        </p:cTn>
+                                        <p:tgtEl>
+                                          <p:spTgt spid="4"/>
+                                        </p:tgtEl>
+                                        <p:attrNameLst>
+                                          <p:attrName>style.visibility</p:attrName>
+                                        </p:attrNameLst>
+                                      </p:cBhvr>
+                                      <p:to>
+                                        <p:strVal val="visible"/>
+                                      </p:to>
+                                    </p:set>
+                                  </p:childTnLst>
+                                </p:cTn>
+                              </p:par>
+                              <p:par>
+                                <p:cTn id="9" presetID="1" presetClass="entr" presetSubtype="0" fill="hold" nodeType="withEffect">
+                                  <p:stCondLst>
+                                    <p:cond delay="0"/>
+                                  </p:stCondLst>
+                                  <p:childTnLst>
+                                    <p:set>
+                                      <p:cBhvr>
+                                        <p:cTn id="10" dur="1" fill="hold">
+                                          <p:stCondLst>
+                                            <p:cond delay="0"/>
+                                          </p:stCondLst>
+                                        </p:cTn>
+                                        <p:tgtEl>
+                                          <p:spTgt spid="5"/>
+                                        </p:tgtEl>
+                                        <p:attrNameLst>
+                                          <p:attrName>style.visibility</p:attrName>
+                                        </p:attrNameLst>
+                                      </p:cBhvr>
+                                      <p:to>
+                                        <p:strVal val="visible"/>
+                                      </p:to>
+                                    </p:set>
+                                  </p:childTnLst>
+                                </p:cTn>
+                              </p:par>
+                            </p:childTnLst>
+                          </p:cTn>
+                        </p:par>
+                      </p:childTnLst>
+                    </p:cTn>
+                  </p:par>
+                  <p:par>
+                    <p:cTn id="11" fill="hold">
+                      <p:stCondLst>
+                        <p:cond delay="indefinite"/>
+                      </p:stCondLst>
+                      <p:childTnLst>
+                        <p:par>
+                          <p:cTn id="12" fill="hold">
+                            <p:stCondLst>
+                              <p:cond delay="0"/>
+                            </p:stCondLst>
+                            <p:childTnLst>
+                              <p:par>
+                                <p:cTn id="13" presetID="1" presetClass="entr" presetSubtype="0" fill="hold" nodeType="clickEffect">
+                                  <p:stCondLst>
+                                    <p:cond delay="0"/>
+                                  </p:stCondLst>
+                                  <p:childTnLst>
+                                    <p:set>
+                                      <p:cBhvr>
+                                        <p:cTn id="14" dur="1" fill="hold">
+                                          <p:stCondLst>
+                                            <p:cond delay="0"/>
+                                          </p:stCondLst>
+                                        </p:cTn>
+                                        <p:tgtEl>
+                                          <p:spTgt spid="6"/>
+                                        </p:tgtEl>
+                                        <p:attrNameLst>
+                                          <p:attrName>style.visibility</p:attrName>
+                                        </p:attrNameLst>
+                                      </p:cBhvr>
+                                      <p:to>
+                                        <p:strVal val="visible"/>
+                                      </p:to>
+                                    </p:set>
+                                  </p:childTnLst>
+                                </p:cTn>
+                              </p:par>
+                              <p:par>
+                                <p:cTn id="15" presetID="1" presetClass="entr" presetSubtype="0" fill="hold" nodeType="withEffect">
+                                  <p:stCondLst>
+                                    <p:cond delay="0"/>
+                                  </p:stCondLst>
+                                  <p:childTnLst>
+                                    <p:set>
+                                      <p:cBhvr>
+                                        <p:cTn id="16" dur="1" fill="hold">
+                                          <p:stCondLst>
+                                            <p:cond delay="0"/>
+                                          </p:stCondLst>
+                                        </p:cTn>
+                                        <p:tgtEl>
+                                          <p:spTgt spid="7"/>
+                                        </p:tgtEl>
+                                        <p:attrNameLst>
+                                          <p:attrName>style.visibility</p:attrName>
+                                        </p:attrNameLst>
+                                      </p:cBhvr>
+                                      <p:to>
+                                        <p:strVal val="visible"/>
+                                      </p:to>
+                                    </p:set>
+                                  </p:childTnLst>
+                                </p:cTn>
+                              </p:par>
+                              <p:par>
+                                <p:cTn id="17" presetID="1" presetClass="entr" presetSubtype="0" fill="hold" nodeType="withEffect">
+                                  <p:stCondLst>
+                                    <p:cond delay="0"/>
+                                  </p:stCondLst>
+                                  <p:childTnLst>
+                                    <p:set>
+                                      <p:cBhvr>
+                                        <p:cTn id="18" dur="1" fill="hold">
+                                          <p:stCondLst>
+                                            <p:cond delay="0"/>
+                                          </p:stCondLst>
+                                        </p:cTn>
+                                        <p:tgtEl>
+                                          <p:spTgt spid="8"/>
+                                        </p:tgtEl>
+                                        <p:attrNameLst>
+                                          <p:attrName>style.visibility</p:attrName>
+                                        </p:attrNameLst>
+                                      </p:cBhvr>
+                                      <p:to>
+                                        <p:strVal val="visible"/>
+                                      </p:to>
+                                    </p:set>
+                                  </p:childTnLst>
+                                </p:cTn>
+                              </p:par>
+                            </p:childTnLst>
+                          </p:cTn>
+                        </p:par>
+                      </p:childTnLst>
+                    </p:cTn>
+                  </p:par>
+                  <p:par>
+                    <p:cTn id="19" fill="hold">
+                      <p:stCondLst>
+                        <p:cond delay="indefinite"/>
+                      </p:stCondLst>
+                      <p:childTnLst>
+                        <p:par>
+                          <p:cTn id="20" fill="hold">
+                            <p:stCondLst>
+                              <p:cond delay="0"/>
+                            </p:stCondLst>
+                            <p:childTnLst>
+                              <p:par>
+                                <p:cTn id="21" presetID="1" presetClass="entr" presetSubtype="0" fill="hold" nodeType="clickEffect">
+                                  <p:stCondLst>
+                                    <p:cond delay="0"/>
+                                  </p:stCondLst>
+                                  <p:childTnLst>
+                                    <p:set>
+                                      <p:cBhvr>
+                                        <p:cTn id="22" dur="1" fill="hold">
+                                          <p:stCondLst>
+                                            <p:cond delay="0"/>
+                                          </p:stCondLst>
+                                        </p:cTn>
+                                        <p:tgtEl>
+                                          <p:spTgt spid="9"/>
+                                        </p:tgtEl>
+                                        <p:attrNameLst>
+                                          <p:attrName>style.visibility</p:attrName>
+                                        </p:attrNameLst>
+                                      </p:cBhvr>
+                                      <p:to>
+                                        <p:strVal val="visible"/>
+                                      </p:to>
+                                    </p:set>
+                                  </p:childTnLst>
+                                </p:cTn>
+                              </p:par>
+                              <p:par>
+                                <p:cTn id="23" presetID="1" presetClass="entr" presetSubtype="0" fill="hold" nodeType="withEffect">
+                                  <p:stCondLst>
+                                    <p:cond delay="0"/>
+                                  </p:stCondLst>
+                                  <p:childTnLst>
+                                    <p:set>
+                                      <p:cBhvr>
+                                        <p:cTn id="24" dur="1" fill="hold">
+                                          <p:stCondLst>
+                                            <p:cond delay="0"/>
+                                          </p:stCondLst>
+                                        </p:cTn>
+                                        <p:tgtEl>
+                                          <p:spTgt spid="10"/>
+                                        </p:tgtEl>
+                                        <p:attrNameLst>
+                                          <p:attrName>style.visibility</p:attrName>
+                                        </p:attrNameLst>
+                                      </p:cBhvr>
+                                      <p:to>
+                                        <p:strVal val="visible"/>
+                                      </p:to>
+                                    </p:set>
+                                  </p:childTnLst>
+                                </p:cTn>
+                              </p:par>
+                              <p:par>
+                                <p:cTn id="25" presetID="1" presetClass="entr" presetSubtype="0" fill="hold" nodeType="withEffect">
+                                  <p:stCondLst>
+                                    <p:cond delay="0"/>
+                                  </p:stCondLst>
+                                  <p:childTnLst>
+                                    <p:set>
+                                      <p:cBhvr>
+                                        <p:cTn id="26" dur="1" fill="hold">
+                                          <p:stCondLst>
+                                            <p:cond delay="0"/>
+                                          </p:stCondLst>
+                                        </p:cTn>
+                                        <p:tgtEl>
+                                          <p:spTgt spid="11"/>
+                                        </p:tgtEl>
+                                        <p:attrNameLst>
+                                          <p:attrName>style.visibility</p:attrName>
+                                        </p:attrNameLst>
+                                      </p:cBhvr>
+                                      <p:to>
+                                        <p:strVal val="visible"/>
+                                      </p:to>
+                                    </p:set>
+                                  </p:childTnLst>
+                                </p:cTn>
+                              </p:par>
+                            </p:childTnLst>
+                          </p:cTn>
+                        </p:par>
+                      </p:childTnLst>
+                    </p:cTn>
+                  </p:par>
+                </p:childTnLst>
+              </p:cTn>
+              <p:prevCondLst>
+                <p:cond evt="onPrev" delay="0">
+                  <p:tgtEl>
+                    <p:sldTgt/>
+                  </p:tgtEl>
+                </p:cond>
+              </p:prevCondLst>
+              <p:nextCondLst>
+                <p:cond evt="onNext" delay="0">
+                  <p:tgtEl>
+                    <p:sldTgt/>
+                  </p:tgtEl>
+                </p:cond>
+              </p:nextCondLst>
+            </p:seq>
+          </p:childTnLst>
+        </p:cTn>
+      </p:par>
+    </p:tnLst>
+  </p:timing>
 </p:sld>
 </file>
 

</xml_diff>

<commit_message>
deck 3-2: P2 polish — em dashes, alt text, reading order, notes format
- Every audience-facing em dash rewritten per the relationship expressed
  (colon for definition/expansion, comma/semicolon for continuation,
  parentheses for the one aside); time-range en dashes kept
- Alt text on every meaningful figure: ER diagram, graph edge, layer
  stack, optimizer diagram, race timeline, nested-history sets, populated
  method flowchart
- Reading order: conclusion cards moved after the figures they conclude
  (slides 17, 22); banner reads last on 27
- Speaker notes converted to the canonical 'N minutes — *purpose*'
  opening line (native italics) on all 28 slides; the three build slides
  carry ===== delivery scripts whose ANIMATE markers match click counts
  exactly (asserted 1/2/3)

Co-Authored-By: Claude Opus 5 <noreply@anthropic.com>
</commit_message>
<xml_diff>
--- a/course/lectures/act-3-software-in-the-world/02-compute-environments-and-data-management/3-2-Data-Management.pptx
+++ b/course/lectures/act-3-software-in-the-world/02-compute-environments-and-data-management/3-2-Data-Management.pptx
@@ -1577,7 +1577,11 @@
           <a:lstStyle/>
           <a:p>
             <a:r>
-              <a:t>TIMING: 1 minute.</a:t>
+              <a:t>1 minute — </a:t>
+            </a:r>
+            <a:r>
+              <a:rPr i="1"/>
+              <a:t>Frame the 75 minutes: represent, retrieve, preserve, treated as a design space, not an SQL tutorial.</a:t>
             </a:r>
           </a:p>
           <a:p/>
@@ -1659,7 +1663,11 @@
           <a:lstStyle/>
           <a:p>
             <a:r>
-              <a:t>TIMING: 4 minutes.</a:t>
+              <a:t>4 minutes — </a:t>
+            </a:r>
+            <a:r>
+              <a:rPr i="1"/>
+              <a:t>Show the schema as enforced obligations, then expose what it cannot state.</a:t>
             </a:r>
           </a:p>
           <a:p/>
@@ -1747,7 +1755,11 @@
           <a:lstStyle/>
           <a:p>
             <a:r>
-              <a:t>TIMING: 3 minutes.</a:t>
+              <a:t>3 minutes — </a:t>
+            </a:r>
+            <a:r>
+              <a:rPr i="1"/>
+              <a:t>Price normalization vs denormalization as one cost moved between write and read paths.</a:t>
             </a:r>
           </a:p>
           <a:p/>
@@ -1835,7 +1847,11 @@
           <a:lstStyle/>
           <a:p>
             <a:r>
-              <a:t>TIMING: 3 minutes.</a:t>
+              <a:t>3 minutes — </a:t>
+            </a:r>
+            <a:r>
+              <a:rPr i="1"/>
+              <a:t>Students judge two valid rows; per-row validity is not application correctness.</a:t>
             </a:r>
           </a:p>
           <a:p/>
@@ -1854,6 +1870,26 @@
           <a:p>
             <a:r>
               <a:t>Transition: before we can fix enforcement, we need the other half of the design space — how we ASK the database questions. Query interfaces, then execution, then back here for concurrency.</a:t>
+            </a:r>
+          </a:p>
+          <a:p>
+            <a:r>
+              <a:t>=====</a:t>
+            </a:r>
+          </a:p>
+          <a:p>
+            <a:r>
+              <a:t>Ask the posed question and collect reasons: every constraint passes, so is the application correct?</a:t>
+            </a:r>
+          </a:p>
+          <a:p>
+            <a:r>
+              <a:t>ANIMATE</a:t>
+            </a:r>
+          </a:p>
+          <a:p>
+            <a:r>
+              <a:t>Reveal: the pair violates the invariant. Overlap is a property of the pair; no per-row check can see it.</a:t>
             </a:r>
           </a:p>
         </p:txBody>
@@ -1923,7 +1959,11 @@
           <a:lstStyle/>
           <a:p>
             <a:r>
-              <a:t>TIMING: 2 minutes.</a:t>
+              <a:t>2 minutes — </a:t>
+            </a:r>
+            <a:r>
+              <a:rPr i="1"/>
+              <a:t>Establish SQL as a specification: WHAT, never HOW.</a:t>
             </a:r>
           </a:p>
           <a:p/>
@@ -2011,7 +2051,11 @@
           <a:lstStyle/>
           <a:p>
             <a:r>
-              <a:t>TIMING: 2 minutes.</a:t>
+              <a:t>2 minutes — </a:t>
+            </a:r>
+            <a:r>
+              <a:rPr i="1"/>
+              <a:t>Show what an ORM buys and what it structurally costs on the same query.</a:t>
             </a:r>
           </a:p>
           <a:p/>
@@ -2099,7 +2143,11 @@
           <a:lstStyle/>
           <a:p>
             <a:r>
-              <a:t>TIMING: 3 minutes.</a:t>
+              <a:t>3 minutes — </a:t>
+            </a:r>
+            <a:r>
+              <a:rPr i="1"/>
+              <a:t>Dissolve ORM-vs-SQL into layers of one pipeline.</a:t>
             </a:r>
           </a:p>
           <a:p/>
@@ -2187,7 +2235,11 @@
           <a:lstStyle/>
           <a:p>
             <a:r>
-              <a:t>TIMING: 4 minutes.</a:t>
+              <a:t>4 minutes — </a:t>
+            </a:r>
+            <a:r>
+              <a:rPr i="1"/>
+              <a:t>Make the optimizer the central actor choosing among candidate plans by cost.</a:t>
             </a:r>
           </a:p>
           <a:p/>
@@ -2275,7 +2327,11 @@
           <a:lstStyle/>
           <a:p>
             <a:r>
-              <a:t>TIMING: 2 minutes.</a:t>
+              <a:t>2 minutes — </a:t>
+            </a:r>
+            <a:r>
+              <a:rPr i="1"/>
+              <a:t>One query, two plans, very different costs; indexes are design decisions.</a:t>
             </a:r>
           </a:p>
           <a:p/>
@@ -2357,7 +2413,11 @@
           <a:lstStyle/>
           <a:p>
             <a:r>
-              <a:t>TIMING: 2 minutes.</a:t>
+              <a:t>2 minutes — </a:t>
+            </a:r>
+            <a:r>
+              <a:rPr i="1"/>
+              <a:t>Expose the N+1 shape: correct code, terrible access pattern; review emitted queries.</a:t>
             </a:r>
           </a:p>
           <a:p/>
@@ -2451,7 +2511,11 @@
           <a:lstStyle/>
           <a:p>
             <a:r>
-              <a:t>TIMING: 5 minutes.</a:t>
+              <a:t>5 minutes — </a:t>
+            </a:r>
+            <a:r>
+              <a:rPr i="1"/>
+              <a:t>Students predict the race; locally correct requests break a global invariant.</a:t>
             </a:r>
           </a:p>
           <a:p/>
@@ -2482,6 +2546,36 @@
           <a:p>
             <a:r>
               <a:t>Do NOT let anyone claim a foreign key or CHECK would have stopped it — slide 10 established why not; it resurfaces with the fixes on slide 23.</a:t>
+            </a:r>
+          </a:p>
+          <a:p>
+            <a:r>
+              <a:t>=====</a:t>
+            </a:r>
+          </a:p>
+          <a:p>
+            <a:r>
+              <a:t>Walk t1 and t2: both availability checks run against a table containing neither insert. Ask: can both INSERTs succeed?</a:t>
+            </a:r>
+          </a:p>
+          <a:p>
+            <a:r>
+              <a:t>ANIMATE</a:t>
+            </a:r>
+          </a:p>
+          <a:p>
+            <a:r>
+              <a:t>Both inserts proceed; nothing has failed yet.</a:t>
+            </a:r>
+          </a:p>
+          <a:p>
+            <a:r>
+              <a:t>ANIMATE</a:t>
+            </a:r>
+          </a:p>
+          <a:p>
+            <a:r>
+              <a:t>Both commits succeed; room 117 is double-booked. No statement failed; the defect lives only in the interleaving.</a:t>
             </a:r>
           </a:p>
         </p:txBody>
@@ -2551,7 +2645,11 @@
           <a:lstStyle/>
           <a:p>
             <a:r>
-              <a:t>TIMING: 3 minutes.</a:t>
+              <a:t>3 minutes — </a:t>
+            </a:r>
+            <a:r>
+              <a:rPr i="1"/>
+              <a:t>Establish persistence, sharing, and concurrency as separable requirements.</a:t>
             </a:r>
           </a:p>
           <a:p/>
@@ -2639,7 +2737,11 @@
           <a:lstStyle/>
           <a:p>
             <a:r>
-              <a:t>TIMING: 3 minutes.</a:t>
+              <a:t>3 minutes — </a:t>
+            </a:r>
+            <a:r>
+              <a:rPr i="1"/>
+              <a:t>Fix what ACID promises; C does not mean your application is correct.</a:t>
             </a:r>
           </a:p>
           <a:p/>
@@ -2727,7 +2829,11 @@
           <a:lstStyle/>
           <a:p>
             <a:r>
-              <a:t>TIMING: 3 minutes.</a:t>
+              <a:t>3 minutes — </a:t>
+            </a:r>
+            <a:r>
+              <a:rPr i="1"/>
+              <a:t>Define isolation as a policy over permitted histories, serializability the core.</a:t>
             </a:r>
           </a:p>
           <a:p/>
@@ -2820,7 +2926,11 @@
           <a:lstStyle/>
           <a:p>
             <a:r>
-              <a:t>TIMING: 2 minutes.</a:t>
+              <a:t>2 minutes — </a:t>
+            </a:r>
+            <a:r>
+              <a:rPr i="1"/>
+              <a:t>Place our race on the isolation dial; the default is a choice someone else made.</a:t>
             </a:r>
           </a:p>
           <a:p/>
@@ -2908,7 +3018,11 @@
           <a:lstStyle/>
           <a:p>
             <a:r>
-              <a:t>TIMING: 3 minutes.</a:t>
+              <a:t>3 minutes — </a:t>
+            </a:r>
+            <a:r>
+              <a:rPr i="1"/>
+              <a:t>Students propose enforcement homes; compare schema, isolation contract, lock discipline.</a:t>
             </a:r>
           </a:p>
           <a:p/>
@@ -2945,6 +3059,46 @@
           <a:p>
             <a:r>
               <a:t>If asked about the document-model alternative: embedding reservations in the room document makes the invariant single-document, enforced by a compare-and-swap on one object — a legitimate fourth point in the space, with its own costs (hot document, cross-room queries).</a:t>
+            </a:r>
+          </a:p>
+          <a:p>
+            <a:r>
+              <a:t>=====</a:t>
+            </a:r>
+          </a:p>
+          <a:p>
+            <a:r>
+              <a:t>Collect proposals first: where could the invariant live? Students will offer constraints, transactions, locks; organize their answers into the three rows as they appear.</a:t>
+            </a:r>
+          </a:p>
+          <a:p>
+            <a:r>
+              <a:t>ANIMATE</a:t>
+            </a:r>
+          </a:p>
+          <a:p>
+            <a:r>
+              <a:t>Exclusion constraint: the schema states the invariant; the engine rejects the insert.</a:t>
+            </a:r>
+          </a:p>
+          <a:p>
+            <a:r>
+              <a:t>ANIMATE</a:t>
+            </a:r>
+          </a:p>
+          <a:p>
+            <a:r>
+              <a:t>Serializable plus retry: the isolation contract excludes the bad history; the application owns retries.</a:t>
+            </a:r>
+          </a:p>
+          <a:p>
+            <a:r>
+              <a:t>ANIMATE</a:t>
+            </a:r>
+          </a:p>
+          <a:p>
+            <a:r>
+              <a:t>Explicit locking: your discipline serializes writers per room; one forgetful code path breaks it.</a:t>
             </a:r>
           </a:p>
         </p:txBody>
@@ -3014,7 +3168,11 @@
           <a:lstStyle/>
           <a:p>
             <a:r>
-              <a:t>TIMING: 2 minutes.</a:t>
+              <a:t>2 minutes — </a:t>
+            </a:r>
+            <a:r>
+              <a:rPr i="1"/>
+              <a:t>Price concurrency control: contention, retries, throughput.</a:t>
             </a:r>
           </a:p>
           <a:p/>
@@ -3102,7 +3260,11 @@
           <a:lstStyle/>
           <a:p>
             <a:r>
-              <a:t>TIMING: 4 minutes.</a:t>
+              <a:t>4 minutes — </a:t>
+            </a:r>
+            <a:r>
+              <a:rPr i="1"/>
+              <a:t>Schema evolution: representation, existing records, availability mid-migration.</a:t>
             </a:r>
           </a:p>
           <a:p/>
@@ -3196,7 +3358,11 @@
           <a:lstStyle/>
           <a:p>
             <a:r>
-              <a:t>TIMING: 4 minutes.</a:t>
+              <a:t>4 minutes — </a:t>
+            </a:r>
+            <a:r>
+              <a:rPr i="1"/>
+              <a:t>Re-walk the Act III method with every box filled by one of today's decisions.</a:t>
             </a:r>
           </a:p>
           <a:p/>
@@ -3284,7 +3450,11 @@
           <a:lstStyle/>
           <a:p>
             <a:r>
-              <a:t>TIMING: 2 minutes.</a:t>
+              <a:t>2 minutes — </a:t>
+            </a:r>
+            <a:r>
+              <a:rPr i="1"/>
+              <a:t>Close the governing question; hand off to Technical Debt, Architecture &amp; Supply Chains.</a:t>
             </a:r>
           </a:p>
           <a:p/>
@@ -3366,7 +3536,11 @@
           <a:lstStyle/>
           <a:p>
             <a:r>
-              <a:t>TIMING: 1 minute.</a:t>
+              <a:t>1 minute — </a:t>
+            </a:r>
+            <a:r>
+              <a:rPr i="1"/>
+              <a:t>Orient: five movements, each named by the engineering question it answers.</a:t>
             </a:r>
           </a:p>
           <a:p/>
@@ -3442,7 +3616,11 @@
           <a:lstStyle/>
           <a:p>
             <a:r>
-              <a:t>TIMING: 3 minutes.</a:t>
+              <a:t>3 minutes — </a:t>
+            </a:r>
+            <a:r>
+              <a:rPr i="1"/>
+              <a:t>Name the database as an engineering component; storage mechanisms form their own axis.</a:t>
             </a:r>
           </a:p>
           <a:p/>
@@ -3530,7 +3708,11 @@
           <a:lstStyle/>
           <a:p>
             <a:r>
-              <a:t>TIMING: 4 minutes.</a:t>
+              <a:t>4 minutes — </a:t>
+            </a:r>
+            <a:r>
+              <a:rPr i="1"/>
+              <a:t>Establish the five-dimension model the rest of the lecture lives on.</a:t>
             </a:r>
           </a:p>
           <a:p/>
@@ -3618,7 +3800,11 @@
           <a:lstStyle/>
           <a:p>
             <a:r>
-              <a:t>TIMING: 2 minutes.</a:t>
+              <a:t>2 minutes — </a:t>
+            </a:r>
+            <a:r>
+              <a:rPr i="1"/>
+              <a:t>Show the same facts in four native shapes; separate data model from storage mechanism.</a:t>
             </a:r>
           </a:p>
           <a:p/>
@@ -3711,7 +3897,11 @@
           <a:lstStyle/>
           <a:p>
             <a:r>
-              <a:t>TIMING: 2 minutes.</a:t>
+              <a:t>2 minutes — </a:t>
+            </a:r>
+            <a:r>
+              <a:rPr i="1"/>
+              <a:t>Make relational vs NoSQL a requirements question, not a camp war.</a:t>
             </a:r>
           </a:p>
           <a:p/>
@@ -3798,7 +3988,11 @@
           <a:lstStyle/>
           <a:p>
             <a:r>
-              <a:t>TIMING: 2 minutes.</a:t>
+              <a:t>2 minutes — </a:t>
+            </a:r>
+            <a:r>
+              <a:rPr i="1"/>
+              <a:t>Make guarantees, not product labels, the object of interrogation.</a:t>
             </a:r>
           </a:p>
           <a:p/>
@@ -3880,7 +4074,11 @@
           <a:lstStyle/>
           <a:p>
             <a:r>
-              <a:t>TIMING: 2 minutes.</a:t>
+              <a:t>2 minutes — </a:t>
+            </a:r>
+            <a:r>
+              <a:rPr i="1"/>
+              <a:t>Students map each workload's requirements onto database capabilities.</a:t>
             </a:r>
           </a:p>
           <a:p/>
@@ -3973,7 +4171,11 @@
           <a:lstStyle/>
           <a:p>
             <a:r>
-              <a:t>TIMING: 3 minutes.</a:t>
+              <a:t>3 minutes — </a:t>
+            </a:r>
+            <a:r>
+              <a:rPr i="1"/>
+              <a:t>Derive the ER model; entities give the invariant its vocabulary, not its enforcement.</a:t>
             </a:r>
           </a:p>
           <a:p/>
@@ -11346,7 +11548,7 @@
                 </a:solidFill>
                 <a:latin typeface="Calibri"/>
               </a:rPr>
-              <a:t>Act III — Engineering Software Systems</a:t>
+              <a:t>Act III: Engineering Software Systems</a:t>
             </a:r>
           </a:p>
         </p:txBody>
@@ -11453,7 +11655,7 @@
       </p:sp>
       <p:sp>
         <p:nvSpPr>
-          <p:cNvPr id="3" name="Block"/>
+          <p:cNvPr id="3" name="Block" descr="ER diagram: USER and ROOM each relate one-to-many to RESERVATION; attribute lists sit beneath each entity; the no-overlap invariant is stated below the diagram"/>
           <p:cNvSpPr/>
           <p:nvPr/>
         </p:nvSpPr>
@@ -11702,7 +11904,7 @@
       </p:sp>
       <p:cxnSp>
         <p:nvCxnSpPr>
-          <p:cNvPr id="8" name="RelLine"/>
+          <p:cNvPr id="8" name="RelLine" descr="one-to-many connector pointing toward RESERVATION"/>
           <p:cNvCxnSpPr/>
           <p:nvPr/>
         </p:nvCxnSpPr>
@@ -11738,7 +11940,7 @@
       </p:cxnSp>
       <p:cxnSp>
         <p:nvCxnSpPr>
-          <p:cNvPr id="9" name="RelLine"/>
+          <p:cNvPr id="9" name="RelLine" descr="one-to-many connector pointing toward RESERVATION"/>
           <p:cNvCxnSpPr/>
           <p:nvPr/>
         </p:nvCxnSpPr>
@@ -12598,16 +12800,7 @@
                 </a:solidFill>
                 <a:latin typeface="Calibri"/>
               </a:rPr>
-              <a:t>REFERENCES</a:t>
-            </a:r>
-            <a:r>
-              <a:rPr sz="2000" b="0">
-                <a:solidFill>
-                  <a:srgbClr val="555960"/>
-                </a:solidFill>
-                <a:latin typeface="Calibri"/>
-              </a:rPr>
-              <a:t> — that row must exist</a:t>
+              <a:t>REFERENCES: that row must exist</a:t>
             </a:r>
           </a:p>
           <a:p>
@@ -12623,16 +12816,7 @@
                 </a:solidFill>
                 <a:latin typeface="Calibri"/>
               </a:rPr>
-              <a:t>NOT NULL</a:t>
-            </a:r>
-            <a:r>
-              <a:rPr sz="2000" b="0">
-                <a:solidFill>
-                  <a:srgbClr val="555960"/>
-                </a:solidFill>
-                <a:latin typeface="Calibri"/>
-              </a:rPr>
-              <a:t> — the fact must be present</a:t>
+              <a:t>NOT NULL: the fact must be present</a:t>
             </a:r>
           </a:p>
           <a:p>
@@ -12648,16 +12832,7 @@
                 </a:solidFill>
                 <a:latin typeface="Calibri"/>
               </a:rPr>
-              <a:t>CHECK</a:t>
-            </a:r>
-            <a:r>
-              <a:rPr sz="2000" b="0">
-                <a:solidFill>
-                  <a:srgbClr val="555960"/>
-                </a:solidFill>
-                <a:latin typeface="Calibri"/>
-              </a:rPr>
-              <a:t> — true within one row</a:t>
+              <a:t>CHECK: true within one row</a:t>
             </a:r>
           </a:p>
         </p:txBody>
@@ -13210,7 +13385,7 @@
                 </a:solidFill>
                 <a:latin typeface="Calibri"/>
               </a:rPr>
-              <a:t>Join on every read, or copy and own the copies' staleness. The read/write mix settles it — not a doctrine.</a:t>
+              <a:t>Join on every read, or copy and own the copies' staleness. The read/write mix settles it, not a doctrine.</a:t>
             </a:r>
           </a:p>
         </p:txBody>
@@ -14447,7 +14622,7 @@
                 </a:solidFill>
                 <a:latin typeface="Calibri"/>
               </a:rPr>
-              <a:t>Illustrative — real syntax depends on the library</a:t>
+              <a:t>Illustrative: real syntax depends on the library</a:t>
             </a:r>
           </a:p>
         </p:txBody>
@@ -14924,7 +15099,7 @@
       </p:sp>
       <p:sp>
         <p:nvSpPr>
-          <p:cNvPr id="3" name="Block"/>
+          <p:cNvPr id="3" name="Block" descr="Five-layer stack read downward: application objects, ORM, SQL, engine, stored data; each layer hands its output to the one below"/>
           <p:cNvSpPr/>
           <p:nvPr/>
         </p:nvSpPr>
@@ -15075,7 +15250,7 @@
                 </a:solidFill>
                 <a:latin typeface="Calibri"/>
               </a:rPr>
-              <a:t>ORM — maps objects to rows; emits SQL</a:t>
+              <a:t>ORM: maps objects to rows; emits SQL</a:t>
             </a:r>
           </a:p>
         </p:txBody>
@@ -15176,7 +15351,7 @@
                 </a:solidFill>
                 <a:latin typeface="Calibri"/>
               </a:rPr>
-              <a:t>SQL — the declarative WHAT</a:t>
+              <a:t>SQL: the declarative WHAT</a:t>
             </a:r>
           </a:p>
         </p:txBody>
@@ -15277,7 +15452,7 @@
                 </a:solidFill>
                 <a:latin typeface="Calibri"/>
               </a:rPr>
-              <a:t>Engine — plans and executes (HOW)</a:t>
+              <a:t>Engine: plans and executes (HOW)</a:t>
             </a:r>
           </a:p>
         </p:txBody>
@@ -15378,7 +15553,7 @@
                 </a:solidFill>
                 <a:latin typeface="Calibri"/>
               </a:rPr>
-              <a:t>Stored data — pages, rows, indexes</a:t>
+              <a:t>Stored data: pages, rows, indexes</a:t>
             </a:r>
           </a:p>
         </p:txBody>
@@ -15545,105 +15720,6 @@
       </p:sp>
       <p:sp>
         <p:nvSpPr>
-          <p:cNvPr id="14" name="Card"/>
-          <p:cNvSpPr/>
-          <p:nvPr/>
-        </p:nvSpPr>
-        <p:spPr>
-          <a:xfrm>
-            <a:off x="411480" y="4892040"/>
-            <a:ext cx="8321040" cy="960120"/>
-          </a:xfrm>
-          <a:prstGeom prst="rect">
-            <a:avLst/>
-          </a:prstGeom>
-          <a:solidFill>
-            <a:srgbClr val="F5F1E8"/>
-          </a:solidFill>
-          <a:ln>
-            <a:noFill/>
-          </a:ln>
-          <a:effectLst/>
-        </p:spPr>
-        <p:style>
-          <a:lnRef idx="1">
-            <a:schemeClr val="accent1"/>
-          </a:lnRef>
-          <a:fillRef idx="3">
-            <a:schemeClr val="accent1"/>
-          </a:fillRef>
-          <a:effectRef idx="2">
-            <a:schemeClr val="accent1"/>
-          </a:effectRef>
-          <a:fontRef idx="minor">
-            <a:schemeClr val="lt1"/>
-          </a:fontRef>
-        </p:style>
-        <p:txBody>
-          <a:bodyPr rtlCol="0" anchor="ctr" wrap="square"/>
-          <a:lstStyle/>
-          <a:p>
-            <a:pPr algn="ctr"/>
-          </a:p>
-        </p:txBody>
-      </p:sp>
-      <p:sp>
-        <p:nvSpPr>
-          <p:cNvPr id="15" name="CardBody"/>
-          <p:cNvSpPr txBox="1"/>
-          <p:nvPr/>
-        </p:nvSpPr>
-        <p:spPr>
-          <a:xfrm>
-            <a:off x="557784" y="4965192"/>
-            <a:ext cx="8046720" cy="822960"/>
-          </a:xfrm>
-          <a:prstGeom prst="rect">
-            <a:avLst/>
-          </a:prstGeom>
-          <a:noFill/>
-        </p:spPr>
-        <p:txBody>
-          <a:bodyPr wrap="square">
-            <a:spAutoFit/>
-          </a:bodyPr>
-          <a:lstStyle/>
-          <a:p>
-            <a:pPr algn="l">
-              <a:spcAft>
-                <a:spcPts val="300"/>
-              </a:spcAft>
-            </a:pPr>
-            <a:r>
-              <a:rPr sz="2000" b="1">
-                <a:solidFill>
-                  <a:srgbClr val="5C4826"/>
-                </a:solidFill>
-                <a:latin typeface="Calibri"/>
-              </a:rPr>
-              <a:t>It compares candidate plans by estimated cost, using statistics about YOUR data</a:t>
-            </a:r>
-          </a:p>
-          <a:p>
-            <a:pPr algn="l">
-              <a:spcAft>
-                <a:spcPts val="400"/>
-              </a:spcAft>
-            </a:pPr>
-            <a:r>
-              <a:rPr sz="2000" b="0">
-                <a:solidFill>
-                  <a:srgbClr val="555960"/>
-                </a:solidFill>
-                <a:latin typeface="Calibri"/>
-              </a:rPr>
-              <a:t>Same SQL, thousandfold cost differences. The levers you supply: indexes, layout, fresh statistics.</a:t>
-            </a:r>
-          </a:p>
-        </p:txBody>
-      </p:sp>
-      <p:sp>
-        <p:nvSpPr>
           <p:cNvPr id="16" name="Block"/>
           <p:cNvSpPr/>
           <p:nvPr/>
@@ -15838,7 +15914,7 @@
       </p:sp>
       <p:sp>
         <p:nvSpPr>
-          <p:cNvPr id="20" name="Block"/>
+          <p:cNvPr id="20" name="Block" descr="Query execution diagram: parse and validate feeds a logical plan; the logical plan and statistics about your data feed the optimizer; two candidate plans branch from it, sequential scan and index range scan; the lowest estimated cost executes"/>
           <p:cNvSpPr/>
           <p:nvPr/>
         </p:nvSpPr>
@@ -16368,6 +16444,105 @@
                 <a:latin typeface="Calibri"/>
               </a:rPr>
               <a:t>Execute the chosen plan</a:t>
+            </a:r>
+          </a:p>
+        </p:txBody>
+      </p:sp>
+      <p:sp>
+        <p:nvSpPr>
+          <p:cNvPr id="14" name="Card"/>
+          <p:cNvSpPr/>
+          <p:nvPr/>
+        </p:nvSpPr>
+        <p:spPr>
+          <a:xfrm>
+            <a:off x="411480" y="4892040"/>
+            <a:ext cx="8321040" cy="960120"/>
+          </a:xfrm>
+          <a:prstGeom prst="rect">
+            <a:avLst/>
+          </a:prstGeom>
+          <a:solidFill>
+            <a:srgbClr val="F5F1E8"/>
+          </a:solidFill>
+          <a:ln>
+            <a:noFill/>
+          </a:ln>
+          <a:effectLst/>
+        </p:spPr>
+        <p:style>
+          <a:lnRef idx="1">
+            <a:schemeClr val="accent1"/>
+          </a:lnRef>
+          <a:fillRef idx="3">
+            <a:schemeClr val="accent1"/>
+          </a:fillRef>
+          <a:effectRef idx="2">
+            <a:schemeClr val="accent1"/>
+          </a:effectRef>
+          <a:fontRef idx="minor">
+            <a:schemeClr val="lt1"/>
+          </a:fontRef>
+        </p:style>
+        <p:txBody>
+          <a:bodyPr rtlCol="0" anchor="ctr" wrap="square"/>
+          <a:lstStyle/>
+          <a:p>
+            <a:pPr algn="ctr"/>
+          </a:p>
+        </p:txBody>
+      </p:sp>
+      <p:sp>
+        <p:nvSpPr>
+          <p:cNvPr id="15" name="CardBody"/>
+          <p:cNvSpPr txBox="1"/>
+          <p:nvPr/>
+        </p:nvSpPr>
+        <p:spPr>
+          <a:xfrm>
+            <a:off x="557784" y="4965192"/>
+            <a:ext cx="8046720" cy="822960"/>
+          </a:xfrm>
+          <a:prstGeom prst="rect">
+            <a:avLst/>
+          </a:prstGeom>
+          <a:noFill/>
+        </p:spPr>
+        <p:txBody>
+          <a:bodyPr wrap="square">
+            <a:spAutoFit/>
+          </a:bodyPr>
+          <a:lstStyle/>
+          <a:p>
+            <a:pPr algn="l">
+              <a:spcAft>
+                <a:spcPts val="300"/>
+              </a:spcAft>
+            </a:pPr>
+            <a:r>
+              <a:rPr sz="2000" b="1">
+                <a:solidFill>
+                  <a:srgbClr val="5C4826"/>
+                </a:solidFill>
+                <a:latin typeface="Calibri"/>
+              </a:rPr>
+              <a:t>It compares candidate plans by estimated cost, using statistics about YOUR data</a:t>
+            </a:r>
+          </a:p>
+          <a:p>
+            <a:pPr algn="l">
+              <a:spcAft>
+                <a:spcPts val="400"/>
+              </a:spcAft>
+            </a:pPr>
+            <a:r>
+              <a:rPr sz="2000" b="0">
+                <a:solidFill>
+                  <a:srgbClr val="555960"/>
+                </a:solidFill>
+                <a:latin typeface="Calibri"/>
+              </a:rPr>
+              <a:t>Same SQL, thousandfold cost differences. The levers you supply: indexes, layout, fresh statistics.</a:t>
             </a:r>
           </a:p>
         </p:txBody>
@@ -16757,7 +16932,7 @@
                 </a:solidFill>
                 <a:latin typeface="Calibri"/>
               </a:rPr>
-              <a:t>Same query text — the index changed the plan</a:t>
+              <a:t>Same query text; the index changed the plan</a:t>
             </a:r>
           </a:p>
           <a:p>
@@ -17953,7 +18128,7 @@
       </p:sp>
       <p:sp>
         <p:nvSpPr>
-          <p:cNvPr id="3" name="Block"/>
+          <p:cNvPr id="3" name="Block" descr="Two-column timeline: requests A and B for room 117 with overlapping times; both availability checks run before either insert; both inserts then commit"/>
           <p:cNvSpPr/>
           <p:nvPr/>
         </p:nvSpPr>
@@ -18003,7 +18178,7 @@
                 </a:solidFill>
                 <a:latin typeface="Calibri"/>
               </a:rPr>
-              <a:t>REQUEST A — 117, 10:00–11:00</a:t>
+              <a:t>REQUEST A: 117, 10:00–11:00</a:t>
             </a:r>
           </a:p>
         </p:txBody>
@@ -18060,7 +18235,7 @@
                 </a:solidFill>
                 <a:latin typeface="Calibri"/>
               </a:rPr>
-              <a:t>REQUEST B — 117, 10:30–11:30</a:t>
+              <a:t>REQUEST B: 117, 10:30–11:30</a:t>
             </a:r>
           </a:p>
         </p:txBody>
@@ -18387,7 +18562,7 @@
                 </a:solidFill>
                 <a:latin typeface="Calibri"/>
               </a:rPr>
-              <a:t>No statement failed, no constraint fired — and each request, read alone, follows the intended algorithm exactly.</a:t>
+              <a:t>No statement failed, no constraint fired, and each request, read alone, follows the intended algorithm exactly.</a:t>
             </a:r>
           </a:p>
         </p:txBody>
@@ -19277,106 +19452,7 @@
       </p:sp>
       <p:sp>
         <p:nvSpPr>
-          <p:cNvPr id="6" name="Card"/>
-          <p:cNvSpPr/>
-          <p:nvPr/>
-        </p:nvSpPr>
-        <p:spPr>
-          <a:xfrm>
-            <a:off x="411480" y="4251960"/>
-            <a:ext cx="8321040" cy="1417320"/>
-          </a:xfrm>
-          <a:prstGeom prst="rect">
-            <a:avLst/>
-          </a:prstGeom>
-          <a:solidFill>
-            <a:srgbClr val="F5F1E8"/>
-          </a:solidFill>
-          <a:ln>
-            <a:noFill/>
-          </a:ln>
-          <a:effectLst/>
-        </p:spPr>
-        <p:style>
-          <a:lnRef idx="1">
-            <a:schemeClr val="accent1"/>
-          </a:lnRef>
-          <a:fillRef idx="3">
-            <a:schemeClr val="accent1"/>
-          </a:fillRef>
-          <a:effectRef idx="2">
-            <a:schemeClr val="accent1"/>
-          </a:effectRef>
-          <a:fontRef idx="minor">
-            <a:schemeClr val="lt1"/>
-          </a:fontRef>
-        </p:style>
-        <p:txBody>
-          <a:bodyPr rtlCol="0" anchor="ctr" wrap="square"/>
-          <a:lstStyle/>
-          <a:p>
-            <a:pPr algn="ctr"/>
-          </a:p>
-        </p:txBody>
-      </p:sp>
-      <p:sp>
-        <p:nvSpPr>
-          <p:cNvPr id="7" name="CardBody"/>
-          <p:cNvSpPr txBox="1"/>
-          <p:nvPr/>
-        </p:nvSpPr>
-        <p:spPr>
-          <a:xfrm>
-            <a:off x="557784" y="4325112"/>
-            <a:ext cx="8046720" cy="1280160"/>
-          </a:xfrm>
-          <a:prstGeom prst="rect">
-            <a:avLst/>
-          </a:prstGeom>
-          <a:noFill/>
-        </p:spPr>
-        <p:txBody>
-          <a:bodyPr wrap="square">
-            <a:spAutoFit/>
-          </a:bodyPr>
-          <a:lstStyle/>
-          <a:p>
-            <a:pPr algn="l">
-              <a:spcAft>
-                <a:spcPts val="300"/>
-              </a:spcAft>
-            </a:pPr>
-            <a:r>
-              <a:rPr sz="2000" b="1">
-                <a:solidFill>
-                  <a:srgbClr val="5C4826"/>
-                </a:solidFill>
-                <a:latin typeface="Calibri"/>
-              </a:rPr>
-              <a:t>Act II's move again: correctness = every permitted history preserves the invariant</a:t>
-            </a:r>
-          </a:p>
-          <a:p>
-            <a:pPr algn="l">
-              <a:spcAft>
-                <a:spcPts val="400"/>
-              </a:spcAft>
-            </a:pPr>
-            <a:r>
-              <a:rPr sz="2000" b="0">
-                <a:solidFill>
-                  <a:srgbClr val="555960"/>
-                </a:solidFill>
-                <a:latin typeface="Calibri"/>
-              </a:rPr>
-              <a:t>With the check and the insert inside one transaction, one request must appear to run second; its check then sees the other's row.</a:t>
-            </a:r>
-          </a:p>
-        </p:txBody>
-      </p:sp>
-      <p:sp>
-        <p:nvSpPr>
-          <p:cNvPr id="8" name="SetOuter"/>
+          <p:cNvPr id="8" name="SetOuter" descr="Nested sets: all interleavings contain the histories your isolation level permits, which contain the serializable core; the double-booking history lies inside the permitted set but outside the serializable core"/>
           <p:cNvSpPr/>
           <p:nvPr/>
         </p:nvSpPr>
@@ -19640,6 +19716,105 @@
                 <a:latin typeface="Calibri"/>
               </a:rPr>
               <a:t>history</a:t>
+            </a:r>
+          </a:p>
+        </p:txBody>
+      </p:sp>
+      <p:sp>
+        <p:nvSpPr>
+          <p:cNvPr id="6" name="Card"/>
+          <p:cNvSpPr/>
+          <p:nvPr/>
+        </p:nvSpPr>
+        <p:spPr>
+          <a:xfrm>
+            <a:off x="411480" y="4251960"/>
+            <a:ext cx="8321040" cy="1417320"/>
+          </a:xfrm>
+          <a:prstGeom prst="rect">
+            <a:avLst/>
+          </a:prstGeom>
+          <a:solidFill>
+            <a:srgbClr val="F5F1E8"/>
+          </a:solidFill>
+          <a:ln>
+            <a:noFill/>
+          </a:ln>
+          <a:effectLst/>
+        </p:spPr>
+        <p:style>
+          <a:lnRef idx="1">
+            <a:schemeClr val="accent1"/>
+          </a:lnRef>
+          <a:fillRef idx="3">
+            <a:schemeClr val="accent1"/>
+          </a:fillRef>
+          <a:effectRef idx="2">
+            <a:schemeClr val="accent1"/>
+          </a:effectRef>
+          <a:fontRef idx="minor">
+            <a:schemeClr val="lt1"/>
+          </a:fontRef>
+        </p:style>
+        <p:txBody>
+          <a:bodyPr rtlCol="0" anchor="ctr" wrap="square"/>
+          <a:lstStyle/>
+          <a:p>
+            <a:pPr algn="ctr"/>
+          </a:p>
+        </p:txBody>
+      </p:sp>
+      <p:sp>
+        <p:nvSpPr>
+          <p:cNvPr id="7" name="CardBody"/>
+          <p:cNvSpPr txBox="1"/>
+          <p:nvPr/>
+        </p:nvSpPr>
+        <p:spPr>
+          <a:xfrm>
+            <a:off x="557784" y="4325112"/>
+            <a:ext cx="8046720" cy="1280160"/>
+          </a:xfrm>
+          <a:prstGeom prst="rect">
+            <a:avLst/>
+          </a:prstGeom>
+          <a:noFill/>
+        </p:spPr>
+        <p:txBody>
+          <a:bodyPr wrap="square">
+            <a:spAutoFit/>
+          </a:bodyPr>
+          <a:lstStyle/>
+          <a:p>
+            <a:pPr algn="l">
+              <a:spcAft>
+                <a:spcPts val="300"/>
+              </a:spcAft>
+            </a:pPr>
+            <a:r>
+              <a:rPr sz="2000" b="1">
+                <a:solidFill>
+                  <a:srgbClr val="5C4826"/>
+                </a:solidFill>
+                <a:latin typeface="Calibri"/>
+              </a:rPr>
+              <a:t>Act II's move again: correctness = every permitted history preserves the invariant</a:t>
+            </a:r>
+          </a:p>
+          <a:p>
+            <a:pPr algn="l">
+              <a:spcAft>
+                <a:spcPts val="400"/>
+              </a:spcAft>
+            </a:pPr>
+            <a:r>
+              <a:rPr sz="2000" b="0">
+                <a:solidFill>
+                  <a:srgbClr val="555960"/>
+                </a:solidFill>
+                <a:latin typeface="Calibri"/>
+              </a:rPr>
+              <a:t>With the check and the insert inside one transaction, one request must appear to run second; its check then sees the other's row.</a:t>
             </a:r>
           </a:p>
         </p:txBody>
@@ -20114,7 +20289,7 @@
                 </a:solidFill>
                 <a:latin typeface="Calibri"/>
               </a:rPr>
-              <a:t>Race excluded — one transaction aborts</a:t>
+              <a:t>Race excluded: one transaction aborts</a:t>
             </a:r>
           </a:p>
           <a:p>
@@ -20688,7 +20863,7 @@
                 </a:solidFill>
                 <a:latin typeface="Calibri"/>
               </a:rPr>
-              <a:t>SELECT … FOR UPDATE the room row first — your LOCKING DISCIPLINE, per room</a:t>
+              <a:t>SELECT … FOR UPDATE the room row first: your LOCKING DISCIPLINE, per room</a:t>
             </a:r>
           </a:p>
           <a:p>
@@ -21357,7 +21532,7 @@
                 </a:solidFill>
                 <a:latin typeface="Calibri"/>
               </a:rPr>
-              <a:t>Hot rooms serialize — the waiting IS the mechanism working</a:t>
+              <a:t>Hot rooms serialize; the waiting IS the mechanism working</a:t>
             </a:r>
           </a:p>
         </p:txBody>
@@ -21837,7 +22012,7 @@
                 </a:solidFill>
                 <a:latin typeface="Calibri"/>
               </a:rPr>
-              <a:t>Weekly recitation, every Tuesday — a recurrence-rule column? a series table? expanded rows?</a:t>
+              <a:t>Weekly recitation, every Tuesday: a recurrence-rule column? a series table? expanded rows?</a:t>
             </a:r>
           </a:p>
           <a:p>
@@ -21975,7 +22150,7 @@
                 </a:solidFill>
                 <a:latin typeface="Calibri"/>
               </a:rPr>
-              <a:t>What happens to the rows already there — backfill, defaults, or dual reads?</a:t>
+              <a:t>What happens to the rows already there: backfill, defaults, or dual reads?</a:t>
             </a:r>
           </a:p>
           <a:p>
@@ -22197,7 +22372,7 @@
       </p:sp>
       <p:sp>
         <p:nvSpPr>
-          <p:cNvPr id="3" name="Block"/>
+          <p:cNvPr id="3" name="Block" descr="Act III engineering method flowchart populated with this lecture's decisions: problem (preserve correct reservations), model (entities, intervals, invariant), judgment (relational, normalized), realize (schema and queries), evidence (plans and the race), accept or reject (adopt the exclusion constraint); an alignment lane runs alongside"/>
           <p:cNvSpPr/>
           <p:nvPr/>
         </p:nvSpPr>
@@ -22958,6 +23133,40 @@
       </p:cxnSp>
       <p:sp>
         <p:nvSpPr>
+          <p:cNvPr id="21" name="MethodNote"/>
+          <p:cNvSpPr txBox="1"/>
+          <p:nvPr/>
+        </p:nvSpPr>
+        <p:spPr>
+          <a:xfrm>
+            <a:off x="411480" y="4937760"/>
+            <a:ext cx="8321040" cy="731520"/>
+          </a:xfrm>
+          <a:prstGeom prst="rect">
+            <a:avLst/>
+          </a:prstGeom>
+          <a:noFill/>
+        </p:spPr>
+        <p:txBody>
+          <a:bodyPr wrap="square">
+            <a:spAutoFit/>
+          </a:bodyPr>
+          <a:lstStyle/>
+          <a:p>
+            <a:r>
+              <a:rPr sz="2000" b="0">
+                <a:solidFill>
+                  <a:srgbClr val="555960"/>
+                </a:solidFill>
+                <a:latin typeface="Calibri"/>
+              </a:rPr>
+              <a:t>Tuesday's frame, today's artifacts: every box filled by a decision made in this lecture.</a:t>
+            </a:r>
+          </a:p>
+        </p:txBody>
+      </p:sp>
+      <p:sp>
+        <p:nvSpPr>
           <p:cNvPr id="19" name="FooterBand"/>
           <p:cNvSpPr/>
           <p:nvPr/>
@@ -23034,41 +23243,7 @@
                 </a:solidFill>
                 <a:latin typeface="Calibri"/>
               </a:rPr>
-              <a:t>The same method as Tuesday — different models, same discipline</a:t>
-            </a:r>
-          </a:p>
-        </p:txBody>
-      </p:sp>
-      <p:sp>
-        <p:nvSpPr>
-          <p:cNvPr id="21" name="MethodNote"/>
-          <p:cNvSpPr txBox="1"/>
-          <p:nvPr/>
-        </p:nvSpPr>
-        <p:spPr>
-          <a:xfrm>
-            <a:off x="411480" y="4937760"/>
-            <a:ext cx="8321040" cy="731520"/>
-          </a:xfrm>
-          <a:prstGeom prst="rect">
-            <a:avLst/>
-          </a:prstGeom>
-          <a:noFill/>
-        </p:spPr>
-        <p:txBody>
-          <a:bodyPr wrap="square">
-            <a:spAutoFit/>
-          </a:bodyPr>
-          <a:lstStyle/>
-          <a:p>
-            <a:r>
-              <a:rPr sz="2000" b="0">
-                <a:solidFill>
-                  <a:srgbClr val="555960"/>
-                </a:solidFill>
-                <a:latin typeface="Calibri"/>
-              </a:rPr>
-              <a:t>Tuesday's frame, today's artifacts: every box filled by a decision made in this lecture.</a:t>
+              <a:t>The same method as Tuesday: different models, same discipline</a:t>
             </a:r>
           </a:p>
         </p:txBody>
@@ -23506,7 +23681,7 @@
                 </a:solidFill>
                 <a:latin typeface="Calibri"/>
               </a:rPr>
-              <a:t>The system's own shape — and everything it inherited — become the object of engineering.</a:t>
+              <a:t>The system's own shape (and everything it inherited) becomes the object of engineering.</a:t>
             </a:r>
           </a:p>
         </p:txBody>
@@ -26324,7 +26499,7 @@
       </p:sp>
       <p:cxnSp>
         <p:nvCxnSpPr>
-          <p:cNvPr id="19" name="Edge"/>
+          <p:cNvPr id="19" name="Edge" descr="Edge connecting the USER and ROOM nodes, labeled RESERVED 10:00 to 11:00"/>
           <p:cNvCxnSpPr/>
           <p:nvPr/>
         </p:nvCxnSpPr>
@@ -27627,7 +27802,7 @@
                 </a:solidFill>
                 <a:latin typeface="Calibri"/>
               </a:rPr>
-              <a:t>A — ROOM RESERVATIONS</a:t>
+              <a:t>A: ROOM RESERVATIONS</a:t>
             </a:r>
           </a:p>
           <a:p>
@@ -27790,7 +27965,7 @@
                 </a:solidFill>
                 <a:latin typeface="Calibri"/>
               </a:rPr>
-              <a:t>B — DOOR-SENSOR TELEMETRY</a:t>
+              <a:t>B: DOOR-SENSOR TELEMETRY</a:t>
             </a:r>
           </a:p>
           <a:p>

</xml_diff>